<commit_message>
docs(a4): align Jiajun slides with Python 3 detection scope
Update the rule, 14-check evidence, and review status for 4115d9325.

Generated-by: Codex
</commit_message>
<xml_diff>
--- a/presentation/Jiajun-TIKA-4408-section.pptx
+++ b/presentation/Jiajun-TIKA-4408-section.pptx
@@ -2,32 +2,32 @@
 <file path=ppt/presentation.xml><?xml version="1.0" encoding="utf-8"?>
 <p:presentation xmlns:p="http://schemas.openxmlformats.org/presentationml/2006/main" embedTrueTypeFonts="1" saveSubsetFonts="0">
   <p:sldMasterIdLst>
-    <p:sldMasterId xmlns:r="http://schemas.openxmlformats.org/officeDocument/2006/relationships" id="2147483648" r:id="Rfa21778d95aa4600"/>
-    <p:sldMasterId xmlns:r="http://schemas.openxmlformats.org/officeDocument/2006/relationships" id="2147483650" r:id="Rcb538838d4bf48fa"/>
+    <p:sldMasterId xmlns:r="http://schemas.openxmlformats.org/officeDocument/2006/relationships" id="2147483648" r:id="Rd49851b5c380416f"/>
+    <p:sldMasterId xmlns:r="http://schemas.openxmlformats.org/officeDocument/2006/relationships" id="2147483650" r:id="R05265bdbafa84269"/>
   </p:sldMasterIdLst>
   <p:notesMasterIdLst>
-    <p:notesMasterId xmlns:r="http://schemas.openxmlformats.org/officeDocument/2006/relationships" r:id="R07c587eea103431d"/>
+    <p:notesMasterId xmlns:r="http://schemas.openxmlformats.org/officeDocument/2006/relationships" r:id="Rcfb62667cd864ef6"/>
   </p:notesMasterIdLst>
   <p:sldIdLst>
-    <p:sldId xmlns:r="http://schemas.openxmlformats.org/officeDocument/2006/relationships" id="256" r:id="R062f0daeed984626"/>
-    <p:sldId xmlns:r="http://schemas.openxmlformats.org/officeDocument/2006/relationships" id="257" r:id="R2e38fc37ae904e5e"/>
-    <p:sldId xmlns:r="http://schemas.openxmlformats.org/officeDocument/2006/relationships" id="258" r:id="Rce90d57ff9be4cb9"/>
-    <p:sldId xmlns:r="http://schemas.openxmlformats.org/officeDocument/2006/relationships" id="259" r:id="R037d10c5ef4541ca"/>
+    <p:sldId xmlns:r="http://schemas.openxmlformats.org/officeDocument/2006/relationships" id="256" r:id="R9db96786411a4e3d"/>
+    <p:sldId xmlns:r="http://schemas.openxmlformats.org/officeDocument/2006/relationships" id="257" r:id="R67058dd9418a455a"/>
+    <p:sldId xmlns:r="http://schemas.openxmlformats.org/officeDocument/2006/relationships" id="258" r:id="R25da52b2ca1347de"/>
+    <p:sldId xmlns:r="http://schemas.openxmlformats.org/officeDocument/2006/relationships" id="259" r:id="R0b690752bc564561"/>
   </p:sldIdLst>
   <p:sldSz cx="12192000" cy="6858000"/>
   <p:notesSz cx="6858000" cy="9144000"/>
   <p:embeddedFontLst>
     <p:embeddedFont>
       <p:font typeface="Manrope"/>
-      <p:regular xmlns:r="http://schemas.openxmlformats.org/officeDocument/2006/relationships" r:id="Re014075c23764527"/>
-      <p:bold xmlns:r="http://schemas.openxmlformats.org/officeDocument/2006/relationships" r:id="R78a998028eef458f"/>
+      <p:regular xmlns:r="http://schemas.openxmlformats.org/officeDocument/2006/relationships" r:id="Rf798f33f4b054dbf"/>
+      <p:bold xmlns:r="http://schemas.openxmlformats.org/officeDocument/2006/relationships" r:id="Re4a8b335cf2540b8"/>
     </p:embeddedFont>
     <p:embeddedFont>
       <p:font typeface="Roboto Mono"/>
-      <p:regular xmlns:r="http://schemas.openxmlformats.org/officeDocument/2006/relationships" r:id="R09e0305abedc480d"/>
-      <p:bold xmlns:r="http://schemas.openxmlformats.org/officeDocument/2006/relationships" r:id="R56090035e1fd4180"/>
-      <p:italic xmlns:r="http://schemas.openxmlformats.org/officeDocument/2006/relationships" r:id="Rb89e8ad6d14f40ed"/>
-      <p:boldItalic xmlns:r="http://schemas.openxmlformats.org/officeDocument/2006/relationships" r:id="Rf6492c66a944428a"/>
+      <p:regular xmlns:r="http://schemas.openxmlformats.org/officeDocument/2006/relationships" r:id="R68f84b6bca7a446b"/>
+      <p:bold xmlns:r="http://schemas.openxmlformats.org/officeDocument/2006/relationships" r:id="Rb04f4d52a10445a1"/>
+      <p:italic xmlns:r="http://schemas.openxmlformats.org/officeDocument/2006/relationships" r:id="Rb2845851964c4ce0"/>
+      <p:boldItalic xmlns:r="http://schemas.openxmlformats.org/officeDocument/2006/relationships" r:id="R664e02aff8614d0c"/>
     </p:embeddedFont>
   </p:embeddedFontLst>
   <p:defaultTextStyle>
@@ -752,7 +752,7 @@
               <a:buNone/>
             </a:pPr>
             <a:r>
-              <a:t>The first challenge was understanding why Tika identified this Python script as Shell. A shebang is the first line that names the interpreter. The old Python rule searched for slash bin slash env python at offset one. Offset means the starting position, counted from zero. In this input, that substring actually starts at offset six, so the Python rule missed it and a Shell rule matched instead. The fix checks the complete env-Python prefix at the start of the file. Understanding the existing rules made it possible to keep the change focused.</a:t>
+              <a:t>The first challenge was understanding why Tika identified this Python script as Shell. A shebang is the first line that names the interpreter. The old Python rule searched for slash bin slash env python at offset one. Offset means the starting position, counted from zero. In this input, that substring actually starts at offset six, so the Python rule missed it and a Shell rule matched instead. The narrowed fix checks the complete no-space env python3 prefix at the start of the file. Prefix matching also covers python3.11. Understanding the existing rules made it possible to define this limited scope clearly.</a:t>
             </a:r>
             <a:endParaRPr/>
           </a:p>
@@ -797,7 +797,7 @@
               <a:buNone/>
             </a:pPr>
             <a:r>
-              <a:t>先说明现象：Python 首行却识别成 Shell。offset 是从 0 开始数的位置。原规则检查位置 1，但 /bin/env python 实际从位置 6 开始，所以 Python 规则没命中。修复改成从文件开头匹配完整前缀。也支持 #! 后有一个空格的形式。这里强调读懂已有规则的挑战。</a:t>
+              <a:t>先说明现象：Python 首行却识别成 Shell。offset 是从 0 开始数的位置。原规则检查位置 1，但 /bin/env python 实际从位置 6 开始，所以 Python 规则没命中。当前修复只从文件开头匹配无空格的 #!/usr/bin/env python3 前缀，因此也匹配 python3.11。单空格、多空格、Tab 和 env python 不属于本次修复范围。这是原始 issue 的部分修复。</a:t>
             </a:r>
             <a:endParaRPr/>
           </a:p>
@@ -842,7 +842,7 @@
               <a:buNone/>
             </a:pPr>
             <a:r>
-              <a:t>The patch also includes the spaced form #! /usr/bin/env python. It preserves existing direct-path Python rules. Arbitrary env options such as env -S are outside this patch.</a:t>
+              <a:t>Current scope confirmed 25 October 2026: one literal #!/usr/bin/env python3 prefix at offset 0. Existing direct-path Python rules remain unchanged. Bare env python, whitespace after #!, and env options such as env -S are outside this patch; the original ticket contains additional cases that remain uncovered.</a:t>
             </a:r>
             <a:endParaRPr/>
           </a:p>
@@ -902,7 +902,7 @@
               <a:buNone/>
             </a:pPr>
             <a:r>
-              <a:t>https://github.com/u8026876/comp2120-gyg-a5/commit/cefa66955d74b2bf488d5ff4044fe2a6563bbf96</a:t>
+              <a:t>https://github.com/u8026876/comp2120-gyg-a5/commit/4115d9325295bf4a6a26ba8a1a05f5969ec953f2</a:t>
             </a:r>
             <a:endParaRPr/>
           </a:p>
@@ -932,7 +932,7 @@
               <a:buNone/>
             </a:pPr>
             <a:r>
-              <a:t>Contribution and assistance: Jiajun owns TIKA-4408. Codex assisted the implementation, testing, and presentation preparation. Kyubin supplied independent validation and review. Terry supplied additional review feedback. The visual template belongs to the group and was shared by Kyubin.</a:t>
+              <a:t>Contribution and assistance: Jiajun owns TIKA-4408. Codex assisted the implementation, testing, and presentation preparation. Kyubin supplied independent validation and review of the earlier version; the narrowed revision needs renewed human review. Terry supplied additional review feedback. The visual template belongs to the group and was shared by Kyubin.</a:t>
             </a:r>
             <a:endParaRPr/>
           </a:p>
@@ -1042,7 +1042,7 @@
               <a:buNone/>
             </a:pPr>
             <a:r>
-              <a:t>A successful result for one Python example would leave important questions unanswered. The regression checks covered Python variants, direct Python paths, and Shell scripts. They also separated content-only detection from detection with a dot-py filename hint, because metadata can affect the result. A leading-newline control checked that the rule really required the start of the file. Running the same eighteen checks before and after the fix gave a clear comparison: seven failed before the change, and all eighteen passed afterwards. This evidence helped show both the repair and its compatibility boundaries.</a:t>
+              <a:t>A successful result for one Python example would leave important questions unanswered. The regression checks covered env python3 and python3.11, existing direct Python paths, and Shell scripts. They separated content-only detection from detection with a dot-py filename hint, because metadata can affect the result. A leading-newline control checked that the rule required the start of the file. Running the same fourteen checks with the original broken rule and then the narrowed fix gave a clear comparison: four failed before the change, and all fourteen passed afterwards. This evidence shows the repair within the chosen scope.</a:t>
             </a:r>
             <a:endParaRPr/>
           </a:p>
@@ -1087,7 +1087,7 @@
               <a:buNone/>
             </a:pPr>
             <a:r>
-              <a:t>这页讲如何证明修复可靠。content-only 是不给文件名，只靠内容识别；filename hint 是额外给 script.py。两种方式分开测，防止文件名掩盖内容规则的问题。还测原本正常的 Python 路径、Shell，以及前面多一个换行的输入。18 项修复前 7 失败，修复后全通过。不要把本地测试说成远程 CI。</a:t>
+              <a:t>这页讲如何证明当前收窄后的修复可靠。content-only 是不给文件名，只靠内容识别；filename hint 是额外给 script.py。两种方式分开测，防止文件名掩盖内容规则的问题。还测原本正常的 Python 路径、Shell，以及前面多一个换行的输入。当前 14 项测试在原 offset 1 规则下有 4 项失败，换成 python3 前缀规则后全通过。不要再使用之前 18 项、7 项失败的数据描述当前版本。</a:t>
             </a:r>
             <a:endParaRPr/>
           </a:p>
@@ -1132,7 +1132,7 @@
               <a:buNone/>
             </a:pPr>
             <a:r>
-              <a:t>The 18 checks are focused regression cases, not 18 separate test methods. Original expanded reproduction baseline: apache/tika@4847f78. Published fix: cefa66955d74b2bf488d5ff4044fe2a6563bbf96. Wider local core validation on the group branch reported 1,377 tests, 0 failures/errors, 2 skipped. Kyubin reported 11 skipped in a different environment. No full Tika repository test or remote CI claim is made.</a:t>
+              <a:t>The 14 checks are parameterized regression cases, not 14 separate test methods. On 25 October 2026, the negative control kept these tests and temporarily restored only the original /bin/env python rule at offset 1: 4 failures, 0 errors. The Python 3-only rule in commit 4115d9325295bf4a6a26ba8a1a05f5969ec953f2 then passed all 14 checks. Full local core clean install with pedantic checks and randomized locale passed: 1,373 tests, 0 failures/errors, 2 skipped; alternate Xerces checks: 12 tests, 2 skipped; TikaIT: 1 passed; annotation-processor tests: 8 passed; quality checks passed. Kyubin's earlier approval covered cefa669, not this narrowed revision. No full Tika repository test or remote CI claim is made.</a:t>
             </a:r>
             <a:endParaRPr/>
           </a:p>
@@ -1192,7 +1192,7 @@
               <a:buNone/>
             </a:pPr>
             <a:r>
-              <a:t>https://github.com/u8026876/comp2120-gyg-a5/commit/cefa66955d74b2bf488d5ff4044fe2a6563bbf96</a:t>
+              <a:t>https://github.com/u8026876/comp2120-gyg-a5/commit/4115d9325295bf4a6a26ba8a1a05f5969ec953f2</a:t>
             </a:r>
             <a:endParaRPr/>
           </a:p>
@@ -1207,7 +1207,7 @@
               <a:buNone/>
             </a:pPr>
             <a:r>
-              <a:t>https://github.com/u8026876/comp2120-gyg-a5/pull/4#pullrequestreview-5584302852</a:t>
+              <a:t/>
             </a:r>
             <a:endParaRPr/>
           </a:p>
@@ -1222,22 +1222,7 @@
               <a:buNone/>
             </a:pPr>
             <a:r>
-              <a:t/>
-            </a:r>
-            <a:endParaRPr/>
-          </a:p>
-          <a:p xmlns:a="http://schemas.openxmlformats.org/drawingml/2006/main">
-            <a:pPr marL="0" lvl="0" indent="0" algn="l">
-              <a:spcBef>
-                <a:spcPts val="0"/>
-              </a:spcBef>
-              <a:spcAft>
-                <a:spcPts val="0"/>
-              </a:spcAft>
-              <a:buNone/>
-            </a:pPr>
-            <a:r>
-              <a:t>Contribution and assistance: Jiajun owns TIKA-4408. Codex assisted the implementation, testing, and presentation preparation. Kyubin supplied independent validation and review. Terry supplied additional review feedback. The visual template belongs to the group and was shared by Kyubin.</a:t>
+              <a:t>Contribution and assistance: Jiajun owns TIKA-4408. Codex assisted the implementation, testing, and presentation preparation. Kyubin supplied independent validation and review of the earlier version; the narrowed revision needs renewed human review. Terry supplied additional review feedback. The visual template belongs to the group and was shared by Kyubin.</a:t>
             </a:r>
             <a:endParaRPr/>
           </a:p>
@@ -1347,7 +1332,7 @@
               <a:buNone/>
             </a:pPr>
             <a:r>
-              <a:t>Terry suggested an ordinary-text example that tested the opposite direction: could Tika incorrectly call this Python? The x occupies position zero, so slash bin slash env python begins exactly at position one, where the old rule expected it. That accidental match produced a false positive. A negative test checks that unsuitable input does not trigger the Python rule. Kyubin separately verified this content-only example: the original rules returned text slash x-python, while the fixed rules returned text slash plain. The proposed improvement is to keep this example in the automated regression suite.</a:t>
+              <a:t>Terry suggested an ordinary-text example that tested the opposite direction: could Tika incorrectly call this Python? The x occupies position zero, so slash bin slash env python begins exactly at position one, where the old rule expected it. That accidental match produced a false positive. A negative test checks that unsuitable input does not trigger the Python rule. Kyubin separately verified this example on the earlier fix: the original rules returned text slash x-python, while that reviewed version returned text slash plain. The lesson is to preserve useful review examples as automated tests; this permanent test is currently deferred.</a:t>
             </a:r>
             <a:endParaRPr/>
           </a:p>
@@ -1392,7 +1377,7 @@
               <a:buNone/>
             </a:pPr>
             <a:r>
-              <a:t>这不是要执行的 Python 代码，而是故意构造的普通文本。x 占位置 0，后面的 /bin/env python 正好在位置 1，因此旧规则会误报为 Python。false positive 就是误报。Terry 提议把它加入长期测试，Kyubin 已单独验证修复后为普通文本。它尚未进入提交的 18 项测试，所以不要说已经加好了，也不要说修复仍有这个 bug。</a:t>
+              <a:t>这不是要执行的 Python 代码，而是故意构造的普通文本。x 占位置 0，后面的 /bin/env python 正好在位置 1，因此旧规则会误报为 Python。false positive 就是误报。Terry 提议把它加入长期测试，Kyubin 对早先 cefa669 版本做过独立验证。图中结果引用的是那次历史验证，不表示他已批准当前收窄版本。该反例未进入当前 14 项测试，永久回归测试暂缓。</a:t>
             </a:r>
             <a:endParaRPr/>
           </a:p>
@@ -1437,7 +1422,7 @@
               <a:buNone/>
             </a:pPr>
             <a:r>
-              <a:t>Observed results refer to Kyubin's separate content-only probe against original and fixed MIME registries. The permanent regression test remains proposed. The current fix already handles the probed input correctly.</a:t>
+              <a:t>These observed results refer only to Kyubin's earlier separate content-only probe on cefa669 and the original MIME registry. They are historical review evidence, not a fresh test or approval of the narrowed Python 3-only revision. The permanent regression test remains deferred.</a:t>
             </a:r>
             <a:endParaRPr/>
           </a:p>
@@ -1542,7 +1527,7 @@
               <a:buNone/>
             </a:pPr>
             <a:r>
-              <a:t>Contribution and assistance: Jiajun owns TIKA-4408. Codex assisted the implementation, testing, and presentation preparation. Kyubin supplied independent validation and review. Terry supplied additional review feedback. The visual template belongs to the group and was shared by Kyubin.</a:t>
+              <a:t>Contribution and assistance: Jiajun owns TIKA-4408. Codex assisted the implementation, testing, and presentation preparation. Kyubin supplied independent validation and review of the earlier version; the narrowed revision needs renewed human review. Terry supplied additional review feedback. The visual template belongs to the group and was shared by Kyubin.</a:t>
             </a:r>
             <a:endParaRPr/>
           </a:p>
@@ -1877,7 +1862,7 @@
               <a:buNone/>
             </a:pPr>
             <a:r>
-              <a:t>Contribution and assistance: Jiajun owns TIKA-4408. Codex assisted the implementation, testing, and presentation preparation. Kyubin supplied independent validation and review. Terry supplied additional review feedback. The visual template belongs to the group and was shared by Kyubin.</a:t>
+              <a:t>Contribution and assistance: Jiajun owns TIKA-4408. Codex assisted the implementation, testing, and presentation preparation. Kyubin supplied independent validation and review of the earlier version; the narrowed revision needs renewed human review. Terry supplied additional review feedback. The visual template belongs to the group and was shared by Kyubin.</a:t>
             </a:r>
             <a:endParaRPr/>
           </a:p>
@@ -1925,7 +1910,7 @@
           <p:cNvPr id="11" name="Google Shape;11;p2">
             <a:extLst xmlns:a="http://schemas.openxmlformats.org/drawingml/2006/main">
               <a:ext uri="{FF2B5EF4-FFF2-40B4-BE49-F238E27FC236}">
-                <a16:creationId xmlns:a16="http://schemas.microsoft.com/office/drawing/2014/main" id="{1992E541-0D25-4936-A0B1-A43AFC1DD9BF}"/>
+                <a16:creationId xmlns:a16="http://schemas.microsoft.com/office/drawing/2014/main" id="{0CF5E1AD-AD99-4F7A-90CC-2CE801AAF480}"/>
               </a:ext>
             </a:extLst>
           </p:cNvPr>
@@ -2062,7 +2047,7 @@
           <p:cNvPr id="12" name="Google Shape;12;p2">
             <a:extLst xmlns:a="http://schemas.openxmlformats.org/drawingml/2006/main">
               <a:ext uri="{FF2B5EF4-FFF2-40B4-BE49-F238E27FC236}">
-                <a16:creationId xmlns:a16="http://schemas.microsoft.com/office/drawing/2014/main" id="{37B1126E-E58C-4EF4-9BDB-88E28D6243A9}"/>
+                <a16:creationId xmlns:a16="http://schemas.microsoft.com/office/drawing/2014/main" id="{7DC7EA1D-32E4-4CC2-8EEC-E2E6FFAA8859}"/>
               </a:ext>
             </a:extLst>
           </p:cNvPr>
@@ -2216,7 +2201,7 @@
           <p:cNvPr id="15" name="Google Shape;15;p4">
             <a:extLst xmlns:a="http://schemas.openxmlformats.org/drawingml/2006/main">
               <a:ext uri="{FF2B5EF4-FFF2-40B4-BE49-F238E27FC236}">
-                <a16:creationId xmlns:a16="http://schemas.microsoft.com/office/drawing/2014/main" id="{9EAF2F38-64AB-45B9-997D-780B9A4E1770}"/>
+                <a16:creationId xmlns:a16="http://schemas.microsoft.com/office/drawing/2014/main" id="{E33E2926-912D-4F77-A9D9-D4DD398294FB}"/>
               </a:ext>
             </a:extLst>
           </p:cNvPr>
@@ -2353,7 +2338,7 @@
           <p:cNvPr id="16" name="Google Shape;16;p4">
             <a:extLst xmlns:a="http://schemas.openxmlformats.org/drawingml/2006/main">
               <a:ext uri="{FF2B5EF4-FFF2-40B4-BE49-F238E27FC236}">
-                <a16:creationId xmlns:a16="http://schemas.microsoft.com/office/drawing/2014/main" id="{55CBB7EB-7659-444F-BC52-0CEF45AD1438}"/>
+                <a16:creationId xmlns:a16="http://schemas.microsoft.com/office/drawing/2014/main" id="{4498C1E9-15DD-4DC6-8260-3C1DB6900880}"/>
               </a:ext>
             </a:extLst>
           </p:cNvPr>
@@ -2490,7 +2475,7 @@
           <p:cNvPr id="17" name="Google Shape;17;p4">
             <a:extLst xmlns:a="http://schemas.openxmlformats.org/drawingml/2006/main">
               <a:ext uri="{FF2B5EF4-FFF2-40B4-BE49-F238E27FC236}">
-                <a16:creationId xmlns:a16="http://schemas.microsoft.com/office/drawing/2014/main" id="{5697712A-8218-4063-BF58-86ACB9E40FC8}"/>
+                <a16:creationId xmlns:a16="http://schemas.microsoft.com/office/drawing/2014/main" id="{AC2DEB2E-F396-4D8D-B4C3-DFE2D6864C79}"/>
               </a:ext>
             </a:extLst>
           </p:cNvPr>
@@ -2644,7 +2629,7 @@
           <p:cNvPr id="19" name="Google Shape;19;p5">
             <a:extLst xmlns:a="http://schemas.openxmlformats.org/drawingml/2006/main">
               <a:ext uri="{FF2B5EF4-FFF2-40B4-BE49-F238E27FC236}">
-                <a16:creationId xmlns:a16="http://schemas.microsoft.com/office/drawing/2014/main" id="{59F09153-414A-4503-ADC2-18697F5935D5}"/>
+                <a16:creationId xmlns:a16="http://schemas.microsoft.com/office/drawing/2014/main" id="{9A25414B-A5D4-4652-B611-709154D431AB}"/>
               </a:ext>
             </a:extLst>
           </p:cNvPr>
@@ -2781,7 +2766,7 @@
           <p:cNvPr id="20" name="Google Shape;20;p5">
             <a:extLst xmlns:a="http://schemas.openxmlformats.org/drawingml/2006/main">
               <a:ext uri="{FF2B5EF4-FFF2-40B4-BE49-F238E27FC236}">
-                <a16:creationId xmlns:a16="http://schemas.microsoft.com/office/drawing/2014/main" id="{A6BDEF8E-C064-4C28-8B1A-25663DB179C3}"/>
+                <a16:creationId xmlns:a16="http://schemas.microsoft.com/office/drawing/2014/main" id="{F9971FB0-4910-4704-82FE-35A77DF8C572}"/>
               </a:ext>
             </a:extLst>
           </p:cNvPr>
@@ -2918,7 +2903,7 @@
           <p:cNvPr id="21" name="Google Shape;21;p5">
             <a:extLst xmlns:a="http://schemas.openxmlformats.org/drawingml/2006/main">
               <a:ext uri="{FF2B5EF4-FFF2-40B4-BE49-F238E27FC236}">
-                <a16:creationId xmlns:a16="http://schemas.microsoft.com/office/drawing/2014/main" id="{FCA70644-D7D5-482D-8B95-9F519EA862F6}"/>
+                <a16:creationId xmlns:a16="http://schemas.microsoft.com/office/drawing/2014/main" id="{C4807A8C-3A3A-49E2-AD60-51202A83C580}"/>
               </a:ext>
             </a:extLst>
           </p:cNvPr>
@@ -3072,7 +3057,7 @@
           <p:cNvPr id="23" name="Google Shape;23;p6">
             <a:extLst xmlns:a="http://schemas.openxmlformats.org/drawingml/2006/main">
               <a:ext uri="{FF2B5EF4-FFF2-40B4-BE49-F238E27FC236}">
-                <a16:creationId xmlns:a16="http://schemas.microsoft.com/office/drawing/2014/main" id="{BF0E52CF-15AE-4F3D-AF79-48AE4BCA3E23}"/>
+                <a16:creationId xmlns:a16="http://schemas.microsoft.com/office/drawing/2014/main" id="{E940F8E1-F24D-4A83-9589-5AEA59DADB68}"/>
               </a:ext>
             </a:extLst>
           </p:cNvPr>
@@ -3209,7 +3194,7 @@
           <p:cNvPr id="24" name="Google Shape;24;p6">
             <a:extLst xmlns:a="http://schemas.openxmlformats.org/drawingml/2006/main">
               <a:ext uri="{FF2B5EF4-FFF2-40B4-BE49-F238E27FC236}">
-                <a16:creationId xmlns:a16="http://schemas.microsoft.com/office/drawing/2014/main" id="{3434EC93-637F-4C9E-AF86-5D72F81578C5}"/>
+                <a16:creationId xmlns:a16="http://schemas.microsoft.com/office/drawing/2014/main" id="{CD668096-E874-4C8A-BF2F-24946C6C645D}"/>
               </a:ext>
             </a:extLst>
           </p:cNvPr>
@@ -3363,7 +3348,7 @@
           <p:cNvPr id="26" name="Google Shape;26;p7">
             <a:extLst xmlns:a="http://schemas.openxmlformats.org/drawingml/2006/main">
               <a:ext uri="{FF2B5EF4-FFF2-40B4-BE49-F238E27FC236}">
-                <a16:creationId xmlns:a16="http://schemas.microsoft.com/office/drawing/2014/main" id="{8471C678-2670-406A-9D52-DA13499A09BF}"/>
+                <a16:creationId xmlns:a16="http://schemas.microsoft.com/office/drawing/2014/main" id="{919CC0DE-ABAD-4C7E-8B7F-3B7045C154C9}"/>
               </a:ext>
             </a:extLst>
           </p:cNvPr>
@@ -3500,7 +3485,7 @@
           <p:cNvPr id="27" name="Google Shape;27;p7">
             <a:extLst xmlns:a="http://schemas.openxmlformats.org/drawingml/2006/main">
               <a:ext uri="{FF2B5EF4-FFF2-40B4-BE49-F238E27FC236}">
-                <a16:creationId xmlns:a16="http://schemas.microsoft.com/office/drawing/2014/main" id="{DF74C6FF-BC5C-4755-9418-E134F02A7E3C}"/>
+                <a16:creationId xmlns:a16="http://schemas.microsoft.com/office/drawing/2014/main" id="{088D7DD5-D341-49E7-A5F9-F318A8E1207B}"/>
               </a:ext>
             </a:extLst>
           </p:cNvPr>
@@ -3660,7 +3645,7 @@
   </p:cSld>
   <p:clrMap bg1="lt1" tx1="dk1" bg2="dk2" tx2="lt2" accent1="accent1" accent2="accent2" accent3="accent3" accent4="accent4" accent5="accent5" accent6="accent6" hlink="hlink" folHlink="folHlink"/>
   <p:sldLayoutIdLst>
-    <p:sldLayoutId xmlns:r="http://schemas.openxmlformats.org/officeDocument/2006/relationships" id="2147483649" r:id="R9a7c1aa3ab3a461f"/>
+    <p:sldLayoutId xmlns:r="http://schemas.openxmlformats.org/officeDocument/2006/relationships" id="2147483649" r:id="R68e20a153dfd44ca"/>
   </p:sldLayoutIdLst>
   <p:hf sldNum="0" hdr="0" ftr="0" dt="0"/>
   <p:txStyles>
@@ -4345,10 +4330,10 @@
   </p:cSld>
   <p:clrMap bg1="lt1" tx1="dk1" bg2="dk2" tx2="lt2" accent1="accent1" accent2="accent2" accent3="accent3" accent4="accent4" accent5="accent5" accent6="accent6" hlink="hlink" folHlink="folHlink"/>
   <p:sldLayoutIdLst>
-    <p:sldLayoutId xmlns:r="http://schemas.openxmlformats.org/officeDocument/2006/relationships" id="2147483651" r:id="R7896200c8a1548a0"/>
-    <p:sldLayoutId xmlns:r="http://schemas.openxmlformats.org/officeDocument/2006/relationships" id="2147483652" r:id="R003723175f0742cb"/>
-    <p:sldLayoutId xmlns:r="http://schemas.openxmlformats.org/officeDocument/2006/relationships" id="2147483653" r:id="R640273a3503048c0"/>
-    <p:sldLayoutId xmlns:r="http://schemas.openxmlformats.org/officeDocument/2006/relationships" id="2147483654" r:id="Rcd72772904c04b9d"/>
+    <p:sldLayoutId xmlns:r="http://schemas.openxmlformats.org/officeDocument/2006/relationships" id="2147483651" r:id="Rc461ede2a7774f10"/>
+    <p:sldLayoutId xmlns:r="http://schemas.openxmlformats.org/officeDocument/2006/relationships" id="2147483652" r:id="Rb75320dbc4894863"/>
+    <p:sldLayoutId xmlns:r="http://schemas.openxmlformats.org/officeDocument/2006/relationships" id="2147483653" r:id="R24cf339b31294936"/>
+    <p:sldLayoutId xmlns:r="http://schemas.openxmlformats.org/officeDocument/2006/relationships" id="2147483654" r:id="R0c13650087024d51"/>
   </p:sldLayoutIdLst>
   <p:hf sldNum="0" hdr="0" ftr="0" dt="0"/>
   <p:txStyles>
@@ -5570,7 +5555,7 @@
           <p:cNvPr id="42" name="Google Shape;42;p9">
             <a:extLst xmlns:a="http://schemas.openxmlformats.org/drawingml/2006/main">
               <a:ext uri="{FF2B5EF4-FFF2-40B4-BE49-F238E27FC236}">
-                <a16:creationId xmlns:a16="http://schemas.microsoft.com/office/drawing/2014/main" id="{C1340FE7-B61F-41F0-A116-925E50319B7C}"/>
+                <a16:creationId xmlns:a16="http://schemas.microsoft.com/office/drawing/2014/main" id="{DFE48758-14A9-44C0-A2CC-836A15F68535}"/>
               </a:ext>
             </a:extLst>
           </p:cNvPr>
@@ -5621,7 +5606,7 @@
           <p:cNvPr id="43" name="Google Shape;43;p9">
             <a:extLst xmlns:a="http://schemas.openxmlformats.org/drawingml/2006/main">
               <a:ext uri="{FF2B5EF4-FFF2-40B4-BE49-F238E27FC236}">
-                <a16:creationId xmlns:a16="http://schemas.microsoft.com/office/drawing/2014/main" id="{DFBAAEE3-A132-436E-9D22-08B27C35CD00}"/>
+                <a16:creationId xmlns:a16="http://schemas.microsoft.com/office/drawing/2014/main" id="{5986D919-E229-4ABA-96CD-001E2F2E8546}"/>
               </a:ext>
             </a:extLst>
           </p:cNvPr>
@@ -5685,7 +5670,7 @@
           <p:cNvPr id="44" name="Google Shape;44;p9">
             <a:extLst xmlns:a="http://schemas.openxmlformats.org/drawingml/2006/main">
               <a:ext uri="{FF2B5EF4-FFF2-40B4-BE49-F238E27FC236}">
-                <a16:creationId xmlns:a16="http://schemas.microsoft.com/office/drawing/2014/main" id="{6073055B-66AA-4AC5-841A-797957109C9A}"/>
+                <a16:creationId xmlns:a16="http://schemas.microsoft.com/office/drawing/2014/main" id="{FBB1A3B3-2DA4-489E-8EFB-017BA1B25CE4}"/>
               </a:ext>
             </a:extLst>
           </p:cNvPr>
@@ -5749,7 +5734,7 @@
           <p:cNvPr id="45" name="Google Shape;45;p9">
             <a:extLst xmlns:a="http://schemas.openxmlformats.org/drawingml/2006/main">
               <a:ext uri="{FF2B5EF4-FFF2-40B4-BE49-F238E27FC236}">
-                <a16:creationId xmlns:a16="http://schemas.microsoft.com/office/drawing/2014/main" id="{A9C7B549-6AAC-417E-BC30-3CA6964C4B46}"/>
+                <a16:creationId xmlns:a16="http://schemas.microsoft.com/office/drawing/2014/main" id="{2309D870-D76B-445E-BE76-8749D84DDF9F}"/>
               </a:ext>
             </a:extLst>
           </p:cNvPr>
@@ -5847,7 +5832,7 @@
           <p:cNvPr id="46" name="Google Shape;46;p9">
             <a:extLst xmlns:a="http://schemas.openxmlformats.org/drawingml/2006/main">
               <a:ext uri="{FF2B5EF4-FFF2-40B4-BE49-F238E27FC236}">
-                <a16:creationId xmlns:a16="http://schemas.microsoft.com/office/drawing/2014/main" id="{E57E1CAC-9BC7-43EC-92C5-7741A4537BC1}"/>
+                <a16:creationId xmlns:a16="http://schemas.microsoft.com/office/drawing/2014/main" id="{299F6F40-C40A-4490-81A8-D1EA28D49980}"/>
               </a:ext>
             </a:extLst>
           </p:cNvPr>
@@ -5911,7 +5896,7 @@
           <p:cNvPr id="47" name="Google Shape;47;p9">
             <a:extLst xmlns:a="http://schemas.openxmlformats.org/drawingml/2006/main">
               <a:ext uri="{FF2B5EF4-FFF2-40B4-BE49-F238E27FC236}">
-                <a16:creationId xmlns:a16="http://schemas.microsoft.com/office/drawing/2014/main" id="{191B553B-F88A-44D5-986D-1DE7A551EDDC}"/>
+                <a16:creationId xmlns:a16="http://schemas.microsoft.com/office/drawing/2014/main" id="{9C9B5724-1456-4814-9E5D-A225757015F4}"/>
               </a:ext>
             </a:extLst>
           </p:cNvPr>
@@ -6007,7 +5992,7 @@
           <p:cNvPr id="48" name="Google Shape;48;p9">
             <a:extLst xmlns:a="http://schemas.openxmlformats.org/drawingml/2006/main">
               <a:ext uri="{FF2B5EF4-FFF2-40B4-BE49-F238E27FC236}">
-                <a16:creationId xmlns:a16="http://schemas.microsoft.com/office/drawing/2014/main" id="{8C37168D-6927-438E-AB48-D40BF8862705}"/>
+                <a16:creationId xmlns:a16="http://schemas.microsoft.com/office/drawing/2014/main" id="{2D339E40-78FD-49E0-A147-4B915366E107}"/>
               </a:ext>
             </a:extLst>
           </p:cNvPr>
@@ -6103,7 +6088,7 @@
           <p:cNvPr id="49" name="Google Shape;49;p9">
             <a:extLst xmlns:a="http://schemas.openxmlformats.org/drawingml/2006/main">
               <a:ext uri="{FF2B5EF4-FFF2-40B4-BE49-F238E27FC236}">
-                <a16:creationId xmlns:a16="http://schemas.microsoft.com/office/drawing/2014/main" id="{CFFD0363-3CA8-4E8D-BC5A-667442094B37}"/>
+                <a16:creationId xmlns:a16="http://schemas.microsoft.com/office/drawing/2014/main" id="{FA08A004-7705-4E49-86B0-E8A3E12601BA}"/>
               </a:ext>
             </a:extLst>
           </p:cNvPr>
@@ -6298,7 +6283,7 @@
           <p:cNvPr id="50" name="Google Shape;50;p9">
             <a:extLst xmlns:a="http://schemas.openxmlformats.org/drawingml/2006/main">
               <a:ext uri="{FF2B5EF4-FFF2-40B4-BE49-F238E27FC236}">
-                <a16:creationId xmlns:a16="http://schemas.microsoft.com/office/drawing/2014/main" id="{19CC6346-043C-4C88-BB39-64BC8D1DEEF0}"/>
+                <a16:creationId xmlns:a16="http://schemas.microsoft.com/office/drawing/2014/main" id="{D4E8937C-10F5-4DAF-B7D2-7757E2EDA0AF}"/>
               </a:ext>
             </a:extLst>
           </p:cNvPr>
@@ -6473,7 +6458,7 @@
           <p:cNvPr id="51" name="Google Shape;51;p9">
             <a:extLst xmlns:a="http://schemas.openxmlformats.org/drawingml/2006/main">
               <a:ext uri="{FF2B5EF4-FFF2-40B4-BE49-F238E27FC236}">
-                <a16:creationId xmlns:a16="http://schemas.microsoft.com/office/drawing/2014/main" id="{83BADD35-9E46-4E83-8266-1B7177A0C4CF}"/>
+                <a16:creationId xmlns:a16="http://schemas.microsoft.com/office/drawing/2014/main" id="{FC2F51B2-E2A8-4C51-976A-9286CEBFE1BD}"/>
               </a:ext>
             </a:extLst>
           </p:cNvPr>
@@ -6595,7 +6580,7 @@
                 <a:ea typeface="Roboto Mono"/>
                 <a:cs typeface="Roboto Mono"/>
               </a:rPr>
-              <a:t>#!/usr/bin/env python</a:t>
+              <a:t>#!/usr/bin/env python3</a:t>
             </a:r>
             <a:endParaRPr sz="2200">
               <a:solidFill>
@@ -6648,7 +6633,7 @@
           <p:cNvPr id="52" name="Google Shape;52;p9">
             <a:extLst xmlns:a="http://schemas.openxmlformats.org/drawingml/2006/main">
               <a:ext uri="{FF2B5EF4-FFF2-40B4-BE49-F238E27FC236}">
-                <a16:creationId xmlns:a16="http://schemas.microsoft.com/office/drawing/2014/main" id="{CC8605B5-D1D1-4293-8306-D137143565D5}"/>
+                <a16:creationId xmlns:a16="http://schemas.microsoft.com/office/drawing/2014/main" id="{4343A830-9923-4DE0-8366-FDCD02F0FBA8}"/>
               </a:ext>
             </a:extLst>
           </p:cNvPr>
@@ -6788,7 +6773,7 @@
           <p:cNvPr id="53" name="Google Shape;53;p9">
             <a:extLst xmlns:a="http://schemas.openxmlformats.org/drawingml/2006/main">
               <a:ext uri="{FF2B5EF4-FFF2-40B4-BE49-F238E27FC236}">
-                <a16:creationId xmlns:a16="http://schemas.microsoft.com/office/drawing/2014/main" id="{5B17C138-3530-430F-9552-64D06802E843}"/>
+                <a16:creationId xmlns:a16="http://schemas.microsoft.com/office/drawing/2014/main" id="{1B8336E6-0542-4A7F-9852-13AE4656980E}"/>
               </a:ext>
             </a:extLst>
           </p:cNvPr>
@@ -6928,7 +6913,7 @@
           <p:cNvPr id="54" name="Google Shape;54;p9">
             <a:extLst xmlns:a="http://schemas.openxmlformats.org/drawingml/2006/main">
               <a:ext uri="{FF2B5EF4-FFF2-40B4-BE49-F238E27FC236}">
-                <a16:creationId xmlns:a16="http://schemas.microsoft.com/office/drawing/2014/main" id="{A3E23A32-8612-4039-98B3-E1AB2E225B98}"/>
+                <a16:creationId xmlns:a16="http://schemas.microsoft.com/office/drawing/2014/main" id="{B2F3B98C-85E9-435E-BF31-287C6A2D2F57}"/>
               </a:ext>
             </a:extLst>
           </p:cNvPr>
@@ -7101,7 +7086,7 @@
           <p:cNvPr id="55" name="cause-takeaway">
             <a:extLst xmlns:a="http://schemas.openxmlformats.org/drawingml/2006/main">
               <a:ext uri="{FF2B5EF4-FFF2-40B4-BE49-F238E27FC236}">
-                <a16:creationId xmlns:a16="http://schemas.microsoft.com/office/drawing/2014/main" id="{A65D76B2-A3C4-47E2-84CD-34CCADD80579}"/>
+                <a16:creationId xmlns:a16="http://schemas.microsoft.com/office/drawing/2014/main" id="{EB5656FF-A0E4-447E-BD86-770EFDC39EFC}"/>
               </a:ext>
             </a:extLst>
           </p:cNvPr>
@@ -7249,7 +7234,7 @@
                 <a:ea typeface="Manrope"/>
                 <a:cs typeface="Manrope"/>
               </a:rPr>
-              <a:t>The challenge was tracing which detection rule matched, and why.</a:t>
+              <a:t>Scope: no-space python3 prefix; python3.11 is also covered.</a:t>
             </a:r>
           </a:p>
         </p:txBody>
@@ -7257,7 +7242,7 @@
     </p:spTree>
     <p:extLst>
       <p:ext uri="{BB962C8B-B14F-4D97-AF65-F5344CB8AC3E}">
-        <p14:creationId xmlns:p14="http://schemas.microsoft.com/office/powerpoint/2010/main" val="1680951504"/>
+        <p14:creationId xmlns:p14="http://schemas.microsoft.com/office/powerpoint/2010/main" val="263949053"/>
       </p:ext>
     </p:extLst>
   </p:cSld>
@@ -7288,7 +7273,7 @@
           <p:cNvPr id="77" name="Google Shape;77;p11">
             <a:extLst xmlns:a="http://schemas.openxmlformats.org/drawingml/2006/main">
               <a:ext uri="{FF2B5EF4-FFF2-40B4-BE49-F238E27FC236}">
-                <a16:creationId xmlns:a16="http://schemas.microsoft.com/office/drawing/2014/main" id="{BFFB46ED-80CE-4967-BE50-1A7E4044B174}"/>
+                <a16:creationId xmlns:a16="http://schemas.microsoft.com/office/drawing/2014/main" id="{85B4C56A-0F69-420B-ADE7-0E3EBAF2A874}"/>
               </a:ext>
             </a:extLst>
           </p:cNvPr>
@@ -7352,7 +7337,7 @@
           <p:cNvPr id="78" name="Google Shape;78;p11">
             <a:extLst xmlns:a="http://schemas.openxmlformats.org/drawingml/2006/main">
               <a:ext uri="{FF2B5EF4-FFF2-40B4-BE49-F238E27FC236}">
-                <a16:creationId xmlns:a16="http://schemas.microsoft.com/office/drawing/2014/main" id="{4F547F1B-07C7-4334-855E-F7347EAB298C}"/>
+                <a16:creationId xmlns:a16="http://schemas.microsoft.com/office/drawing/2014/main" id="{6D1021EB-F500-4DF7-9169-55BA2B49232D}"/>
               </a:ext>
             </a:extLst>
           </p:cNvPr>
@@ -7416,7 +7401,7 @@
           <p:cNvPr id="79" name="Google Shape;79;p11">
             <a:extLst xmlns:a="http://schemas.openxmlformats.org/drawingml/2006/main">
               <a:ext uri="{FF2B5EF4-FFF2-40B4-BE49-F238E27FC236}">
-                <a16:creationId xmlns:a16="http://schemas.microsoft.com/office/drawing/2014/main" id="{D8C37912-345D-412E-980D-DD51CD273976}"/>
+                <a16:creationId xmlns:a16="http://schemas.microsoft.com/office/drawing/2014/main" id="{F4F76437-5963-4990-908B-6E8A970AF7D9}"/>
               </a:ext>
             </a:extLst>
           </p:cNvPr>
@@ -7514,7 +7499,7 @@
           <p:cNvPr id="80" name="Google Shape;80;p11">
             <a:extLst xmlns:a="http://schemas.openxmlformats.org/drawingml/2006/main">
               <a:ext uri="{FF2B5EF4-FFF2-40B4-BE49-F238E27FC236}">
-                <a16:creationId xmlns:a16="http://schemas.microsoft.com/office/drawing/2014/main" id="{E80A6EAA-E288-4677-80CA-10F201D90F7F}"/>
+                <a16:creationId xmlns:a16="http://schemas.microsoft.com/office/drawing/2014/main" id="{E2F3BB4C-1A6B-435F-80B9-A3E318254DCC}"/>
               </a:ext>
             </a:extLst>
           </p:cNvPr>
@@ -7578,7 +7563,7 @@
           <p:cNvPr id="81" name="Google Shape;81;p11">
             <a:extLst xmlns:a="http://schemas.openxmlformats.org/drawingml/2006/main">
               <a:ext uri="{FF2B5EF4-FFF2-40B4-BE49-F238E27FC236}">
-                <a16:creationId xmlns:a16="http://schemas.microsoft.com/office/drawing/2014/main" id="{7A0ADB32-8CB8-43A1-91EF-3D8C5F6C7CD2}"/>
+                <a16:creationId xmlns:a16="http://schemas.microsoft.com/office/drawing/2014/main" id="{EEDBB18F-9A0C-4EDE-9B17-B1D2EF44F85E}"/>
               </a:ext>
             </a:extLst>
           </p:cNvPr>
@@ -7642,7 +7627,7 @@
           <p:cNvPr id="82" name="Google Shape;82;p11">
             <a:extLst xmlns:a="http://schemas.openxmlformats.org/drawingml/2006/main">
               <a:ext uri="{FF2B5EF4-FFF2-40B4-BE49-F238E27FC236}">
-                <a16:creationId xmlns:a16="http://schemas.microsoft.com/office/drawing/2014/main" id="{91C40E41-CFD6-43E0-B9CB-F225F04E37A9}"/>
+                <a16:creationId xmlns:a16="http://schemas.microsoft.com/office/drawing/2014/main" id="{D2D7D429-E746-4778-86E7-CCEB99DC4F9E}"/>
               </a:ext>
             </a:extLst>
           </p:cNvPr>
@@ -7706,7 +7691,7 @@
           <p:cNvPr id="83" name="Google Shape;83;p11">
             <a:extLst xmlns:a="http://schemas.openxmlformats.org/drawingml/2006/main">
               <a:ext uri="{FF2B5EF4-FFF2-40B4-BE49-F238E27FC236}">
-                <a16:creationId xmlns:a16="http://schemas.microsoft.com/office/drawing/2014/main" id="{090ABDF0-E7EE-4D30-9468-B62BD5EC0841}"/>
+                <a16:creationId xmlns:a16="http://schemas.microsoft.com/office/drawing/2014/main" id="{77E09756-5E2B-460C-9132-93A24F74064F}"/>
               </a:ext>
             </a:extLst>
           </p:cNvPr>
@@ -7881,7 +7866,7 @@
           <p:cNvPr id="84" name="Google Shape;84;p11">
             <a:extLst xmlns:a="http://schemas.openxmlformats.org/drawingml/2006/main">
               <a:ext uri="{FF2B5EF4-FFF2-40B4-BE49-F238E27FC236}">
-                <a16:creationId xmlns:a16="http://schemas.microsoft.com/office/drawing/2014/main" id="{0EAB67C9-729F-45B7-8354-1BEC3D8B9817}"/>
+                <a16:creationId xmlns:a16="http://schemas.microsoft.com/office/drawing/2014/main" id="{D4A5914B-0218-4B8E-9E2E-EA6BD86A48FB}"/>
               </a:ext>
             </a:extLst>
           </p:cNvPr>
@@ -7945,7 +7930,7 @@
           <p:cNvPr id="85" name="Google Shape;85;p11">
             <a:extLst xmlns:a="http://schemas.openxmlformats.org/drawingml/2006/main">
               <a:ext uri="{FF2B5EF4-FFF2-40B4-BE49-F238E27FC236}">
-                <a16:creationId xmlns:a16="http://schemas.microsoft.com/office/drawing/2014/main" id="{7872E774-C705-4431-89B2-257C771B4C47}"/>
+                <a16:creationId xmlns:a16="http://schemas.microsoft.com/office/drawing/2014/main" id="{38297A2C-1C72-4F50-A6FC-13FA3E49E66D}"/>
               </a:ext>
             </a:extLst>
           </p:cNvPr>
@@ -8009,7 +7994,7 @@
           <p:cNvPr id="86" name="Google Shape;86;p11">
             <a:extLst xmlns:a="http://schemas.openxmlformats.org/drawingml/2006/main">
               <a:ext uri="{FF2B5EF4-FFF2-40B4-BE49-F238E27FC236}">
-                <a16:creationId xmlns:a16="http://schemas.microsoft.com/office/drawing/2014/main" id="{2CA38638-F1D0-4CE5-A12E-E40F9FDD339F}"/>
+                <a16:creationId xmlns:a16="http://schemas.microsoft.com/office/drawing/2014/main" id="{C9220618-1408-4C33-B304-16BA6BE95639}"/>
               </a:ext>
             </a:extLst>
           </p:cNvPr>
@@ -8184,7 +8169,7 @@
           <p:cNvPr id="87" name="Google Shape;87;p11">
             <a:extLst xmlns:a="http://schemas.openxmlformats.org/drawingml/2006/main">
               <a:ext uri="{FF2B5EF4-FFF2-40B4-BE49-F238E27FC236}">
-                <a16:creationId xmlns:a16="http://schemas.microsoft.com/office/drawing/2014/main" id="{06448C92-2418-4982-B7E5-C8DC977E27CC}"/>
+                <a16:creationId xmlns:a16="http://schemas.microsoft.com/office/drawing/2014/main" id="{177D11EB-CCA6-40BA-8845-0001869CD58F}"/>
               </a:ext>
             </a:extLst>
           </p:cNvPr>
@@ -8248,7 +8233,7 @@
           <p:cNvPr id="88" name="Google Shape;88;p11">
             <a:extLst xmlns:a="http://schemas.openxmlformats.org/drawingml/2006/main">
               <a:ext uri="{FF2B5EF4-FFF2-40B4-BE49-F238E27FC236}">
-                <a16:creationId xmlns:a16="http://schemas.microsoft.com/office/drawing/2014/main" id="{9B2D947C-DE19-451B-93F0-EB3077165569}"/>
+                <a16:creationId xmlns:a16="http://schemas.microsoft.com/office/drawing/2014/main" id="{C29F6DDA-1872-4E6C-82C7-F1FFB3791F50}"/>
               </a:ext>
             </a:extLst>
           </p:cNvPr>
@@ -8326,7 +8311,7 @@
                 <a:ea typeface="Manrope"/>
                 <a:cs typeface="Manrope"/>
               </a:rPr>
-              <a:t>Same 18 focused checks: 7 failures before, 0 after</a:t>
+              <a:t>Same 14 focused checks: 4 failures before, 0 after</a:t>
             </a:r>
             <a:endParaRPr sz="2400" b="1">
               <a:solidFill>
@@ -8344,7 +8329,7 @@
           <p:cNvPr id="89" name="Google Shape;89;p11">
             <a:extLst xmlns:a="http://schemas.openxmlformats.org/drawingml/2006/main">
               <a:ext uri="{FF2B5EF4-FFF2-40B4-BE49-F238E27FC236}">
-                <a16:creationId xmlns:a16="http://schemas.microsoft.com/office/drawing/2014/main" id="{E17AA8AE-636C-4366-BC59-D9E54291B3F2}"/>
+                <a16:creationId xmlns:a16="http://schemas.microsoft.com/office/drawing/2014/main" id="{03595C2E-E22E-485E-9381-AA659690AAB1}"/>
               </a:ext>
             </a:extLst>
           </p:cNvPr>
@@ -8466,7 +8451,7 @@
                 <a:ea typeface="Manrope"/>
                 <a:cs typeface="Manrope"/>
               </a:rPr>
-              <a:t>All 18 passed after the fix. These are local results.</a:t>
+              <a:t>All 14 passed after the fix. These are local results.</a:t>
             </a:r>
             <a:endParaRPr sz="1900">
               <a:solidFill>
@@ -8517,7 +8502,7 @@
     </p:spTree>
     <p:extLst>
       <p:ext uri="{BB962C8B-B14F-4D97-AF65-F5344CB8AC3E}">
-        <p14:creationId xmlns:p14="http://schemas.microsoft.com/office/powerpoint/2010/main" val="2084517141"/>
+        <p14:creationId xmlns:p14="http://schemas.microsoft.com/office/powerpoint/2010/main" val="307552279"/>
       </p:ext>
     </p:extLst>
   </p:cSld>
@@ -8548,7 +8533,7 @@
           <p:cNvPr id="42" name="Google Shape;42;p9">
             <a:extLst xmlns:a="http://schemas.openxmlformats.org/drawingml/2006/main">
               <a:ext uri="{FF2B5EF4-FFF2-40B4-BE49-F238E27FC236}">
-                <a16:creationId xmlns:a16="http://schemas.microsoft.com/office/drawing/2014/main" id="{C1340FE7-B61F-41F0-A116-925E50319B7C}"/>
+                <a16:creationId xmlns:a16="http://schemas.microsoft.com/office/drawing/2014/main" id="{DFE48758-14A9-44C0-A2CC-836A15F68535}"/>
               </a:ext>
             </a:extLst>
           </p:cNvPr>
@@ -8599,7 +8584,7 @@
           <p:cNvPr id="43" name="Google Shape;43;p9">
             <a:extLst xmlns:a="http://schemas.openxmlformats.org/drawingml/2006/main">
               <a:ext uri="{FF2B5EF4-FFF2-40B4-BE49-F238E27FC236}">
-                <a16:creationId xmlns:a16="http://schemas.microsoft.com/office/drawing/2014/main" id="{DFBAAEE3-A132-436E-9D22-08B27C35CD00}"/>
+                <a16:creationId xmlns:a16="http://schemas.microsoft.com/office/drawing/2014/main" id="{5986D919-E229-4ABA-96CD-001E2F2E8546}"/>
               </a:ext>
             </a:extLst>
           </p:cNvPr>
@@ -8663,7 +8648,7 @@
           <p:cNvPr id="44" name="Google Shape;44;p9">
             <a:extLst xmlns:a="http://schemas.openxmlformats.org/drawingml/2006/main">
               <a:ext uri="{FF2B5EF4-FFF2-40B4-BE49-F238E27FC236}">
-                <a16:creationId xmlns:a16="http://schemas.microsoft.com/office/drawing/2014/main" id="{6073055B-66AA-4AC5-841A-797957109C9A}"/>
+                <a16:creationId xmlns:a16="http://schemas.microsoft.com/office/drawing/2014/main" id="{FBB1A3B3-2DA4-489E-8EFB-017BA1B25CE4}"/>
               </a:ext>
             </a:extLst>
           </p:cNvPr>
@@ -8727,7 +8712,7 @@
           <p:cNvPr id="45" name="Google Shape;45;p9">
             <a:extLst xmlns:a="http://schemas.openxmlformats.org/drawingml/2006/main">
               <a:ext uri="{FF2B5EF4-FFF2-40B4-BE49-F238E27FC236}">
-                <a16:creationId xmlns:a16="http://schemas.microsoft.com/office/drawing/2014/main" id="{A9C7B549-6AAC-417E-BC30-3CA6964C4B46}"/>
+                <a16:creationId xmlns:a16="http://schemas.microsoft.com/office/drawing/2014/main" id="{2309D870-D76B-445E-BE76-8749D84DDF9F}"/>
               </a:ext>
             </a:extLst>
           </p:cNvPr>
@@ -8825,7 +8810,7 @@
           <p:cNvPr id="46" name="Google Shape;46;p9">
             <a:extLst xmlns:a="http://schemas.openxmlformats.org/drawingml/2006/main">
               <a:ext uri="{FF2B5EF4-FFF2-40B4-BE49-F238E27FC236}">
-                <a16:creationId xmlns:a16="http://schemas.microsoft.com/office/drawing/2014/main" id="{E57E1CAC-9BC7-43EC-92C5-7741A4537BC1}"/>
+                <a16:creationId xmlns:a16="http://schemas.microsoft.com/office/drawing/2014/main" id="{299F6F40-C40A-4490-81A8-D1EA28D49980}"/>
               </a:ext>
             </a:extLst>
           </p:cNvPr>
@@ -8889,7 +8874,7 @@
           <p:cNvPr id="47" name="Google Shape;47;p9">
             <a:extLst xmlns:a="http://schemas.openxmlformats.org/drawingml/2006/main">
               <a:ext uri="{FF2B5EF4-FFF2-40B4-BE49-F238E27FC236}">
-                <a16:creationId xmlns:a16="http://schemas.microsoft.com/office/drawing/2014/main" id="{191B553B-F88A-44D5-986D-1DE7A551EDDC}"/>
+                <a16:creationId xmlns:a16="http://schemas.microsoft.com/office/drawing/2014/main" id="{9C9B5724-1456-4814-9E5D-A225757015F4}"/>
               </a:ext>
             </a:extLst>
           </p:cNvPr>
@@ -8985,7 +8970,7 @@
           <p:cNvPr id="48" name="Google Shape;48;p9">
             <a:extLst xmlns:a="http://schemas.openxmlformats.org/drawingml/2006/main">
               <a:ext uri="{FF2B5EF4-FFF2-40B4-BE49-F238E27FC236}">
-                <a16:creationId xmlns:a16="http://schemas.microsoft.com/office/drawing/2014/main" id="{8C37168D-6927-438E-AB48-D40BF8862705}"/>
+                <a16:creationId xmlns:a16="http://schemas.microsoft.com/office/drawing/2014/main" id="{2D339E40-78FD-49E0-A147-4B915366E107}"/>
               </a:ext>
             </a:extLst>
           </p:cNvPr>
@@ -9063,7 +9048,7 @@
                 <a:ea typeface="Manrope"/>
                 <a:cs typeface="Manrope"/>
               </a:rPr>
-              <a:t>FIXED RULE: FILE-START CHECK</a:t>
+              <a:t>EARLIER FIX: FILE-START CHECK</a:t>
             </a:r>
             <a:endParaRPr sz="1200" b="1">
               <a:solidFill>
@@ -9081,7 +9066,7 @@
           <p:cNvPr id="49" name="Google Shape;49;p9">
             <a:extLst xmlns:a="http://schemas.openxmlformats.org/drawingml/2006/main">
               <a:ext uri="{FF2B5EF4-FFF2-40B4-BE49-F238E27FC236}">
-                <a16:creationId xmlns:a16="http://schemas.microsoft.com/office/drawing/2014/main" id="{CFFD0363-3CA8-4E8D-BC5A-667442094B37}"/>
+                <a16:creationId xmlns:a16="http://schemas.microsoft.com/office/drawing/2014/main" id="{FA08A004-7705-4E49-86B0-E8A3E12601BA}"/>
               </a:ext>
             </a:extLst>
           </p:cNvPr>
@@ -9265,7 +9250,7 @@
           <p:cNvPr id="50" name="Google Shape;50;p9">
             <a:extLst xmlns:a="http://schemas.openxmlformats.org/drawingml/2006/main">
               <a:ext uri="{FF2B5EF4-FFF2-40B4-BE49-F238E27FC236}">
-                <a16:creationId xmlns:a16="http://schemas.microsoft.com/office/drawing/2014/main" id="{19CC6346-043C-4C88-BB39-64BC8D1DEEF0}"/>
+                <a16:creationId xmlns:a16="http://schemas.microsoft.com/office/drawing/2014/main" id="{D4E8937C-10F5-4DAF-B7D2-7757E2EDA0AF}"/>
               </a:ext>
             </a:extLst>
           </p:cNvPr>
@@ -9440,7 +9425,7 @@
           <p:cNvPr id="51" name="Google Shape;51;p9">
             <a:extLst xmlns:a="http://schemas.openxmlformats.org/drawingml/2006/main">
               <a:ext uri="{FF2B5EF4-FFF2-40B4-BE49-F238E27FC236}">
-                <a16:creationId xmlns:a16="http://schemas.microsoft.com/office/drawing/2014/main" id="{83BADD35-9E46-4E83-8266-1B7177A0C4CF}"/>
+                <a16:creationId xmlns:a16="http://schemas.microsoft.com/office/drawing/2014/main" id="{FC2F51B2-E2A8-4C51-976A-9286CEBFE1BD}"/>
               </a:ext>
             </a:extLst>
           </p:cNvPr>
@@ -9615,7 +9600,7 @@
           <p:cNvPr id="52" name="Google Shape;52;p9">
             <a:extLst xmlns:a="http://schemas.openxmlformats.org/drawingml/2006/main">
               <a:ext uri="{FF2B5EF4-FFF2-40B4-BE49-F238E27FC236}">
-                <a16:creationId xmlns:a16="http://schemas.microsoft.com/office/drawing/2014/main" id="{CC8605B5-D1D1-4293-8306-D137143565D5}"/>
+                <a16:creationId xmlns:a16="http://schemas.microsoft.com/office/drawing/2014/main" id="{4343A830-9923-4DE0-8366-FDCD02F0FBA8}"/>
               </a:ext>
             </a:extLst>
           </p:cNvPr>
@@ -9755,7 +9740,7 @@
           <p:cNvPr id="53" name="Google Shape;53;p9">
             <a:extLst xmlns:a="http://schemas.openxmlformats.org/drawingml/2006/main">
               <a:ext uri="{FF2B5EF4-FFF2-40B4-BE49-F238E27FC236}">
-                <a16:creationId xmlns:a16="http://schemas.microsoft.com/office/drawing/2014/main" id="{5B17C138-3530-430F-9552-64D06802E843}"/>
+                <a16:creationId xmlns:a16="http://schemas.microsoft.com/office/drawing/2014/main" id="{1B8336E6-0542-4A7F-9852-13AE4656980E}"/>
               </a:ext>
             </a:extLst>
           </p:cNvPr>
@@ -9895,7 +9880,7 @@
           <p:cNvPr id="54" name="Google Shape;54;p9">
             <a:extLst xmlns:a="http://schemas.openxmlformats.org/drawingml/2006/main">
               <a:ext uri="{FF2B5EF4-FFF2-40B4-BE49-F238E27FC236}">
-                <a16:creationId xmlns:a16="http://schemas.microsoft.com/office/drawing/2014/main" id="{A3E23A32-8612-4039-98B3-E1AB2E225B98}"/>
+                <a16:creationId xmlns:a16="http://schemas.microsoft.com/office/drawing/2014/main" id="{B2F3B98C-85E9-435E-BF31-287C6A2D2F57}"/>
               </a:ext>
             </a:extLst>
           </p:cNvPr>
@@ -10068,7 +10053,7 @@
           <p:cNvPr id="55" name="review-limit">
             <a:extLst xmlns:a="http://schemas.openxmlformats.org/drawingml/2006/main">
               <a:ext uri="{FF2B5EF4-FFF2-40B4-BE49-F238E27FC236}">
-                <a16:creationId xmlns:a16="http://schemas.microsoft.com/office/drawing/2014/main" id="{A8D66395-283D-4A74-A83C-675C189512F4}"/>
+                <a16:creationId xmlns:a16="http://schemas.microsoft.com/office/drawing/2014/main" id="{9BD8D7BE-0AEA-4376-8424-1F685A25D622}"/>
               </a:ext>
             </a:extLst>
           </p:cNvPr>
@@ -10216,7 +10201,7 @@
                 <a:ea typeface="Manrope"/>
                 <a:cs typeface="Manrope"/>
               </a:rPr>
-              <a:t>Terry suggested this case. Kyubin verified it separately. Automated test still pending.</a:t>
+              <a:t>Kyubin checked the earlier fix separately. A permanent regression test is deferred.</a:t>
             </a:r>
           </a:p>
         </p:txBody>
@@ -10224,7 +10209,7 @@
     </p:spTree>
     <p:extLst>
       <p:ext uri="{BB962C8B-B14F-4D97-AF65-F5344CB8AC3E}">
-        <p14:creationId xmlns:p14="http://schemas.microsoft.com/office/powerpoint/2010/main" val="1680951504"/>
+        <p14:creationId xmlns:p14="http://schemas.microsoft.com/office/powerpoint/2010/main" val="263949053"/>
       </p:ext>
     </p:extLst>
   </p:cSld>
@@ -10255,7 +10240,7 @@
           <p:cNvPr id="60" name="Google Shape;60;p10">
             <a:extLst xmlns:a="http://schemas.openxmlformats.org/drawingml/2006/main">
               <a:ext uri="{FF2B5EF4-FFF2-40B4-BE49-F238E27FC236}">
-                <a16:creationId xmlns:a16="http://schemas.microsoft.com/office/drawing/2014/main" id="{9A128FC0-4835-47C9-99B3-8BBF8C7DE779}"/>
+                <a16:creationId xmlns:a16="http://schemas.microsoft.com/office/drawing/2014/main" id="{D780B256-EC9E-420E-A747-E3927BC58D66}"/>
               </a:ext>
             </a:extLst>
           </p:cNvPr>
@@ -10319,7 +10304,7 @@
           <p:cNvPr id="61" name="Google Shape;61;p10">
             <a:extLst xmlns:a="http://schemas.openxmlformats.org/drawingml/2006/main">
               <a:ext uri="{FF2B5EF4-FFF2-40B4-BE49-F238E27FC236}">
-                <a16:creationId xmlns:a16="http://schemas.microsoft.com/office/drawing/2014/main" id="{A594872E-5FB5-4509-91F2-8B3819097AD0}"/>
+                <a16:creationId xmlns:a16="http://schemas.microsoft.com/office/drawing/2014/main" id="{96C02A87-4351-418E-B26B-F3C8063A86A2}"/>
               </a:ext>
             </a:extLst>
           </p:cNvPr>
@@ -10383,7 +10368,7 @@
           <p:cNvPr id="62" name="Google Shape;62;p10">
             <a:extLst xmlns:a="http://schemas.openxmlformats.org/drawingml/2006/main">
               <a:ext uri="{FF2B5EF4-FFF2-40B4-BE49-F238E27FC236}">
-                <a16:creationId xmlns:a16="http://schemas.microsoft.com/office/drawing/2014/main" id="{6895F370-DC84-4C67-B143-32251B176A1A}"/>
+                <a16:creationId xmlns:a16="http://schemas.microsoft.com/office/drawing/2014/main" id="{0122C7E9-8C16-4483-B227-1E2A81DB304E}"/>
               </a:ext>
             </a:extLst>
           </p:cNvPr>
@@ -10481,7 +10466,7 @@
           <p:cNvPr id="63" name="Google Shape;63;p10">
             <a:extLst xmlns:a="http://schemas.openxmlformats.org/drawingml/2006/main">
               <a:ext uri="{FF2B5EF4-FFF2-40B4-BE49-F238E27FC236}">
-                <a16:creationId xmlns:a16="http://schemas.microsoft.com/office/drawing/2014/main" id="{ECF57BD3-0FEB-4263-A74B-8F98125E11CD}"/>
+                <a16:creationId xmlns:a16="http://schemas.microsoft.com/office/drawing/2014/main" id="{1A57919E-0F93-4978-9620-FDC78E696AF3}"/>
               </a:ext>
             </a:extLst>
           </p:cNvPr>
@@ -10545,7 +10530,7 @@
           <p:cNvPr id="64" name="Google Shape;64;p10">
             <a:extLst xmlns:a="http://schemas.openxmlformats.org/drawingml/2006/main">
               <a:ext uri="{FF2B5EF4-FFF2-40B4-BE49-F238E27FC236}">
-                <a16:creationId xmlns:a16="http://schemas.microsoft.com/office/drawing/2014/main" id="{8D1264DC-C57E-4C98-9FFA-CD62CC2D6183}"/>
+                <a16:creationId xmlns:a16="http://schemas.microsoft.com/office/drawing/2014/main" id="{DA9B0A24-0670-4ACB-8608-1734C82B2435}"/>
               </a:ext>
             </a:extLst>
           </p:cNvPr>
@@ -10685,7 +10670,7 @@
           <p:cNvPr id="65" name="Google Shape;65;p10">
             <a:extLst xmlns:a="http://schemas.openxmlformats.org/drawingml/2006/main">
               <a:ext uri="{FF2B5EF4-FFF2-40B4-BE49-F238E27FC236}">
-                <a16:creationId xmlns:a16="http://schemas.microsoft.com/office/drawing/2014/main" id="{49D9879A-A2D5-4BD0-AA1A-E24C9D6AAB3B}"/>
+                <a16:creationId xmlns:a16="http://schemas.microsoft.com/office/drawing/2014/main" id="{9B9DA8E0-75C6-4D14-BE86-5437516505BC}"/>
               </a:ext>
             </a:extLst>
           </p:cNvPr>
@@ -10860,7 +10845,7 @@
           <p:cNvPr id="66" name="Google Shape;66;p10">
             <a:extLst xmlns:a="http://schemas.openxmlformats.org/drawingml/2006/main">
               <a:ext uri="{FF2B5EF4-FFF2-40B4-BE49-F238E27FC236}">
-                <a16:creationId xmlns:a16="http://schemas.microsoft.com/office/drawing/2014/main" id="{D6104348-1828-43B7-B061-03CD275E6464}"/>
+                <a16:creationId xmlns:a16="http://schemas.microsoft.com/office/drawing/2014/main" id="{9CD38A49-C457-413D-BD78-A51D2EF43CA6}"/>
               </a:ext>
             </a:extLst>
           </p:cNvPr>
@@ -11000,7 +10985,7 @@
           <p:cNvPr id="67" name="Google Shape;67;p10">
             <a:extLst xmlns:a="http://schemas.openxmlformats.org/drawingml/2006/main">
               <a:ext uri="{FF2B5EF4-FFF2-40B4-BE49-F238E27FC236}">
-                <a16:creationId xmlns:a16="http://schemas.microsoft.com/office/drawing/2014/main" id="{6E886ED4-9093-4FDE-BB9E-15966EBCC987}"/>
+                <a16:creationId xmlns:a16="http://schemas.microsoft.com/office/drawing/2014/main" id="{5326D100-6C1D-4DE2-94DB-7DEACEE915B4}"/>
               </a:ext>
             </a:extLst>
           </p:cNvPr>
@@ -11175,7 +11160,7 @@
           <p:cNvPr id="68" name="Google Shape;68;p10">
             <a:extLst xmlns:a="http://schemas.openxmlformats.org/drawingml/2006/main">
               <a:ext uri="{FF2B5EF4-FFF2-40B4-BE49-F238E27FC236}">
-                <a16:creationId xmlns:a16="http://schemas.microsoft.com/office/drawing/2014/main" id="{BD984870-DF5F-4EE6-A1EB-02C641416082}"/>
+                <a16:creationId xmlns:a16="http://schemas.microsoft.com/office/drawing/2014/main" id="{B4837A24-8F79-417F-8240-E2D90F609D37}"/>
               </a:ext>
             </a:extLst>
           </p:cNvPr>
@@ -11315,7 +11300,7 @@
           <p:cNvPr id="69" name="Google Shape;69;p10">
             <a:extLst xmlns:a="http://schemas.openxmlformats.org/drawingml/2006/main">
               <a:ext uri="{FF2B5EF4-FFF2-40B4-BE49-F238E27FC236}">
-                <a16:creationId xmlns:a16="http://schemas.microsoft.com/office/drawing/2014/main" id="{D57D816B-D246-49BA-8C8A-043DEA7D8175}"/>
+                <a16:creationId xmlns:a16="http://schemas.microsoft.com/office/drawing/2014/main" id="{2AFE3487-E02B-4EB7-A5FE-D106829FF781}"/>
               </a:ext>
             </a:extLst>
           </p:cNvPr>
@@ -11490,7 +11475,7 @@
           <p:cNvPr id="70" name="Google Shape;70;p10">
             <a:extLst xmlns:a="http://schemas.openxmlformats.org/drawingml/2006/main">
               <a:ext uri="{FF2B5EF4-FFF2-40B4-BE49-F238E27FC236}">
-                <a16:creationId xmlns:a16="http://schemas.microsoft.com/office/drawing/2014/main" id="{37629784-5123-4FF6-8A1B-DCE3506A903D}"/>
+                <a16:creationId xmlns:a16="http://schemas.microsoft.com/office/drawing/2014/main" id="{FF7504C3-DFE5-490E-A973-4705DCC78783}"/>
               </a:ext>
             </a:extLst>
           </p:cNvPr>
@@ -11630,7 +11615,7 @@
           <p:cNvPr id="71" name="Google Shape;71;p10">
             <a:extLst xmlns:a="http://schemas.openxmlformats.org/drawingml/2006/main">
               <a:ext uri="{FF2B5EF4-FFF2-40B4-BE49-F238E27FC236}">
-                <a16:creationId xmlns:a16="http://schemas.microsoft.com/office/drawing/2014/main" id="{BDF5CF00-E513-45A8-AFE1-03F7A7B6A97E}"/>
+                <a16:creationId xmlns:a16="http://schemas.microsoft.com/office/drawing/2014/main" id="{935884B8-6389-4BC6-B711-9413E3DC09BC}"/>
               </a:ext>
             </a:extLst>
           </p:cNvPr>
@@ -11803,7 +11788,7 @@
     </p:spTree>
     <p:extLst>
       <p:ext uri="{BB962C8B-B14F-4D97-AF65-F5344CB8AC3E}">
-        <p14:creationId xmlns:p14="http://schemas.microsoft.com/office/powerpoint/2010/main" val="318805761"/>
+        <p14:creationId xmlns:p14="http://schemas.microsoft.com/office/powerpoint/2010/main" val="376606384"/>
       </p:ext>
     </p:extLst>
   </p:cSld>

</xml_diff>

<commit_message>
docs(a4): align Jiajun slides with unspaced Python env prefix
Update the rule, 16-check evidence, and review status for 7a8ea6bb6.

Generated-by: Codex
</commit_message>
<xml_diff>
--- a/presentation/Jiajun-TIKA-4408-section.pptx
+++ b/presentation/Jiajun-TIKA-4408-section.pptx
@@ -2,32 +2,32 @@
 <file path=ppt/presentation.xml><?xml version="1.0" encoding="utf-8"?>
 <p:presentation xmlns:p="http://schemas.openxmlformats.org/presentationml/2006/main" embedTrueTypeFonts="1" saveSubsetFonts="0">
   <p:sldMasterIdLst>
-    <p:sldMasterId xmlns:r="http://schemas.openxmlformats.org/officeDocument/2006/relationships" id="2147483648" r:id="Rd49851b5c380416f"/>
-    <p:sldMasterId xmlns:r="http://schemas.openxmlformats.org/officeDocument/2006/relationships" id="2147483650" r:id="R05265bdbafa84269"/>
+    <p:sldMasterId xmlns:r="http://schemas.openxmlformats.org/officeDocument/2006/relationships" id="2147483648" r:id="R7d3481794f8b4146"/>
+    <p:sldMasterId xmlns:r="http://schemas.openxmlformats.org/officeDocument/2006/relationships" id="2147483650" r:id="R4a92aa488af346b3"/>
   </p:sldMasterIdLst>
   <p:notesMasterIdLst>
-    <p:notesMasterId xmlns:r="http://schemas.openxmlformats.org/officeDocument/2006/relationships" r:id="Rcfb62667cd864ef6"/>
+    <p:notesMasterId xmlns:r="http://schemas.openxmlformats.org/officeDocument/2006/relationships" r:id="R39cbbea3e1d64cc3"/>
   </p:notesMasterIdLst>
   <p:sldIdLst>
-    <p:sldId xmlns:r="http://schemas.openxmlformats.org/officeDocument/2006/relationships" id="256" r:id="R9db96786411a4e3d"/>
-    <p:sldId xmlns:r="http://schemas.openxmlformats.org/officeDocument/2006/relationships" id="257" r:id="R67058dd9418a455a"/>
-    <p:sldId xmlns:r="http://schemas.openxmlformats.org/officeDocument/2006/relationships" id="258" r:id="R25da52b2ca1347de"/>
-    <p:sldId xmlns:r="http://schemas.openxmlformats.org/officeDocument/2006/relationships" id="259" r:id="R0b690752bc564561"/>
+    <p:sldId xmlns:r="http://schemas.openxmlformats.org/officeDocument/2006/relationships" id="256" r:id="Rbd3c6578ce5649a3"/>
+    <p:sldId xmlns:r="http://schemas.openxmlformats.org/officeDocument/2006/relationships" id="257" r:id="R01d70f7bf33c4a93"/>
+    <p:sldId xmlns:r="http://schemas.openxmlformats.org/officeDocument/2006/relationships" id="258" r:id="R8f9c55c020064460"/>
+    <p:sldId xmlns:r="http://schemas.openxmlformats.org/officeDocument/2006/relationships" id="259" r:id="R107bb44f878c4cf7"/>
   </p:sldIdLst>
   <p:sldSz cx="12192000" cy="6858000"/>
   <p:notesSz cx="6858000" cy="9144000"/>
   <p:embeddedFontLst>
     <p:embeddedFont>
       <p:font typeface="Manrope"/>
-      <p:regular xmlns:r="http://schemas.openxmlformats.org/officeDocument/2006/relationships" r:id="Rf798f33f4b054dbf"/>
-      <p:bold xmlns:r="http://schemas.openxmlformats.org/officeDocument/2006/relationships" r:id="Re4a8b335cf2540b8"/>
+      <p:regular xmlns:r="http://schemas.openxmlformats.org/officeDocument/2006/relationships" r:id="Rfec981ab9dd94728"/>
+      <p:bold xmlns:r="http://schemas.openxmlformats.org/officeDocument/2006/relationships" r:id="R4c81d41a4eba4489"/>
     </p:embeddedFont>
     <p:embeddedFont>
       <p:font typeface="Roboto Mono"/>
-      <p:regular xmlns:r="http://schemas.openxmlformats.org/officeDocument/2006/relationships" r:id="R68f84b6bca7a446b"/>
-      <p:bold xmlns:r="http://schemas.openxmlformats.org/officeDocument/2006/relationships" r:id="Rb04f4d52a10445a1"/>
-      <p:italic xmlns:r="http://schemas.openxmlformats.org/officeDocument/2006/relationships" r:id="Rb2845851964c4ce0"/>
-      <p:boldItalic xmlns:r="http://schemas.openxmlformats.org/officeDocument/2006/relationships" r:id="R664e02aff8614d0c"/>
+      <p:regular xmlns:r="http://schemas.openxmlformats.org/officeDocument/2006/relationships" r:id="Ra9ffa8487dee4916"/>
+      <p:bold xmlns:r="http://schemas.openxmlformats.org/officeDocument/2006/relationships" r:id="R3a31224c0bf749d5"/>
+      <p:italic xmlns:r="http://schemas.openxmlformats.org/officeDocument/2006/relationships" r:id="Rf85621f0fd9d4499"/>
+      <p:boldItalic xmlns:r="http://schemas.openxmlformats.org/officeDocument/2006/relationships" r:id="R46446f4ab0d147b7"/>
     </p:embeddedFont>
   </p:embeddedFontLst>
   <p:defaultTextStyle>
@@ -752,7 +752,7 @@
               <a:buNone/>
             </a:pPr>
             <a:r>
-              <a:t>The first challenge was understanding why Tika identified this Python script as Shell. A shebang is the first line that names the interpreter. The old Python rule searched for slash bin slash env python at offset one. Offset means the starting position, counted from zero. In this input, that substring actually starts at offset six, so the Python rule missed it and a Shell rule matched instead. The narrowed fix checks the complete no-space env python3 prefix at the start of the file. Prefix matching also covers python3.11. Understanding the existing rules made it possible to define this limited scope clearly.</a:t>
+              <a:t>The first challenge was understanding why Tika identified this Python script as Shell. A shebang is the first line that names the interpreter. The old Python rule searched for slash bin slash env python at offset one. Offset means the starting position, counted from zero. In this input, that substring actually starts at offset six, so the Python rule missed it and a Shell rule matched instead. The fix checks the complete no-space env python prefix at the start of the file. The same prefix covers python, python3 and python3.11. Understanding the existing rules helped us define the scope clearly.</a:t>
             </a:r>
             <a:endParaRPr/>
           </a:p>
@@ -797,7 +797,7 @@
               <a:buNone/>
             </a:pPr>
             <a:r>
-              <a:t>先说明现象：Python 首行却识别成 Shell。offset 是从 0 开始数的位置。原规则检查位置 1，但 /bin/env python 实际从位置 6 开始，所以 Python 规则没命中。当前修复只从文件开头匹配无空格的 #!/usr/bin/env python3 前缀，因此也匹配 python3.11。单空格、多空格、Tab 和 env python 不属于本次修复范围。这是原始 issue 的部分修复。</a:t>
+              <a:t>先说明现象：Python 首行却识别成 Shell。offset 是从 0 开始数的位置。原规则检查位置 1，但 /bin/env python 实际从位置 6 开始，所以 Python 规则没命中。当前修复从文件开头匹配 #!/usr/bin/env python 前缀，同时覆盖 python、python3 和 python3.11。#! 后的单空格、多空格和 Tab 不属于本次修复范围。</a:t>
             </a:r>
             <a:endParaRPr/>
           </a:p>
@@ -842,7 +842,7 @@
               <a:buNone/>
             </a:pPr>
             <a:r>
-              <a:t>Current scope confirmed 25 October 2026: one literal #!/usr/bin/env python3 prefix at offset 0. Existing direct-path Python rules remain unchanged. Bare env python, whitespace after #!, and env options such as env -S are outside this patch; the original ticket contains additional cases that remain uncovered.</a:t>
+              <a:t>Current scope confirmed 25 October 2026: one literal #!/usr/bin/env python prefix at offset 0. Prefix matching covers python and version suffixes, with python3 and python3.11 included in the tests. Existing direct-path Python rules remain unchanged. Whitespace after #! and env options such as env -S are outside this patch. This does not claim support for every Python shebang variant.</a:t>
             </a:r>
             <a:endParaRPr/>
           </a:p>
@@ -902,7 +902,7 @@
               <a:buNone/>
             </a:pPr>
             <a:r>
-              <a:t>https://github.com/u8026876/comp2120-gyg-a5/commit/4115d9325295bf4a6a26ba8a1a05f5969ec953f2</a:t>
+              <a:t>https://github.com/u8026876/comp2120-gyg-a5/commit/7a8ea6bb62b86c9f7f0b74f81eb052e4c5bedd4f</a:t>
             </a:r>
             <a:endParaRPr/>
           </a:p>
@@ -932,7 +932,7 @@
               <a:buNone/>
             </a:pPr>
             <a:r>
-              <a:t>Contribution and assistance: Jiajun owns TIKA-4408. Codex assisted the implementation, testing, and presentation preparation. Kyubin supplied independent validation and review of the earlier version; the narrowed revision needs renewed human review. Terry supplied additional review feedback. The visual template belongs to the group and was shared by Kyubin.</a:t>
+              <a:t>Contribution and assistance: Jiajun owns TIKA-4408. Codex assisted the implementation, testing, and presentation preparation. Kyubin supplied independent validation and review of the earlier version. The current revision needs renewed human review. Terry supplied additional review feedback. The visual template belongs to the group and was shared by Kyubin.</a:t>
             </a:r>
             <a:endParaRPr/>
           </a:p>
@@ -1042,7 +1042,7 @@
               <a:buNone/>
             </a:pPr>
             <a:r>
-              <a:t>A successful result for one Python example would leave important questions unanswered. The regression checks covered env python3 and python3.11, existing direct Python paths, and Shell scripts. They separated content-only detection from detection with a dot-py filename hint, because metadata can affect the result. A leading-newline control checked that the rule required the start of the file. Running the same fourteen checks with the original broken rule and then the narrowed fix gave a clear comparison: four failed before the change, and all fourteen passed afterwards. This evidence shows the repair within the chosen scope.</a:t>
+              <a:t>A successful result for one Python example would leave important questions unanswered. The regression checks covered env python, python3 and python3.11, existing direct Python paths, and Shell scripts. They separated content-only detection from detection with a dot-py filename hint, because metadata can affect the result. A leading-newline control checked that the rule required the start of the file. Running the same sixteen checks with the original broken rule and then the current fix gave a clear comparison: six failed before the change, and all sixteen passed afterwards. This evidence shows the repair within the chosen scope.</a:t>
             </a:r>
             <a:endParaRPr/>
           </a:p>
@@ -1087,7 +1087,7 @@
               <a:buNone/>
             </a:pPr>
             <a:r>
-              <a:t>这页讲如何证明当前收窄后的修复可靠。content-only 是不给文件名，只靠内容识别；filename hint 是额外给 script.py。两种方式分开测，防止文件名掩盖内容规则的问题。还测原本正常的 Python 路径、Shell，以及前面多一个换行的输入。当前 14 项测试在原 offset 1 规则下有 4 项失败，换成 python3 前缀规则后全通过。不要再使用之前 18 项、7 项失败的数据描述当前版本。</a:t>
+              <a:t>这页讲如何证明当前修复可靠。content-only 是不给文件名，只靠内容识别；filename hint 是额外给 script.py。两种方式分开测，防止文件名掩盖内容规则的问题。还测原本正常的 Python 路径、Shell，以及前面多一个换行的输入。当前 16 项测试在原 offset 1 规则下有 6 项失败，换成通用 python 前缀规则后全通过。这里使用当前版本的测试结果。</a:t>
             </a:r>
             <a:endParaRPr/>
           </a:p>
@@ -1132,7 +1132,7 @@
               <a:buNone/>
             </a:pPr>
             <a:r>
-              <a:t>The 14 checks are parameterized regression cases, not 14 separate test methods. On 25 October 2026, the negative control kept these tests and temporarily restored only the original /bin/env python rule at offset 1: 4 failures, 0 errors. The Python 3-only rule in commit 4115d9325295bf4a6a26ba8a1a05f5969ec953f2 then passed all 14 checks. Full local core clean install with pedantic checks and randomized locale passed: 1,373 tests, 0 failures/errors, 2 skipped; alternate Xerces checks: 12 tests, 2 skipped; TikaIT: 1 passed; annotation-processor tests: 8 passed; quality checks passed. Kyubin's earlier approval covered cefa669, not this narrowed revision. No full Tika repository test or remote CI claim is made.</a:t>
+              <a:t>The 16 checks are parameterized regression cases, not 16 separate test methods. On 25 October 2026, the negative control kept these tests and temporarily restored only the original /bin/env python rule at offset 1: 6 failures, 0 errors. The generic no-space Python prefix rule in commit 7a8ea6bb62b86c9f7f0b74f81eb052e4c5bedd4f then passed all 16 checks. Full local core clean install with pedantic checks and randomized locale passed: 1,375 tests, 0 failures/errors, 2 skipped; alternate Xerces checks: 12 tests, 2 skipped; TikaIT: 1 passed; annotation-processor tests: 8 passed; quality checks passed. Kyubin's earlier approval covered cefa669, not this current revision. No full Tika repository test or remote CI claim is made.</a:t>
             </a:r>
             <a:endParaRPr/>
           </a:p>
@@ -1192,7 +1192,7 @@
               <a:buNone/>
             </a:pPr>
             <a:r>
-              <a:t>https://github.com/u8026876/comp2120-gyg-a5/commit/4115d9325295bf4a6a26ba8a1a05f5969ec953f2</a:t>
+              <a:t>https://github.com/u8026876/comp2120-gyg-a5/commit/7a8ea6bb62b86c9f7f0b74f81eb052e4c5bedd4f</a:t>
             </a:r>
             <a:endParaRPr/>
           </a:p>
@@ -1222,7 +1222,7 @@
               <a:buNone/>
             </a:pPr>
             <a:r>
-              <a:t>Contribution and assistance: Jiajun owns TIKA-4408. Codex assisted the implementation, testing, and presentation preparation. Kyubin supplied independent validation and review of the earlier version; the narrowed revision needs renewed human review. Terry supplied additional review feedback. The visual template belongs to the group and was shared by Kyubin.</a:t>
+              <a:t>Contribution and assistance: Jiajun owns TIKA-4408. Codex assisted the implementation, testing, and presentation preparation. Kyubin supplied independent validation and review of the earlier version. The current revision needs renewed human review. Terry supplied additional review feedback. The visual template belongs to the group and was shared by Kyubin.</a:t>
             </a:r>
             <a:endParaRPr/>
           </a:p>
@@ -1377,7 +1377,7 @@
               <a:buNone/>
             </a:pPr>
             <a:r>
-              <a:t>这不是要执行的 Python 代码，而是故意构造的普通文本。x 占位置 0，后面的 /bin/env python 正好在位置 1，因此旧规则会误报为 Python。false positive 就是误报。Terry 提议把它加入长期测试，Kyubin 对早先 cefa669 版本做过独立验证。图中结果引用的是那次历史验证，不表示他已批准当前收窄版本。该反例未进入当前 14 项测试，永久回归测试暂缓。</a:t>
+              <a:t>这不是要执行的 Python 代码，而是故意构造的普通文本。x 占位置 0，后面的 /bin/env python 正好在位置 1，因此旧规则会误报为 Python。false positive 就是误报。Terry 提议把它加入长期测试，Kyubin 对早先 cefa669 版本做过独立验证。图中结果引用的是那次历史验证，不表示他已批准当前版本。该反例未进入当前 16 项测试，永久回归测试暂缓。</a:t>
             </a:r>
             <a:endParaRPr/>
           </a:p>
@@ -1422,7 +1422,7 @@
               <a:buNone/>
             </a:pPr>
             <a:r>
-              <a:t>These observed results refer only to Kyubin's earlier separate content-only probe on cefa669 and the original MIME registry. They are historical review evidence, not a fresh test or approval of the narrowed Python 3-only revision. The permanent regression test remains deferred.</a:t>
+              <a:t>These observed results refer only to Kyubin's earlier separate content-only probe on cefa669 and the original MIME registry. They are historical review evidence, not a fresh test or approval of the current generic Python prefix revision. The permanent regression test remains deferred.</a:t>
             </a:r>
             <a:endParaRPr/>
           </a:p>
@@ -1527,7 +1527,7 @@
               <a:buNone/>
             </a:pPr>
             <a:r>
-              <a:t>Contribution and assistance: Jiajun owns TIKA-4408. Codex assisted the implementation, testing, and presentation preparation. Kyubin supplied independent validation and review of the earlier version; the narrowed revision needs renewed human review. Terry supplied additional review feedback. The visual template belongs to the group and was shared by Kyubin.</a:t>
+              <a:t>Contribution and assistance: Jiajun owns TIKA-4408. Codex assisted the implementation, testing, and presentation preparation. Kyubin supplied independent validation and review of the earlier version. The current revision needs renewed human review. Terry supplied additional review feedback. The visual template belongs to the group and was shared by Kyubin.</a:t>
             </a:r>
             <a:endParaRPr/>
           </a:p>
@@ -1862,7 +1862,7 @@
               <a:buNone/>
             </a:pPr>
             <a:r>
-              <a:t>Contribution and assistance: Jiajun owns TIKA-4408. Codex assisted the implementation, testing, and presentation preparation. Kyubin supplied independent validation and review of the earlier version; the narrowed revision needs renewed human review. Terry supplied additional review feedback. The visual template belongs to the group and was shared by Kyubin.</a:t>
+              <a:t>Contribution and assistance: Jiajun owns TIKA-4408. Codex assisted the implementation, testing, and presentation preparation. Kyubin supplied independent validation and review of the earlier version. The current revision needs renewed human review. Terry supplied additional review feedback. The visual template belongs to the group and was shared by Kyubin.</a:t>
             </a:r>
             <a:endParaRPr/>
           </a:p>
@@ -1910,7 +1910,7 @@
           <p:cNvPr id="11" name="Google Shape;11;p2">
             <a:extLst xmlns:a="http://schemas.openxmlformats.org/drawingml/2006/main">
               <a:ext uri="{FF2B5EF4-FFF2-40B4-BE49-F238E27FC236}">
-                <a16:creationId xmlns:a16="http://schemas.microsoft.com/office/drawing/2014/main" id="{0CF5E1AD-AD99-4F7A-90CC-2CE801AAF480}"/>
+                <a16:creationId xmlns:a16="http://schemas.microsoft.com/office/drawing/2014/main" id="{278A28B7-CA3A-4089-A8E7-83059BDDDEF6}"/>
               </a:ext>
             </a:extLst>
           </p:cNvPr>
@@ -2047,7 +2047,7 @@
           <p:cNvPr id="12" name="Google Shape;12;p2">
             <a:extLst xmlns:a="http://schemas.openxmlformats.org/drawingml/2006/main">
               <a:ext uri="{FF2B5EF4-FFF2-40B4-BE49-F238E27FC236}">
-                <a16:creationId xmlns:a16="http://schemas.microsoft.com/office/drawing/2014/main" id="{7DC7EA1D-32E4-4CC2-8EEC-E2E6FFAA8859}"/>
+                <a16:creationId xmlns:a16="http://schemas.microsoft.com/office/drawing/2014/main" id="{96E62322-A7DE-4134-B059-A84CEF4D27D8}"/>
               </a:ext>
             </a:extLst>
           </p:cNvPr>
@@ -2201,7 +2201,7 @@
           <p:cNvPr id="15" name="Google Shape;15;p4">
             <a:extLst xmlns:a="http://schemas.openxmlformats.org/drawingml/2006/main">
               <a:ext uri="{FF2B5EF4-FFF2-40B4-BE49-F238E27FC236}">
-                <a16:creationId xmlns:a16="http://schemas.microsoft.com/office/drawing/2014/main" id="{E33E2926-912D-4F77-A9D9-D4DD398294FB}"/>
+                <a16:creationId xmlns:a16="http://schemas.microsoft.com/office/drawing/2014/main" id="{AC7723D6-18E1-43E7-984E-2500009670BE}"/>
               </a:ext>
             </a:extLst>
           </p:cNvPr>
@@ -2338,7 +2338,7 @@
           <p:cNvPr id="16" name="Google Shape;16;p4">
             <a:extLst xmlns:a="http://schemas.openxmlformats.org/drawingml/2006/main">
               <a:ext uri="{FF2B5EF4-FFF2-40B4-BE49-F238E27FC236}">
-                <a16:creationId xmlns:a16="http://schemas.microsoft.com/office/drawing/2014/main" id="{4498C1E9-15DD-4DC6-8260-3C1DB6900880}"/>
+                <a16:creationId xmlns:a16="http://schemas.microsoft.com/office/drawing/2014/main" id="{32170826-853C-475A-89BC-2E6DCA086531}"/>
               </a:ext>
             </a:extLst>
           </p:cNvPr>
@@ -2475,7 +2475,7 @@
           <p:cNvPr id="17" name="Google Shape;17;p4">
             <a:extLst xmlns:a="http://schemas.openxmlformats.org/drawingml/2006/main">
               <a:ext uri="{FF2B5EF4-FFF2-40B4-BE49-F238E27FC236}">
-                <a16:creationId xmlns:a16="http://schemas.microsoft.com/office/drawing/2014/main" id="{AC2DEB2E-F396-4D8D-B4C3-DFE2D6864C79}"/>
+                <a16:creationId xmlns:a16="http://schemas.microsoft.com/office/drawing/2014/main" id="{00B73ED3-0958-4560-A306-5447940B7451}"/>
               </a:ext>
             </a:extLst>
           </p:cNvPr>
@@ -2629,7 +2629,7 @@
           <p:cNvPr id="19" name="Google Shape;19;p5">
             <a:extLst xmlns:a="http://schemas.openxmlformats.org/drawingml/2006/main">
               <a:ext uri="{FF2B5EF4-FFF2-40B4-BE49-F238E27FC236}">
-                <a16:creationId xmlns:a16="http://schemas.microsoft.com/office/drawing/2014/main" id="{9A25414B-A5D4-4652-B611-709154D431AB}"/>
+                <a16:creationId xmlns:a16="http://schemas.microsoft.com/office/drawing/2014/main" id="{89D9217F-4114-4D10-8EC3-0BF0020B3272}"/>
               </a:ext>
             </a:extLst>
           </p:cNvPr>
@@ -2766,7 +2766,7 @@
           <p:cNvPr id="20" name="Google Shape;20;p5">
             <a:extLst xmlns:a="http://schemas.openxmlformats.org/drawingml/2006/main">
               <a:ext uri="{FF2B5EF4-FFF2-40B4-BE49-F238E27FC236}">
-                <a16:creationId xmlns:a16="http://schemas.microsoft.com/office/drawing/2014/main" id="{F9971FB0-4910-4704-82FE-35A77DF8C572}"/>
+                <a16:creationId xmlns:a16="http://schemas.microsoft.com/office/drawing/2014/main" id="{5A54D4FF-89CA-4D56-98B0-6E1E9E674416}"/>
               </a:ext>
             </a:extLst>
           </p:cNvPr>
@@ -2903,7 +2903,7 @@
           <p:cNvPr id="21" name="Google Shape;21;p5">
             <a:extLst xmlns:a="http://schemas.openxmlformats.org/drawingml/2006/main">
               <a:ext uri="{FF2B5EF4-FFF2-40B4-BE49-F238E27FC236}">
-                <a16:creationId xmlns:a16="http://schemas.microsoft.com/office/drawing/2014/main" id="{C4807A8C-3A3A-49E2-AD60-51202A83C580}"/>
+                <a16:creationId xmlns:a16="http://schemas.microsoft.com/office/drawing/2014/main" id="{1C424A45-5477-4BD4-AEA2-62347B004432}"/>
               </a:ext>
             </a:extLst>
           </p:cNvPr>
@@ -3057,7 +3057,7 @@
           <p:cNvPr id="23" name="Google Shape;23;p6">
             <a:extLst xmlns:a="http://schemas.openxmlformats.org/drawingml/2006/main">
               <a:ext uri="{FF2B5EF4-FFF2-40B4-BE49-F238E27FC236}">
-                <a16:creationId xmlns:a16="http://schemas.microsoft.com/office/drawing/2014/main" id="{E940F8E1-F24D-4A83-9589-5AEA59DADB68}"/>
+                <a16:creationId xmlns:a16="http://schemas.microsoft.com/office/drawing/2014/main" id="{0085D972-A233-49BD-A862-94D8F4B52F08}"/>
               </a:ext>
             </a:extLst>
           </p:cNvPr>
@@ -3194,7 +3194,7 @@
           <p:cNvPr id="24" name="Google Shape;24;p6">
             <a:extLst xmlns:a="http://schemas.openxmlformats.org/drawingml/2006/main">
               <a:ext uri="{FF2B5EF4-FFF2-40B4-BE49-F238E27FC236}">
-                <a16:creationId xmlns:a16="http://schemas.microsoft.com/office/drawing/2014/main" id="{CD668096-E874-4C8A-BF2F-24946C6C645D}"/>
+                <a16:creationId xmlns:a16="http://schemas.microsoft.com/office/drawing/2014/main" id="{72E550EA-AE1E-4AB5-8B8D-E8FAB05F8385}"/>
               </a:ext>
             </a:extLst>
           </p:cNvPr>
@@ -3348,7 +3348,7 @@
           <p:cNvPr id="26" name="Google Shape;26;p7">
             <a:extLst xmlns:a="http://schemas.openxmlformats.org/drawingml/2006/main">
               <a:ext uri="{FF2B5EF4-FFF2-40B4-BE49-F238E27FC236}">
-                <a16:creationId xmlns:a16="http://schemas.microsoft.com/office/drawing/2014/main" id="{919CC0DE-ABAD-4C7E-8B7F-3B7045C154C9}"/>
+                <a16:creationId xmlns:a16="http://schemas.microsoft.com/office/drawing/2014/main" id="{1895F37E-39DF-4CF7-89A1-7D39D754CE04}"/>
               </a:ext>
             </a:extLst>
           </p:cNvPr>
@@ -3485,7 +3485,7 @@
           <p:cNvPr id="27" name="Google Shape;27;p7">
             <a:extLst xmlns:a="http://schemas.openxmlformats.org/drawingml/2006/main">
               <a:ext uri="{FF2B5EF4-FFF2-40B4-BE49-F238E27FC236}">
-                <a16:creationId xmlns:a16="http://schemas.microsoft.com/office/drawing/2014/main" id="{088D7DD5-D341-49E7-A5F9-F318A8E1207B}"/>
+                <a16:creationId xmlns:a16="http://schemas.microsoft.com/office/drawing/2014/main" id="{AF5462B7-0C59-486B-A941-83C66DE28C65}"/>
               </a:ext>
             </a:extLst>
           </p:cNvPr>
@@ -3645,7 +3645,7 @@
   </p:cSld>
   <p:clrMap bg1="lt1" tx1="dk1" bg2="dk2" tx2="lt2" accent1="accent1" accent2="accent2" accent3="accent3" accent4="accent4" accent5="accent5" accent6="accent6" hlink="hlink" folHlink="folHlink"/>
   <p:sldLayoutIdLst>
-    <p:sldLayoutId xmlns:r="http://schemas.openxmlformats.org/officeDocument/2006/relationships" id="2147483649" r:id="R68e20a153dfd44ca"/>
+    <p:sldLayoutId xmlns:r="http://schemas.openxmlformats.org/officeDocument/2006/relationships" id="2147483649" r:id="R24bc878ace2541ab"/>
   </p:sldLayoutIdLst>
   <p:hf sldNum="0" hdr="0" ftr="0" dt="0"/>
   <p:txStyles>
@@ -4330,10 +4330,10 @@
   </p:cSld>
   <p:clrMap bg1="lt1" tx1="dk1" bg2="dk2" tx2="lt2" accent1="accent1" accent2="accent2" accent3="accent3" accent4="accent4" accent5="accent5" accent6="accent6" hlink="hlink" folHlink="folHlink"/>
   <p:sldLayoutIdLst>
-    <p:sldLayoutId xmlns:r="http://schemas.openxmlformats.org/officeDocument/2006/relationships" id="2147483651" r:id="Rc461ede2a7774f10"/>
-    <p:sldLayoutId xmlns:r="http://schemas.openxmlformats.org/officeDocument/2006/relationships" id="2147483652" r:id="Rb75320dbc4894863"/>
-    <p:sldLayoutId xmlns:r="http://schemas.openxmlformats.org/officeDocument/2006/relationships" id="2147483653" r:id="R24cf339b31294936"/>
-    <p:sldLayoutId xmlns:r="http://schemas.openxmlformats.org/officeDocument/2006/relationships" id="2147483654" r:id="R0c13650087024d51"/>
+    <p:sldLayoutId xmlns:r="http://schemas.openxmlformats.org/officeDocument/2006/relationships" id="2147483651" r:id="R758ccf8cc08b40cd"/>
+    <p:sldLayoutId xmlns:r="http://schemas.openxmlformats.org/officeDocument/2006/relationships" id="2147483652" r:id="R794546490d034342"/>
+    <p:sldLayoutId xmlns:r="http://schemas.openxmlformats.org/officeDocument/2006/relationships" id="2147483653" r:id="R4667a408473343d5"/>
+    <p:sldLayoutId xmlns:r="http://schemas.openxmlformats.org/officeDocument/2006/relationships" id="2147483654" r:id="R0bf6acc55a224d74"/>
   </p:sldLayoutIdLst>
   <p:hf sldNum="0" hdr="0" ftr="0" dt="0"/>
   <p:txStyles>
@@ -5555,7 +5555,7 @@
           <p:cNvPr id="42" name="Google Shape;42;p9">
             <a:extLst xmlns:a="http://schemas.openxmlformats.org/drawingml/2006/main">
               <a:ext uri="{FF2B5EF4-FFF2-40B4-BE49-F238E27FC236}">
-                <a16:creationId xmlns:a16="http://schemas.microsoft.com/office/drawing/2014/main" id="{DFE48758-14A9-44C0-A2CC-836A15F68535}"/>
+                <a16:creationId xmlns:a16="http://schemas.microsoft.com/office/drawing/2014/main" id="{83C4B260-092A-4ED5-AD1A-C8F029B084D1}"/>
               </a:ext>
             </a:extLst>
           </p:cNvPr>
@@ -5606,7 +5606,7 @@
           <p:cNvPr id="43" name="Google Shape;43;p9">
             <a:extLst xmlns:a="http://schemas.openxmlformats.org/drawingml/2006/main">
               <a:ext uri="{FF2B5EF4-FFF2-40B4-BE49-F238E27FC236}">
-                <a16:creationId xmlns:a16="http://schemas.microsoft.com/office/drawing/2014/main" id="{5986D919-E229-4ABA-96CD-001E2F2E8546}"/>
+                <a16:creationId xmlns:a16="http://schemas.microsoft.com/office/drawing/2014/main" id="{24E5E759-489C-4530-9367-B83430A8554A}"/>
               </a:ext>
             </a:extLst>
           </p:cNvPr>
@@ -5670,7 +5670,7 @@
           <p:cNvPr id="44" name="Google Shape;44;p9">
             <a:extLst xmlns:a="http://schemas.openxmlformats.org/drawingml/2006/main">
               <a:ext uri="{FF2B5EF4-FFF2-40B4-BE49-F238E27FC236}">
-                <a16:creationId xmlns:a16="http://schemas.microsoft.com/office/drawing/2014/main" id="{FBB1A3B3-2DA4-489E-8EFB-017BA1B25CE4}"/>
+                <a16:creationId xmlns:a16="http://schemas.microsoft.com/office/drawing/2014/main" id="{0B61773D-7488-4265-B0AD-33E7CD29D35F}"/>
               </a:ext>
             </a:extLst>
           </p:cNvPr>
@@ -5734,7 +5734,7 @@
           <p:cNvPr id="45" name="Google Shape;45;p9">
             <a:extLst xmlns:a="http://schemas.openxmlformats.org/drawingml/2006/main">
               <a:ext uri="{FF2B5EF4-FFF2-40B4-BE49-F238E27FC236}">
-                <a16:creationId xmlns:a16="http://schemas.microsoft.com/office/drawing/2014/main" id="{2309D870-D76B-445E-BE76-8749D84DDF9F}"/>
+                <a16:creationId xmlns:a16="http://schemas.microsoft.com/office/drawing/2014/main" id="{44A3F6B0-FB16-4F4B-A469-08478C26C1F6}"/>
               </a:ext>
             </a:extLst>
           </p:cNvPr>
@@ -5832,7 +5832,7 @@
           <p:cNvPr id="46" name="Google Shape;46;p9">
             <a:extLst xmlns:a="http://schemas.openxmlformats.org/drawingml/2006/main">
               <a:ext uri="{FF2B5EF4-FFF2-40B4-BE49-F238E27FC236}">
-                <a16:creationId xmlns:a16="http://schemas.microsoft.com/office/drawing/2014/main" id="{299F6F40-C40A-4490-81A8-D1EA28D49980}"/>
+                <a16:creationId xmlns:a16="http://schemas.microsoft.com/office/drawing/2014/main" id="{41A40B0D-6F99-42C2-8D83-48C99B192D92}"/>
               </a:ext>
             </a:extLst>
           </p:cNvPr>
@@ -5896,7 +5896,7 @@
           <p:cNvPr id="47" name="Google Shape;47;p9">
             <a:extLst xmlns:a="http://schemas.openxmlformats.org/drawingml/2006/main">
               <a:ext uri="{FF2B5EF4-FFF2-40B4-BE49-F238E27FC236}">
-                <a16:creationId xmlns:a16="http://schemas.microsoft.com/office/drawing/2014/main" id="{9C9B5724-1456-4814-9E5D-A225757015F4}"/>
+                <a16:creationId xmlns:a16="http://schemas.microsoft.com/office/drawing/2014/main" id="{594E6614-93FF-409F-A827-80E689265BE2}"/>
               </a:ext>
             </a:extLst>
           </p:cNvPr>
@@ -5992,7 +5992,7 @@
           <p:cNvPr id="48" name="Google Shape;48;p9">
             <a:extLst xmlns:a="http://schemas.openxmlformats.org/drawingml/2006/main">
               <a:ext uri="{FF2B5EF4-FFF2-40B4-BE49-F238E27FC236}">
-                <a16:creationId xmlns:a16="http://schemas.microsoft.com/office/drawing/2014/main" id="{2D339E40-78FD-49E0-A147-4B915366E107}"/>
+                <a16:creationId xmlns:a16="http://schemas.microsoft.com/office/drawing/2014/main" id="{9C7D0C6B-2781-43CB-AA4B-457B80702F20}"/>
               </a:ext>
             </a:extLst>
           </p:cNvPr>
@@ -6088,7 +6088,7 @@
           <p:cNvPr id="49" name="Google Shape;49;p9">
             <a:extLst xmlns:a="http://schemas.openxmlformats.org/drawingml/2006/main">
               <a:ext uri="{FF2B5EF4-FFF2-40B4-BE49-F238E27FC236}">
-                <a16:creationId xmlns:a16="http://schemas.microsoft.com/office/drawing/2014/main" id="{FA08A004-7705-4E49-86B0-E8A3E12601BA}"/>
+                <a16:creationId xmlns:a16="http://schemas.microsoft.com/office/drawing/2014/main" id="{42C40909-52F8-47B6-8A63-9DB0028FE599}"/>
               </a:ext>
             </a:extLst>
           </p:cNvPr>
@@ -6283,7 +6283,7 @@
           <p:cNvPr id="50" name="Google Shape;50;p9">
             <a:extLst xmlns:a="http://schemas.openxmlformats.org/drawingml/2006/main">
               <a:ext uri="{FF2B5EF4-FFF2-40B4-BE49-F238E27FC236}">
-                <a16:creationId xmlns:a16="http://schemas.microsoft.com/office/drawing/2014/main" id="{D4E8937C-10F5-4DAF-B7D2-7757E2EDA0AF}"/>
+                <a16:creationId xmlns:a16="http://schemas.microsoft.com/office/drawing/2014/main" id="{6762FDE2-8574-4647-B467-8538203751C7}"/>
               </a:ext>
             </a:extLst>
           </p:cNvPr>
@@ -6458,7 +6458,7 @@
           <p:cNvPr id="51" name="Google Shape;51;p9">
             <a:extLst xmlns:a="http://schemas.openxmlformats.org/drawingml/2006/main">
               <a:ext uri="{FF2B5EF4-FFF2-40B4-BE49-F238E27FC236}">
-                <a16:creationId xmlns:a16="http://schemas.microsoft.com/office/drawing/2014/main" id="{FC2F51B2-E2A8-4C51-976A-9286CEBFE1BD}"/>
+                <a16:creationId xmlns:a16="http://schemas.microsoft.com/office/drawing/2014/main" id="{ECBB4C41-2C25-491A-8A03-6993E07EE589}"/>
               </a:ext>
             </a:extLst>
           </p:cNvPr>
@@ -6580,7 +6580,7 @@
                 <a:ea typeface="Roboto Mono"/>
                 <a:cs typeface="Roboto Mono"/>
               </a:rPr>
-              <a:t>#!/usr/bin/env python3</a:t>
+              <a:t>#!/usr/bin/env python</a:t>
             </a:r>
             <a:endParaRPr sz="2200">
               <a:solidFill>
@@ -6633,7 +6633,7 @@
           <p:cNvPr id="52" name="Google Shape;52;p9">
             <a:extLst xmlns:a="http://schemas.openxmlformats.org/drawingml/2006/main">
               <a:ext uri="{FF2B5EF4-FFF2-40B4-BE49-F238E27FC236}">
-                <a16:creationId xmlns:a16="http://schemas.microsoft.com/office/drawing/2014/main" id="{4343A830-9923-4DE0-8366-FDCD02F0FBA8}"/>
+                <a16:creationId xmlns:a16="http://schemas.microsoft.com/office/drawing/2014/main" id="{718B6741-8ABA-45F9-B241-4728C6DFEB93}"/>
               </a:ext>
             </a:extLst>
           </p:cNvPr>
@@ -6773,7 +6773,7 @@
           <p:cNvPr id="53" name="Google Shape;53;p9">
             <a:extLst xmlns:a="http://schemas.openxmlformats.org/drawingml/2006/main">
               <a:ext uri="{FF2B5EF4-FFF2-40B4-BE49-F238E27FC236}">
-                <a16:creationId xmlns:a16="http://schemas.microsoft.com/office/drawing/2014/main" id="{1B8336E6-0542-4A7F-9852-13AE4656980E}"/>
+                <a16:creationId xmlns:a16="http://schemas.microsoft.com/office/drawing/2014/main" id="{CE69BC14-FC10-4AE5-A8D0-DFBF53B9014A}"/>
               </a:ext>
             </a:extLst>
           </p:cNvPr>
@@ -6913,7 +6913,7 @@
           <p:cNvPr id="54" name="Google Shape;54;p9">
             <a:extLst xmlns:a="http://schemas.openxmlformats.org/drawingml/2006/main">
               <a:ext uri="{FF2B5EF4-FFF2-40B4-BE49-F238E27FC236}">
-                <a16:creationId xmlns:a16="http://schemas.microsoft.com/office/drawing/2014/main" id="{B2F3B98C-85E9-435E-BF31-287C6A2D2F57}"/>
+                <a16:creationId xmlns:a16="http://schemas.microsoft.com/office/drawing/2014/main" id="{96C8555E-276D-409C-8577-8E5D1C3FE42A}"/>
               </a:ext>
             </a:extLst>
           </p:cNvPr>
@@ -7086,7 +7086,7 @@
           <p:cNvPr id="55" name="cause-takeaway">
             <a:extLst xmlns:a="http://schemas.openxmlformats.org/drawingml/2006/main">
               <a:ext uri="{FF2B5EF4-FFF2-40B4-BE49-F238E27FC236}">
-                <a16:creationId xmlns:a16="http://schemas.microsoft.com/office/drawing/2014/main" id="{EB5656FF-A0E4-447E-BD86-770EFDC39EFC}"/>
+                <a16:creationId xmlns:a16="http://schemas.microsoft.com/office/drawing/2014/main" id="{FDDE953E-C44D-4EC9-80FB-3F8A6F59D94E}"/>
               </a:ext>
             </a:extLst>
           </p:cNvPr>
@@ -7234,7 +7234,7 @@
                 <a:ea typeface="Manrope"/>
                 <a:cs typeface="Manrope"/>
               </a:rPr>
-              <a:t>Scope: no-space python3 prefix; python3.11 is also covered.</a:t>
+              <a:t>One prefix covers python, python3 and python3.11 without a space after #!.</a:t>
             </a:r>
           </a:p>
         </p:txBody>
@@ -7242,7 +7242,7 @@
     </p:spTree>
     <p:extLst>
       <p:ext uri="{BB962C8B-B14F-4D97-AF65-F5344CB8AC3E}">
-        <p14:creationId xmlns:p14="http://schemas.microsoft.com/office/powerpoint/2010/main" val="263949053"/>
+        <p14:creationId xmlns:p14="http://schemas.microsoft.com/office/powerpoint/2010/main" val="1603504256"/>
       </p:ext>
     </p:extLst>
   </p:cSld>
@@ -7273,7 +7273,7 @@
           <p:cNvPr id="77" name="Google Shape;77;p11">
             <a:extLst xmlns:a="http://schemas.openxmlformats.org/drawingml/2006/main">
               <a:ext uri="{FF2B5EF4-FFF2-40B4-BE49-F238E27FC236}">
-                <a16:creationId xmlns:a16="http://schemas.microsoft.com/office/drawing/2014/main" id="{85B4C56A-0F69-420B-ADE7-0E3EBAF2A874}"/>
+                <a16:creationId xmlns:a16="http://schemas.microsoft.com/office/drawing/2014/main" id="{DA8843D0-912F-4021-A232-B4BFFB73FE2D}"/>
               </a:ext>
             </a:extLst>
           </p:cNvPr>
@@ -7337,7 +7337,7 @@
           <p:cNvPr id="78" name="Google Shape;78;p11">
             <a:extLst xmlns:a="http://schemas.openxmlformats.org/drawingml/2006/main">
               <a:ext uri="{FF2B5EF4-FFF2-40B4-BE49-F238E27FC236}">
-                <a16:creationId xmlns:a16="http://schemas.microsoft.com/office/drawing/2014/main" id="{6D1021EB-F500-4DF7-9169-55BA2B49232D}"/>
+                <a16:creationId xmlns:a16="http://schemas.microsoft.com/office/drawing/2014/main" id="{BEDCA2B6-E824-4545-B7C6-ED940655B987}"/>
               </a:ext>
             </a:extLst>
           </p:cNvPr>
@@ -7401,7 +7401,7 @@
           <p:cNvPr id="79" name="Google Shape;79;p11">
             <a:extLst xmlns:a="http://schemas.openxmlformats.org/drawingml/2006/main">
               <a:ext uri="{FF2B5EF4-FFF2-40B4-BE49-F238E27FC236}">
-                <a16:creationId xmlns:a16="http://schemas.microsoft.com/office/drawing/2014/main" id="{F4F76437-5963-4990-908B-6E8A970AF7D9}"/>
+                <a16:creationId xmlns:a16="http://schemas.microsoft.com/office/drawing/2014/main" id="{CC2D6198-2800-4C6E-A094-8E50FE06023A}"/>
               </a:ext>
             </a:extLst>
           </p:cNvPr>
@@ -7499,7 +7499,7 @@
           <p:cNvPr id="80" name="Google Shape;80;p11">
             <a:extLst xmlns:a="http://schemas.openxmlformats.org/drawingml/2006/main">
               <a:ext uri="{FF2B5EF4-FFF2-40B4-BE49-F238E27FC236}">
-                <a16:creationId xmlns:a16="http://schemas.microsoft.com/office/drawing/2014/main" id="{E2F3BB4C-1A6B-435F-80B9-A3E318254DCC}"/>
+                <a16:creationId xmlns:a16="http://schemas.microsoft.com/office/drawing/2014/main" id="{30861CD9-05E1-4FBD-A28B-E774C1BAA6CE}"/>
               </a:ext>
             </a:extLst>
           </p:cNvPr>
@@ -7563,7 +7563,7 @@
           <p:cNvPr id="81" name="Google Shape;81;p11">
             <a:extLst xmlns:a="http://schemas.openxmlformats.org/drawingml/2006/main">
               <a:ext uri="{FF2B5EF4-FFF2-40B4-BE49-F238E27FC236}">
-                <a16:creationId xmlns:a16="http://schemas.microsoft.com/office/drawing/2014/main" id="{EEDBB18F-9A0C-4EDE-9B17-B1D2EF44F85E}"/>
+                <a16:creationId xmlns:a16="http://schemas.microsoft.com/office/drawing/2014/main" id="{3048AC93-7689-480A-A78E-8419B918576F}"/>
               </a:ext>
             </a:extLst>
           </p:cNvPr>
@@ -7627,7 +7627,7 @@
           <p:cNvPr id="82" name="Google Shape;82;p11">
             <a:extLst xmlns:a="http://schemas.openxmlformats.org/drawingml/2006/main">
               <a:ext uri="{FF2B5EF4-FFF2-40B4-BE49-F238E27FC236}">
-                <a16:creationId xmlns:a16="http://schemas.microsoft.com/office/drawing/2014/main" id="{D2D7D429-E746-4778-86E7-CCEB99DC4F9E}"/>
+                <a16:creationId xmlns:a16="http://schemas.microsoft.com/office/drawing/2014/main" id="{7719966E-85E9-412C-BEEB-9D0F6A5D7DCF}"/>
               </a:ext>
             </a:extLst>
           </p:cNvPr>
@@ -7691,7 +7691,7 @@
           <p:cNvPr id="83" name="Google Shape;83;p11">
             <a:extLst xmlns:a="http://schemas.openxmlformats.org/drawingml/2006/main">
               <a:ext uri="{FF2B5EF4-FFF2-40B4-BE49-F238E27FC236}">
-                <a16:creationId xmlns:a16="http://schemas.microsoft.com/office/drawing/2014/main" id="{77E09756-5E2B-460C-9132-93A24F74064F}"/>
+                <a16:creationId xmlns:a16="http://schemas.microsoft.com/office/drawing/2014/main" id="{73ECC39D-42D2-4F0E-8BFE-0878B10AB2B0}"/>
               </a:ext>
             </a:extLst>
           </p:cNvPr>
@@ -7866,7 +7866,7 @@
           <p:cNvPr id="84" name="Google Shape;84;p11">
             <a:extLst xmlns:a="http://schemas.openxmlformats.org/drawingml/2006/main">
               <a:ext uri="{FF2B5EF4-FFF2-40B4-BE49-F238E27FC236}">
-                <a16:creationId xmlns:a16="http://schemas.microsoft.com/office/drawing/2014/main" id="{D4A5914B-0218-4B8E-9E2E-EA6BD86A48FB}"/>
+                <a16:creationId xmlns:a16="http://schemas.microsoft.com/office/drawing/2014/main" id="{A4038D59-8F24-4AFB-A89C-C497201D5495}"/>
               </a:ext>
             </a:extLst>
           </p:cNvPr>
@@ -7930,7 +7930,7 @@
           <p:cNvPr id="85" name="Google Shape;85;p11">
             <a:extLst xmlns:a="http://schemas.openxmlformats.org/drawingml/2006/main">
               <a:ext uri="{FF2B5EF4-FFF2-40B4-BE49-F238E27FC236}">
-                <a16:creationId xmlns:a16="http://schemas.microsoft.com/office/drawing/2014/main" id="{38297A2C-1C72-4F50-A6FC-13FA3E49E66D}"/>
+                <a16:creationId xmlns:a16="http://schemas.microsoft.com/office/drawing/2014/main" id="{4482BE90-E18F-4FB5-89A5-374185B285E2}"/>
               </a:ext>
             </a:extLst>
           </p:cNvPr>
@@ -7994,7 +7994,7 @@
           <p:cNvPr id="86" name="Google Shape;86;p11">
             <a:extLst xmlns:a="http://schemas.openxmlformats.org/drawingml/2006/main">
               <a:ext uri="{FF2B5EF4-FFF2-40B4-BE49-F238E27FC236}">
-                <a16:creationId xmlns:a16="http://schemas.microsoft.com/office/drawing/2014/main" id="{C9220618-1408-4C33-B304-16BA6BE95639}"/>
+                <a16:creationId xmlns:a16="http://schemas.microsoft.com/office/drawing/2014/main" id="{A22EA4F7-27D3-44AA-AD8A-0373F5E37232}"/>
               </a:ext>
             </a:extLst>
           </p:cNvPr>
@@ -8169,7 +8169,7 @@
           <p:cNvPr id="87" name="Google Shape;87;p11">
             <a:extLst xmlns:a="http://schemas.openxmlformats.org/drawingml/2006/main">
               <a:ext uri="{FF2B5EF4-FFF2-40B4-BE49-F238E27FC236}">
-                <a16:creationId xmlns:a16="http://schemas.microsoft.com/office/drawing/2014/main" id="{177D11EB-CCA6-40BA-8845-0001869CD58F}"/>
+                <a16:creationId xmlns:a16="http://schemas.microsoft.com/office/drawing/2014/main" id="{194A0D5B-D42F-4EE5-81AA-D962F8133B41}"/>
               </a:ext>
             </a:extLst>
           </p:cNvPr>
@@ -8233,7 +8233,7 @@
           <p:cNvPr id="88" name="Google Shape;88;p11">
             <a:extLst xmlns:a="http://schemas.openxmlformats.org/drawingml/2006/main">
               <a:ext uri="{FF2B5EF4-FFF2-40B4-BE49-F238E27FC236}">
-                <a16:creationId xmlns:a16="http://schemas.microsoft.com/office/drawing/2014/main" id="{C29F6DDA-1872-4E6C-82C7-F1FFB3791F50}"/>
+                <a16:creationId xmlns:a16="http://schemas.microsoft.com/office/drawing/2014/main" id="{4E105200-3305-47D3-B5FB-0739A89B70BC}"/>
               </a:ext>
             </a:extLst>
           </p:cNvPr>
@@ -8311,7 +8311,7 @@
                 <a:ea typeface="Manrope"/>
                 <a:cs typeface="Manrope"/>
               </a:rPr>
-              <a:t>Same 14 focused checks: 4 failures before, 0 after</a:t>
+              <a:t>Same 16 focused checks: 6 failures before, 0 after</a:t>
             </a:r>
             <a:endParaRPr sz="2400" b="1">
               <a:solidFill>
@@ -8329,7 +8329,7 @@
           <p:cNvPr id="89" name="Google Shape;89;p11">
             <a:extLst xmlns:a="http://schemas.openxmlformats.org/drawingml/2006/main">
               <a:ext uri="{FF2B5EF4-FFF2-40B4-BE49-F238E27FC236}">
-                <a16:creationId xmlns:a16="http://schemas.microsoft.com/office/drawing/2014/main" id="{03595C2E-E22E-485E-9381-AA659690AAB1}"/>
+                <a16:creationId xmlns:a16="http://schemas.microsoft.com/office/drawing/2014/main" id="{9AB5721A-E390-416B-B1E2-F3C17BF7D432}"/>
               </a:ext>
             </a:extLst>
           </p:cNvPr>
@@ -8451,7 +8451,7 @@
                 <a:ea typeface="Manrope"/>
                 <a:cs typeface="Manrope"/>
               </a:rPr>
-              <a:t>All 14 passed after the fix. These are local results.</a:t>
+              <a:t>All 16 passed after the fix. These are local results.</a:t>
             </a:r>
             <a:endParaRPr sz="1900">
               <a:solidFill>
@@ -8502,7 +8502,7 @@
     </p:spTree>
     <p:extLst>
       <p:ext uri="{BB962C8B-B14F-4D97-AF65-F5344CB8AC3E}">
-        <p14:creationId xmlns:p14="http://schemas.microsoft.com/office/powerpoint/2010/main" val="307552279"/>
+        <p14:creationId xmlns:p14="http://schemas.microsoft.com/office/powerpoint/2010/main" val="1352234155"/>
       </p:ext>
     </p:extLst>
   </p:cSld>
@@ -8533,7 +8533,7 @@
           <p:cNvPr id="42" name="Google Shape;42;p9">
             <a:extLst xmlns:a="http://schemas.openxmlformats.org/drawingml/2006/main">
               <a:ext uri="{FF2B5EF4-FFF2-40B4-BE49-F238E27FC236}">
-                <a16:creationId xmlns:a16="http://schemas.microsoft.com/office/drawing/2014/main" id="{DFE48758-14A9-44C0-A2CC-836A15F68535}"/>
+                <a16:creationId xmlns:a16="http://schemas.microsoft.com/office/drawing/2014/main" id="{83C4B260-092A-4ED5-AD1A-C8F029B084D1}"/>
               </a:ext>
             </a:extLst>
           </p:cNvPr>
@@ -8584,7 +8584,7 @@
           <p:cNvPr id="43" name="Google Shape;43;p9">
             <a:extLst xmlns:a="http://schemas.openxmlformats.org/drawingml/2006/main">
               <a:ext uri="{FF2B5EF4-FFF2-40B4-BE49-F238E27FC236}">
-                <a16:creationId xmlns:a16="http://schemas.microsoft.com/office/drawing/2014/main" id="{5986D919-E229-4ABA-96CD-001E2F2E8546}"/>
+                <a16:creationId xmlns:a16="http://schemas.microsoft.com/office/drawing/2014/main" id="{24E5E759-489C-4530-9367-B83430A8554A}"/>
               </a:ext>
             </a:extLst>
           </p:cNvPr>
@@ -8648,7 +8648,7 @@
           <p:cNvPr id="44" name="Google Shape;44;p9">
             <a:extLst xmlns:a="http://schemas.openxmlformats.org/drawingml/2006/main">
               <a:ext uri="{FF2B5EF4-FFF2-40B4-BE49-F238E27FC236}">
-                <a16:creationId xmlns:a16="http://schemas.microsoft.com/office/drawing/2014/main" id="{FBB1A3B3-2DA4-489E-8EFB-017BA1B25CE4}"/>
+                <a16:creationId xmlns:a16="http://schemas.microsoft.com/office/drawing/2014/main" id="{0B61773D-7488-4265-B0AD-33E7CD29D35F}"/>
               </a:ext>
             </a:extLst>
           </p:cNvPr>
@@ -8712,7 +8712,7 @@
           <p:cNvPr id="45" name="Google Shape;45;p9">
             <a:extLst xmlns:a="http://schemas.openxmlformats.org/drawingml/2006/main">
               <a:ext uri="{FF2B5EF4-FFF2-40B4-BE49-F238E27FC236}">
-                <a16:creationId xmlns:a16="http://schemas.microsoft.com/office/drawing/2014/main" id="{2309D870-D76B-445E-BE76-8749D84DDF9F}"/>
+                <a16:creationId xmlns:a16="http://schemas.microsoft.com/office/drawing/2014/main" id="{44A3F6B0-FB16-4F4B-A469-08478C26C1F6}"/>
               </a:ext>
             </a:extLst>
           </p:cNvPr>
@@ -8810,7 +8810,7 @@
           <p:cNvPr id="46" name="Google Shape;46;p9">
             <a:extLst xmlns:a="http://schemas.openxmlformats.org/drawingml/2006/main">
               <a:ext uri="{FF2B5EF4-FFF2-40B4-BE49-F238E27FC236}">
-                <a16:creationId xmlns:a16="http://schemas.microsoft.com/office/drawing/2014/main" id="{299F6F40-C40A-4490-81A8-D1EA28D49980}"/>
+                <a16:creationId xmlns:a16="http://schemas.microsoft.com/office/drawing/2014/main" id="{41A40B0D-6F99-42C2-8D83-48C99B192D92}"/>
               </a:ext>
             </a:extLst>
           </p:cNvPr>
@@ -8874,7 +8874,7 @@
           <p:cNvPr id="47" name="Google Shape;47;p9">
             <a:extLst xmlns:a="http://schemas.openxmlformats.org/drawingml/2006/main">
               <a:ext uri="{FF2B5EF4-FFF2-40B4-BE49-F238E27FC236}">
-                <a16:creationId xmlns:a16="http://schemas.microsoft.com/office/drawing/2014/main" id="{9C9B5724-1456-4814-9E5D-A225757015F4}"/>
+                <a16:creationId xmlns:a16="http://schemas.microsoft.com/office/drawing/2014/main" id="{594E6614-93FF-409F-A827-80E689265BE2}"/>
               </a:ext>
             </a:extLst>
           </p:cNvPr>
@@ -8970,7 +8970,7 @@
           <p:cNvPr id="48" name="Google Shape;48;p9">
             <a:extLst xmlns:a="http://schemas.openxmlformats.org/drawingml/2006/main">
               <a:ext uri="{FF2B5EF4-FFF2-40B4-BE49-F238E27FC236}">
-                <a16:creationId xmlns:a16="http://schemas.microsoft.com/office/drawing/2014/main" id="{2D339E40-78FD-49E0-A147-4B915366E107}"/>
+                <a16:creationId xmlns:a16="http://schemas.microsoft.com/office/drawing/2014/main" id="{9C7D0C6B-2781-43CB-AA4B-457B80702F20}"/>
               </a:ext>
             </a:extLst>
           </p:cNvPr>
@@ -9066,7 +9066,7 @@
           <p:cNvPr id="49" name="Google Shape;49;p9">
             <a:extLst xmlns:a="http://schemas.openxmlformats.org/drawingml/2006/main">
               <a:ext uri="{FF2B5EF4-FFF2-40B4-BE49-F238E27FC236}">
-                <a16:creationId xmlns:a16="http://schemas.microsoft.com/office/drawing/2014/main" id="{FA08A004-7705-4E49-86B0-E8A3E12601BA}"/>
+                <a16:creationId xmlns:a16="http://schemas.microsoft.com/office/drawing/2014/main" id="{42C40909-52F8-47B6-8A63-9DB0028FE599}"/>
               </a:ext>
             </a:extLst>
           </p:cNvPr>
@@ -9250,7 +9250,7 @@
           <p:cNvPr id="50" name="Google Shape;50;p9">
             <a:extLst xmlns:a="http://schemas.openxmlformats.org/drawingml/2006/main">
               <a:ext uri="{FF2B5EF4-FFF2-40B4-BE49-F238E27FC236}">
-                <a16:creationId xmlns:a16="http://schemas.microsoft.com/office/drawing/2014/main" id="{D4E8937C-10F5-4DAF-B7D2-7757E2EDA0AF}"/>
+                <a16:creationId xmlns:a16="http://schemas.microsoft.com/office/drawing/2014/main" id="{6762FDE2-8574-4647-B467-8538203751C7}"/>
               </a:ext>
             </a:extLst>
           </p:cNvPr>
@@ -9425,7 +9425,7 @@
           <p:cNvPr id="51" name="Google Shape;51;p9">
             <a:extLst xmlns:a="http://schemas.openxmlformats.org/drawingml/2006/main">
               <a:ext uri="{FF2B5EF4-FFF2-40B4-BE49-F238E27FC236}">
-                <a16:creationId xmlns:a16="http://schemas.microsoft.com/office/drawing/2014/main" id="{FC2F51B2-E2A8-4C51-976A-9286CEBFE1BD}"/>
+                <a16:creationId xmlns:a16="http://schemas.microsoft.com/office/drawing/2014/main" id="{ECBB4C41-2C25-491A-8A03-6993E07EE589}"/>
               </a:ext>
             </a:extLst>
           </p:cNvPr>
@@ -9600,7 +9600,7 @@
           <p:cNvPr id="52" name="Google Shape;52;p9">
             <a:extLst xmlns:a="http://schemas.openxmlformats.org/drawingml/2006/main">
               <a:ext uri="{FF2B5EF4-FFF2-40B4-BE49-F238E27FC236}">
-                <a16:creationId xmlns:a16="http://schemas.microsoft.com/office/drawing/2014/main" id="{4343A830-9923-4DE0-8366-FDCD02F0FBA8}"/>
+                <a16:creationId xmlns:a16="http://schemas.microsoft.com/office/drawing/2014/main" id="{718B6741-8ABA-45F9-B241-4728C6DFEB93}"/>
               </a:ext>
             </a:extLst>
           </p:cNvPr>
@@ -9740,7 +9740,7 @@
           <p:cNvPr id="53" name="Google Shape;53;p9">
             <a:extLst xmlns:a="http://schemas.openxmlformats.org/drawingml/2006/main">
               <a:ext uri="{FF2B5EF4-FFF2-40B4-BE49-F238E27FC236}">
-                <a16:creationId xmlns:a16="http://schemas.microsoft.com/office/drawing/2014/main" id="{1B8336E6-0542-4A7F-9852-13AE4656980E}"/>
+                <a16:creationId xmlns:a16="http://schemas.microsoft.com/office/drawing/2014/main" id="{CE69BC14-FC10-4AE5-A8D0-DFBF53B9014A}"/>
               </a:ext>
             </a:extLst>
           </p:cNvPr>
@@ -9880,7 +9880,7 @@
           <p:cNvPr id="54" name="Google Shape;54;p9">
             <a:extLst xmlns:a="http://schemas.openxmlformats.org/drawingml/2006/main">
               <a:ext uri="{FF2B5EF4-FFF2-40B4-BE49-F238E27FC236}">
-                <a16:creationId xmlns:a16="http://schemas.microsoft.com/office/drawing/2014/main" id="{B2F3B98C-85E9-435E-BF31-287C6A2D2F57}"/>
+                <a16:creationId xmlns:a16="http://schemas.microsoft.com/office/drawing/2014/main" id="{96C8555E-276D-409C-8577-8E5D1C3FE42A}"/>
               </a:ext>
             </a:extLst>
           </p:cNvPr>
@@ -10053,7 +10053,7 @@
           <p:cNvPr id="55" name="review-limit">
             <a:extLst xmlns:a="http://schemas.openxmlformats.org/drawingml/2006/main">
               <a:ext uri="{FF2B5EF4-FFF2-40B4-BE49-F238E27FC236}">
-                <a16:creationId xmlns:a16="http://schemas.microsoft.com/office/drawing/2014/main" id="{9BD8D7BE-0AEA-4376-8424-1F685A25D622}"/>
+                <a16:creationId xmlns:a16="http://schemas.microsoft.com/office/drawing/2014/main" id="{EBCBC57F-F098-4824-AC63-F596CD3F7E18}"/>
               </a:ext>
             </a:extLst>
           </p:cNvPr>
@@ -10209,7 +10209,7 @@
     </p:spTree>
     <p:extLst>
       <p:ext uri="{BB962C8B-B14F-4D97-AF65-F5344CB8AC3E}">
-        <p14:creationId xmlns:p14="http://schemas.microsoft.com/office/powerpoint/2010/main" val="263949053"/>
+        <p14:creationId xmlns:p14="http://schemas.microsoft.com/office/powerpoint/2010/main" val="1603504256"/>
       </p:ext>
     </p:extLst>
   </p:cSld>
@@ -10240,7 +10240,7 @@
           <p:cNvPr id="60" name="Google Shape;60;p10">
             <a:extLst xmlns:a="http://schemas.openxmlformats.org/drawingml/2006/main">
               <a:ext uri="{FF2B5EF4-FFF2-40B4-BE49-F238E27FC236}">
-                <a16:creationId xmlns:a16="http://schemas.microsoft.com/office/drawing/2014/main" id="{D780B256-EC9E-420E-A747-E3927BC58D66}"/>
+                <a16:creationId xmlns:a16="http://schemas.microsoft.com/office/drawing/2014/main" id="{598541F1-6F25-41B4-BFC0-4FDF170D3080}"/>
               </a:ext>
             </a:extLst>
           </p:cNvPr>
@@ -10304,7 +10304,7 @@
           <p:cNvPr id="61" name="Google Shape;61;p10">
             <a:extLst xmlns:a="http://schemas.openxmlformats.org/drawingml/2006/main">
               <a:ext uri="{FF2B5EF4-FFF2-40B4-BE49-F238E27FC236}">
-                <a16:creationId xmlns:a16="http://schemas.microsoft.com/office/drawing/2014/main" id="{96C02A87-4351-418E-B26B-F3C8063A86A2}"/>
+                <a16:creationId xmlns:a16="http://schemas.microsoft.com/office/drawing/2014/main" id="{AEC4C21E-25F8-404A-980F-B6A3F60E14E2}"/>
               </a:ext>
             </a:extLst>
           </p:cNvPr>
@@ -10368,7 +10368,7 @@
           <p:cNvPr id="62" name="Google Shape;62;p10">
             <a:extLst xmlns:a="http://schemas.openxmlformats.org/drawingml/2006/main">
               <a:ext uri="{FF2B5EF4-FFF2-40B4-BE49-F238E27FC236}">
-                <a16:creationId xmlns:a16="http://schemas.microsoft.com/office/drawing/2014/main" id="{0122C7E9-8C16-4483-B227-1E2A81DB304E}"/>
+                <a16:creationId xmlns:a16="http://schemas.microsoft.com/office/drawing/2014/main" id="{217E1CB0-8C21-43DA-9C53-979C71365882}"/>
               </a:ext>
             </a:extLst>
           </p:cNvPr>
@@ -10466,7 +10466,7 @@
           <p:cNvPr id="63" name="Google Shape;63;p10">
             <a:extLst xmlns:a="http://schemas.openxmlformats.org/drawingml/2006/main">
               <a:ext uri="{FF2B5EF4-FFF2-40B4-BE49-F238E27FC236}">
-                <a16:creationId xmlns:a16="http://schemas.microsoft.com/office/drawing/2014/main" id="{1A57919E-0F93-4978-9620-FDC78E696AF3}"/>
+                <a16:creationId xmlns:a16="http://schemas.microsoft.com/office/drawing/2014/main" id="{B5ACBB98-8D95-4D1F-92E2-F39549BA7CC5}"/>
               </a:ext>
             </a:extLst>
           </p:cNvPr>
@@ -10530,7 +10530,7 @@
           <p:cNvPr id="64" name="Google Shape;64;p10">
             <a:extLst xmlns:a="http://schemas.openxmlformats.org/drawingml/2006/main">
               <a:ext uri="{FF2B5EF4-FFF2-40B4-BE49-F238E27FC236}">
-                <a16:creationId xmlns:a16="http://schemas.microsoft.com/office/drawing/2014/main" id="{DA9B0A24-0670-4ACB-8608-1734C82B2435}"/>
+                <a16:creationId xmlns:a16="http://schemas.microsoft.com/office/drawing/2014/main" id="{B39B895F-439D-46E3-A6D7-590583935859}"/>
               </a:ext>
             </a:extLst>
           </p:cNvPr>
@@ -10670,7 +10670,7 @@
           <p:cNvPr id="65" name="Google Shape;65;p10">
             <a:extLst xmlns:a="http://schemas.openxmlformats.org/drawingml/2006/main">
               <a:ext uri="{FF2B5EF4-FFF2-40B4-BE49-F238E27FC236}">
-                <a16:creationId xmlns:a16="http://schemas.microsoft.com/office/drawing/2014/main" id="{9B9DA8E0-75C6-4D14-BE86-5437516505BC}"/>
+                <a16:creationId xmlns:a16="http://schemas.microsoft.com/office/drawing/2014/main" id="{79FABF11-EDDC-43CB-93B1-202CCEFA4202}"/>
               </a:ext>
             </a:extLst>
           </p:cNvPr>
@@ -10845,7 +10845,7 @@
           <p:cNvPr id="66" name="Google Shape;66;p10">
             <a:extLst xmlns:a="http://schemas.openxmlformats.org/drawingml/2006/main">
               <a:ext uri="{FF2B5EF4-FFF2-40B4-BE49-F238E27FC236}">
-                <a16:creationId xmlns:a16="http://schemas.microsoft.com/office/drawing/2014/main" id="{9CD38A49-C457-413D-BD78-A51D2EF43CA6}"/>
+                <a16:creationId xmlns:a16="http://schemas.microsoft.com/office/drawing/2014/main" id="{A31AB736-D46C-474E-90D7-2FB6BE3072FB}"/>
               </a:ext>
             </a:extLst>
           </p:cNvPr>
@@ -10985,7 +10985,7 @@
           <p:cNvPr id="67" name="Google Shape;67;p10">
             <a:extLst xmlns:a="http://schemas.openxmlformats.org/drawingml/2006/main">
               <a:ext uri="{FF2B5EF4-FFF2-40B4-BE49-F238E27FC236}">
-                <a16:creationId xmlns:a16="http://schemas.microsoft.com/office/drawing/2014/main" id="{5326D100-6C1D-4DE2-94DB-7DEACEE915B4}"/>
+                <a16:creationId xmlns:a16="http://schemas.microsoft.com/office/drawing/2014/main" id="{F88E5557-EF39-4AF1-8D22-A7FE115EE695}"/>
               </a:ext>
             </a:extLst>
           </p:cNvPr>
@@ -11160,7 +11160,7 @@
           <p:cNvPr id="68" name="Google Shape;68;p10">
             <a:extLst xmlns:a="http://schemas.openxmlformats.org/drawingml/2006/main">
               <a:ext uri="{FF2B5EF4-FFF2-40B4-BE49-F238E27FC236}">
-                <a16:creationId xmlns:a16="http://schemas.microsoft.com/office/drawing/2014/main" id="{B4837A24-8F79-417F-8240-E2D90F609D37}"/>
+                <a16:creationId xmlns:a16="http://schemas.microsoft.com/office/drawing/2014/main" id="{1F51005F-4851-47B4-949A-B8AA835B1654}"/>
               </a:ext>
             </a:extLst>
           </p:cNvPr>
@@ -11300,7 +11300,7 @@
           <p:cNvPr id="69" name="Google Shape;69;p10">
             <a:extLst xmlns:a="http://schemas.openxmlformats.org/drawingml/2006/main">
               <a:ext uri="{FF2B5EF4-FFF2-40B4-BE49-F238E27FC236}">
-                <a16:creationId xmlns:a16="http://schemas.microsoft.com/office/drawing/2014/main" id="{2AFE3487-E02B-4EB7-A5FE-D106829FF781}"/>
+                <a16:creationId xmlns:a16="http://schemas.microsoft.com/office/drawing/2014/main" id="{FD4B1F3D-BC26-4CCC-BA6D-35BBC7FAA9CC}"/>
               </a:ext>
             </a:extLst>
           </p:cNvPr>
@@ -11475,7 +11475,7 @@
           <p:cNvPr id="70" name="Google Shape;70;p10">
             <a:extLst xmlns:a="http://schemas.openxmlformats.org/drawingml/2006/main">
               <a:ext uri="{FF2B5EF4-FFF2-40B4-BE49-F238E27FC236}">
-                <a16:creationId xmlns:a16="http://schemas.microsoft.com/office/drawing/2014/main" id="{FF7504C3-DFE5-490E-A973-4705DCC78783}"/>
+                <a16:creationId xmlns:a16="http://schemas.microsoft.com/office/drawing/2014/main" id="{38770463-6FE4-40AD-B6A3-EBE2360E196D}"/>
               </a:ext>
             </a:extLst>
           </p:cNvPr>
@@ -11615,7 +11615,7 @@
           <p:cNvPr id="71" name="Google Shape;71;p10">
             <a:extLst xmlns:a="http://schemas.openxmlformats.org/drawingml/2006/main">
               <a:ext uri="{FF2B5EF4-FFF2-40B4-BE49-F238E27FC236}">
-                <a16:creationId xmlns:a16="http://schemas.microsoft.com/office/drawing/2014/main" id="{935884B8-6389-4BC6-B711-9413E3DC09BC}"/>
+                <a16:creationId xmlns:a16="http://schemas.microsoft.com/office/drawing/2014/main" id="{A40478A9-5A42-43FA-9FCE-E8A012E2D55C}"/>
               </a:ext>
             </a:extLst>
           </p:cNvPr>
@@ -11788,7 +11788,7 @@
     </p:spTree>
     <p:extLst>
       <p:ext uri="{BB962C8B-B14F-4D97-AF65-F5344CB8AC3E}">
-        <p14:creationId xmlns:p14="http://schemas.microsoft.com/office/powerpoint/2010/main" val="376606384"/>
+        <p14:creationId xmlns:p14="http://schemas.microsoft.com/office/powerpoint/2010/main" val="1496330542"/>
       </p:ext>
     </p:extLst>
   </p:cSld>

</xml_diff>

<commit_message>
docs(a4): align Jiajun slides with paired Python env prefixes
Update the rule, 18-check evidence, and existing approval for 471afbe22.

Generated-by: Codex
</commit_message>
<xml_diff>
--- a/presentation/Jiajun-TIKA-4408-section.pptx
+++ b/presentation/Jiajun-TIKA-4408-section.pptx
@@ -2,32 +2,32 @@
 <file path=ppt/presentation.xml><?xml version="1.0" encoding="utf-8"?>
 <p:presentation xmlns:p="http://schemas.openxmlformats.org/presentationml/2006/main" embedTrueTypeFonts="1" saveSubsetFonts="0">
   <p:sldMasterIdLst>
-    <p:sldMasterId xmlns:r="http://schemas.openxmlformats.org/officeDocument/2006/relationships" id="2147483648" r:id="R7d3481794f8b4146"/>
-    <p:sldMasterId xmlns:r="http://schemas.openxmlformats.org/officeDocument/2006/relationships" id="2147483650" r:id="R4a92aa488af346b3"/>
+    <p:sldMasterId xmlns:r="http://schemas.openxmlformats.org/officeDocument/2006/relationships" id="2147483648" r:id="Re8aeb17c13e94c6c"/>
+    <p:sldMasterId xmlns:r="http://schemas.openxmlformats.org/officeDocument/2006/relationships" id="2147483650" r:id="R1f684f86f069429b"/>
   </p:sldMasterIdLst>
   <p:notesMasterIdLst>
-    <p:notesMasterId xmlns:r="http://schemas.openxmlformats.org/officeDocument/2006/relationships" r:id="R39cbbea3e1d64cc3"/>
+    <p:notesMasterId xmlns:r="http://schemas.openxmlformats.org/officeDocument/2006/relationships" r:id="R63250f908ac844ea"/>
   </p:notesMasterIdLst>
   <p:sldIdLst>
-    <p:sldId xmlns:r="http://schemas.openxmlformats.org/officeDocument/2006/relationships" id="256" r:id="Rbd3c6578ce5649a3"/>
-    <p:sldId xmlns:r="http://schemas.openxmlformats.org/officeDocument/2006/relationships" id="257" r:id="R01d70f7bf33c4a93"/>
-    <p:sldId xmlns:r="http://schemas.openxmlformats.org/officeDocument/2006/relationships" id="258" r:id="R8f9c55c020064460"/>
-    <p:sldId xmlns:r="http://schemas.openxmlformats.org/officeDocument/2006/relationships" id="259" r:id="R107bb44f878c4cf7"/>
+    <p:sldId xmlns:r="http://schemas.openxmlformats.org/officeDocument/2006/relationships" id="256" r:id="Rfc3eeb7e3ae242d8"/>
+    <p:sldId xmlns:r="http://schemas.openxmlformats.org/officeDocument/2006/relationships" id="257" r:id="Rb8e7e01332fa49d8"/>
+    <p:sldId xmlns:r="http://schemas.openxmlformats.org/officeDocument/2006/relationships" id="258" r:id="Rbed1cd04bd76423a"/>
+    <p:sldId xmlns:r="http://schemas.openxmlformats.org/officeDocument/2006/relationships" id="259" r:id="Reda7994dad024eb8"/>
   </p:sldIdLst>
   <p:sldSz cx="12192000" cy="6858000"/>
   <p:notesSz cx="6858000" cy="9144000"/>
   <p:embeddedFontLst>
     <p:embeddedFont>
       <p:font typeface="Manrope"/>
-      <p:regular xmlns:r="http://schemas.openxmlformats.org/officeDocument/2006/relationships" r:id="Rfec981ab9dd94728"/>
-      <p:bold xmlns:r="http://schemas.openxmlformats.org/officeDocument/2006/relationships" r:id="R4c81d41a4eba4489"/>
+      <p:regular xmlns:r="http://schemas.openxmlformats.org/officeDocument/2006/relationships" r:id="Rac4b06eb18c74260"/>
+      <p:bold xmlns:r="http://schemas.openxmlformats.org/officeDocument/2006/relationships" r:id="R411a33194b8c4b92"/>
     </p:embeddedFont>
     <p:embeddedFont>
       <p:font typeface="Roboto Mono"/>
-      <p:regular xmlns:r="http://schemas.openxmlformats.org/officeDocument/2006/relationships" r:id="Ra9ffa8487dee4916"/>
-      <p:bold xmlns:r="http://schemas.openxmlformats.org/officeDocument/2006/relationships" r:id="R3a31224c0bf749d5"/>
-      <p:italic xmlns:r="http://schemas.openxmlformats.org/officeDocument/2006/relationships" r:id="Rf85621f0fd9d4499"/>
-      <p:boldItalic xmlns:r="http://schemas.openxmlformats.org/officeDocument/2006/relationships" r:id="R46446f4ab0d147b7"/>
+      <p:regular xmlns:r="http://schemas.openxmlformats.org/officeDocument/2006/relationships" r:id="R025908181d17463d"/>
+      <p:bold xmlns:r="http://schemas.openxmlformats.org/officeDocument/2006/relationships" r:id="R7b1f32bc4a884afb"/>
+      <p:italic xmlns:r="http://schemas.openxmlformats.org/officeDocument/2006/relationships" r:id="R1f622fa0f3044b17"/>
+      <p:boldItalic xmlns:r="http://schemas.openxmlformats.org/officeDocument/2006/relationships" r:id="Rfe42d6deb1b447a4"/>
     </p:embeddedFont>
   </p:embeddedFontLst>
   <p:defaultTextStyle>
@@ -752,7 +752,7 @@
               <a:buNone/>
             </a:pPr>
             <a:r>
-              <a:t>The first challenge was understanding why Tika identified this Python script as Shell. A shebang is the first line that names the interpreter. The old Python rule searched for slash bin slash env python at offset one. Offset means the starting position, counted from zero. In this input, that substring actually starts at offset six, so the Python rule missed it and a Shell rule matched instead. The fix checks the complete no-space env python prefix at the start of the file. The same prefix covers python, python3 and python3.11. Understanding the existing rules helped us define the scope clearly.</a:t>
+              <a:t>The first challenge was understanding why Tika identified this Python script as Shell. A shebang is the first line that names the interpreter. The old Python rule searched for slash bin slash env python at offset one. Offset means the starting position, counted from zero. In this input, that substring actually starts at offset six, so the Python rule missed it and a Shell rule matched instead. The fix checks two complete prefixes at the start of the file, with no space or exactly one space after hash and exclamation mark. This follows the existing direct-path Python rules, which also have both forms. Prefix matching covers python and version suffixes such as python3 and python3.11.</a:t>
             </a:r>
             <a:endParaRPr/>
           </a:p>
@@ -797,7 +797,7 @@
               <a:buNone/>
             </a:pPr>
             <a:r>
-              <a:t>先说明现象：Python 首行却识别成 Shell。offset 是从 0 开始数的位置。原规则检查位置 1，但 /bin/env python 实际从位置 6 开始，所以 Python 规则没命中。当前修复从文件开头匹配 #!/usr/bin/env python 前缀，同时覆盖 python、python3 和 python3.11。#! 后的单空格、多空格和 Tab 不属于本次修复范围。</a:t>
+              <a:t>先说明现象：Python 首行却识别成 Shell。offset 是从 0 开始数的位置。原规则检查位置 1，但 /bin/env python 实际从位置 6 开始，所以 Python 规则没命中。修复从位置 0 匹配两条完整前缀：#!/usr/bin/env python 和 #! /usr/bin/env python。这与已有 Python 直接路径规则成对列出无空格和一个空格的方式一致。前缀匹配同时兼容 python、python3 和 python3.11。多空格、Tab 和 env 参数不在本次修复范围。</a:t>
             </a:r>
             <a:endParaRPr/>
           </a:p>
@@ -842,7 +842,7 @@
               <a:buNone/>
             </a:pPr>
             <a:r>
-              <a:t>Current scope confirmed 25 October 2026: one literal #!/usr/bin/env python prefix at offset 0. Prefix matching covers python and version suffixes, with python3 and python3.11 included in the tests. Existing direct-path Python rules remain unchanged. Whitespace after #! and env options such as env -S are outside this patch. This does not claim support for every Python shebang variant.</a:t>
+              <a:t>Current scope confirmed 25 October 2026: two literal string prefixes at offset 0, #!/usr/bin/env python and #! /usr/bin/env python. The paired form follows the existing direct-path Python rules, which remain unchanged. Tests include the no-space python, python3 and python3.11 cases plus exactly one space in #! /usr/bin/env python3. Prefix matching also permits version suffixes for the one-space rule, although those variants are not separate rows in the test matrix. Multiple spaces, Tab characters, env options such as env -S, and regex-based whitespace handling are outside this patch.</a:t>
             </a:r>
             <a:endParaRPr/>
           </a:p>
@@ -902,7 +902,7 @@
               <a:buNone/>
             </a:pPr>
             <a:r>
-              <a:t>https://github.com/u8026876/comp2120-gyg-a5/commit/7a8ea6bb62b86c9f7f0b74f81eb052e4c5bedd4f</a:t>
+              <a:t>https://github.com/u8026876/comp2120-gyg-a5/commit/471afbe222655b31cb46415b979a856ccdadcea4</a:t>
             </a:r>
             <a:endParaRPr/>
           </a:p>
@@ -932,7 +932,7 @@
               <a:buNone/>
             </a:pPr>
             <a:r>
-              <a:t>Contribution and assistance: Jiajun owns TIKA-4408. Codex assisted the implementation, testing, and presentation preparation. Kyubin supplied independent validation and review of the earlier version. The current revision needs renewed human review. Terry supplied additional review feedback. The visual template belongs to the group and was shared by Kyubin.</a:t>
+              <a:t>Contribution and assistance: Jiajun owns TIKA-4408. Codex assisted the implementation, testing, and presentation preparation. Kyubin supplied independent validation and approved cefa669. The restored code is identical to that reviewed source, and the group review policy retains that approval. Terry supplied additional review feedback. The PR is open, with merge and upstream submission pending. The visual template belongs to the group and was shared by Kyubin.</a:t>
             </a:r>
             <a:endParaRPr/>
           </a:p>
@@ -1042,7 +1042,7 @@
               <a:buNone/>
             </a:pPr>
             <a:r>
-              <a:t>A successful result for one Python example would leave important questions unanswered. The regression checks covered env python, python3 and python3.11, existing direct Python paths, and Shell scripts. They separated content-only detection from detection with a dot-py filename hint, because metadata can affect the result. A leading-newline control checked that the rule required the start of the file. Running the same sixteen checks with the original broken rule and then the current fix gave a clear comparison: six failed before the change, and all sixteen passed afterwards. This evidence shows the repair within the chosen scope.</a:t>
+              <a:t>A successful result for one Python example would leave important questions unanswered. The regression checks covered env python, python3 and python3.11 without a space after hash and exclamation mark, and an env python3 example with exactly one space. They also covered existing direct Python paths and Shell scripts. We separated content-only detection from detection with a dot-py filename hint, because metadata can affect the result. A leading-newline control checked that the rule required the start of the file. The same eighteen checks gave seven failures with the original rule, and all eighteen passed with the restored pair of prefixes.</a:t>
             </a:r>
             <a:endParaRPr/>
           </a:p>
@@ -1087,7 +1087,7 @@
               <a:buNone/>
             </a:pPr>
             <a:r>
-              <a:t>这页讲如何证明当前修复可靠。content-only 是不给文件名，只靠内容识别；filename hint 是额外给 script.py。两种方式分开测，防止文件名掩盖内容规则的问题。还测原本正常的 Python 路径、Shell，以及前面多一个换行的输入。当前 16 项测试在原 offset 1 规则下有 6 项失败，换成通用 python 前缀规则后全通过。这里使用当前版本的测试结果。</a:t>
+              <a:t>这页讲如何证明修复可靠。content-only 是不给文件名，只靠内容识别；filename hint 是额外给 script.py。无空格的 python、python3、python3.11，加上一个空格的 #! /usr/bin/env python3，都分别用两种方式测试。还测原本正常的 Python 路径、Shell，以及前面多一个换行的输入。相同 18 项测试在原 offset 1 规则下有 7 项失败，换成两条位置 0 的前缀规则后全通过。</a:t>
             </a:r>
             <a:endParaRPr/>
           </a:p>
@@ -1132,7 +1132,7 @@
               <a:buNone/>
             </a:pPr>
             <a:r>
-              <a:t>The 16 checks are parameterized regression cases, not 16 separate test methods. On 25 October 2026, the negative control kept these tests and temporarily restored only the original /bin/env python rule at offset 1: 6 failures, 0 errors. The generic no-space Python prefix rule in commit 7a8ea6bb62b86c9f7f0b74f81eb052e4c5bedd4f then passed all 16 checks. Full local core clean install with pedantic checks and randomized locale passed: 1,375 tests, 0 failures/errors, 2 skipped; alternate Xerces checks: 12 tests, 2 skipped; TikaIT: 1 passed; annotation-processor tests: 8 passed; quality checks passed. Kyubin's earlier approval covered cefa669, not this current revision. No full Tika repository test or remote CI claim is made.</a:t>
+              <a:t>The 18 checks are parameterized regression cases, not 18 separate test methods. On 25 October 2026, the negative control kept these tests and temporarily restored only the original /bin/env python rule at offset 1: 7 failures, 0 errors. A second control retained only the no-space prefix: 18 tests, 1 failure in the one-space content-only case. The two Python prefix rules in commit 471afbe222655b31cb46415b979a856ccdadcea4 then passed all 18 checks. Full local core clean install with pedantic checks and randomized locale passed: 1,377 tests, 0 failures/errors, 2 skipped; alternate Xerces checks: 12 tests, 2 skipped; TikaIT: 1 passed; annotation-processor tests: 8 passed; quality checks passed. The restored source is byte-identical to cefa669, which Kyubin approved. The group review policy allows existing reviews to count when they cover the submitted change, so that peer approval remains applicable. Merge and upstream submission remain pending. No full Tika repository test or remote CI claim is made.</a:t>
             </a:r>
             <a:endParaRPr/>
           </a:p>
@@ -1192,7 +1192,7 @@
               <a:buNone/>
             </a:pPr>
             <a:r>
-              <a:t>https://github.com/u8026876/comp2120-gyg-a5/commit/7a8ea6bb62b86c9f7f0b74f81eb052e4c5bedd4f</a:t>
+              <a:t>https://github.com/u8026876/comp2120-gyg-a5/commit/471afbe222655b31cb46415b979a856ccdadcea4</a:t>
             </a:r>
             <a:endParaRPr/>
           </a:p>
@@ -1222,7 +1222,7 @@
               <a:buNone/>
             </a:pPr>
             <a:r>
-              <a:t>Contribution and assistance: Jiajun owns TIKA-4408. Codex assisted the implementation, testing, and presentation preparation. Kyubin supplied independent validation and review of the earlier version. The current revision needs renewed human review. Terry supplied additional review feedback. The visual template belongs to the group and was shared by Kyubin.</a:t>
+              <a:t>Contribution and assistance: Jiajun owns TIKA-4408. Codex assisted the implementation, testing, and presentation preparation. Kyubin supplied independent validation and approved cefa669. The restored code is identical to that reviewed source, and the group review policy retains that approval. Terry supplied additional review feedback. The PR is open, with merge and upstream submission pending. The visual template belongs to the group and was shared by Kyubin.</a:t>
             </a:r>
             <a:endParaRPr/>
           </a:p>
@@ -1377,7 +1377,7 @@
               <a:buNone/>
             </a:pPr>
             <a:r>
-              <a:t>这不是要执行的 Python 代码，而是故意构造的普通文本。x 占位置 0，后面的 /bin/env python 正好在位置 1，因此旧规则会误报为 Python。false positive 就是误报。Terry 提议把它加入长期测试，Kyubin 对早先 cefa669 版本做过独立验证。图中结果引用的是那次历史验证，不表示他已批准当前版本。该反例未进入当前 16 项测试，永久回归测试暂缓。</a:t>
+              <a:t>这不是要执行的 Python 代码，而是故意构造的普通文本。x 占位置 0，后面的 /bin/env python 正好在位置 1，因此旧规则会误报为 Python。false positive 就是误报。Terry 提议把它加入长期测试，Kyubin 对 cefa669 版本做过独立验证。图中结果引用的是那次单独验证，当前 review 状态以 PR 记录为准。该反例未进入当前 18 项测试，永久回归测试暂缓。</a:t>
             </a:r>
             <a:endParaRPr/>
           </a:p>
@@ -1422,7 +1422,7 @@
               <a:buNone/>
             </a:pPr>
             <a:r>
-              <a:t>These observed results refer only to Kyubin's earlier separate content-only probe on cefa669 and the original MIME registry. They are historical review evidence, not a fresh test or approval of the current generic Python prefix revision. The permanent regression test remains deferred.</a:t>
+              <a:t>These observed results come from Kyubin's separate content-only probe on cefa669 and the original MIME registry. This is recorded review evidence rather than a fresh automated check in the current 18-case matrix. The permanent regression test remains deferred. Current review status is recorded on the PR.</a:t>
             </a:r>
             <a:endParaRPr/>
           </a:p>
@@ -1527,7 +1527,7 @@
               <a:buNone/>
             </a:pPr>
             <a:r>
-              <a:t>Contribution and assistance: Jiajun owns TIKA-4408. Codex assisted the implementation, testing, and presentation preparation. Kyubin supplied independent validation and review of the earlier version. The current revision needs renewed human review. Terry supplied additional review feedback. The visual template belongs to the group and was shared by Kyubin.</a:t>
+              <a:t>Contribution and assistance: Jiajun owns TIKA-4408. Codex assisted the implementation, testing, and presentation preparation. Kyubin supplied independent validation and approved cefa669. The restored code is identical to that reviewed source, and the group review policy retains that approval. Terry supplied additional review feedback. The PR is open, with merge and upstream submission pending. The visual template belongs to the group and was shared by Kyubin.</a:t>
             </a:r>
             <a:endParaRPr/>
           </a:p>
@@ -1862,7 +1862,7 @@
               <a:buNone/>
             </a:pPr>
             <a:r>
-              <a:t>Contribution and assistance: Jiajun owns TIKA-4408. Codex assisted the implementation, testing, and presentation preparation. Kyubin supplied independent validation and review of the earlier version. The current revision needs renewed human review. Terry supplied additional review feedback. The visual template belongs to the group and was shared by Kyubin.</a:t>
+              <a:t>Contribution and assistance: Jiajun owns TIKA-4408. Codex assisted the implementation, testing, and presentation preparation. Kyubin supplied independent validation and approved cefa669. The restored code is identical to that reviewed source, and the group review policy retains that approval. Terry supplied additional review feedback. The PR is open, with merge and upstream submission pending. The visual template belongs to the group and was shared by Kyubin.</a:t>
             </a:r>
             <a:endParaRPr/>
           </a:p>
@@ -1910,7 +1910,7 @@
           <p:cNvPr id="11" name="Google Shape;11;p2">
             <a:extLst xmlns:a="http://schemas.openxmlformats.org/drawingml/2006/main">
               <a:ext uri="{FF2B5EF4-FFF2-40B4-BE49-F238E27FC236}">
-                <a16:creationId xmlns:a16="http://schemas.microsoft.com/office/drawing/2014/main" id="{278A28B7-CA3A-4089-A8E7-83059BDDDEF6}"/>
+                <a16:creationId xmlns:a16="http://schemas.microsoft.com/office/drawing/2014/main" id="{8419BC4A-AB4F-4939-A3CB-EAC1788F6A42}"/>
               </a:ext>
             </a:extLst>
           </p:cNvPr>
@@ -2047,7 +2047,7 @@
           <p:cNvPr id="12" name="Google Shape;12;p2">
             <a:extLst xmlns:a="http://schemas.openxmlformats.org/drawingml/2006/main">
               <a:ext uri="{FF2B5EF4-FFF2-40B4-BE49-F238E27FC236}">
-                <a16:creationId xmlns:a16="http://schemas.microsoft.com/office/drawing/2014/main" id="{96E62322-A7DE-4134-B059-A84CEF4D27D8}"/>
+                <a16:creationId xmlns:a16="http://schemas.microsoft.com/office/drawing/2014/main" id="{72FDEE64-1AFD-4A7F-993C-1A955970ABDA}"/>
               </a:ext>
             </a:extLst>
           </p:cNvPr>
@@ -2201,7 +2201,7 @@
           <p:cNvPr id="15" name="Google Shape;15;p4">
             <a:extLst xmlns:a="http://schemas.openxmlformats.org/drawingml/2006/main">
               <a:ext uri="{FF2B5EF4-FFF2-40B4-BE49-F238E27FC236}">
-                <a16:creationId xmlns:a16="http://schemas.microsoft.com/office/drawing/2014/main" id="{AC7723D6-18E1-43E7-984E-2500009670BE}"/>
+                <a16:creationId xmlns:a16="http://schemas.microsoft.com/office/drawing/2014/main" id="{3BAC645A-8630-4D79-94D6-B5E25B8644BB}"/>
               </a:ext>
             </a:extLst>
           </p:cNvPr>
@@ -2338,7 +2338,7 @@
           <p:cNvPr id="16" name="Google Shape;16;p4">
             <a:extLst xmlns:a="http://schemas.openxmlformats.org/drawingml/2006/main">
               <a:ext uri="{FF2B5EF4-FFF2-40B4-BE49-F238E27FC236}">
-                <a16:creationId xmlns:a16="http://schemas.microsoft.com/office/drawing/2014/main" id="{32170826-853C-475A-89BC-2E6DCA086531}"/>
+                <a16:creationId xmlns:a16="http://schemas.microsoft.com/office/drawing/2014/main" id="{443749A5-2521-411E-84DF-8048D717D2A2}"/>
               </a:ext>
             </a:extLst>
           </p:cNvPr>
@@ -2475,7 +2475,7 @@
           <p:cNvPr id="17" name="Google Shape;17;p4">
             <a:extLst xmlns:a="http://schemas.openxmlformats.org/drawingml/2006/main">
               <a:ext uri="{FF2B5EF4-FFF2-40B4-BE49-F238E27FC236}">
-                <a16:creationId xmlns:a16="http://schemas.microsoft.com/office/drawing/2014/main" id="{00B73ED3-0958-4560-A306-5447940B7451}"/>
+                <a16:creationId xmlns:a16="http://schemas.microsoft.com/office/drawing/2014/main" id="{6D09A10B-1B85-473D-9E8D-6BED8F0388A8}"/>
               </a:ext>
             </a:extLst>
           </p:cNvPr>
@@ -2629,7 +2629,7 @@
           <p:cNvPr id="19" name="Google Shape;19;p5">
             <a:extLst xmlns:a="http://schemas.openxmlformats.org/drawingml/2006/main">
               <a:ext uri="{FF2B5EF4-FFF2-40B4-BE49-F238E27FC236}">
-                <a16:creationId xmlns:a16="http://schemas.microsoft.com/office/drawing/2014/main" id="{89D9217F-4114-4D10-8EC3-0BF0020B3272}"/>
+                <a16:creationId xmlns:a16="http://schemas.microsoft.com/office/drawing/2014/main" id="{F115295E-85C1-4456-B8DF-31DF7B6C627C}"/>
               </a:ext>
             </a:extLst>
           </p:cNvPr>
@@ -2766,7 +2766,7 @@
           <p:cNvPr id="20" name="Google Shape;20;p5">
             <a:extLst xmlns:a="http://schemas.openxmlformats.org/drawingml/2006/main">
               <a:ext uri="{FF2B5EF4-FFF2-40B4-BE49-F238E27FC236}">
-                <a16:creationId xmlns:a16="http://schemas.microsoft.com/office/drawing/2014/main" id="{5A54D4FF-89CA-4D56-98B0-6E1E9E674416}"/>
+                <a16:creationId xmlns:a16="http://schemas.microsoft.com/office/drawing/2014/main" id="{80AE2A0E-B7A9-4502-AACB-E5B789F703FE}"/>
               </a:ext>
             </a:extLst>
           </p:cNvPr>
@@ -2903,7 +2903,7 @@
           <p:cNvPr id="21" name="Google Shape;21;p5">
             <a:extLst xmlns:a="http://schemas.openxmlformats.org/drawingml/2006/main">
               <a:ext uri="{FF2B5EF4-FFF2-40B4-BE49-F238E27FC236}">
-                <a16:creationId xmlns:a16="http://schemas.microsoft.com/office/drawing/2014/main" id="{1C424A45-5477-4BD4-AEA2-62347B004432}"/>
+                <a16:creationId xmlns:a16="http://schemas.microsoft.com/office/drawing/2014/main" id="{7681E8BD-6771-40A6-9853-A62EBE20DD1B}"/>
               </a:ext>
             </a:extLst>
           </p:cNvPr>
@@ -3057,7 +3057,7 @@
           <p:cNvPr id="23" name="Google Shape;23;p6">
             <a:extLst xmlns:a="http://schemas.openxmlformats.org/drawingml/2006/main">
               <a:ext uri="{FF2B5EF4-FFF2-40B4-BE49-F238E27FC236}">
-                <a16:creationId xmlns:a16="http://schemas.microsoft.com/office/drawing/2014/main" id="{0085D972-A233-49BD-A862-94D8F4B52F08}"/>
+                <a16:creationId xmlns:a16="http://schemas.microsoft.com/office/drawing/2014/main" id="{9EE92BEE-9C49-46FF-AB14-C8F6EF10B10F}"/>
               </a:ext>
             </a:extLst>
           </p:cNvPr>
@@ -3194,7 +3194,7 @@
           <p:cNvPr id="24" name="Google Shape;24;p6">
             <a:extLst xmlns:a="http://schemas.openxmlformats.org/drawingml/2006/main">
               <a:ext uri="{FF2B5EF4-FFF2-40B4-BE49-F238E27FC236}">
-                <a16:creationId xmlns:a16="http://schemas.microsoft.com/office/drawing/2014/main" id="{72E550EA-AE1E-4AB5-8B8D-E8FAB05F8385}"/>
+                <a16:creationId xmlns:a16="http://schemas.microsoft.com/office/drawing/2014/main" id="{3B89CF53-BDE8-476B-8DC8-A6E3F9CE8D3C}"/>
               </a:ext>
             </a:extLst>
           </p:cNvPr>
@@ -3348,7 +3348,7 @@
           <p:cNvPr id="26" name="Google Shape;26;p7">
             <a:extLst xmlns:a="http://schemas.openxmlformats.org/drawingml/2006/main">
               <a:ext uri="{FF2B5EF4-FFF2-40B4-BE49-F238E27FC236}">
-                <a16:creationId xmlns:a16="http://schemas.microsoft.com/office/drawing/2014/main" id="{1895F37E-39DF-4CF7-89A1-7D39D754CE04}"/>
+                <a16:creationId xmlns:a16="http://schemas.microsoft.com/office/drawing/2014/main" id="{E18FD40E-96A9-4C40-92A2-A37F107EB4D6}"/>
               </a:ext>
             </a:extLst>
           </p:cNvPr>
@@ -3485,7 +3485,7 @@
           <p:cNvPr id="27" name="Google Shape;27;p7">
             <a:extLst xmlns:a="http://schemas.openxmlformats.org/drawingml/2006/main">
               <a:ext uri="{FF2B5EF4-FFF2-40B4-BE49-F238E27FC236}">
-                <a16:creationId xmlns:a16="http://schemas.microsoft.com/office/drawing/2014/main" id="{AF5462B7-0C59-486B-A941-83C66DE28C65}"/>
+                <a16:creationId xmlns:a16="http://schemas.microsoft.com/office/drawing/2014/main" id="{3774171E-C7DC-4713-8AEC-B00C0FE87CDE}"/>
               </a:ext>
             </a:extLst>
           </p:cNvPr>
@@ -3645,7 +3645,7 @@
   </p:cSld>
   <p:clrMap bg1="lt1" tx1="dk1" bg2="dk2" tx2="lt2" accent1="accent1" accent2="accent2" accent3="accent3" accent4="accent4" accent5="accent5" accent6="accent6" hlink="hlink" folHlink="folHlink"/>
   <p:sldLayoutIdLst>
-    <p:sldLayoutId xmlns:r="http://schemas.openxmlformats.org/officeDocument/2006/relationships" id="2147483649" r:id="R24bc878ace2541ab"/>
+    <p:sldLayoutId xmlns:r="http://schemas.openxmlformats.org/officeDocument/2006/relationships" id="2147483649" r:id="R8f76fec9297148cb"/>
   </p:sldLayoutIdLst>
   <p:hf sldNum="0" hdr="0" ftr="0" dt="0"/>
   <p:txStyles>
@@ -4330,10 +4330,10 @@
   </p:cSld>
   <p:clrMap bg1="lt1" tx1="dk1" bg2="dk2" tx2="lt2" accent1="accent1" accent2="accent2" accent3="accent3" accent4="accent4" accent5="accent5" accent6="accent6" hlink="hlink" folHlink="folHlink"/>
   <p:sldLayoutIdLst>
-    <p:sldLayoutId xmlns:r="http://schemas.openxmlformats.org/officeDocument/2006/relationships" id="2147483651" r:id="R758ccf8cc08b40cd"/>
-    <p:sldLayoutId xmlns:r="http://schemas.openxmlformats.org/officeDocument/2006/relationships" id="2147483652" r:id="R794546490d034342"/>
-    <p:sldLayoutId xmlns:r="http://schemas.openxmlformats.org/officeDocument/2006/relationships" id="2147483653" r:id="R4667a408473343d5"/>
-    <p:sldLayoutId xmlns:r="http://schemas.openxmlformats.org/officeDocument/2006/relationships" id="2147483654" r:id="R0bf6acc55a224d74"/>
+    <p:sldLayoutId xmlns:r="http://schemas.openxmlformats.org/officeDocument/2006/relationships" id="2147483651" r:id="Rebf8a2a2f9234b9d"/>
+    <p:sldLayoutId xmlns:r="http://schemas.openxmlformats.org/officeDocument/2006/relationships" id="2147483652" r:id="R757457ba1f264c05"/>
+    <p:sldLayoutId xmlns:r="http://schemas.openxmlformats.org/officeDocument/2006/relationships" id="2147483653" r:id="R2c07d903a66c4425"/>
+    <p:sldLayoutId xmlns:r="http://schemas.openxmlformats.org/officeDocument/2006/relationships" id="2147483654" r:id="R2bd7af8bab0d4cf2"/>
   </p:sldLayoutIdLst>
   <p:hf sldNum="0" hdr="0" ftr="0" dt="0"/>
   <p:txStyles>
@@ -5555,7 +5555,7 @@
           <p:cNvPr id="42" name="Google Shape;42;p9">
             <a:extLst xmlns:a="http://schemas.openxmlformats.org/drawingml/2006/main">
               <a:ext uri="{FF2B5EF4-FFF2-40B4-BE49-F238E27FC236}">
-                <a16:creationId xmlns:a16="http://schemas.microsoft.com/office/drawing/2014/main" id="{83C4B260-092A-4ED5-AD1A-C8F029B084D1}"/>
+                <a16:creationId xmlns:a16="http://schemas.microsoft.com/office/drawing/2014/main" id="{C649A7DE-3EB6-4F20-99F1-6CCEBCD4FFF0}"/>
               </a:ext>
             </a:extLst>
           </p:cNvPr>
@@ -5606,7 +5606,7 @@
           <p:cNvPr id="43" name="Google Shape;43;p9">
             <a:extLst xmlns:a="http://schemas.openxmlformats.org/drawingml/2006/main">
               <a:ext uri="{FF2B5EF4-FFF2-40B4-BE49-F238E27FC236}">
-                <a16:creationId xmlns:a16="http://schemas.microsoft.com/office/drawing/2014/main" id="{24E5E759-489C-4530-9367-B83430A8554A}"/>
+                <a16:creationId xmlns:a16="http://schemas.microsoft.com/office/drawing/2014/main" id="{F563E5C4-AF43-47DB-A4EC-C542AA844741}"/>
               </a:ext>
             </a:extLst>
           </p:cNvPr>
@@ -5670,7 +5670,7 @@
           <p:cNvPr id="44" name="Google Shape;44;p9">
             <a:extLst xmlns:a="http://schemas.openxmlformats.org/drawingml/2006/main">
               <a:ext uri="{FF2B5EF4-FFF2-40B4-BE49-F238E27FC236}">
-                <a16:creationId xmlns:a16="http://schemas.microsoft.com/office/drawing/2014/main" id="{0B61773D-7488-4265-B0AD-33E7CD29D35F}"/>
+                <a16:creationId xmlns:a16="http://schemas.microsoft.com/office/drawing/2014/main" id="{980F5A0C-EB58-44AD-BE53-98BAFE1A5342}"/>
               </a:ext>
             </a:extLst>
           </p:cNvPr>
@@ -5734,7 +5734,7 @@
           <p:cNvPr id="45" name="Google Shape;45;p9">
             <a:extLst xmlns:a="http://schemas.openxmlformats.org/drawingml/2006/main">
               <a:ext uri="{FF2B5EF4-FFF2-40B4-BE49-F238E27FC236}">
-                <a16:creationId xmlns:a16="http://schemas.microsoft.com/office/drawing/2014/main" id="{44A3F6B0-FB16-4F4B-A469-08478C26C1F6}"/>
+                <a16:creationId xmlns:a16="http://schemas.microsoft.com/office/drawing/2014/main" id="{33D82BA1-51F6-46A3-A292-B6322244794D}"/>
               </a:ext>
             </a:extLst>
           </p:cNvPr>
@@ -5832,7 +5832,7 @@
           <p:cNvPr id="46" name="Google Shape;46;p9">
             <a:extLst xmlns:a="http://schemas.openxmlformats.org/drawingml/2006/main">
               <a:ext uri="{FF2B5EF4-FFF2-40B4-BE49-F238E27FC236}">
-                <a16:creationId xmlns:a16="http://schemas.microsoft.com/office/drawing/2014/main" id="{41A40B0D-6F99-42C2-8D83-48C99B192D92}"/>
+                <a16:creationId xmlns:a16="http://schemas.microsoft.com/office/drawing/2014/main" id="{35D0A4BF-CD5A-4522-B7C2-CCF382DD9AEF}"/>
               </a:ext>
             </a:extLst>
           </p:cNvPr>
@@ -5896,7 +5896,7 @@
           <p:cNvPr id="47" name="Google Shape;47;p9">
             <a:extLst xmlns:a="http://schemas.openxmlformats.org/drawingml/2006/main">
               <a:ext uri="{FF2B5EF4-FFF2-40B4-BE49-F238E27FC236}">
-                <a16:creationId xmlns:a16="http://schemas.microsoft.com/office/drawing/2014/main" id="{594E6614-93FF-409F-A827-80E689265BE2}"/>
+                <a16:creationId xmlns:a16="http://schemas.microsoft.com/office/drawing/2014/main" id="{9CA6DB4B-926F-4A17-9A79-E05731261294}"/>
               </a:ext>
             </a:extLst>
           </p:cNvPr>
@@ -5992,7 +5992,7 @@
           <p:cNvPr id="48" name="Google Shape;48;p9">
             <a:extLst xmlns:a="http://schemas.openxmlformats.org/drawingml/2006/main">
               <a:ext uri="{FF2B5EF4-FFF2-40B4-BE49-F238E27FC236}">
-                <a16:creationId xmlns:a16="http://schemas.microsoft.com/office/drawing/2014/main" id="{9C7D0C6B-2781-43CB-AA4B-457B80702F20}"/>
+                <a16:creationId xmlns:a16="http://schemas.microsoft.com/office/drawing/2014/main" id="{1F616BD8-03FF-4592-AFB6-3DAFFA80CB77}"/>
               </a:ext>
             </a:extLst>
           </p:cNvPr>
@@ -6070,7 +6070,7 @@
                 <a:ea typeface="Manrope"/>
                 <a:cs typeface="Manrope"/>
               </a:rPr>
-              <a:t>FIXED RULE: START OF FILE</a:t>
+              <a:t>FIXED RULES: OFFSET 0</a:t>
             </a:r>
             <a:endParaRPr sz="1200" b="1">
               <a:solidFill>
@@ -6088,7 +6088,7 @@
           <p:cNvPr id="49" name="Google Shape;49;p9">
             <a:extLst xmlns:a="http://schemas.openxmlformats.org/drawingml/2006/main">
               <a:ext uri="{FF2B5EF4-FFF2-40B4-BE49-F238E27FC236}">
-                <a16:creationId xmlns:a16="http://schemas.microsoft.com/office/drawing/2014/main" id="{42C40909-52F8-47B6-8A63-9DB0028FE599}"/>
+                <a16:creationId xmlns:a16="http://schemas.microsoft.com/office/drawing/2014/main" id="{18971D54-D8AE-49CB-9CEC-FA517F7E60AA}"/>
               </a:ext>
             </a:extLst>
           </p:cNvPr>
@@ -6283,7 +6283,7 @@
           <p:cNvPr id="50" name="Google Shape;50;p9">
             <a:extLst xmlns:a="http://schemas.openxmlformats.org/drawingml/2006/main">
               <a:ext uri="{FF2B5EF4-FFF2-40B4-BE49-F238E27FC236}">
-                <a16:creationId xmlns:a16="http://schemas.microsoft.com/office/drawing/2014/main" id="{6762FDE2-8574-4647-B467-8538203751C7}"/>
+                <a16:creationId xmlns:a16="http://schemas.microsoft.com/office/drawing/2014/main" id="{11EF46E8-D964-43AC-9470-80C28F10DA9E}"/>
               </a:ext>
             </a:extLst>
           </p:cNvPr>
@@ -6458,7 +6458,7 @@
           <p:cNvPr id="51" name="Google Shape;51;p9">
             <a:extLst xmlns:a="http://schemas.openxmlformats.org/drawingml/2006/main">
               <a:ext uri="{FF2B5EF4-FFF2-40B4-BE49-F238E27FC236}">
-                <a16:creationId xmlns:a16="http://schemas.microsoft.com/office/drawing/2014/main" id="{ECBB4C41-2C25-491A-8A03-6993E07EE589}"/>
+                <a16:creationId xmlns:a16="http://schemas.microsoft.com/office/drawing/2014/main" id="{5D9793FC-D20C-4A75-99E4-D049FB147C61}"/>
               </a:ext>
             </a:extLst>
           </p:cNvPr>
@@ -6615,7 +6615,7 @@
                 <a:ea typeface="Roboto Mono"/>
                 <a:cs typeface="Roboto Mono"/>
               </a:rPr>
-              <a:t>at offset 0</a:t>
+              <a:t>#! /usr/bin/env python</a:t>
             </a:r>
             <a:endParaRPr sz="2200">
               <a:solidFill>
@@ -6633,7 +6633,7 @@
           <p:cNvPr id="52" name="Google Shape;52;p9">
             <a:extLst xmlns:a="http://schemas.openxmlformats.org/drawingml/2006/main">
               <a:ext uri="{FF2B5EF4-FFF2-40B4-BE49-F238E27FC236}">
-                <a16:creationId xmlns:a16="http://schemas.microsoft.com/office/drawing/2014/main" id="{718B6741-8ABA-45F9-B241-4728C6DFEB93}"/>
+                <a16:creationId xmlns:a16="http://schemas.microsoft.com/office/drawing/2014/main" id="{144C3DDD-C040-4974-89DF-3E832254EF11}"/>
               </a:ext>
             </a:extLst>
           </p:cNvPr>
@@ -6773,7 +6773,7 @@
           <p:cNvPr id="53" name="Google Shape;53;p9">
             <a:extLst xmlns:a="http://schemas.openxmlformats.org/drawingml/2006/main">
               <a:ext uri="{FF2B5EF4-FFF2-40B4-BE49-F238E27FC236}">
-                <a16:creationId xmlns:a16="http://schemas.microsoft.com/office/drawing/2014/main" id="{CE69BC14-FC10-4AE5-A8D0-DFBF53B9014A}"/>
+                <a16:creationId xmlns:a16="http://schemas.microsoft.com/office/drawing/2014/main" id="{891A0147-F0A1-4ABB-A43C-E67884E61197}"/>
               </a:ext>
             </a:extLst>
           </p:cNvPr>
@@ -6913,7 +6913,7 @@
           <p:cNvPr id="54" name="Google Shape;54;p9">
             <a:extLst xmlns:a="http://schemas.openxmlformats.org/drawingml/2006/main">
               <a:ext uri="{FF2B5EF4-FFF2-40B4-BE49-F238E27FC236}">
-                <a16:creationId xmlns:a16="http://schemas.microsoft.com/office/drawing/2014/main" id="{96C8555E-276D-409C-8577-8E5D1C3FE42A}"/>
+                <a16:creationId xmlns:a16="http://schemas.microsoft.com/office/drawing/2014/main" id="{2C6D2F51-FA40-42D0-B0E3-CE24DABECCF3}"/>
               </a:ext>
             </a:extLst>
           </p:cNvPr>
@@ -7086,7 +7086,7 @@
           <p:cNvPr id="55" name="cause-takeaway">
             <a:extLst xmlns:a="http://schemas.openxmlformats.org/drawingml/2006/main">
               <a:ext uri="{FF2B5EF4-FFF2-40B4-BE49-F238E27FC236}">
-                <a16:creationId xmlns:a16="http://schemas.microsoft.com/office/drawing/2014/main" id="{FDDE953E-C44D-4EC9-80FB-3F8A6F59D94E}"/>
+                <a16:creationId xmlns:a16="http://schemas.microsoft.com/office/drawing/2014/main" id="{FA78872B-AEED-4137-9964-050E960AE9CD}"/>
               </a:ext>
             </a:extLst>
           </p:cNvPr>
@@ -7234,7 +7234,7 @@
                 <a:ea typeface="Manrope"/>
                 <a:cs typeface="Manrope"/>
               </a:rPr>
-              <a:t>One prefix covers python, python3 and python3.11 without a space after #!.</a:t>
+              <a:t>Two literal prefixes follow the existing direct-path Python rules.</a:t>
             </a:r>
           </a:p>
         </p:txBody>
@@ -7242,7 +7242,7 @@
     </p:spTree>
     <p:extLst>
       <p:ext uri="{BB962C8B-B14F-4D97-AF65-F5344CB8AC3E}">
-        <p14:creationId xmlns:p14="http://schemas.microsoft.com/office/powerpoint/2010/main" val="1603504256"/>
+        <p14:creationId xmlns:p14="http://schemas.microsoft.com/office/powerpoint/2010/main" val="1007464614"/>
       </p:ext>
     </p:extLst>
   </p:cSld>
@@ -7273,7 +7273,7 @@
           <p:cNvPr id="77" name="Google Shape;77;p11">
             <a:extLst xmlns:a="http://schemas.openxmlformats.org/drawingml/2006/main">
               <a:ext uri="{FF2B5EF4-FFF2-40B4-BE49-F238E27FC236}">
-                <a16:creationId xmlns:a16="http://schemas.microsoft.com/office/drawing/2014/main" id="{DA8843D0-912F-4021-A232-B4BFFB73FE2D}"/>
+                <a16:creationId xmlns:a16="http://schemas.microsoft.com/office/drawing/2014/main" id="{24AFC286-C4DC-47DE-AAD2-5651998C7310}"/>
               </a:ext>
             </a:extLst>
           </p:cNvPr>
@@ -7337,7 +7337,7 @@
           <p:cNvPr id="78" name="Google Shape;78;p11">
             <a:extLst xmlns:a="http://schemas.openxmlformats.org/drawingml/2006/main">
               <a:ext uri="{FF2B5EF4-FFF2-40B4-BE49-F238E27FC236}">
-                <a16:creationId xmlns:a16="http://schemas.microsoft.com/office/drawing/2014/main" id="{BEDCA2B6-E824-4545-B7C6-ED940655B987}"/>
+                <a16:creationId xmlns:a16="http://schemas.microsoft.com/office/drawing/2014/main" id="{6E0C3C9E-1533-4FA0-BE79-7C2175E47497}"/>
               </a:ext>
             </a:extLst>
           </p:cNvPr>
@@ -7401,7 +7401,7 @@
           <p:cNvPr id="79" name="Google Shape;79;p11">
             <a:extLst xmlns:a="http://schemas.openxmlformats.org/drawingml/2006/main">
               <a:ext uri="{FF2B5EF4-FFF2-40B4-BE49-F238E27FC236}">
-                <a16:creationId xmlns:a16="http://schemas.microsoft.com/office/drawing/2014/main" id="{CC2D6198-2800-4C6E-A094-8E50FE06023A}"/>
+                <a16:creationId xmlns:a16="http://schemas.microsoft.com/office/drawing/2014/main" id="{AE5251DE-3515-4D3C-885D-2D92AD1010EB}"/>
               </a:ext>
             </a:extLst>
           </p:cNvPr>
@@ -7499,7 +7499,7 @@
           <p:cNvPr id="80" name="Google Shape;80;p11">
             <a:extLst xmlns:a="http://schemas.openxmlformats.org/drawingml/2006/main">
               <a:ext uri="{FF2B5EF4-FFF2-40B4-BE49-F238E27FC236}">
-                <a16:creationId xmlns:a16="http://schemas.microsoft.com/office/drawing/2014/main" id="{30861CD9-05E1-4FBD-A28B-E774C1BAA6CE}"/>
+                <a16:creationId xmlns:a16="http://schemas.microsoft.com/office/drawing/2014/main" id="{F7EE6444-BEAA-418D-9914-0CD76A877499}"/>
               </a:ext>
             </a:extLst>
           </p:cNvPr>
@@ -7563,7 +7563,7 @@
           <p:cNvPr id="81" name="Google Shape;81;p11">
             <a:extLst xmlns:a="http://schemas.openxmlformats.org/drawingml/2006/main">
               <a:ext uri="{FF2B5EF4-FFF2-40B4-BE49-F238E27FC236}">
-                <a16:creationId xmlns:a16="http://schemas.microsoft.com/office/drawing/2014/main" id="{3048AC93-7689-480A-A78E-8419B918576F}"/>
+                <a16:creationId xmlns:a16="http://schemas.microsoft.com/office/drawing/2014/main" id="{8A9EA259-6FB4-4B8A-B14F-766042BF42B5}"/>
               </a:ext>
             </a:extLst>
           </p:cNvPr>
@@ -7627,7 +7627,7 @@
           <p:cNvPr id="82" name="Google Shape;82;p11">
             <a:extLst xmlns:a="http://schemas.openxmlformats.org/drawingml/2006/main">
               <a:ext uri="{FF2B5EF4-FFF2-40B4-BE49-F238E27FC236}">
-                <a16:creationId xmlns:a16="http://schemas.microsoft.com/office/drawing/2014/main" id="{7719966E-85E9-412C-BEEB-9D0F6A5D7DCF}"/>
+                <a16:creationId xmlns:a16="http://schemas.microsoft.com/office/drawing/2014/main" id="{6D9D3FDD-C93C-4509-8783-D4D0DEB32FFD}"/>
               </a:ext>
             </a:extLst>
           </p:cNvPr>
@@ -7691,7 +7691,7 @@
           <p:cNvPr id="83" name="Google Shape;83;p11">
             <a:extLst xmlns:a="http://schemas.openxmlformats.org/drawingml/2006/main">
               <a:ext uri="{FF2B5EF4-FFF2-40B4-BE49-F238E27FC236}">
-                <a16:creationId xmlns:a16="http://schemas.microsoft.com/office/drawing/2014/main" id="{73ECC39D-42D2-4F0E-8BFE-0878B10AB2B0}"/>
+                <a16:creationId xmlns:a16="http://schemas.microsoft.com/office/drawing/2014/main" id="{417B289C-C86E-4B89-9968-96E5AB32B66B}"/>
               </a:ext>
             </a:extLst>
           </p:cNvPr>
@@ -7866,7 +7866,7 @@
           <p:cNvPr id="84" name="Google Shape;84;p11">
             <a:extLst xmlns:a="http://schemas.openxmlformats.org/drawingml/2006/main">
               <a:ext uri="{FF2B5EF4-FFF2-40B4-BE49-F238E27FC236}">
-                <a16:creationId xmlns:a16="http://schemas.microsoft.com/office/drawing/2014/main" id="{A4038D59-8F24-4AFB-A89C-C497201D5495}"/>
+                <a16:creationId xmlns:a16="http://schemas.microsoft.com/office/drawing/2014/main" id="{79F93235-188B-4766-BE29-7A079D7F67FC}"/>
               </a:ext>
             </a:extLst>
           </p:cNvPr>
@@ -7930,7 +7930,7 @@
           <p:cNvPr id="85" name="Google Shape;85;p11">
             <a:extLst xmlns:a="http://schemas.openxmlformats.org/drawingml/2006/main">
               <a:ext uri="{FF2B5EF4-FFF2-40B4-BE49-F238E27FC236}">
-                <a16:creationId xmlns:a16="http://schemas.microsoft.com/office/drawing/2014/main" id="{4482BE90-E18F-4FB5-89A5-374185B285E2}"/>
+                <a16:creationId xmlns:a16="http://schemas.microsoft.com/office/drawing/2014/main" id="{503F3250-1DB3-49CD-81D7-23079AA17209}"/>
               </a:ext>
             </a:extLst>
           </p:cNvPr>
@@ -7994,7 +7994,7 @@
           <p:cNvPr id="86" name="Google Shape;86;p11">
             <a:extLst xmlns:a="http://schemas.openxmlformats.org/drawingml/2006/main">
               <a:ext uri="{FF2B5EF4-FFF2-40B4-BE49-F238E27FC236}">
-                <a16:creationId xmlns:a16="http://schemas.microsoft.com/office/drawing/2014/main" id="{A22EA4F7-27D3-44AA-AD8A-0373F5E37232}"/>
+                <a16:creationId xmlns:a16="http://schemas.microsoft.com/office/drawing/2014/main" id="{46FE0F30-B444-457F-979A-D852074A2895}"/>
               </a:ext>
             </a:extLst>
           </p:cNvPr>
@@ -8169,7 +8169,7 @@
           <p:cNvPr id="87" name="Google Shape;87;p11">
             <a:extLst xmlns:a="http://schemas.openxmlformats.org/drawingml/2006/main">
               <a:ext uri="{FF2B5EF4-FFF2-40B4-BE49-F238E27FC236}">
-                <a16:creationId xmlns:a16="http://schemas.microsoft.com/office/drawing/2014/main" id="{194A0D5B-D42F-4EE5-81AA-D962F8133B41}"/>
+                <a16:creationId xmlns:a16="http://schemas.microsoft.com/office/drawing/2014/main" id="{07629426-1091-4373-9A9D-F21C112CF420}"/>
               </a:ext>
             </a:extLst>
           </p:cNvPr>
@@ -8233,7 +8233,7 @@
           <p:cNvPr id="88" name="Google Shape;88;p11">
             <a:extLst xmlns:a="http://schemas.openxmlformats.org/drawingml/2006/main">
               <a:ext uri="{FF2B5EF4-FFF2-40B4-BE49-F238E27FC236}">
-                <a16:creationId xmlns:a16="http://schemas.microsoft.com/office/drawing/2014/main" id="{4E105200-3305-47D3-B5FB-0739A89B70BC}"/>
+                <a16:creationId xmlns:a16="http://schemas.microsoft.com/office/drawing/2014/main" id="{76757074-0547-430B-976E-4EC8F196C9D2}"/>
               </a:ext>
             </a:extLst>
           </p:cNvPr>
@@ -8311,7 +8311,7 @@
                 <a:ea typeface="Manrope"/>
                 <a:cs typeface="Manrope"/>
               </a:rPr>
-              <a:t>Same 16 focused checks: 6 failures before, 0 after</a:t>
+              <a:t>Same 18 focused checks: 7 failures before, 0 after</a:t>
             </a:r>
             <a:endParaRPr sz="2400" b="1">
               <a:solidFill>
@@ -8329,7 +8329,7 @@
           <p:cNvPr id="89" name="Google Shape;89;p11">
             <a:extLst xmlns:a="http://schemas.openxmlformats.org/drawingml/2006/main">
               <a:ext uri="{FF2B5EF4-FFF2-40B4-BE49-F238E27FC236}">
-                <a16:creationId xmlns:a16="http://schemas.microsoft.com/office/drawing/2014/main" id="{9AB5721A-E390-416B-B1E2-F3C17BF7D432}"/>
+                <a16:creationId xmlns:a16="http://schemas.microsoft.com/office/drawing/2014/main" id="{9AB7F8B2-ECE8-42A6-B5CB-7BF342CD72FB}"/>
               </a:ext>
             </a:extLst>
           </p:cNvPr>
@@ -8451,7 +8451,7 @@
                 <a:ea typeface="Manrope"/>
                 <a:cs typeface="Manrope"/>
               </a:rPr>
-              <a:t>All 16 passed after the fix. These are local results.</a:t>
+              <a:t>All 18 passed after the fix. These are local results.</a:t>
             </a:r>
             <a:endParaRPr sz="1900">
               <a:solidFill>
@@ -8502,7 +8502,7 @@
     </p:spTree>
     <p:extLst>
       <p:ext uri="{BB962C8B-B14F-4D97-AF65-F5344CB8AC3E}">
-        <p14:creationId xmlns:p14="http://schemas.microsoft.com/office/powerpoint/2010/main" val="1352234155"/>
+        <p14:creationId xmlns:p14="http://schemas.microsoft.com/office/powerpoint/2010/main" val="1042123372"/>
       </p:ext>
     </p:extLst>
   </p:cSld>
@@ -8533,7 +8533,7 @@
           <p:cNvPr id="42" name="Google Shape;42;p9">
             <a:extLst xmlns:a="http://schemas.openxmlformats.org/drawingml/2006/main">
               <a:ext uri="{FF2B5EF4-FFF2-40B4-BE49-F238E27FC236}">
-                <a16:creationId xmlns:a16="http://schemas.microsoft.com/office/drawing/2014/main" id="{83C4B260-092A-4ED5-AD1A-C8F029B084D1}"/>
+                <a16:creationId xmlns:a16="http://schemas.microsoft.com/office/drawing/2014/main" id="{C649A7DE-3EB6-4F20-99F1-6CCEBCD4FFF0}"/>
               </a:ext>
             </a:extLst>
           </p:cNvPr>
@@ -8584,7 +8584,7 @@
           <p:cNvPr id="43" name="Google Shape;43;p9">
             <a:extLst xmlns:a="http://schemas.openxmlformats.org/drawingml/2006/main">
               <a:ext uri="{FF2B5EF4-FFF2-40B4-BE49-F238E27FC236}">
-                <a16:creationId xmlns:a16="http://schemas.microsoft.com/office/drawing/2014/main" id="{24E5E759-489C-4530-9367-B83430A8554A}"/>
+                <a16:creationId xmlns:a16="http://schemas.microsoft.com/office/drawing/2014/main" id="{F563E5C4-AF43-47DB-A4EC-C542AA844741}"/>
               </a:ext>
             </a:extLst>
           </p:cNvPr>
@@ -8648,7 +8648,7 @@
           <p:cNvPr id="44" name="Google Shape;44;p9">
             <a:extLst xmlns:a="http://schemas.openxmlformats.org/drawingml/2006/main">
               <a:ext uri="{FF2B5EF4-FFF2-40B4-BE49-F238E27FC236}">
-                <a16:creationId xmlns:a16="http://schemas.microsoft.com/office/drawing/2014/main" id="{0B61773D-7488-4265-B0AD-33E7CD29D35F}"/>
+                <a16:creationId xmlns:a16="http://schemas.microsoft.com/office/drawing/2014/main" id="{980F5A0C-EB58-44AD-BE53-98BAFE1A5342}"/>
               </a:ext>
             </a:extLst>
           </p:cNvPr>
@@ -8712,7 +8712,7 @@
           <p:cNvPr id="45" name="Google Shape;45;p9">
             <a:extLst xmlns:a="http://schemas.openxmlformats.org/drawingml/2006/main">
               <a:ext uri="{FF2B5EF4-FFF2-40B4-BE49-F238E27FC236}">
-                <a16:creationId xmlns:a16="http://schemas.microsoft.com/office/drawing/2014/main" id="{44A3F6B0-FB16-4F4B-A469-08478C26C1F6}"/>
+                <a16:creationId xmlns:a16="http://schemas.microsoft.com/office/drawing/2014/main" id="{33D82BA1-51F6-46A3-A292-B6322244794D}"/>
               </a:ext>
             </a:extLst>
           </p:cNvPr>
@@ -8810,7 +8810,7 @@
           <p:cNvPr id="46" name="Google Shape;46;p9">
             <a:extLst xmlns:a="http://schemas.openxmlformats.org/drawingml/2006/main">
               <a:ext uri="{FF2B5EF4-FFF2-40B4-BE49-F238E27FC236}">
-                <a16:creationId xmlns:a16="http://schemas.microsoft.com/office/drawing/2014/main" id="{41A40B0D-6F99-42C2-8D83-48C99B192D92}"/>
+                <a16:creationId xmlns:a16="http://schemas.microsoft.com/office/drawing/2014/main" id="{35D0A4BF-CD5A-4522-B7C2-CCF382DD9AEF}"/>
               </a:ext>
             </a:extLst>
           </p:cNvPr>
@@ -8874,7 +8874,7 @@
           <p:cNvPr id="47" name="Google Shape;47;p9">
             <a:extLst xmlns:a="http://schemas.openxmlformats.org/drawingml/2006/main">
               <a:ext uri="{FF2B5EF4-FFF2-40B4-BE49-F238E27FC236}">
-                <a16:creationId xmlns:a16="http://schemas.microsoft.com/office/drawing/2014/main" id="{594E6614-93FF-409F-A827-80E689265BE2}"/>
+                <a16:creationId xmlns:a16="http://schemas.microsoft.com/office/drawing/2014/main" id="{9CA6DB4B-926F-4A17-9A79-E05731261294}"/>
               </a:ext>
             </a:extLst>
           </p:cNvPr>
@@ -8970,7 +8970,7 @@
           <p:cNvPr id="48" name="Google Shape;48;p9">
             <a:extLst xmlns:a="http://schemas.openxmlformats.org/drawingml/2006/main">
               <a:ext uri="{FF2B5EF4-FFF2-40B4-BE49-F238E27FC236}">
-                <a16:creationId xmlns:a16="http://schemas.microsoft.com/office/drawing/2014/main" id="{9C7D0C6B-2781-43CB-AA4B-457B80702F20}"/>
+                <a16:creationId xmlns:a16="http://schemas.microsoft.com/office/drawing/2014/main" id="{1F616BD8-03FF-4592-AFB6-3DAFFA80CB77}"/>
               </a:ext>
             </a:extLst>
           </p:cNvPr>
@@ -9066,7 +9066,7 @@
           <p:cNvPr id="49" name="Google Shape;49;p9">
             <a:extLst xmlns:a="http://schemas.openxmlformats.org/drawingml/2006/main">
               <a:ext uri="{FF2B5EF4-FFF2-40B4-BE49-F238E27FC236}">
-                <a16:creationId xmlns:a16="http://schemas.microsoft.com/office/drawing/2014/main" id="{42C40909-52F8-47B6-8A63-9DB0028FE599}"/>
+                <a16:creationId xmlns:a16="http://schemas.microsoft.com/office/drawing/2014/main" id="{18971D54-D8AE-49CB-9CEC-FA517F7E60AA}"/>
               </a:ext>
             </a:extLst>
           </p:cNvPr>
@@ -9250,7 +9250,7 @@
           <p:cNvPr id="50" name="Google Shape;50;p9">
             <a:extLst xmlns:a="http://schemas.openxmlformats.org/drawingml/2006/main">
               <a:ext uri="{FF2B5EF4-FFF2-40B4-BE49-F238E27FC236}">
-                <a16:creationId xmlns:a16="http://schemas.microsoft.com/office/drawing/2014/main" id="{6762FDE2-8574-4647-B467-8538203751C7}"/>
+                <a16:creationId xmlns:a16="http://schemas.microsoft.com/office/drawing/2014/main" id="{11EF46E8-D964-43AC-9470-80C28F10DA9E}"/>
               </a:ext>
             </a:extLst>
           </p:cNvPr>
@@ -9425,7 +9425,7 @@
           <p:cNvPr id="51" name="Google Shape;51;p9">
             <a:extLst xmlns:a="http://schemas.openxmlformats.org/drawingml/2006/main">
               <a:ext uri="{FF2B5EF4-FFF2-40B4-BE49-F238E27FC236}">
-                <a16:creationId xmlns:a16="http://schemas.microsoft.com/office/drawing/2014/main" id="{ECBB4C41-2C25-491A-8A03-6993E07EE589}"/>
+                <a16:creationId xmlns:a16="http://schemas.microsoft.com/office/drawing/2014/main" id="{5D9793FC-D20C-4A75-99E4-D049FB147C61}"/>
               </a:ext>
             </a:extLst>
           </p:cNvPr>
@@ -9600,7 +9600,7 @@
           <p:cNvPr id="52" name="Google Shape;52;p9">
             <a:extLst xmlns:a="http://schemas.openxmlformats.org/drawingml/2006/main">
               <a:ext uri="{FF2B5EF4-FFF2-40B4-BE49-F238E27FC236}">
-                <a16:creationId xmlns:a16="http://schemas.microsoft.com/office/drawing/2014/main" id="{718B6741-8ABA-45F9-B241-4728C6DFEB93}"/>
+                <a16:creationId xmlns:a16="http://schemas.microsoft.com/office/drawing/2014/main" id="{144C3DDD-C040-4974-89DF-3E832254EF11}"/>
               </a:ext>
             </a:extLst>
           </p:cNvPr>
@@ -9740,7 +9740,7 @@
           <p:cNvPr id="53" name="Google Shape;53;p9">
             <a:extLst xmlns:a="http://schemas.openxmlformats.org/drawingml/2006/main">
               <a:ext uri="{FF2B5EF4-FFF2-40B4-BE49-F238E27FC236}">
-                <a16:creationId xmlns:a16="http://schemas.microsoft.com/office/drawing/2014/main" id="{CE69BC14-FC10-4AE5-A8D0-DFBF53B9014A}"/>
+                <a16:creationId xmlns:a16="http://schemas.microsoft.com/office/drawing/2014/main" id="{891A0147-F0A1-4ABB-A43C-E67884E61197}"/>
               </a:ext>
             </a:extLst>
           </p:cNvPr>
@@ -9880,7 +9880,7 @@
           <p:cNvPr id="54" name="Google Shape;54;p9">
             <a:extLst xmlns:a="http://schemas.openxmlformats.org/drawingml/2006/main">
               <a:ext uri="{FF2B5EF4-FFF2-40B4-BE49-F238E27FC236}">
-                <a16:creationId xmlns:a16="http://schemas.microsoft.com/office/drawing/2014/main" id="{96C8555E-276D-409C-8577-8E5D1C3FE42A}"/>
+                <a16:creationId xmlns:a16="http://schemas.microsoft.com/office/drawing/2014/main" id="{2C6D2F51-FA40-42D0-B0E3-CE24DABECCF3}"/>
               </a:ext>
             </a:extLst>
           </p:cNvPr>
@@ -10053,7 +10053,7 @@
           <p:cNvPr id="55" name="review-limit">
             <a:extLst xmlns:a="http://schemas.openxmlformats.org/drawingml/2006/main">
               <a:ext uri="{FF2B5EF4-FFF2-40B4-BE49-F238E27FC236}">
-                <a16:creationId xmlns:a16="http://schemas.microsoft.com/office/drawing/2014/main" id="{EBCBC57F-F098-4824-AC63-F596CD3F7E18}"/>
+                <a16:creationId xmlns:a16="http://schemas.microsoft.com/office/drawing/2014/main" id="{CB801659-53C3-4D16-A259-30A0DA7CA219}"/>
               </a:ext>
             </a:extLst>
           </p:cNvPr>
@@ -10209,7 +10209,7 @@
     </p:spTree>
     <p:extLst>
       <p:ext uri="{BB962C8B-B14F-4D97-AF65-F5344CB8AC3E}">
-        <p14:creationId xmlns:p14="http://schemas.microsoft.com/office/powerpoint/2010/main" val="1603504256"/>
+        <p14:creationId xmlns:p14="http://schemas.microsoft.com/office/powerpoint/2010/main" val="1007464614"/>
       </p:ext>
     </p:extLst>
   </p:cSld>
@@ -10240,7 +10240,7 @@
           <p:cNvPr id="60" name="Google Shape;60;p10">
             <a:extLst xmlns:a="http://schemas.openxmlformats.org/drawingml/2006/main">
               <a:ext uri="{FF2B5EF4-FFF2-40B4-BE49-F238E27FC236}">
-                <a16:creationId xmlns:a16="http://schemas.microsoft.com/office/drawing/2014/main" id="{598541F1-6F25-41B4-BFC0-4FDF170D3080}"/>
+                <a16:creationId xmlns:a16="http://schemas.microsoft.com/office/drawing/2014/main" id="{EA26F8E9-B2B4-4F71-B282-16387F35F775}"/>
               </a:ext>
             </a:extLst>
           </p:cNvPr>
@@ -10304,7 +10304,7 @@
           <p:cNvPr id="61" name="Google Shape;61;p10">
             <a:extLst xmlns:a="http://schemas.openxmlformats.org/drawingml/2006/main">
               <a:ext uri="{FF2B5EF4-FFF2-40B4-BE49-F238E27FC236}">
-                <a16:creationId xmlns:a16="http://schemas.microsoft.com/office/drawing/2014/main" id="{AEC4C21E-25F8-404A-980F-B6A3F60E14E2}"/>
+                <a16:creationId xmlns:a16="http://schemas.microsoft.com/office/drawing/2014/main" id="{477ACC48-F0F9-4C9C-8C1D-2C43549D9CDF}"/>
               </a:ext>
             </a:extLst>
           </p:cNvPr>
@@ -10368,7 +10368,7 @@
           <p:cNvPr id="62" name="Google Shape;62;p10">
             <a:extLst xmlns:a="http://schemas.openxmlformats.org/drawingml/2006/main">
               <a:ext uri="{FF2B5EF4-FFF2-40B4-BE49-F238E27FC236}">
-                <a16:creationId xmlns:a16="http://schemas.microsoft.com/office/drawing/2014/main" id="{217E1CB0-8C21-43DA-9C53-979C71365882}"/>
+                <a16:creationId xmlns:a16="http://schemas.microsoft.com/office/drawing/2014/main" id="{EE63C3A9-2F82-4443-B657-8A3980D42F4F}"/>
               </a:ext>
             </a:extLst>
           </p:cNvPr>
@@ -10466,7 +10466,7 @@
           <p:cNvPr id="63" name="Google Shape;63;p10">
             <a:extLst xmlns:a="http://schemas.openxmlformats.org/drawingml/2006/main">
               <a:ext uri="{FF2B5EF4-FFF2-40B4-BE49-F238E27FC236}">
-                <a16:creationId xmlns:a16="http://schemas.microsoft.com/office/drawing/2014/main" id="{B5ACBB98-8D95-4D1F-92E2-F39549BA7CC5}"/>
+                <a16:creationId xmlns:a16="http://schemas.microsoft.com/office/drawing/2014/main" id="{750A9B0D-3985-4205-BE33-CDFBB9743C58}"/>
               </a:ext>
             </a:extLst>
           </p:cNvPr>
@@ -10530,7 +10530,7 @@
           <p:cNvPr id="64" name="Google Shape;64;p10">
             <a:extLst xmlns:a="http://schemas.openxmlformats.org/drawingml/2006/main">
               <a:ext uri="{FF2B5EF4-FFF2-40B4-BE49-F238E27FC236}">
-                <a16:creationId xmlns:a16="http://schemas.microsoft.com/office/drawing/2014/main" id="{B39B895F-439D-46E3-A6D7-590583935859}"/>
+                <a16:creationId xmlns:a16="http://schemas.microsoft.com/office/drawing/2014/main" id="{5ACE5F7A-0897-4BBE-8A51-582A131F91FD}"/>
               </a:ext>
             </a:extLst>
           </p:cNvPr>
@@ -10670,7 +10670,7 @@
           <p:cNvPr id="65" name="Google Shape;65;p10">
             <a:extLst xmlns:a="http://schemas.openxmlformats.org/drawingml/2006/main">
               <a:ext uri="{FF2B5EF4-FFF2-40B4-BE49-F238E27FC236}">
-                <a16:creationId xmlns:a16="http://schemas.microsoft.com/office/drawing/2014/main" id="{79FABF11-EDDC-43CB-93B1-202CCEFA4202}"/>
+                <a16:creationId xmlns:a16="http://schemas.microsoft.com/office/drawing/2014/main" id="{5BBC0063-C1C6-4DB9-A57E-7B608277AED8}"/>
               </a:ext>
             </a:extLst>
           </p:cNvPr>
@@ -10845,7 +10845,7 @@
           <p:cNvPr id="66" name="Google Shape;66;p10">
             <a:extLst xmlns:a="http://schemas.openxmlformats.org/drawingml/2006/main">
               <a:ext uri="{FF2B5EF4-FFF2-40B4-BE49-F238E27FC236}">
-                <a16:creationId xmlns:a16="http://schemas.microsoft.com/office/drawing/2014/main" id="{A31AB736-D46C-474E-90D7-2FB6BE3072FB}"/>
+                <a16:creationId xmlns:a16="http://schemas.microsoft.com/office/drawing/2014/main" id="{A4295220-7EB5-4C0C-8827-955D83C60DF6}"/>
               </a:ext>
             </a:extLst>
           </p:cNvPr>
@@ -10985,7 +10985,7 @@
           <p:cNvPr id="67" name="Google Shape;67;p10">
             <a:extLst xmlns:a="http://schemas.openxmlformats.org/drawingml/2006/main">
               <a:ext uri="{FF2B5EF4-FFF2-40B4-BE49-F238E27FC236}">
-                <a16:creationId xmlns:a16="http://schemas.microsoft.com/office/drawing/2014/main" id="{F88E5557-EF39-4AF1-8D22-A7FE115EE695}"/>
+                <a16:creationId xmlns:a16="http://schemas.microsoft.com/office/drawing/2014/main" id="{204183BF-EBF4-45A3-903A-53FBCCCC9D5C}"/>
               </a:ext>
             </a:extLst>
           </p:cNvPr>
@@ -11160,7 +11160,7 @@
           <p:cNvPr id="68" name="Google Shape;68;p10">
             <a:extLst xmlns:a="http://schemas.openxmlformats.org/drawingml/2006/main">
               <a:ext uri="{FF2B5EF4-FFF2-40B4-BE49-F238E27FC236}">
-                <a16:creationId xmlns:a16="http://schemas.microsoft.com/office/drawing/2014/main" id="{1F51005F-4851-47B4-949A-B8AA835B1654}"/>
+                <a16:creationId xmlns:a16="http://schemas.microsoft.com/office/drawing/2014/main" id="{2BB066E7-47F7-4D71-9954-4EFE8EB7E355}"/>
               </a:ext>
             </a:extLst>
           </p:cNvPr>
@@ -11300,7 +11300,7 @@
           <p:cNvPr id="69" name="Google Shape;69;p10">
             <a:extLst xmlns:a="http://schemas.openxmlformats.org/drawingml/2006/main">
               <a:ext uri="{FF2B5EF4-FFF2-40B4-BE49-F238E27FC236}">
-                <a16:creationId xmlns:a16="http://schemas.microsoft.com/office/drawing/2014/main" id="{FD4B1F3D-BC26-4CCC-BA6D-35BBC7FAA9CC}"/>
+                <a16:creationId xmlns:a16="http://schemas.microsoft.com/office/drawing/2014/main" id="{A3792373-862B-4D1D-B6FC-3A9A99C58C74}"/>
               </a:ext>
             </a:extLst>
           </p:cNvPr>
@@ -11475,7 +11475,7 @@
           <p:cNvPr id="70" name="Google Shape;70;p10">
             <a:extLst xmlns:a="http://schemas.openxmlformats.org/drawingml/2006/main">
               <a:ext uri="{FF2B5EF4-FFF2-40B4-BE49-F238E27FC236}">
-                <a16:creationId xmlns:a16="http://schemas.microsoft.com/office/drawing/2014/main" id="{38770463-6FE4-40AD-B6A3-EBE2360E196D}"/>
+                <a16:creationId xmlns:a16="http://schemas.microsoft.com/office/drawing/2014/main" id="{A805EEED-0476-4E8A-8D52-AAAF0A5E4AB2}"/>
               </a:ext>
             </a:extLst>
           </p:cNvPr>
@@ -11615,7 +11615,7 @@
           <p:cNvPr id="71" name="Google Shape;71;p10">
             <a:extLst xmlns:a="http://schemas.openxmlformats.org/drawingml/2006/main">
               <a:ext uri="{FF2B5EF4-FFF2-40B4-BE49-F238E27FC236}">
-                <a16:creationId xmlns:a16="http://schemas.microsoft.com/office/drawing/2014/main" id="{A40478A9-5A42-43FA-9FCE-E8A012E2D55C}"/>
+                <a16:creationId xmlns:a16="http://schemas.microsoft.com/office/drawing/2014/main" id="{AD409504-FF7E-451E-AAEF-D674B707033A}"/>
               </a:ext>
             </a:extLst>
           </p:cNvPr>
@@ -11788,7 +11788,7 @@
     </p:spTree>
     <p:extLst>
       <p:ext uri="{BB962C8B-B14F-4D97-AF65-F5344CB8AC3E}">
-        <p14:creationId xmlns:p14="http://schemas.microsoft.com/office/powerpoint/2010/main" val="1496330542"/>
+        <p14:creationId xmlns:p14="http://schemas.microsoft.com/office/powerpoint/2010/main" val="875521473"/>
       </p:ext>
     </p:extLst>
   </p:cSld>

</xml_diff>

<commit_message>
docs(a4): align Jiajun slides with interests and lessons
Replace the challenges section with two slides on interesting findings and lessons learned.

Generated-by: Codex
</commit_message>
<xml_diff>
--- a/presentation/Jiajun-TIKA-4408-section.pptx
+++ b/presentation/Jiajun-TIKA-4408-section.pptx
@@ -2,32 +2,30 @@
 <file path=ppt/presentation.xml><?xml version="1.0" encoding="utf-8"?>
 <p:presentation xmlns:p="http://schemas.openxmlformats.org/presentationml/2006/main" embedTrueTypeFonts="1" saveSubsetFonts="0">
   <p:sldMasterIdLst>
-    <p:sldMasterId xmlns:r="http://schemas.openxmlformats.org/officeDocument/2006/relationships" id="2147483648" r:id="Re8aeb17c13e94c6c"/>
-    <p:sldMasterId xmlns:r="http://schemas.openxmlformats.org/officeDocument/2006/relationships" id="2147483650" r:id="R1f684f86f069429b"/>
+    <p:sldMasterId xmlns:r="http://schemas.openxmlformats.org/officeDocument/2006/relationships" id="2147483648" r:id="R76f79b9d2a064d50"/>
+    <p:sldMasterId xmlns:r="http://schemas.openxmlformats.org/officeDocument/2006/relationships" id="2147483650" r:id="R4d3e57be102b41aa"/>
   </p:sldMasterIdLst>
   <p:notesMasterIdLst>
-    <p:notesMasterId xmlns:r="http://schemas.openxmlformats.org/officeDocument/2006/relationships" r:id="R63250f908ac844ea"/>
+    <p:notesMasterId xmlns:r="http://schemas.openxmlformats.org/officeDocument/2006/relationships" r:id="R51761ac7d81548c4"/>
   </p:notesMasterIdLst>
   <p:sldIdLst>
-    <p:sldId xmlns:r="http://schemas.openxmlformats.org/officeDocument/2006/relationships" id="256" r:id="Rfc3eeb7e3ae242d8"/>
-    <p:sldId xmlns:r="http://schemas.openxmlformats.org/officeDocument/2006/relationships" id="257" r:id="Rb8e7e01332fa49d8"/>
-    <p:sldId xmlns:r="http://schemas.openxmlformats.org/officeDocument/2006/relationships" id="258" r:id="Rbed1cd04bd76423a"/>
-    <p:sldId xmlns:r="http://schemas.openxmlformats.org/officeDocument/2006/relationships" id="259" r:id="Reda7994dad024eb8"/>
+    <p:sldId xmlns:r="http://schemas.openxmlformats.org/officeDocument/2006/relationships" id="256" r:id="R7ea89d8be5654ed0"/>
+    <p:sldId xmlns:r="http://schemas.openxmlformats.org/officeDocument/2006/relationships" id="257" r:id="R9cd594cd8a414257"/>
   </p:sldIdLst>
   <p:sldSz cx="12192000" cy="6858000"/>
   <p:notesSz cx="6858000" cy="9144000"/>
   <p:embeddedFontLst>
     <p:embeddedFont>
       <p:font typeface="Manrope"/>
-      <p:regular xmlns:r="http://schemas.openxmlformats.org/officeDocument/2006/relationships" r:id="Rac4b06eb18c74260"/>
-      <p:bold xmlns:r="http://schemas.openxmlformats.org/officeDocument/2006/relationships" r:id="R411a33194b8c4b92"/>
+      <p:regular xmlns:r="http://schemas.openxmlformats.org/officeDocument/2006/relationships" r:id="R0744738a2f504997"/>
+      <p:bold xmlns:r="http://schemas.openxmlformats.org/officeDocument/2006/relationships" r:id="Rd13b12300c7b4046"/>
     </p:embeddedFont>
     <p:embeddedFont>
       <p:font typeface="Roboto Mono"/>
-      <p:regular xmlns:r="http://schemas.openxmlformats.org/officeDocument/2006/relationships" r:id="R025908181d17463d"/>
-      <p:bold xmlns:r="http://schemas.openxmlformats.org/officeDocument/2006/relationships" r:id="R7b1f32bc4a884afb"/>
-      <p:italic xmlns:r="http://schemas.openxmlformats.org/officeDocument/2006/relationships" r:id="R1f622fa0f3044b17"/>
-      <p:boldItalic xmlns:r="http://schemas.openxmlformats.org/officeDocument/2006/relationships" r:id="Rfe42d6deb1b447a4"/>
+      <p:regular xmlns:r="http://schemas.openxmlformats.org/officeDocument/2006/relationships" r:id="R0e694f502ecd4c39"/>
+      <p:bold xmlns:r="http://schemas.openxmlformats.org/officeDocument/2006/relationships" r:id="Ra66dc41999634b02"/>
+      <p:italic xmlns:r="http://schemas.openxmlformats.org/officeDocument/2006/relationships" r:id="R186331e7abfa4e73"/>
+      <p:boldItalic xmlns:r="http://schemas.openxmlformats.org/officeDocument/2006/relationships" r:id="R1e7a32fbdbc24f8b"/>
     </p:embeddedFont>
   </p:embeddedFontLst>
   <p:defaultTextStyle>
@@ -737,7 +735,7 @@
               <a:buNone/>
             </a:pPr>
             <a:r>
-              <a:t>Suggested English speaker notes (approximately 50-70 seconds at a comfortable pace):</a:t>
+              <a:t>Suggested English speaker notes (approximately 60-90 seconds at a comfortable pace):</a:t>
             </a:r>
             <a:endParaRPr/>
           </a:p>
@@ -752,7 +750,7 @@
               <a:buNone/>
             </a:pPr>
             <a:r>
-              <a:t>The first challenge was understanding why Tika identified this Python script as Shell. A shebang is the first line that names the interpreter. The old Python rule searched for slash bin slash env python at offset one. Offset means the starting position, counted from zero. In this input, that substring actually starts at offset six, so the Python rule missed it and a Shell rule matched instead. The fix checks two complete prefixes at the start of the file, with no space or exactly one space after hash and exclamation mark. This follows the existing direct-path Python rules, which also have both forms. Prefix matching covers python and version suffixes such as python3 and python3.11.</a:t>
+              <a:t>What we found interesting was that a filename could hide a missing content rule. The two sides show exactly the same file content, with one space after the hash and exclamation mark. In this control test, we kept the no-space rule but temporarily left out the single-space rule. With the content alone, Tika reported plain text. When we also supplied the filename script dot py, it reported Python. If we had tested only with a filename, the input would have seemed to work. We would have missed the gap in the content rule. Our current fix includes both literal prefixes, so this input now returns Python in both modes. This does not mean a dot-py filename always wins. The result depends on how the content rules and filename hint work together.</a:t>
             </a:r>
             <a:endParaRPr/>
           </a:p>
@@ -797,7 +795,7 @@
               <a:buNone/>
             </a:pPr>
             <a:r>
-              <a:t>先说明现象：Python 首行却识别成 Shell。offset 是从 0 开始数的位置。原规则检查位置 1，但 /bin/env python 实际从位置 6 开始，所以 Python 规则没命中。修复从位置 0 匹配两条完整前缀：#!/usr/bin/env python 和 #! /usr/bin/env python。这与已有 Python 直接路径规则成对列出无空格和一个空格的方式一致。前缀匹配同时兼容 python、python3 和 python3.11。多空格、Tab 和 env 参数不在本次修复范围。</a:t>
+              <a:t>这页讲有趣的发现：文件名提示可能掩盖内容规则的缺失。左右是同一份内容，#! 后恰好一个空格。对照测试暂时只保留无空格规则：不提供文件名时是 text/plain，提供 script.py 时是 text/x-python。因此，只测试带文件名的情况，可能误以为内容识别已经正常。当前完整修复包含两条前缀，该输入在两种模式下都返回 Python。不要扩大为“任何 .py 文件都会被识别成 Python”。</a:t>
             </a:r>
             <a:endParaRPr/>
           </a:p>
@@ -842,7 +840,7 @@
               <a:buNone/>
             </a:pPr>
             <a:r>
-              <a:t>Current scope confirmed 25 October 2026: two literal string prefixes at offset 0, #!/usr/bin/env python and #! /usr/bin/env python. The paired form follows the existing direct-path Python rules, which remain unchanged. Tests include the no-space python, python3 and python3.11 cases plus exactly one space in #! /usr/bin/env python3. Prefix matching also permits version suffixes for the one-space rule, although those variants are not separate rows in the test matrix. Multiple spaces, Tab characters, env options such as env -S, and regex-based whitespace handling are outside this patch.</a:t>
+              <a:t>This comparison is the fresh no-space-only negative control recorded on 25 October 2026: 18 checks, 1 failure. The single-space content-only row returned text/plain, while the same row with script.py passed its expected text/x-python result. It is not the original offset-1 control, where no-space Python inputs failed in both modes. Final code 471afbe222655b31cb46415b979a856ccdadcea4 contains literal offset-0 prefixes #!/usr/bin/env python and #! /usr/bin/env python. The same 18 checks passed with the complete fix. These are local results for the tested inputs, not remote CI or whole-project validation.</a:t>
             </a:r>
             <a:endParaRPr/>
           </a:p>
@@ -1027,7 +1025,7 @@
               <a:buNone/>
             </a:pPr>
             <a:r>
-              <a:t>Suggested English speaker notes (approximately 50-70 seconds at a comfortable pace):</a:t>
+              <a:t>Suggested English speaker notes (approximately 60-90 seconds at a comfortable pace):</a:t>
             </a:r>
             <a:endParaRPr/>
           </a:p>
@@ -1042,7 +1040,7 @@
               <a:buNone/>
             </a:pPr>
             <a:r>
-              <a:t>A successful result for one Python example would leave important questions unanswered. The regression checks covered env python, python3 and python3.11 without a space after hash and exclamation mark, and an env python3 example with exactly one space. They also covered existing direct Python paths and Shell scripts. We separated content-only detection from detection with a dot-py filename hint, because metadata can affect the result. A leading-newline control checked that the rule required the start of the file. The same eighteen checks gave seven failures with the original rule, and all eighteen passed with the restored pair of prefixes.</a:t>
+              <a:t>We learnt four things from this work. First, test the content alone and then add a filename. A correct result with a filename may hide a gap in content detection. Second, test different kinds of input. We checked Python examples, real Shell scripts and a boundary case with a newline before the shebang. Terry also suggested ordinary text that could accidentally match the old Python rule. That example shows why review is useful, and keeping it as a permanent test is a future improvement. Third, follow existing project conventions. Other Python rules already use a pair of literal prefixes, with no space and exactly one space after the hash and exclamation mark. We followed that style and kept extra whitespace outside the scope. Finally, reproduce the behavior and compare the same tests after a focused fix. Next time, I would plan the input list earlier and keep more useful review examples as automated tests.</a:t>
             </a:r>
             <a:endParaRPr/>
           </a:p>
@@ -1087,7 +1085,7 @@
               <a:buNone/>
             </a:pPr>
             <a:r>
-              <a:t>这页讲如何证明修复可靠。content-only 是不给文件名，只靠内容识别；filename hint 是额外给 script.py。无空格的 python、python3、python3.11，加上一个空格的 #! /usr/bin/env python3，都分别用两种方式测试。还测原本正常的 Python 路径、Shell，以及前面多一个换行的输入。相同 18 项测试在原 offset 1 规则下有 7 项失败，换成两条位置 0 的前缀规则后全通过。</a:t>
+              <a:t>这页讲学到了什么：第一，同时测试不给文件名和给 filename hint 两种模式。第二，测试正确的 Python 输入，也保留 Shell 和边界输入；Terry 的普通文本反例说明 review 能发现遗漏，但它还没有加入长期自动测试。第三，遵循项目已有规则风格，成对列出无空格和一个空格的字面量前缀，不扩大成任意空白或正则。第四，保留先复现、针对性修改、相同测试前后对比的流程。下次改进是更早规划输入类型，并把有价值的 review 验证转成永久测试。</a:t>
             </a:r>
             <a:endParaRPr/>
           </a:p>
@@ -1132,7 +1130,7 @@
               <a:buNone/>
             </a:pPr>
             <a:r>
-              <a:t>The 18 checks are parameterized regression cases, not 18 separate test methods. On 25 October 2026, the negative control kept these tests and temporarily restored only the original /bin/env python rule at offset 1: 7 failures, 0 errors. A second control retained only the no-space prefix: 18 tests, 1 failure in the one-space content-only case. The two Python prefix rules in commit 471afbe222655b31cb46415b979a856ccdadcea4 then passed all 18 checks. Full local core clean install with pedantic checks and randomized locale passed: 1,377 tests, 0 failures/errors, 2 skipped; alternate Xerces checks: 12 tests, 2 skipped; TikaIT: 1 passed; annotation-processor tests: 8 passed; quality checks passed. The restored source is byte-identical to cefa669, which Kyubin approved. The group review policy allows existing reviews to count when they cover the submitted change, so that peer approval remains applicable. Merge and upstream submission remain pending. No full Tika repository test or remote CI claim is made.</a:t>
+              <a:t>Current code is 471afbe222655b31cb46415b979a856ccdadcea4, byte-identical to cefa669, which Kyubin approved. The final local evidence remains 18 focused checks passed; 1,377 core tests with 0 failures/errors and 2 skipped; alternate Xerces 12 tests with 2 skipped; TikaIT 1 passed; annotation processor 8 passed; quality checks passed. The implemented scope is the no-space and exactly-one-space literal prefixes. Multiple spaces, Tab and env options remain outside scope. Terry's x/bin/env python probe was checked separately by Kyubin, but is not part of the 18 automated checks. Turning it into a permanent test is a proposed improvement. These lessons come from Jiajun's TIKA-4408 work and do not claim identical experiences for all group members.</a:t>
             </a:r>
             <a:endParaRPr/>
           </a:p>
@@ -1177,6 +1175,21 @@
               <a:buNone/>
             </a:pPr>
             <a:r>
+              <a:t>https://github.com/u8026876/comp2120-gyg-a5/issues/2</a:t>
+            </a:r>
+            <a:endParaRPr/>
+          </a:p>
+          <a:p xmlns:a="http://schemas.openxmlformats.org/drawingml/2006/main">
+            <a:pPr marL="0" lvl="0" indent="0" algn="l">
+              <a:spcBef>
+                <a:spcPts val="0"/>
+              </a:spcBef>
+              <a:spcAft>
+                <a:spcPts val="0"/>
+              </a:spcAft>
+              <a:buNone/>
+            </a:pPr>
+            <a:r>
               <a:t>https://github.com/u8026876/comp2120-gyg-a5/pull/4</a:t>
             </a:r>
             <a:endParaRPr/>
@@ -1193,601 +1206,6 @@
             </a:pPr>
             <a:r>
               <a:t>https://github.com/u8026876/comp2120-gyg-a5/commit/471afbe222655b31cb46415b979a856ccdadcea4</a:t>
-            </a:r>
-            <a:endParaRPr/>
-          </a:p>
-          <a:p xmlns:a="http://schemas.openxmlformats.org/drawingml/2006/main">
-            <a:pPr marL="0" lvl="0" indent="0" algn="l">
-              <a:spcBef>
-                <a:spcPts val="0"/>
-              </a:spcBef>
-              <a:spcAft>
-                <a:spcPts val="0"/>
-              </a:spcAft>
-              <a:buNone/>
-            </a:pPr>
-            <a:r>
-              <a:t/>
-            </a:r>
-            <a:endParaRPr/>
-          </a:p>
-          <a:p xmlns:a="http://schemas.openxmlformats.org/drawingml/2006/main">
-            <a:pPr marL="0" lvl="0" indent="0" algn="l">
-              <a:spcBef>
-                <a:spcPts val="0"/>
-              </a:spcBef>
-              <a:spcAft>
-                <a:spcPts val="0"/>
-              </a:spcAft>
-              <a:buNone/>
-            </a:pPr>
-            <a:r>
-              <a:t>Contribution and assistance: Jiajun owns TIKA-4408. Codex assisted the implementation, testing, and presentation preparation. Kyubin supplied independent validation and approved cefa669. The restored code is identical to that reviewed source, and the group review policy retains that approval. Terry supplied additional review feedback. The PR is open, with merge and upstream submission pending. The visual template belongs to the group and was shared by Kyubin.</a:t>
-            </a:r>
-            <a:endParaRPr/>
-          </a:p>
-        </p:txBody>
-      </p:sp>
-      <p:sp>
-        <p:nvSpPr>
-          <p:cNvPr id="4" name="Slide Number Placeholder 3"/>
-          <p:cNvSpPr>
-            <a:spLocks xmlns:a="http://schemas.openxmlformats.org/drawingml/2006/main" noGrp="1"/>
-          </p:cNvSpPr>
-          <p:nvPr>
-            <p:ph type="sldNum" idx="5"/>
-          </p:nvPr>
-        </p:nvSpPr>
-        <p:spPr/>
-        <p:txBody>
-          <a:bodyPr xmlns:a="http://schemas.openxmlformats.org/drawingml/2006/main"/>
-          <a:lstStyle xmlns:a="http://schemas.openxmlformats.org/drawingml/2006/main"/>
-          <a:p xmlns:a="http://schemas.openxmlformats.org/drawingml/2006/main"/>
-        </p:txBody>
-      </p:sp>
-    </p:spTree>
-  </p:cSld>
-  <p:clrMapOvr>
-    <a:masterClrMapping xmlns:a="http://schemas.openxmlformats.org/drawingml/2006/main"/>
-  </p:clrMapOvr>
-</p:notes>
-</file>
-
-<file path=ppt/notesSlides/notesSlide3.xml><?xml version="1.0" encoding="utf-8"?>
-<p:notes xmlns:p="http://schemas.openxmlformats.org/presentationml/2006/main">
-  <p:cSld>
-    <p:spTree>
-      <p:nvGrpSpPr>
-        <p:cNvPr id="1" name=""/>
-        <p:cNvGrpSpPr/>
-        <p:nvPr/>
-      </p:nvGrpSpPr>
-      <p:grpSpPr>
-        <a:xfrm xmlns:a="http://schemas.openxmlformats.org/drawingml/2006/main"/>
-      </p:grpSpPr>
-      <p:sp>
-        <p:nvSpPr>
-          <p:cNvPr id="2" name="Slide Image Placeholder 1"/>
-          <p:cNvSpPr>
-            <a:spLocks xmlns:a="http://schemas.openxmlformats.org/drawingml/2006/main" noGrp="1"/>
-          </p:cNvSpPr>
-          <p:nvPr>
-            <p:ph type="sldImg" idx="0"/>
-          </p:nvPr>
-        </p:nvSpPr>
-        <p:spPr/>
-      </p:sp>
-      <p:sp>
-        <p:nvSpPr>
-          <p:cNvPr id="3" name="Notes Placeholder 2"/>
-          <p:cNvSpPr>
-            <a:spLocks xmlns:a="http://schemas.openxmlformats.org/drawingml/2006/main" noGrp="1"/>
-          </p:cNvSpPr>
-          <p:nvPr>
-            <p:ph type="body" idx="1"/>
-          </p:nvPr>
-        </p:nvSpPr>
-        <p:spPr/>
-        <p:txBody>
-          <a:bodyPr xmlns:a="http://schemas.openxmlformats.org/drawingml/2006/main"/>
-          <a:lstStyle xmlns:a="http://schemas.openxmlformats.org/drawingml/2006/main"/>
-          <a:p xmlns:a="http://schemas.openxmlformats.org/drawingml/2006/main">
-            <a:pPr marL="0" lvl="0" indent="0" algn="l">
-              <a:spcBef>
-                <a:spcPts val="0"/>
-              </a:spcBef>
-              <a:spcAft>
-                <a:spcPts val="0"/>
-              </a:spcAft>
-              <a:buNone/>
-            </a:pPr>
-            <a:r>
-              <a:t>Presenter: Jiajun Li (Lynnbb88)</a:t>
-            </a:r>
-            <a:endParaRPr/>
-          </a:p>
-          <a:p xmlns:a="http://schemas.openxmlformats.org/drawingml/2006/main">
-            <a:pPr marL="0" lvl="0" indent="0" algn="l">
-              <a:spcBef>
-                <a:spcPts val="0"/>
-              </a:spcBef>
-              <a:spcAft>
-                <a:spcPts val="0"/>
-              </a:spcAft>
-              <a:buNone/>
-            </a:pPr>
-            <a:r>
-              <a:t>Suggested English speaker notes (approximately 50-70 seconds at a comfortable pace):</a:t>
-            </a:r>
-            <a:endParaRPr/>
-          </a:p>
-          <a:p xmlns:a="http://schemas.openxmlformats.org/drawingml/2006/main">
-            <a:pPr marL="0" lvl="0" indent="0" algn="l">
-              <a:spcBef>
-                <a:spcPts val="0"/>
-              </a:spcBef>
-              <a:spcAft>
-                <a:spcPts val="0"/>
-              </a:spcAft>
-              <a:buNone/>
-            </a:pPr>
-            <a:r>
-              <a:t>Terry suggested an ordinary-text example that tested the opposite direction: could Tika incorrectly call this Python? The x occupies position zero, so slash bin slash env python begins exactly at position one, where the old rule expected it. That accidental match produced a false positive. A negative test checks that unsuitable input does not trigger the Python rule. Kyubin separately verified this example on the earlier fix: the original rules returned text slash x-python, while that reviewed version returned text slash plain. The lesson is to preserve useful review examples as automated tests; this permanent test is currently deferred.</a:t>
-            </a:r>
-            <a:endParaRPr/>
-          </a:p>
-          <a:p xmlns:a="http://schemas.openxmlformats.org/drawingml/2006/main">
-            <a:pPr marL="0" lvl="0" indent="0" algn="l">
-              <a:spcBef>
-                <a:spcPts val="0"/>
-              </a:spcBef>
-              <a:spcAft>
-                <a:spcPts val="0"/>
-              </a:spcAft>
-              <a:buNone/>
-            </a:pPr>
-            <a:r>
-              <a:t/>
-            </a:r>
-            <a:endParaRPr/>
-          </a:p>
-          <a:p xmlns:a="http://schemas.openxmlformats.org/drawingml/2006/main">
-            <a:pPr marL="0" lvl="0" indent="0" algn="l">
-              <a:spcBef>
-                <a:spcPts val="0"/>
-              </a:spcBef>
-              <a:spcAft>
-                <a:spcPts val="0"/>
-              </a:spcAft>
-              <a:buNone/>
-            </a:pPr>
-            <a:r>
-              <a:t>中文理解提示：</a:t>
-            </a:r>
-            <a:endParaRPr/>
-          </a:p>
-          <a:p xmlns:a="http://schemas.openxmlformats.org/drawingml/2006/main">
-            <a:pPr marL="0" lvl="0" indent="0" algn="l">
-              <a:spcBef>
-                <a:spcPts val="0"/>
-              </a:spcBef>
-              <a:spcAft>
-                <a:spcPts val="0"/>
-              </a:spcAft>
-              <a:buNone/>
-            </a:pPr>
-            <a:r>
-              <a:t>这不是要执行的 Python 代码，而是故意构造的普通文本。x 占位置 0，后面的 /bin/env python 正好在位置 1，因此旧规则会误报为 Python。false positive 就是误报。Terry 提议把它加入长期测试，Kyubin 对 cefa669 版本做过独立验证。图中结果引用的是那次单独验证，当前 review 状态以 PR 记录为准。该反例未进入当前 18 项测试，永久回归测试暂缓。</a:t>
-            </a:r>
-            <a:endParaRPr/>
-          </a:p>
-          <a:p xmlns:a="http://schemas.openxmlformats.org/drawingml/2006/main">
-            <a:pPr marL="0" lvl="0" indent="0" algn="l">
-              <a:spcBef>
-                <a:spcPts val="0"/>
-              </a:spcBef>
-              <a:spcAft>
-                <a:spcPts val="0"/>
-              </a:spcAft>
-              <a:buNone/>
-            </a:pPr>
-            <a:r>
-              <a:t/>
-            </a:r>
-            <a:endParaRPr/>
-          </a:p>
-          <a:p xmlns:a="http://schemas.openxmlformats.org/drawingml/2006/main">
-            <a:pPr marL="0" lvl="0" indent="0" algn="l">
-              <a:spcBef>
-                <a:spcPts val="0"/>
-              </a:spcBef>
-              <a:spcAft>
-                <a:spcPts val="0"/>
-              </a:spcAft>
-              <a:buNone/>
-            </a:pPr>
-            <a:r>
-              <a:t>Evidence and limits:</a:t>
-            </a:r>
-            <a:endParaRPr/>
-          </a:p>
-          <a:p xmlns:a="http://schemas.openxmlformats.org/drawingml/2006/main">
-            <a:pPr marL="0" lvl="0" indent="0" algn="l">
-              <a:spcBef>
-                <a:spcPts val="0"/>
-              </a:spcBef>
-              <a:spcAft>
-                <a:spcPts val="0"/>
-              </a:spcAft>
-              <a:buNone/>
-            </a:pPr>
-            <a:r>
-              <a:t>These observed results come from Kyubin's separate content-only probe on cefa669 and the original MIME registry. This is recorded review evidence rather than a fresh automated check in the current 18-case matrix. The permanent regression test remains deferred. Current review status is recorded on the PR.</a:t>
-            </a:r>
-            <a:endParaRPr/>
-          </a:p>
-          <a:p xmlns:a="http://schemas.openxmlformats.org/drawingml/2006/main">
-            <a:pPr marL="0" lvl="0" indent="0" algn="l">
-              <a:spcBef>
-                <a:spcPts val="0"/>
-              </a:spcBef>
-              <a:spcAft>
-                <a:spcPts val="0"/>
-              </a:spcAft>
-              <a:buNone/>
-            </a:pPr>
-            <a:r>
-              <a:t/>
-            </a:r>
-            <a:endParaRPr/>
-          </a:p>
-          <a:p xmlns:a="http://schemas.openxmlformats.org/drawingml/2006/main">
-            <a:pPr marL="0" lvl="0" indent="0" algn="l">
-              <a:spcBef>
-                <a:spcPts val="0"/>
-              </a:spcBef>
-              <a:spcAft>
-                <a:spcPts val="0"/>
-              </a:spcAft>
-              <a:buNone/>
-            </a:pPr>
-            <a:r>
-              <a:t>Sources:</a:t>
-            </a:r>
-            <a:endParaRPr/>
-          </a:p>
-          <a:p xmlns:a="http://schemas.openxmlformats.org/drawingml/2006/main">
-            <a:pPr marL="0" lvl="0" indent="0" algn="l">
-              <a:spcBef>
-                <a:spcPts val="0"/>
-              </a:spcBef>
-              <a:spcAft>
-                <a:spcPts val="0"/>
-              </a:spcAft>
-              <a:buNone/>
-            </a:pPr>
-            <a:r>
-              <a:t>https://github.com/u8026876/comp2120-gyg-a5/issues/2#issuecomment-6311536436</a:t>
-            </a:r>
-            <a:endParaRPr/>
-          </a:p>
-          <a:p xmlns:a="http://schemas.openxmlformats.org/drawingml/2006/main">
-            <a:pPr marL="0" lvl="0" indent="0" algn="l">
-              <a:spcBef>
-                <a:spcPts val="0"/>
-              </a:spcBef>
-              <a:spcAft>
-                <a:spcPts val="0"/>
-              </a:spcAft>
-              <a:buNone/>
-            </a:pPr>
-            <a:r>
-              <a:t>https://github.com/u8026876/comp2120-gyg-a5/pull/4#pullrequestreview-5584302852</a:t>
-            </a:r>
-            <a:endParaRPr/>
-          </a:p>
-          <a:p xmlns:a="http://schemas.openxmlformats.org/drawingml/2006/main">
-            <a:pPr marL="0" lvl="0" indent="0" algn="l">
-              <a:spcBef>
-                <a:spcPts val="0"/>
-              </a:spcBef>
-              <a:spcAft>
-                <a:spcPts val="0"/>
-              </a:spcAft>
-              <a:buNone/>
-            </a:pPr>
-            <a:r>
-              <a:t>https://github.com/u8026876/comp2120-gyg-a5/commit/cefa66955d74b2bf488d5ff4044fe2a6563bbf96</a:t>
-            </a:r>
-            <a:endParaRPr/>
-          </a:p>
-          <a:p xmlns:a="http://schemas.openxmlformats.org/drawingml/2006/main">
-            <a:pPr marL="0" lvl="0" indent="0" algn="l">
-              <a:spcBef>
-                <a:spcPts val="0"/>
-              </a:spcBef>
-              <a:spcAft>
-                <a:spcPts val="0"/>
-              </a:spcAft>
-              <a:buNone/>
-            </a:pPr>
-            <a:r>
-              <a:t/>
-            </a:r>
-            <a:endParaRPr/>
-          </a:p>
-          <a:p xmlns:a="http://schemas.openxmlformats.org/drawingml/2006/main">
-            <a:pPr marL="0" lvl="0" indent="0" algn="l">
-              <a:spcBef>
-                <a:spcPts val="0"/>
-              </a:spcBef>
-              <a:spcAft>
-                <a:spcPts val="0"/>
-              </a:spcAft>
-              <a:buNone/>
-            </a:pPr>
-            <a:r>
-              <a:t>Contribution and assistance: Jiajun owns TIKA-4408. Codex assisted the implementation, testing, and presentation preparation. Kyubin supplied independent validation and approved cefa669. The restored code is identical to that reviewed source, and the group review policy retains that approval. Terry supplied additional review feedback. The PR is open, with merge and upstream submission pending. The visual template belongs to the group and was shared by Kyubin.</a:t>
-            </a:r>
-            <a:endParaRPr/>
-          </a:p>
-        </p:txBody>
-      </p:sp>
-      <p:sp>
-        <p:nvSpPr>
-          <p:cNvPr id="4" name="Slide Number Placeholder 3"/>
-          <p:cNvSpPr>
-            <a:spLocks xmlns:a="http://schemas.openxmlformats.org/drawingml/2006/main" noGrp="1"/>
-          </p:cNvSpPr>
-          <p:nvPr>
-            <p:ph type="sldNum" idx="5"/>
-          </p:nvPr>
-        </p:nvSpPr>
-        <p:spPr/>
-        <p:txBody>
-          <a:bodyPr xmlns:a="http://schemas.openxmlformats.org/drawingml/2006/main"/>
-          <a:lstStyle xmlns:a="http://schemas.openxmlformats.org/drawingml/2006/main"/>
-          <a:p xmlns:a="http://schemas.openxmlformats.org/drawingml/2006/main"/>
-        </p:txBody>
-      </p:sp>
-    </p:spTree>
-  </p:cSld>
-  <p:clrMapOvr>
-    <a:masterClrMapping xmlns:a="http://schemas.openxmlformats.org/drawingml/2006/main"/>
-  </p:clrMapOvr>
-</p:notes>
-</file>
-
-<file path=ppt/notesSlides/notesSlide4.xml><?xml version="1.0" encoding="utf-8"?>
-<p:notes xmlns:p="http://schemas.openxmlformats.org/presentationml/2006/main">
-  <p:cSld>
-    <p:spTree>
-      <p:nvGrpSpPr>
-        <p:cNvPr id="1" name=""/>
-        <p:cNvGrpSpPr/>
-        <p:nvPr/>
-      </p:nvGrpSpPr>
-      <p:grpSpPr>
-        <a:xfrm xmlns:a="http://schemas.openxmlformats.org/drawingml/2006/main"/>
-      </p:grpSpPr>
-      <p:sp>
-        <p:nvSpPr>
-          <p:cNvPr id="2" name="Slide Image Placeholder 1"/>
-          <p:cNvSpPr>
-            <a:spLocks xmlns:a="http://schemas.openxmlformats.org/drawingml/2006/main" noGrp="1"/>
-          </p:cNvSpPr>
-          <p:nvPr>
-            <p:ph type="sldImg" idx="0"/>
-          </p:nvPr>
-        </p:nvSpPr>
-        <p:spPr/>
-      </p:sp>
-      <p:sp>
-        <p:nvSpPr>
-          <p:cNvPr id="3" name="Notes Placeholder 2"/>
-          <p:cNvSpPr>
-            <a:spLocks xmlns:a="http://schemas.openxmlformats.org/drawingml/2006/main" noGrp="1"/>
-          </p:cNvSpPr>
-          <p:nvPr>
-            <p:ph type="body" idx="1"/>
-          </p:nvPr>
-        </p:nvSpPr>
-        <p:spPr/>
-        <p:txBody>
-          <a:bodyPr xmlns:a="http://schemas.openxmlformats.org/drawingml/2006/main"/>
-          <a:lstStyle xmlns:a="http://schemas.openxmlformats.org/drawingml/2006/main"/>
-          <a:p xmlns:a="http://schemas.openxmlformats.org/drawingml/2006/main">
-            <a:pPr marL="0" lvl="0" indent="0" algn="l">
-              <a:spcBef>
-                <a:spcPts val="0"/>
-              </a:spcBef>
-              <a:spcAft>
-                <a:spcPts val="0"/>
-              </a:spcAft>
-              <a:buNone/>
-            </a:pPr>
-            <a:r>
-              <a:t>Presenter: Jiajun Li (Lynnbb88)</a:t>
-            </a:r>
-            <a:endParaRPr/>
-          </a:p>
-          <a:p xmlns:a="http://schemas.openxmlformats.org/drawingml/2006/main">
-            <a:pPr marL="0" lvl="0" indent="0" algn="l">
-              <a:spcBef>
-                <a:spcPts val="0"/>
-              </a:spcBef>
-              <a:spcAft>
-                <a:spcPts val="0"/>
-              </a:spcAft>
-              <a:buNone/>
-            </a:pPr>
-            <a:r>
-              <a:t>Suggested English speaker notes (approximately 50-70 seconds at a comfortable pace):</a:t>
-            </a:r>
-            <a:endParaRPr/>
-          </a:p>
-          <a:p xmlns:a="http://schemas.openxmlformats.org/drawingml/2006/main">
-            <a:pPr marL="0" lvl="0" indent="0" algn="l">
-              <a:spcBef>
-                <a:spcPts val="0"/>
-              </a:spcBef>
-              <a:spcAft>
-                <a:spcPts val="0"/>
-              </a:spcAft>
-              <a:buNone/>
-            </a:pPr>
-            <a:r>
-              <a:t>The main lesson is that a small code change can affect several kinds of input. Next time, I would plan that range earlier by writing a test matrix with expected outcomes, including misleading ordinary text and boundary cases. I would also review the extra examples raised by teammates and decide which should become permanent tests. I would keep the approach that worked here: establish a baseline, reproduce the problem, make a focused change, and compare the same checks afterwards. The improvement is earlier and more complete coverage, together with lasting evidence from review.</a:t>
-            </a:r>
-            <a:endParaRPr/>
-          </a:p>
-          <a:p xmlns:a="http://schemas.openxmlformats.org/drawingml/2006/main">
-            <a:pPr marL="0" lvl="0" indent="0" algn="l">
-              <a:spcBef>
-                <a:spcPts val="0"/>
-              </a:spcBef>
-              <a:spcAft>
-                <a:spcPts val="0"/>
-              </a:spcAft>
-              <a:buNone/>
-            </a:pPr>
-            <a:r>
-              <a:t/>
-            </a:r>
-            <a:endParaRPr/>
-          </a:p>
-          <a:p xmlns:a="http://schemas.openxmlformats.org/drawingml/2006/main">
-            <a:pPr marL="0" lvl="0" indent="0" algn="l">
-              <a:spcBef>
-                <a:spcPts val="0"/>
-              </a:spcBef>
-              <a:spcAft>
-                <a:spcPts val="0"/>
-              </a:spcAft>
-              <a:buNone/>
-            </a:pPr>
-            <a:r>
-              <a:t>中文理解提示：</a:t>
-            </a:r>
-            <a:endParaRPr/>
-          </a:p>
-          <a:p xmlns:a="http://schemas.openxmlformats.org/drawingml/2006/main">
-            <a:pPr marL="0" lvl="0" indent="0" algn="l">
-              <a:spcBef>
-                <a:spcPts val="0"/>
-              </a:spcBef>
-              <a:spcAft>
-                <a:spcPts val="0"/>
-              </a:spcAft>
-              <a:buNone/>
-            </a:pPr>
-            <a:r>
-              <a:t>不要说“下次才先写测试”，因为这次已经先复现再修复。真正的改进是更早考虑完整输入分类，特别是反例和边界情况，并把 review 的有效验证保留在自动测试中。保留已有效的流程：baseline、复现、针对性修改、相同测试前后对比。</a:t>
-            </a:r>
-            <a:endParaRPr/>
-          </a:p>
-          <a:p xmlns:a="http://schemas.openxmlformats.org/drawingml/2006/main">
-            <a:pPr marL="0" lvl="0" indent="0" algn="l">
-              <a:spcBef>
-                <a:spcPts val="0"/>
-              </a:spcBef>
-              <a:spcAft>
-                <a:spcPts val="0"/>
-              </a:spcAft>
-              <a:buNone/>
-            </a:pPr>
-            <a:r>
-              <a:t/>
-            </a:r>
-            <a:endParaRPr/>
-          </a:p>
-          <a:p xmlns:a="http://schemas.openxmlformats.org/drawingml/2006/main">
-            <a:pPr marL="0" lvl="0" indent="0" algn="l">
-              <a:spcBef>
-                <a:spcPts val="0"/>
-              </a:spcBef>
-              <a:spcAft>
-                <a:spcPts val="0"/>
-              </a:spcAft>
-              <a:buNone/>
-            </a:pPr>
-            <a:r>
-              <a:t>Evidence and limits:</a:t>
-            </a:r>
-            <a:endParaRPr/>
-          </a:p>
-          <a:p xmlns:a="http://schemas.openxmlformats.org/drawingml/2006/main">
-            <a:pPr marL="0" lvl="0" indent="0" algn="l">
-              <a:spcBef>
-                <a:spcPts val="0"/>
-              </a:spcBef>
-              <a:spcAft>
-                <a:spcPts val="0"/>
-              </a:spcAft>
-              <a:buNone/>
-            </a:pPr>
-            <a:r>
-              <a:t>These are proposed process improvements. The misleading-text regression has not been added as part of preparing this presentation. This section uses TIKA-4408 as Jiajun's concrete example and does not claim identical experiences for every group member.</a:t>
-            </a:r>
-            <a:endParaRPr/>
-          </a:p>
-          <a:p xmlns:a="http://schemas.openxmlformats.org/drawingml/2006/main">
-            <a:pPr marL="0" lvl="0" indent="0" algn="l">
-              <a:spcBef>
-                <a:spcPts val="0"/>
-              </a:spcBef>
-              <a:spcAft>
-                <a:spcPts val="0"/>
-              </a:spcAft>
-              <a:buNone/>
-            </a:pPr>
-            <a:r>
-              <a:t/>
-            </a:r>
-            <a:endParaRPr/>
-          </a:p>
-          <a:p xmlns:a="http://schemas.openxmlformats.org/drawingml/2006/main">
-            <a:pPr marL="0" lvl="0" indent="0" algn="l">
-              <a:spcBef>
-                <a:spcPts val="0"/>
-              </a:spcBef>
-              <a:spcAft>
-                <a:spcPts val="0"/>
-              </a:spcAft>
-              <a:buNone/>
-            </a:pPr>
-            <a:r>
-              <a:t>Sources:</a:t>
-            </a:r>
-            <a:endParaRPr/>
-          </a:p>
-          <a:p xmlns:a="http://schemas.openxmlformats.org/drawingml/2006/main">
-            <a:pPr marL="0" lvl="0" indent="0" algn="l">
-              <a:spcBef>
-                <a:spcPts val="0"/>
-              </a:spcBef>
-              <a:spcAft>
-                <a:spcPts val="0"/>
-              </a:spcAft>
-              <a:buNone/>
-            </a:pPr>
-            <a:r>
-              <a:t>https://github.com/u8026876/comp2120-gyg-a5/issues/2</a:t>
-            </a:r>
-            <a:endParaRPr/>
-          </a:p>
-          <a:p xmlns:a="http://schemas.openxmlformats.org/drawingml/2006/main">
-            <a:pPr marL="0" lvl="0" indent="0" algn="l">
-              <a:spcBef>
-                <a:spcPts val="0"/>
-              </a:spcBef>
-              <a:spcAft>
-                <a:spcPts val="0"/>
-              </a:spcAft>
-              <a:buNone/>
-            </a:pPr>
-            <a:r>
-              <a:t>https://github.com/u8026876/comp2120-gyg-a5/pull/4</a:t>
             </a:r>
             <a:endParaRPr/>
           </a:p>
@@ -1910,7 +1328,7 @@
           <p:cNvPr id="11" name="Google Shape;11;p2">
             <a:extLst xmlns:a="http://schemas.openxmlformats.org/drawingml/2006/main">
               <a:ext uri="{FF2B5EF4-FFF2-40B4-BE49-F238E27FC236}">
-                <a16:creationId xmlns:a16="http://schemas.microsoft.com/office/drawing/2014/main" id="{8419BC4A-AB4F-4939-A3CB-EAC1788F6A42}"/>
+                <a16:creationId xmlns:a16="http://schemas.microsoft.com/office/drawing/2014/main" id="{4C586275-35EE-4D53-8B0E-CA372666649B}"/>
               </a:ext>
             </a:extLst>
           </p:cNvPr>
@@ -2047,7 +1465,7 @@
           <p:cNvPr id="12" name="Google Shape;12;p2">
             <a:extLst xmlns:a="http://schemas.openxmlformats.org/drawingml/2006/main">
               <a:ext uri="{FF2B5EF4-FFF2-40B4-BE49-F238E27FC236}">
-                <a16:creationId xmlns:a16="http://schemas.microsoft.com/office/drawing/2014/main" id="{72FDEE64-1AFD-4A7F-993C-1A955970ABDA}"/>
+                <a16:creationId xmlns:a16="http://schemas.microsoft.com/office/drawing/2014/main" id="{37844590-E6D8-4C31-966D-A6F32F97FAA3}"/>
               </a:ext>
             </a:extLst>
           </p:cNvPr>
@@ -2201,7 +1619,7 @@
           <p:cNvPr id="15" name="Google Shape;15;p4">
             <a:extLst xmlns:a="http://schemas.openxmlformats.org/drawingml/2006/main">
               <a:ext uri="{FF2B5EF4-FFF2-40B4-BE49-F238E27FC236}">
-                <a16:creationId xmlns:a16="http://schemas.microsoft.com/office/drawing/2014/main" id="{3BAC645A-8630-4D79-94D6-B5E25B8644BB}"/>
+                <a16:creationId xmlns:a16="http://schemas.microsoft.com/office/drawing/2014/main" id="{2A0A2D37-BA32-4711-8FAF-B346EC8AC357}"/>
               </a:ext>
             </a:extLst>
           </p:cNvPr>
@@ -2338,7 +1756,7 @@
           <p:cNvPr id="16" name="Google Shape;16;p4">
             <a:extLst xmlns:a="http://schemas.openxmlformats.org/drawingml/2006/main">
               <a:ext uri="{FF2B5EF4-FFF2-40B4-BE49-F238E27FC236}">
-                <a16:creationId xmlns:a16="http://schemas.microsoft.com/office/drawing/2014/main" id="{443749A5-2521-411E-84DF-8048D717D2A2}"/>
+                <a16:creationId xmlns:a16="http://schemas.microsoft.com/office/drawing/2014/main" id="{333ABD2C-18E0-4D65-8C2F-158C04C5921D}"/>
               </a:ext>
             </a:extLst>
           </p:cNvPr>
@@ -2475,7 +1893,7 @@
           <p:cNvPr id="17" name="Google Shape;17;p4">
             <a:extLst xmlns:a="http://schemas.openxmlformats.org/drawingml/2006/main">
               <a:ext uri="{FF2B5EF4-FFF2-40B4-BE49-F238E27FC236}">
-                <a16:creationId xmlns:a16="http://schemas.microsoft.com/office/drawing/2014/main" id="{6D09A10B-1B85-473D-9E8D-6BED8F0388A8}"/>
+                <a16:creationId xmlns:a16="http://schemas.microsoft.com/office/drawing/2014/main" id="{DE5D9A58-EFA7-4B9D-85E3-C8C975893BB1}"/>
               </a:ext>
             </a:extLst>
           </p:cNvPr>
@@ -2629,7 +2047,7 @@
           <p:cNvPr id="19" name="Google Shape;19;p5">
             <a:extLst xmlns:a="http://schemas.openxmlformats.org/drawingml/2006/main">
               <a:ext uri="{FF2B5EF4-FFF2-40B4-BE49-F238E27FC236}">
-                <a16:creationId xmlns:a16="http://schemas.microsoft.com/office/drawing/2014/main" id="{F115295E-85C1-4456-B8DF-31DF7B6C627C}"/>
+                <a16:creationId xmlns:a16="http://schemas.microsoft.com/office/drawing/2014/main" id="{9AE6EE1C-CFC0-43F1-80F7-2BF8A85FCBA2}"/>
               </a:ext>
             </a:extLst>
           </p:cNvPr>
@@ -2766,7 +2184,7 @@
           <p:cNvPr id="20" name="Google Shape;20;p5">
             <a:extLst xmlns:a="http://schemas.openxmlformats.org/drawingml/2006/main">
               <a:ext uri="{FF2B5EF4-FFF2-40B4-BE49-F238E27FC236}">
-                <a16:creationId xmlns:a16="http://schemas.microsoft.com/office/drawing/2014/main" id="{80AE2A0E-B7A9-4502-AACB-E5B789F703FE}"/>
+                <a16:creationId xmlns:a16="http://schemas.microsoft.com/office/drawing/2014/main" id="{22485304-C6F0-486F-8CC4-4C1D6B15FF53}"/>
               </a:ext>
             </a:extLst>
           </p:cNvPr>
@@ -2903,7 +2321,7 @@
           <p:cNvPr id="21" name="Google Shape;21;p5">
             <a:extLst xmlns:a="http://schemas.openxmlformats.org/drawingml/2006/main">
               <a:ext uri="{FF2B5EF4-FFF2-40B4-BE49-F238E27FC236}">
-                <a16:creationId xmlns:a16="http://schemas.microsoft.com/office/drawing/2014/main" id="{7681E8BD-6771-40A6-9853-A62EBE20DD1B}"/>
+                <a16:creationId xmlns:a16="http://schemas.microsoft.com/office/drawing/2014/main" id="{17907D76-ED81-4202-B67A-E08446262308}"/>
               </a:ext>
             </a:extLst>
           </p:cNvPr>
@@ -3057,7 +2475,7 @@
           <p:cNvPr id="23" name="Google Shape;23;p6">
             <a:extLst xmlns:a="http://schemas.openxmlformats.org/drawingml/2006/main">
               <a:ext uri="{FF2B5EF4-FFF2-40B4-BE49-F238E27FC236}">
-                <a16:creationId xmlns:a16="http://schemas.microsoft.com/office/drawing/2014/main" id="{9EE92BEE-9C49-46FF-AB14-C8F6EF10B10F}"/>
+                <a16:creationId xmlns:a16="http://schemas.microsoft.com/office/drawing/2014/main" id="{E031D08E-3E1D-469D-959F-089FC2DE6235}"/>
               </a:ext>
             </a:extLst>
           </p:cNvPr>
@@ -3194,7 +2612,7 @@
           <p:cNvPr id="24" name="Google Shape;24;p6">
             <a:extLst xmlns:a="http://schemas.openxmlformats.org/drawingml/2006/main">
               <a:ext uri="{FF2B5EF4-FFF2-40B4-BE49-F238E27FC236}">
-                <a16:creationId xmlns:a16="http://schemas.microsoft.com/office/drawing/2014/main" id="{3B89CF53-BDE8-476B-8DC8-A6E3F9CE8D3C}"/>
+                <a16:creationId xmlns:a16="http://schemas.microsoft.com/office/drawing/2014/main" id="{DA4DBAF8-CB00-46C5-AAF4-A4D1F0B25334}"/>
               </a:ext>
             </a:extLst>
           </p:cNvPr>
@@ -3348,7 +2766,7 @@
           <p:cNvPr id="26" name="Google Shape;26;p7">
             <a:extLst xmlns:a="http://schemas.openxmlformats.org/drawingml/2006/main">
               <a:ext uri="{FF2B5EF4-FFF2-40B4-BE49-F238E27FC236}">
-                <a16:creationId xmlns:a16="http://schemas.microsoft.com/office/drawing/2014/main" id="{E18FD40E-96A9-4C40-92A2-A37F107EB4D6}"/>
+                <a16:creationId xmlns:a16="http://schemas.microsoft.com/office/drawing/2014/main" id="{E74DF22A-3D1E-4F0C-898C-E64C54AB65EF}"/>
               </a:ext>
             </a:extLst>
           </p:cNvPr>
@@ -3485,7 +2903,7 @@
           <p:cNvPr id="27" name="Google Shape;27;p7">
             <a:extLst xmlns:a="http://schemas.openxmlformats.org/drawingml/2006/main">
               <a:ext uri="{FF2B5EF4-FFF2-40B4-BE49-F238E27FC236}">
-                <a16:creationId xmlns:a16="http://schemas.microsoft.com/office/drawing/2014/main" id="{3774171E-C7DC-4713-8AEC-B00C0FE87CDE}"/>
+                <a16:creationId xmlns:a16="http://schemas.microsoft.com/office/drawing/2014/main" id="{26BA497F-1F49-4396-BCC0-206F9DCAC1ED}"/>
               </a:ext>
             </a:extLst>
           </p:cNvPr>
@@ -3645,7 +3063,7 @@
   </p:cSld>
   <p:clrMap bg1="lt1" tx1="dk1" bg2="dk2" tx2="lt2" accent1="accent1" accent2="accent2" accent3="accent3" accent4="accent4" accent5="accent5" accent6="accent6" hlink="hlink" folHlink="folHlink"/>
   <p:sldLayoutIdLst>
-    <p:sldLayoutId xmlns:r="http://schemas.openxmlformats.org/officeDocument/2006/relationships" id="2147483649" r:id="R8f76fec9297148cb"/>
+    <p:sldLayoutId xmlns:r="http://schemas.openxmlformats.org/officeDocument/2006/relationships" id="2147483649" r:id="R12b7f7e799fc4576"/>
   </p:sldLayoutIdLst>
   <p:hf sldNum="0" hdr="0" ftr="0" dt="0"/>
   <p:txStyles>
@@ -4330,10 +3748,10 @@
   </p:cSld>
   <p:clrMap bg1="lt1" tx1="dk1" bg2="dk2" tx2="lt2" accent1="accent1" accent2="accent2" accent3="accent3" accent4="accent4" accent5="accent5" accent6="accent6" hlink="hlink" folHlink="folHlink"/>
   <p:sldLayoutIdLst>
-    <p:sldLayoutId xmlns:r="http://schemas.openxmlformats.org/officeDocument/2006/relationships" id="2147483651" r:id="Rebf8a2a2f9234b9d"/>
-    <p:sldLayoutId xmlns:r="http://schemas.openxmlformats.org/officeDocument/2006/relationships" id="2147483652" r:id="R757457ba1f264c05"/>
-    <p:sldLayoutId xmlns:r="http://schemas.openxmlformats.org/officeDocument/2006/relationships" id="2147483653" r:id="R2c07d903a66c4425"/>
-    <p:sldLayoutId xmlns:r="http://schemas.openxmlformats.org/officeDocument/2006/relationships" id="2147483654" r:id="R2bd7af8bab0d4cf2"/>
+    <p:sldLayoutId xmlns:r="http://schemas.openxmlformats.org/officeDocument/2006/relationships" id="2147483651" r:id="R4954a85495ff474e"/>
+    <p:sldLayoutId xmlns:r="http://schemas.openxmlformats.org/officeDocument/2006/relationships" id="2147483652" r:id="R98ea582f588240b9"/>
+    <p:sldLayoutId xmlns:r="http://schemas.openxmlformats.org/officeDocument/2006/relationships" id="2147483653" r:id="R4fda7526d9e34c9f"/>
+    <p:sldLayoutId xmlns:r="http://schemas.openxmlformats.org/officeDocument/2006/relationships" id="2147483654" r:id="Rc4b76bc29c7c4925"/>
   </p:sldLayoutIdLst>
   <p:hf sldNum="0" hdr="0" ftr="0" dt="0"/>
   <p:txStyles>
@@ -5555,7 +4973,7 @@
           <p:cNvPr id="42" name="Google Shape;42;p9">
             <a:extLst xmlns:a="http://schemas.openxmlformats.org/drawingml/2006/main">
               <a:ext uri="{FF2B5EF4-FFF2-40B4-BE49-F238E27FC236}">
-                <a16:creationId xmlns:a16="http://schemas.microsoft.com/office/drawing/2014/main" id="{C649A7DE-3EB6-4F20-99F1-6CCEBCD4FFF0}"/>
+                <a16:creationId xmlns:a16="http://schemas.microsoft.com/office/drawing/2014/main" id="{693AB28B-9CFC-4D75-AFE4-7B462C5D448D}"/>
               </a:ext>
             </a:extLst>
           </p:cNvPr>
@@ -5606,7 +5024,7 @@
           <p:cNvPr id="43" name="Google Shape;43;p9">
             <a:extLst xmlns:a="http://schemas.openxmlformats.org/drawingml/2006/main">
               <a:ext uri="{FF2B5EF4-FFF2-40B4-BE49-F238E27FC236}">
-                <a16:creationId xmlns:a16="http://schemas.microsoft.com/office/drawing/2014/main" id="{F563E5C4-AF43-47DB-A4EC-C542AA844741}"/>
+                <a16:creationId xmlns:a16="http://schemas.microsoft.com/office/drawing/2014/main" id="{0E1EB557-327A-4FE2-A99C-52BABA6DE2D7}"/>
               </a:ext>
             </a:extLst>
           </p:cNvPr>
@@ -5652,7 +5070,7 @@
                 <a:ea typeface="Roboto Mono"/>
                 <a:cs typeface="Roboto Mono"/>
               </a:rPr>
-              <a:t>TIKA-4408 / DEVELOPMENT CHALLENGES</a:t>
+              <a:t>TIKA-4408 / INTERESTING FINDINGS</a:t>
             </a:r>
             <a:endParaRPr sz="1100">
               <a:solidFill>
@@ -5670,7 +5088,7 @@
           <p:cNvPr id="44" name="Google Shape;44;p9">
             <a:extLst xmlns:a="http://schemas.openxmlformats.org/drawingml/2006/main">
               <a:ext uri="{FF2B5EF4-FFF2-40B4-BE49-F238E27FC236}">
-                <a16:creationId xmlns:a16="http://schemas.microsoft.com/office/drawing/2014/main" id="{980F5A0C-EB58-44AD-BE53-98BAFE1A5342}"/>
+                <a16:creationId xmlns:a16="http://schemas.microsoft.com/office/drawing/2014/main" id="{1A3CE437-A2A1-4D8A-AA49-DB4AE1B4F043}"/>
               </a:ext>
             </a:extLst>
           </p:cNvPr>
@@ -5734,7 +5152,7 @@
           <p:cNvPr id="45" name="Google Shape;45;p9">
             <a:extLst xmlns:a="http://schemas.openxmlformats.org/drawingml/2006/main">
               <a:ext uri="{FF2B5EF4-FFF2-40B4-BE49-F238E27FC236}">
-                <a16:creationId xmlns:a16="http://schemas.microsoft.com/office/drawing/2014/main" id="{33D82BA1-51F6-46A3-A292-B6322244794D}"/>
+                <a16:creationId xmlns:a16="http://schemas.microsoft.com/office/drawing/2014/main" id="{9DC29648-34FB-415B-8E40-E1BDE594499A}"/>
               </a:ext>
             </a:extLst>
           </p:cNvPr>
@@ -5814,7 +5232,7 @@
                 <a:ea typeface="Manrope"/>
                 <a:cs typeface="Manrope"/>
               </a:rPr>
-              <a:t>Challenge 1: finding the real cause</a:t>
+              <a:t>What we found interesting</a:t>
             </a:r>
             <a:endParaRPr sz="3500" b="1">
               <a:solidFill>
@@ -5832,7 +5250,7 @@
           <p:cNvPr id="46" name="Google Shape;46;p9">
             <a:extLst xmlns:a="http://schemas.openxmlformats.org/drawingml/2006/main">
               <a:ext uri="{FF2B5EF4-FFF2-40B4-BE49-F238E27FC236}">
-                <a16:creationId xmlns:a16="http://schemas.microsoft.com/office/drawing/2014/main" id="{35D0A4BF-CD5A-4522-B7C2-CCF382DD9AEF}"/>
+                <a16:creationId xmlns:a16="http://schemas.microsoft.com/office/drawing/2014/main" id="{9FD4A54D-A6FC-466C-9CDB-114E602B9070}"/>
               </a:ext>
             </a:extLst>
           </p:cNvPr>
@@ -5896,7 +5314,7 @@
           <p:cNvPr id="47" name="Google Shape;47;p9">
             <a:extLst xmlns:a="http://schemas.openxmlformats.org/drawingml/2006/main">
               <a:ext uri="{FF2B5EF4-FFF2-40B4-BE49-F238E27FC236}">
-                <a16:creationId xmlns:a16="http://schemas.microsoft.com/office/drawing/2014/main" id="{9CA6DB4B-926F-4A17-9A79-E05731261294}"/>
+                <a16:creationId xmlns:a16="http://schemas.microsoft.com/office/drawing/2014/main" id="{51995341-984C-46A1-B966-275F91866545}"/>
               </a:ext>
             </a:extLst>
           </p:cNvPr>
@@ -5974,7 +5392,7 @@
                 <a:ea typeface="Manrope"/>
                 <a:cs typeface="Manrope"/>
               </a:rPr>
-              <a:t>OLD RULE: WRONG POSITION</a:t>
+              <a:t>CONTENT ONLY</a:t>
             </a:r>
             <a:endParaRPr sz="1200" b="1">
               <a:solidFill>
@@ -5992,7 +5410,7 @@
           <p:cNvPr id="48" name="Google Shape;48;p9">
             <a:extLst xmlns:a="http://schemas.openxmlformats.org/drawingml/2006/main">
               <a:ext uri="{FF2B5EF4-FFF2-40B4-BE49-F238E27FC236}">
-                <a16:creationId xmlns:a16="http://schemas.microsoft.com/office/drawing/2014/main" id="{1F616BD8-03FF-4592-AFB6-3DAFFA80CB77}"/>
+                <a16:creationId xmlns:a16="http://schemas.microsoft.com/office/drawing/2014/main" id="{85295178-22D5-4A0F-B14E-24B4F193A8EF}"/>
               </a:ext>
             </a:extLst>
           </p:cNvPr>
@@ -6070,7 +5488,7 @@
                 <a:ea typeface="Manrope"/>
                 <a:cs typeface="Manrope"/>
               </a:rPr>
-              <a:t>FIXED RULES: OFFSET 0</a:t>
+              <a:t>WITH script.py</a:t>
             </a:r>
             <a:endParaRPr sz="1200" b="1">
               <a:solidFill>
@@ -6088,7 +5506,7 @@
           <p:cNvPr id="49" name="Google Shape;49;p9">
             <a:extLst xmlns:a="http://schemas.openxmlformats.org/drawingml/2006/main">
               <a:ext uri="{FF2B5EF4-FFF2-40B4-BE49-F238E27FC236}">
-                <a16:creationId xmlns:a16="http://schemas.microsoft.com/office/drawing/2014/main" id="{18971D54-D8AE-49CB-9CEC-FA517F7E60AA}"/>
+                <a16:creationId xmlns:a16="http://schemas.microsoft.com/office/drawing/2014/main" id="{B2BFEBAC-4480-4460-99E5-AEA74FA4524C}"/>
               </a:ext>
             </a:extLst>
           </p:cNvPr>
@@ -6243,7 +5661,7 @@
                 <a:ea typeface="Roboto Mono"/>
                 <a:cs typeface="Roboto Mono"/>
               </a:rPr>
-              <a:t>#!/usr</a:t>
+              <a:t>#! /usr/bin/env </a:t>
             </a:r>
             <a:r>
               <a:rPr sz="4200">
@@ -6254,18 +5672,7 @@
                 <a:ea typeface="Roboto Mono"/>
                 <a:cs typeface="Roboto Mono"/>
               </a:rPr>
-              <a:t>/bin/env python</a:t>
-            </a:r>
-            <a:r>
-              <a:rPr sz="4200">
-                <a:solidFill>
-                  <a:srgbClr val="F0E8D9"/>
-                </a:solidFill>
-                <a:latin typeface="Roboto Mono"/>
-                <a:ea typeface="Roboto Mono"/>
-                <a:cs typeface="Roboto Mono"/>
-              </a:rPr>
-              <a:t>3</a:t>
+              <a:t>python3</a:t>
             </a:r>
             <a:endParaRPr sz="4800">
               <a:solidFill>
@@ -6283,7 +5690,7 @@
           <p:cNvPr id="50" name="Google Shape;50;p9">
             <a:extLst xmlns:a="http://schemas.openxmlformats.org/drawingml/2006/main">
               <a:ext uri="{FF2B5EF4-FFF2-40B4-BE49-F238E27FC236}">
-                <a16:creationId xmlns:a16="http://schemas.microsoft.com/office/drawing/2014/main" id="{11EF46E8-D964-43AC-9470-80C28F10DA9E}"/>
+                <a16:creationId xmlns:a16="http://schemas.microsoft.com/office/drawing/2014/main" id="{D24BBACE-E19E-4394-B7EB-A866A450D6A5}"/>
               </a:ext>
             </a:extLst>
           </p:cNvPr>
@@ -6311,73 +5718,73 @@
           </a:bodyPr>
           <a:lstStyle xmlns:a="http://schemas.openxmlformats.org/drawingml/2006/main">
             <a:defPPr>
-              <a:defRPr sz="1950">
-                <a:latin typeface="Roboto Mono"/>
-                <a:ea typeface="Roboto Mono"/>
-                <a:cs typeface="Roboto Mono"/>
+              <a:defRPr sz="2000">
+                <a:latin typeface="Manrope"/>
+                <a:ea typeface="Manrope"/>
+                <a:cs typeface="Manrope"/>
               </a:defRPr>
             </a:defPPr>
             <a:lvl1pPr>
-              <a:defRPr sz="1950">
-                <a:latin typeface="Roboto Mono"/>
-                <a:ea typeface="Roboto Mono"/>
-                <a:cs typeface="Roboto Mono"/>
+              <a:defRPr sz="2000">
+                <a:latin typeface="Manrope"/>
+                <a:ea typeface="Manrope"/>
+                <a:cs typeface="Manrope"/>
               </a:defRPr>
             </a:lvl1pPr>
             <a:lvl2pPr>
-              <a:defRPr sz="1950">
-                <a:latin typeface="Roboto Mono"/>
-                <a:ea typeface="Roboto Mono"/>
-                <a:cs typeface="Roboto Mono"/>
+              <a:defRPr sz="2000">
+                <a:latin typeface="Manrope"/>
+                <a:ea typeface="Manrope"/>
+                <a:cs typeface="Manrope"/>
               </a:defRPr>
             </a:lvl2pPr>
             <a:lvl3pPr>
-              <a:defRPr sz="1950">
-                <a:latin typeface="Roboto Mono"/>
-                <a:ea typeface="Roboto Mono"/>
-                <a:cs typeface="Roboto Mono"/>
+              <a:defRPr sz="2000">
+                <a:latin typeface="Manrope"/>
+                <a:ea typeface="Manrope"/>
+                <a:cs typeface="Manrope"/>
               </a:defRPr>
             </a:lvl3pPr>
             <a:lvl4pPr>
-              <a:defRPr sz="1950">
-                <a:latin typeface="Roboto Mono"/>
-                <a:ea typeface="Roboto Mono"/>
-                <a:cs typeface="Roboto Mono"/>
+              <a:defRPr sz="2000">
+                <a:latin typeface="Manrope"/>
+                <a:ea typeface="Manrope"/>
+                <a:cs typeface="Manrope"/>
               </a:defRPr>
             </a:lvl4pPr>
             <a:lvl5pPr>
-              <a:defRPr sz="1950">
-                <a:latin typeface="Roboto Mono"/>
-                <a:ea typeface="Roboto Mono"/>
-                <a:cs typeface="Roboto Mono"/>
+              <a:defRPr sz="2000">
+                <a:latin typeface="Manrope"/>
+                <a:ea typeface="Manrope"/>
+                <a:cs typeface="Manrope"/>
               </a:defRPr>
             </a:lvl5pPr>
             <a:lvl6pPr>
-              <a:defRPr sz="1950">
-                <a:latin typeface="Roboto Mono"/>
-                <a:ea typeface="Roboto Mono"/>
-                <a:cs typeface="Roboto Mono"/>
+              <a:defRPr sz="2000">
+                <a:latin typeface="Manrope"/>
+                <a:ea typeface="Manrope"/>
+                <a:cs typeface="Manrope"/>
               </a:defRPr>
             </a:lvl6pPr>
             <a:lvl7pPr>
-              <a:defRPr sz="1950">
-                <a:latin typeface="Roboto Mono"/>
-                <a:ea typeface="Roboto Mono"/>
-                <a:cs typeface="Roboto Mono"/>
+              <a:defRPr sz="2000">
+                <a:latin typeface="Manrope"/>
+                <a:ea typeface="Manrope"/>
+                <a:cs typeface="Manrope"/>
               </a:defRPr>
             </a:lvl7pPr>
             <a:lvl8pPr>
-              <a:defRPr sz="1950">
-                <a:latin typeface="Roboto Mono"/>
-                <a:ea typeface="Roboto Mono"/>
-                <a:cs typeface="Roboto Mono"/>
+              <a:defRPr sz="2000">
+                <a:latin typeface="Manrope"/>
+                <a:ea typeface="Manrope"/>
+                <a:cs typeface="Manrope"/>
               </a:defRPr>
             </a:lvl8pPr>
             <a:lvl9pPr>
-              <a:defRPr sz="1950">
-                <a:latin typeface="Roboto Mono"/>
-                <a:ea typeface="Roboto Mono"/>
-                <a:cs typeface="Roboto Mono"/>
+              <a:defRPr sz="2000">
+                <a:latin typeface="Manrope"/>
+                <a:ea typeface="Manrope"/>
+                <a:cs typeface="Manrope"/>
               </a:defRPr>
             </a:lvl9pPr>
           </a:lstStyle>
@@ -6390,57 +5797,22 @@
                 <a:spcPts val="0"/>
               </a:spcAft>
               <a:buNone/>
-              <a:defRPr sz="1950">
-                <a:latin typeface="Roboto Mono"/>
-                <a:ea typeface="Roboto Mono"/>
-                <a:cs typeface="Roboto Mono"/>
+              <a:defRPr sz="2000">
+                <a:latin typeface="Manrope"/>
+                <a:ea typeface="Manrope"/>
+                <a:cs typeface="Manrope"/>
               </a:defRPr>
             </a:pPr>
             <a:r>
-              <a:rPr sz="1950">
+              <a:rPr sz="2000">
                 <a:solidFill>
                   <a:srgbClr val="203B34"/>
                 </a:solidFill>
-                <a:latin typeface="Roboto Mono"/>
-                <a:ea typeface="Roboto Mono"/>
-                <a:cs typeface="Roboto Mono"/>
+                <a:latin typeface="Manrope"/>
+                <a:ea typeface="Manrope"/>
+                <a:cs typeface="Manrope"/>
               </a:rPr>
-              <a:t>/bin/env python</a:t>
-            </a:r>
-            <a:endParaRPr sz="1900">
-              <a:solidFill>
-                <a:srgbClr val="203B34"/>
-              </a:solidFill>
-              <a:latin typeface="Roboto Mono"/>
-              <a:ea typeface="Roboto Mono"/>
-              <a:cs typeface="Roboto Mono"/>
-            </a:endParaRPr>
-          </a:p>
-          <a:p xmlns:a="http://schemas.openxmlformats.org/drawingml/2006/main">
-            <a:pPr marL="0" marR="0" lvl="0" indent="0" algn="l">
-              <a:spcBef>
-                <a:spcPts val="0"/>
-              </a:spcBef>
-              <a:spcAft>
-                <a:spcPts val="0"/>
-              </a:spcAft>
-              <a:buNone/>
-              <a:defRPr sz="1950">
-                <a:latin typeface="Roboto Mono"/>
-                <a:ea typeface="Roboto Mono"/>
-                <a:cs typeface="Roboto Mono"/>
-              </a:defRPr>
-            </a:pPr>
-            <a:r>
-              <a:rPr sz="1950">
-                <a:solidFill>
-                  <a:srgbClr val="203B34"/>
-                </a:solidFill>
-                <a:latin typeface="Roboto Mono"/>
-                <a:ea typeface="Roboto Mono"/>
-                <a:cs typeface="Roboto Mono"/>
-              </a:rPr>
-              <a:t>at offset 1</a:t>
+              <a:t>No filename hint</a:t>
             </a:r>
             <a:endParaRPr sz="1900">
               <a:solidFill>
@@ -6458,7 +5830,7 @@
           <p:cNvPr id="51" name="Google Shape;51;p9">
             <a:extLst xmlns:a="http://schemas.openxmlformats.org/drawingml/2006/main">
               <a:ext uri="{FF2B5EF4-FFF2-40B4-BE49-F238E27FC236}">
-                <a16:creationId xmlns:a16="http://schemas.microsoft.com/office/drawing/2014/main" id="{5D9793FC-D20C-4A75-99E4-D049FB147C61}"/>
+                <a16:creationId xmlns:a16="http://schemas.microsoft.com/office/drawing/2014/main" id="{5D25A672-DEBE-4E8F-BC10-F12A5A6FF8FF}"/>
               </a:ext>
             </a:extLst>
           </p:cNvPr>
@@ -6486,73 +5858,73 @@
           </a:bodyPr>
           <a:lstStyle xmlns:a="http://schemas.openxmlformats.org/drawingml/2006/main">
             <a:defPPr>
-              <a:defRPr sz="1800">
-                <a:latin typeface="Roboto Mono"/>
-                <a:ea typeface="Roboto Mono"/>
-                <a:cs typeface="Roboto Mono"/>
+              <a:defRPr sz="2000">
+                <a:latin typeface="Manrope"/>
+                <a:ea typeface="Manrope"/>
+                <a:cs typeface="Manrope"/>
               </a:defRPr>
             </a:defPPr>
             <a:lvl1pPr>
-              <a:defRPr sz="1800">
-                <a:latin typeface="Roboto Mono"/>
-                <a:ea typeface="Roboto Mono"/>
-                <a:cs typeface="Roboto Mono"/>
+              <a:defRPr sz="2000">
+                <a:latin typeface="Manrope"/>
+                <a:ea typeface="Manrope"/>
+                <a:cs typeface="Manrope"/>
               </a:defRPr>
             </a:lvl1pPr>
             <a:lvl2pPr>
-              <a:defRPr sz="1800">
-                <a:latin typeface="Roboto Mono"/>
-                <a:ea typeface="Roboto Mono"/>
-                <a:cs typeface="Roboto Mono"/>
+              <a:defRPr sz="2000">
+                <a:latin typeface="Manrope"/>
+                <a:ea typeface="Manrope"/>
+                <a:cs typeface="Manrope"/>
               </a:defRPr>
             </a:lvl2pPr>
             <a:lvl3pPr>
-              <a:defRPr sz="1800">
-                <a:latin typeface="Roboto Mono"/>
-                <a:ea typeface="Roboto Mono"/>
-                <a:cs typeface="Roboto Mono"/>
+              <a:defRPr sz="2000">
+                <a:latin typeface="Manrope"/>
+                <a:ea typeface="Manrope"/>
+                <a:cs typeface="Manrope"/>
               </a:defRPr>
             </a:lvl3pPr>
             <a:lvl4pPr>
-              <a:defRPr sz="1800">
-                <a:latin typeface="Roboto Mono"/>
-                <a:ea typeface="Roboto Mono"/>
-                <a:cs typeface="Roboto Mono"/>
+              <a:defRPr sz="2000">
+                <a:latin typeface="Manrope"/>
+                <a:ea typeface="Manrope"/>
+                <a:cs typeface="Manrope"/>
               </a:defRPr>
             </a:lvl4pPr>
             <a:lvl5pPr>
-              <a:defRPr sz="1800">
-                <a:latin typeface="Roboto Mono"/>
-                <a:ea typeface="Roboto Mono"/>
-                <a:cs typeface="Roboto Mono"/>
+              <a:defRPr sz="2000">
+                <a:latin typeface="Manrope"/>
+                <a:ea typeface="Manrope"/>
+                <a:cs typeface="Manrope"/>
               </a:defRPr>
             </a:lvl5pPr>
             <a:lvl6pPr>
-              <a:defRPr sz="1800">
-                <a:latin typeface="Roboto Mono"/>
-                <a:ea typeface="Roboto Mono"/>
-                <a:cs typeface="Roboto Mono"/>
+              <a:defRPr sz="2000">
+                <a:latin typeface="Manrope"/>
+                <a:ea typeface="Manrope"/>
+                <a:cs typeface="Manrope"/>
               </a:defRPr>
             </a:lvl6pPr>
             <a:lvl7pPr>
-              <a:defRPr sz="1800">
-                <a:latin typeface="Roboto Mono"/>
-                <a:ea typeface="Roboto Mono"/>
-                <a:cs typeface="Roboto Mono"/>
+              <a:defRPr sz="2000">
+                <a:latin typeface="Manrope"/>
+                <a:ea typeface="Manrope"/>
+                <a:cs typeface="Manrope"/>
               </a:defRPr>
             </a:lvl7pPr>
             <a:lvl8pPr>
-              <a:defRPr sz="1800">
-                <a:latin typeface="Roboto Mono"/>
-                <a:ea typeface="Roboto Mono"/>
-                <a:cs typeface="Roboto Mono"/>
+              <a:defRPr sz="2000">
+                <a:latin typeface="Manrope"/>
+                <a:ea typeface="Manrope"/>
+                <a:cs typeface="Manrope"/>
               </a:defRPr>
             </a:lvl8pPr>
             <a:lvl9pPr>
-              <a:defRPr sz="1800">
-                <a:latin typeface="Roboto Mono"/>
-                <a:ea typeface="Roboto Mono"/>
-                <a:cs typeface="Roboto Mono"/>
+              <a:defRPr sz="2000">
+                <a:latin typeface="Manrope"/>
+                <a:ea typeface="Manrope"/>
+                <a:cs typeface="Manrope"/>
               </a:defRPr>
             </a:lvl9pPr>
           </a:lstStyle>
@@ -6565,22 +5937,22 @@
                 <a:spcPts val="0"/>
               </a:spcAft>
               <a:buNone/>
-              <a:defRPr sz="1800">
-                <a:latin typeface="Roboto Mono"/>
-                <a:ea typeface="Roboto Mono"/>
-                <a:cs typeface="Roboto Mono"/>
+              <a:defRPr sz="2000">
+                <a:latin typeface="Manrope"/>
+                <a:ea typeface="Manrope"/>
+                <a:cs typeface="Manrope"/>
               </a:defRPr>
             </a:pPr>
             <a:r>
-              <a:rPr sz="1800">
+              <a:rPr sz="2000">
                 <a:solidFill>
                   <a:srgbClr val="203B34"/>
                 </a:solidFill>
-                <a:latin typeface="Roboto Mono"/>
-                <a:ea typeface="Roboto Mono"/>
-                <a:cs typeface="Roboto Mono"/>
+                <a:latin typeface="Manrope"/>
+                <a:ea typeface="Manrope"/>
+                <a:cs typeface="Manrope"/>
               </a:rPr>
-              <a:t>#!/usr/bin/env python</a:t>
+              <a:t>Same file content</a:t>
             </a:r>
             <a:endParaRPr sz="2200">
               <a:solidFill>
@@ -6600,22 +5972,22 @@
                 <a:spcPts val="0"/>
               </a:spcAft>
               <a:buNone/>
-              <a:defRPr sz="1800">
-                <a:latin typeface="Roboto Mono"/>
-                <a:ea typeface="Roboto Mono"/>
-                <a:cs typeface="Roboto Mono"/>
+              <a:defRPr sz="2000">
+                <a:latin typeface="Manrope"/>
+                <a:ea typeface="Manrope"/>
+                <a:cs typeface="Manrope"/>
               </a:defRPr>
             </a:pPr>
             <a:r>
-              <a:rPr sz="1800">
+              <a:rPr sz="2000">
                 <a:solidFill>
                   <a:srgbClr val="203B34"/>
                 </a:solidFill>
-                <a:latin typeface="Roboto Mono"/>
-                <a:ea typeface="Roboto Mono"/>
-                <a:cs typeface="Roboto Mono"/>
+                <a:latin typeface="Manrope"/>
+                <a:ea typeface="Manrope"/>
+                <a:cs typeface="Manrope"/>
               </a:rPr>
-              <a:t>#! /usr/bin/env python</a:t>
+              <a:t>Python filename hint</a:t>
             </a:r>
             <a:endParaRPr sz="2200">
               <a:solidFill>
@@ -6633,7 +6005,7 @@
           <p:cNvPr id="52" name="Google Shape;52;p9">
             <a:extLst xmlns:a="http://schemas.openxmlformats.org/drawingml/2006/main">
               <a:ext uri="{FF2B5EF4-FFF2-40B4-BE49-F238E27FC236}">
-                <a16:creationId xmlns:a16="http://schemas.microsoft.com/office/drawing/2014/main" id="{144C3DDD-C040-4974-89DF-3E832254EF11}"/>
+                <a16:creationId xmlns:a16="http://schemas.microsoft.com/office/drawing/2014/main" id="{FF171CFB-AAE2-4E29-B37D-5172638ADFDC}"/>
               </a:ext>
             </a:extLst>
           </p:cNvPr>
@@ -6773,7 +6145,7 @@
           <p:cNvPr id="53" name="Google Shape;53;p9">
             <a:extLst xmlns:a="http://schemas.openxmlformats.org/drawingml/2006/main">
               <a:ext uri="{FF2B5EF4-FFF2-40B4-BE49-F238E27FC236}">
-                <a16:creationId xmlns:a16="http://schemas.microsoft.com/office/drawing/2014/main" id="{891A0147-F0A1-4ABB-A43C-E67884E61197}"/>
+                <a16:creationId xmlns:a16="http://schemas.microsoft.com/office/drawing/2014/main" id="{4EF74D33-A52C-42E8-8242-39F71ED6BCA8}"/>
               </a:ext>
             </a:extLst>
           </p:cNvPr>
@@ -6895,7 +6267,7 @@
                 <a:ea typeface="Roboto Mono"/>
                 <a:cs typeface="Roboto Mono"/>
               </a:rPr>
-              <a:t>application/x-sh</a:t>
+              <a:t>text/plain</a:t>
             </a:r>
             <a:endParaRPr sz="2600" b="1">
               <a:solidFill>
@@ -6913,7 +6285,7 @@
           <p:cNvPr id="54" name="Google Shape;54;p9">
             <a:extLst xmlns:a="http://schemas.openxmlformats.org/drawingml/2006/main">
               <a:ext uri="{FF2B5EF4-FFF2-40B4-BE49-F238E27FC236}">
-                <a16:creationId xmlns:a16="http://schemas.microsoft.com/office/drawing/2014/main" id="{2C6D2F51-FA40-42D0-B0E3-CE24DABECCF3}"/>
+                <a16:creationId xmlns:a16="http://schemas.microsoft.com/office/drawing/2014/main" id="{1375C8F7-C844-4E20-A10F-9D54B3CF8B1C}"/>
               </a:ext>
             </a:extLst>
           </p:cNvPr>
@@ -7068,7 +6440,7 @@
                 <a:ea typeface="Manrope"/>
                 <a:cs typeface="Manrope"/>
               </a:rPr>
-              <a:t>The substring starts at offset 6. The old rule checked offset 1.</a:t>
+              <a:t>A filename can hide a missing content rule.</a:t>
             </a:r>
             <a:endParaRPr sz="1250">
               <a:solidFill>
@@ -7083,10 +6455,10 @@
       </p:sp>
       <p:sp>
         <p:nvSpPr>
-          <p:cNvPr id="55" name="cause-takeaway">
+          <p:cNvPr id="55" name="finding-context">
             <a:extLst xmlns:a="http://schemas.openxmlformats.org/drawingml/2006/main">
               <a:ext uri="{FF2B5EF4-FFF2-40B4-BE49-F238E27FC236}">
-                <a16:creationId xmlns:a16="http://schemas.microsoft.com/office/drawing/2014/main" id="{FA78872B-AEED-4137-9964-050E960AE9CD}"/>
+                <a16:creationId xmlns:a16="http://schemas.microsoft.com/office/drawing/2014/main" id="{57721E43-BE52-4A39-8831-FAAFCF30EEB4}"/>
               </a:ext>
             </a:extLst>
           </p:cNvPr>
@@ -7234,7 +6606,7 @@
                 <a:ea typeface="Manrope"/>
                 <a:cs typeface="Manrope"/>
               </a:rPr>
-              <a:t>Two literal prefixes follow the existing direct-path Python rules.</a:t>
+              <a:t>Without the single-space rule. After the fix, both return text/x-python.</a:t>
             </a:r>
           </a:p>
         </p:txBody>
@@ -7242,7 +6614,7 @@
     </p:spTree>
     <p:extLst>
       <p:ext uri="{BB962C8B-B14F-4D97-AF65-F5344CB8AC3E}">
-        <p14:creationId xmlns:p14="http://schemas.microsoft.com/office/powerpoint/2010/main" val="1007464614"/>
+        <p14:creationId xmlns:p14="http://schemas.microsoft.com/office/powerpoint/2010/main" val="1395047100"/>
       </p:ext>
     </p:extLst>
   </p:cSld>
@@ -7255,7 +6627,7 @@
     <p:bg>
       <p:bgPr>
         <a:solidFill xmlns:a="http://schemas.openxmlformats.org/drawingml/2006/main">
-          <a:srgbClr val="203B34"/>
+          <a:srgbClr val="F0E8D9"/>
         </a:solidFill>
       </p:bgPr>
     </p:bg>
@@ -7270,10 +6642,10 @@
       </p:grpSpPr>
       <p:sp>
         <p:nvSpPr>
-          <p:cNvPr id="77" name="Google Shape;77;p11">
+          <p:cNvPr id="60" name="Google Shape;60;p10">
             <a:extLst xmlns:a="http://schemas.openxmlformats.org/drawingml/2006/main">
               <a:ext uri="{FF2B5EF4-FFF2-40B4-BE49-F238E27FC236}">
-                <a16:creationId xmlns:a16="http://schemas.microsoft.com/office/drawing/2014/main" id="{24AFC286-C4DC-47DE-AAD2-5651998C7310}"/>
+                <a16:creationId xmlns:a16="http://schemas.microsoft.com/office/drawing/2014/main" id="{AD55B1AB-7C03-4D60-8781-EB2C0939935D}"/>
               </a:ext>
             </a:extLst>
           </p:cNvPr>
@@ -7313,17 +6685,17 @@
             <a:r>
               <a:rPr sz="1050" b="1">
                 <a:solidFill>
-                  <a:srgbClr val="F0E8D9"/>
+                  <a:srgbClr val="203B34"/>
                 </a:solidFill>
                 <a:latin typeface="Manrope"/>
                 <a:ea typeface="Manrope"/>
                 <a:cs typeface="Manrope"/>
               </a:rPr>
-              <a:t>TIKA-4408 / DEVELOPMENT CHALLENGES</a:t>
+              <a:t>TIKA-4408 / LESSONS</a:t>
             </a:r>
             <a:endParaRPr sz="1050" b="1">
               <a:solidFill>
-                <a:srgbClr val="F0E8D9"/>
+                <a:srgbClr val="203B34"/>
               </a:solidFill>
               <a:latin typeface="Manrope"/>
               <a:ea typeface="Manrope"/>
@@ -7334,10 +6706,10 @@
       </p:sp>
       <p:sp>
         <p:nvSpPr>
-          <p:cNvPr id="78" name="Google Shape;78;p11">
+          <p:cNvPr id="61" name="Google Shape;61;p10">
             <a:extLst xmlns:a="http://schemas.openxmlformats.org/drawingml/2006/main">
               <a:ext uri="{FF2B5EF4-FFF2-40B4-BE49-F238E27FC236}">
-                <a16:creationId xmlns:a16="http://schemas.microsoft.com/office/drawing/2014/main" id="{6E0C3C9E-1533-4FA0-BE79-7C2175E47497}"/>
+                <a16:creationId xmlns:a16="http://schemas.microsoft.com/office/drawing/2014/main" id="{C44F7266-6945-40AC-A711-E69195589FF4}"/>
               </a:ext>
             </a:extLst>
           </p:cNvPr>
@@ -7377,7 +6749,7 @@
             <a:r>
               <a:rPr sz="1000">
                 <a:solidFill>
-                  <a:srgbClr val="B8C7AB"/>
+                  <a:srgbClr val="52665B"/>
                 </a:solidFill>
                 <a:latin typeface="Manrope"/>
                 <a:ea typeface="Manrope"/>
@@ -7387,7 +6759,7 @@
             </a:r>
             <a:endParaRPr sz="1000">
               <a:solidFill>
-                <a:srgbClr val="B8C7AB"/>
+                <a:srgbClr val="52665B"/>
               </a:solidFill>
               <a:latin typeface="Manrope"/>
               <a:ea typeface="Manrope"/>
@@ -7398,10 +6770,10 @@
       </p:sp>
       <p:sp>
         <p:nvSpPr>
-          <p:cNvPr id="79" name="Google Shape;79;p11">
+          <p:cNvPr id="62" name="Google Shape;62;p10">
             <a:extLst xmlns:a="http://schemas.openxmlformats.org/drawingml/2006/main">
               <a:ext uri="{FF2B5EF4-FFF2-40B4-BE49-F238E27FC236}">
-                <a16:creationId xmlns:a16="http://schemas.microsoft.com/office/drawing/2014/main" id="{AE5251DE-3515-4D3C-885D-2D92AD1010EB}"/>
+                <a16:creationId xmlns:a16="http://schemas.microsoft.com/office/drawing/2014/main" id="{FA53D6EA-8696-4C3C-989B-C288B8E42B6E}"/>
               </a:ext>
             </a:extLst>
           </p:cNvPr>
@@ -7475,17 +6847,17 @@
             <a:r>
               <a:rPr sz="3300" b="1">
                 <a:solidFill>
-                  <a:srgbClr val="F0E8D9"/>
+                  <a:srgbClr val="203B34"/>
                 </a:solidFill>
                 <a:latin typeface="Manrope"/>
                 <a:ea typeface="Manrope"/>
                 <a:cs typeface="Manrope"/>
               </a:rPr>
-              <a:t>Challenge 2: proving the fix</a:t>
+              <a:t>What we learnt</a:t>
             </a:r>
             <a:endParaRPr sz="3200" b="1">
               <a:solidFill>
-                <a:srgbClr val="F0E8D9"/>
+                <a:srgbClr val="203B34"/>
               </a:solidFill>
               <a:latin typeface="Manrope"/>
               <a:ea typeface="Manrope"/>
@@ -7496,10 +6868,10 @@
       </p:sp>
       <p:sp>
         <p:nvSpPr>
-          <p:cNvPr id="80" name="Google Shape;80;p11">
+          <p:cNvPr id="63" name="Google Shape;63;p10">
             <a:extLst xmlns:a="http://schemas.openxmlformats.org/drawingml/2006/main">
               <a:ext uri="{FF2B5EF4-FFF2-40B4-BE49-F238E27FC236}">
-                <a16:creationId xmlns:a16="http://schemas.microsoft.com/office/drawing/2014/main" id="{F7EE6444-BEAA-418D-9914-0CD76A877499}"/>
+                <a16:creationId xmlns:a16="http://schemas.microsoft.com/office/drawing/2014/main" id="{318B66DD-5B83-4F05-9D93-8F0A2C5231E9}"/>
               </a:ext>
             </a:extLst>
           </p:cNvPr>
@@ -7539,2973 +6911,6 @@
             <a:r>
               <a:rPr sz="1000">
                 <a:solidFill>
-                  <a:srgbClr val="B8C7AB"/>
-                </a:solidFill>
-                <a:latin typeface="Manrope"/>
-                <a:ea typeface="Manrope"/>
-                <a:cs typeface="Manrope"/>
-              </a:rPr>
-              <a:t>Jiajun Li / TIKA-4408</a:t>
-            </a:r>
-            <a:endParaRPr sz="1000">
-              <a:solidFill>
-                <a:srgbClr val="B8C7AB"/>
-              </a:solidFill>
-              <a:latin typeface="Manrope"/>
-              <a:ea typeface="Manrope"/>
-              <a:cs typeface="Manrope"/>
-            </a:endParaRPr>
-          </a:p>
-        </p:txBody>
-      </p:sp>
-      <p:sp>
-        <p:nvSpPr>
-          <p:cNvPr id="81" name="Google Shape;81;p11">
-            <a:extLst xmlns:a="http://schemas.openxmlformats.org/drawingml/2006/main">
-              <a:ext uri="{FF2B5EF4-FFF2-40B4-BE49-F238E27FC236}">
-                <a16:creationId xmlns:a16="http://schemas.microsoft.com/office/drawing/2014/main" id="{8A9EA259-6FB4-4B8A-B14F-766042BF42B5}"/>
-              </a:ext>
-            </a:extLst>
-          </p:cNvPr>
-          <p:cNvSpPr>
-            <a:spLocks xmlns:a="http://schemas.openxmlformats.org/drawingml/2006/main" noGrp="1"/>
-          </p:cNvSpPr>
-          <p:nvPr/>
-        </p:nvSpPr>
-        <p:spPr>
-          <a:xfrm xmlns:a="http://schemas.openxmlformats.org/drawingml/2006/main">
-            <a:off x="609600" y="2032000"/>
-            <a:ext cx="736500" cy="609600"/>
-          </a:xfrm>
-          <a:prstGeom xmlns:a="http://schemas.openxmlformats.org/drawingml/2006/main" prst="rect">
-            <a:avLst/>
-          </a:prstGeom>
-          <a:noFill xmlns:a="http://schemas.openxmlformats.org/drawingml/2006/main"/>
-          <a:ln xmlns:a="http://schemas.openxmlformats.org/drawingml/2006/main">
-            <a:noFill/>
-          </a:ln>
-        </p:spPr>
-        <p:txBody>
-          <a:bodyPr xmlns:a="http://schemas.openxmlformats.org/drawingml/2006/main" spcFirstLastPara="1" wrap="square" lIns="0" tIns="0" rIns="0" bIns="0" anchor="t">
-            <a:noAutofit/>
-          </a:bodyPr>
-          <a:lstStyle xmlns:a="http://schemas.openxmlformats.org/drawingml/2006/main"/>
-          <a:p xmlns:a="http://schemas.openxmlformats.org/drawingml/2006/main">
-            <a:pPr marL="0" marR="0" lvl="0" indent="0" algn="l">
-              <a:spcBef>
-                <a:spcPts val="0"/>
-              </a:spcBef>
-              <a:spcAft>
-                <a:spcPts val="0"/>
-              </a:spcAft>
-              <a:buNone/>
-            </a:pPr>
-            <a:r>
-              <a:rPr sz="3000" b="1">
-                <a:solidFill>
-                  <a:srgbClr val="F0E8D9"/>
-                </a:solidFill>
-                <a:latin typeface="Roboto Mono"/>
-                <a:ea typeface="Roboto Mono"/>
-                <a:cs typeface="Roboto Mono"/>
-              </a:rPr>
-              <a:t>01</a:t>
-            </a:r>
-            <a:endParaRPr sz="3000" b="1">
-              <a:solidFill>
-                <a:srgbClr val="F0E8D9"/>
-              </a:solidFill>
-              <a:latin typeface="Roboto Mono"/>
-              <a:ea typeface="Roboto Mono"/>
-              <a:cs typeface="Roboto Mono"/>
-            </a:endParaRPr>
-          </a:p>
-        </p:txBody>
-      </p:sp>
-      <p:sp>
-        <p:nvSpPr>
-          <p:cNvPr id="82" name="Google Shape;82;p11">
-            <a:extLst xmlns:a="http://schemas.openxmlformats.org/drawingml/2006/main">
-              <a:ext uri="{FF2B5EF4-FFF2-40B4-BE49-F238E27FC236}">
-                <a16:creationId xmlns:a16="http://schemas.microsoft.com/office/drawing/2014/main" id="{6D9D3FDD-C93C-4509-8783-D4D0DEB32FFD}"/>
-              </a:ext>
-            </a:extLst>
-          </p:cNvPr>
-          <p:cNvSpPr>
-            <a:spLocks xmlns:a="http://schemas.openxmlformats.org/drawingml/2006/main" noGrp="1"/>
-          </p:cNvSpPr>
-          <p:nvPr/>
-        </p:nvSpPr>
-        <p:spPr>
-          <a:xfrm xmlns:a="http://schemas.openxmlformats.org/drawingml/2006/main">
-            <a:off x="1587500" y="2032000"/>
-            <a:ext cx="9994800" cy="533400"/>
-          </a:xfrm>
-          <a:prstGeom xmlns:a="http://schemas.openxmlformats.org/drawingml/2006/main" prst="rect">
-            <a:avLst/>
-          </a:prstGeom>
-          <a:noFill xmlns:a="http://schemas.openxmlformats.org/drawingml/2006/main"/>
-          <a:ln xmlns:a="http://schemas.openxmlformats.org/drawingml/2006/main">
-            <a:noFill/>
-          </a:ln>
-        </p:spPr>
-        <p:txBody>
-          <a:bodyPr xmlns:a="http://schemas.openxmlformats.org/drawingml/2006/main" spcFirstLastPara="1" wrap="square" lIns="0" tIns="0" rIns="0" bIns="0" anchor="t">
-            <a:noAutofit/>
-          </a:bodyPr>
-          <a:lstStyle xmlns:a="http://schemas.openxmlformats.org/drawingml/2006/main"/>
-          <a:p xmlns:a="http://schemas.openxmlformats.org/drawingml/2006/main">
-            <a:pPr marL="0" marR="0" lvl="0" indent="0" algn="l">
-              <a:spcBef>
-                <a:spcPts val="0"/>
-              </a:spcBef>
-              <a:spcAft>
-                <a:spcPts val="0"/>
-              </a:spcAft>
-              <a:buNone/>
-            </a:pPr>
-            <a:r>
-              <a:rPr sz="2400" b="1">
-                <a:solidFill>
-                  <a:srgbClr val="F0E8D9"/>
-                </a:solidFill>
-                <a:latin typeface="Manrope"/>
-                <a:ea typeface="Manrope"/>
-                <a:cs typeface="Manrope"/>
-              </a:rPr>
-              <a:t>Separate content from filename hints</a:t>
-            </a:r>
-            <a:endParaRPr sz="2400" b="1">
-              <a:solidFill>
-                <a:srgbClr val="F0E8D9"/>
-              </a:solidFill>
-              <a:latin typeface="Manrope"/>
-              <a:ea typeface="Manrope"/>
-              <a:cs typeface="Manrope"/>
-            </a:endParaRPr>
-          </a:p>
-        </p:txBody>
-      </p:sp>
-      <p:sp>
-        <p:nvSpPr>
-          <p:cNvPr id="83" name="Google Shape;83;p11">
-            <a:extLst xmlns:a="http://schemas.openxmlformats.org/drawingml/2006/main">
-              <a:ext uri="{FF2B5EF4-FFF2-40B4-BE49-F238E27FC236}">
-                <a16:creationId xmlns:a16="http://schemas.microsoft.com/office/drawing/2014/main" id="{417B289C-C86E-4B89-9968-96E5AB32B66B}"/>
-              </a:ext>
-            </a:extLst>
-          </p:cNvPr>
-          <p:cNvSpPr>
-            <a:spLocks xmlns:a="http://schemas.openxmlformats.org/drawingml/2006/main" noGrp="1"/>
-          </p:cNvSpPr>
-          <p:nvPr/>
-        </p:nvSpPr>
-        <p:spPr>
-          <a:xfrm xmlns:a="http://schemas.openxmlformats.org/drawingml/2006/main">
-            <a:off x="1587500" y="2590800"/>
-            <a:ext cx="9994800" cy="762000"/>
-          </a:xfrm>
-          <a:prstGeom xmlns:a="http://schemas.openxmlformats.org/drawingml/2006/main" prst="rect">
-            <a:avLst/>
-          </a:prstGeom>
-          <a:noFill xmlns:a="http://schemas.openxmlformats.org/drawingml/2006/main"/>
-          <a:ln xmlns:a="http://schemas.openxmlformats.org/drawingml/2006/main">
-            <a:noFill/>
-          </a:ln>
-        </p:spPr>
-        <p:txBody>
-          <a:bodyPr xmlns:a="http://schemas.openxmlformats.org/drawingml/2006/main" spcFirstLastPara="1" wrap="square" lIns="0" tIns="0" rIns="0" bIns="0" anchor="t">
-            <a:noAutofit/>
-          </a:bodyPr>
-          <a:lstStyle xmlns:a="http://schemas.openxmlformats.org/drawingml/2006/main">
-            <a:defPPr>
-              <a:defRPr sz="2000">
-                <a:latin typeface="Manrope"/>
-                <a:ea typeface="Manrope"/>
-                <a:cs typeface="Manrope"/>
-              </a:defRPr>
-            </a:defPPr>
-            <a:lvl1pPr>
-              <a:defRPr sz="2000">
-                <a:latin typeface="Manrope"/>
-                <a:ea typeface="Manrope"/>
-                <a:cs typeface="Manrope"/>
-              </a:defRPr>
-            </a:lvl1pPr>
-            <a:lvl2pPr>
-              <a:defRPr sz="2000">
-                <a:latin typeface="Manrope"/>
-                <a:ea typeface="Manrope"/>
-                <a:cs typeface="Manrope"/>
-              </a:defRPr>
-            </a:lvl2pPr>
-            <a:lvl3pPr>
-              <a:defRPr sz="2000">
-                <a:latin typeface="Manrope"/>
-                <a:ea typeface="Manrope"/>
-                <a:cs typeface="Manrope"/>
-              </a:defRPr>
-            </a:lvl3pPr>
-            <a:lvl4pPr>
-              <a:defRPr sz="2000">
-                <a:latin typeface="Manrope"/>
-                <a:ea typeface="Manrope"/>
-                <a:cs typeface="Manrope"/>
-              </a:defRPr>
-            </a:lvl4pPr>
-            <a:lvl5pPr>
-              <a:defRPr sz="2000">
-                <a:latin typeface="Manrope"/>
-                <a:ea typeface="Manrope"/>
-                <a:cs typeface="Manrope"/>
-              </a:defRPr>
-            </a:lvl5pPr>
-            <a:lvl6pPr>
-              <a:defRPr sz="2000">
-                <a:latin typeface="Manrope"/>
-                <a:ea typeface="Manrope"/>
-                <a:cs typeface="Manrope"/>
-              </a:defRPr>
-            </a:lvl6pPr>
-            <a:lvl7pPr>
-              <a:defRPr sz="2000">
-                <a:latin typeface="Manrope"/>
-                <a:ea typeface="Manrope"/>
-                <a:cs typeface="Manrope"/>
-              </a:defRPr>
-            </a:lvl7pPr>
-            <a:lvl8pPr>
-              <a:defRPr sz="2000">
-                <a:latin typeface="Manrope"/>
-                <a:ea typeface="Manrope"/>
-                <a:cs typeface="Manrope"/>
-              </a:defRPr>
-            </a:lvl8pPr>
-            <a:lvl9pPr>
-              <a:defRPr sz="2000">
-                <a:latin typeface="Manrope"/>
-                <a:ea typeface="Manrope"/>
-                <a:cs typeface="Manrope"/>
-              </a:defRPr>
-            </a:lvl9pPr>
-          </a:lstStyle>
-          <a:p xmlns:a="http://schemas.openxmlformats.org/drawingml/2006/main">
-            <a:pPr marL="0" marR="0" lvl="0" indent="0" algn="l">
-              <a:spcBef>
-                <a:spcPts val="0"/>
-              </a:spcBef>
-              <a:spcAft>
-                <a:spcPts val="0"/>
-              </a:spcAft>
-              <a:buNone/>
-              <a:defRPr sz="2000">
-                <a:latin typeface="Manrope"/>
-                <a:ea typeface="Manrope"/>
-                <a:cs typeface="Manrope"/>
-              </a:defRPr>
-            </a:pPr>
-            <a:r>
-              <a:rPr sz="2000">
-                <a:solidFill>
-                  <a:srgbClr val="B8C7AB"/>
-                </a:solidFill>
-                <a:latin typeface="Manrope"/>
-                <a:ea typeface="Manrope"/>
-                <a:cs typeface="Manrope"/>
-              </a:rPr>
-              <a:t>Test each input without a filename, then with script.py.</a:t>
-            </a:r>
-            <a:endParaRPr sz="1900">
-              <a:solidFill>
-                <a:srgbClr val="B8C7AB"/>
-              </a:solidFill>
-              <a:latin typeface="Manrope"/>
-              <a:ea typeface="Manrope"/>
-              <a:cs typeface="Manrope"/>
-            </a:endParaRPr>
-          </a:p>
-          <a:p xmlns:a="http://schemas.openxmlformats.org/drawingml/2006/main">
-            <a:pPr marL="0" marR="0" lvl="0" indent="0" algn="l">
-              <a:spcBef>
-                <a:spcPts val="0"/>
-              </a:spcBef>
-              <a:spcAft>
-                <a:spcPts val="0"/>
-              </a:spcAft>
-              <a:buNone/>
-              <a:defRPr sz="2000">
-                <a:latin typeface="Manrope"/>
-                <a:ea typeface="Manrope"/>
-                <a:cs typeface="Manrope"/>
-              </a:defRPr>
-            </a:pPr>
-            <a:r>
-              <a:rPr sz="2000">
-                <a:solidFill>
-                  <a:srgbClr val="B8C7AB"/>
-                </a:solidFill>
-                <a:latin typeface="Manrope"/>
-                <a:ea typeface="Manrope"/>
-                <a:cs typeface="Manrope"/>
-              </a:rPr>
-              <a:t>This checks the content rule and the effect of metadata.</a:t>
-            </a:r>
-            <a:endParaRPr sz="1900">
-              <a:solidFill>
-                <a:srgbClr val="B8C7AB"/>
-              </a:solidFill>
-              <a:latin typeface="Manrope"/>
-              <a:ea typeface="Manrope"/>
-              <a:cs typeface="Manrope"/>
-            </a:endParaRPr>
-          </a:p>
-        </p:txBody>
-      </p:sp>
-      <p:sp>
-        <p:nvSpPr>
-          <p:cNvPr id="84" name="Google Shape;84;p11">
-            <a:extLst xmlns:a="http://schemas.openxmlformats.org/drawingml/2006/main">
-              <a:ext uri="{FF2B5EF4-FFF2-40B4-BE49-F238E27FC236}">
-                <a16:creationId xmlns:a16="http://schemas.microsoft.com/office/drawing/2014/main" id="{79F93235-188B-4766-BE29-7A079D7F67FC}"/>
-              </a:ext>
-            </a:extLst>
-          </p:cNvPr>
-          <p:cNvSpPr>
-            <a:spLocks xmlns:a="http://schemas.openxmlformats.org/drawingml/2006/main" noGrp="1"/>
-          </p:cNvSpPr>
-          <p:nvPr/>
-        </p:nvSpPr>
-        <p:spPr>
-          <a:xfrm xmlns:a="http://schemas.openxmlformats.org/drawingml/2006/main">
-            <a:off x="609600" y="3429000"/>
-            <a:ext cx="736500" cy="609600"/>
-          </a:xfrm>
-          <a:prstGeom xmlns:a="http://schemas.openxmlformats.org/drawingml/2006/main" prst="rect">
-            <a:avLst/>
-          </a:prstGeom>
-          <a:noFill xmlns:a="http://schemas.openxmlformats.org/drawingml/2006/main"/>
-          <a:ln xmlns:a="http://schemas.openxmlformats.org/drawingml/2006/main">
-            <a:noFill/>
-          </a:ln>
-        </p:spPr>
-        <p:txBody>
-          <a:bodyPr xmlns:a="http://schemas.openxmlformats.org/drawingml/2006/main" spcFirstLastPara="1" wrap="square" lIns="0" tIns="0" rIns="0" bIns="0" anchor="t">
-            <a:noAutofit/>
-          </a:bodyPr>
-          <a:lstStyle xmlns:a="http://schemas.openxmlformats.org/drawingml/2006/main"/>
-          <a:p xmlns:a="http://schemas.openxmlformats.org/drawingml/2006/main">
-            <a:pPr marL="0" marR="0" lvl="0" indent="0" algn="l">
-              <a:spcBef>
-                <a:spcPts val="0"/>
-              </a:spcBef>
-              <a:spcAft>
-                <a:spcPts val="0"/>
-              </a:spcAft>
-              <a:buNone/>
-            </a:pPr>
-            <a:r>
-              <a:rPr sz="3000" b="1">
-                <a:solidFill>
-                  <a:srgbClr val="F0E8D9"/>
-                </a:solidFill>
-                <a:latin typeface="Roboto Mono"/>
-                <a:ea typeface="Roboto Mono"/>
-                <a:cs typeface="Roboto Mono"/>
-              </a:rPr>
-              <a:t>02</a:t>
-            </a:r>
-            <a:endParaRPr sz="3000" b="1">
-              <a:solidFill>
-                <a:srgbClr val="F0E8D9"/>
-              </a:solidFill>
-              <a:latin typeface="Roboto Mono"/>
-              <a:ea typeface="Roboto Mono"/>
-              <a:cs typeface="Roboto Mono"/>
-            </a:endParaRPr>
-          </a:p>
-        </p:txBody>
-      </p:sp>
-      <p:sp>
-        <p:nvSpPr>
-          <p:cNvPr id="85" name="Google Shape;85;p11">
-            <a:extLst xmlns:a="http://schemas.openxmlformats.org/drawingml/2006/main">
-              <a:ext uri="{FF2B5EF4-FFF2-40B4-BE49-F238E27FC236}">
-                <a16:creationId xmlns:a16="http://schemas.microsoft.com/office/drawing/2014/main" id="{503F3250-1DB3-49CD-81D7-23079AA17209}"/>
-              </a:ext>
-            </a:extLst>
-          </p:cNvPr>
-          <p:cNvSpPr>
-            <a:spLocks xmlns:a="http://schemas.openxmlformats.org/drawingml/2006/main" noGrp="1"/>
-          </p:cNvSpPr>
-          <p:nvPr/>
-        </p:nvSpPr>
-        <p:spPr>
-          <a:xfrm xmlns:a="http://schemas.openxmlformats.org/drawingml/2006/main">
-            <a:off x="1587500" y="3429000"/>
-            <a:ext cx="9994800" cy="533400"/>
-          </a:xfrm>
-          <a:prstGeom xmlns:a="http://schemas.openxmlformats.org/drawingml/2006/main" prst="rect">
-            <a:avLst/>
-          </a:prstGeom>
-          <a:noFill xmlns:a="http://schemas.openxmlformats.org/drawingml/2006/main"/>
-          <a:ln xmlns:a="http://schemas.openxmlformats.org/drawingml/2006/main">
-            <a:noFill/>
-          </a:ln>
-        </p:spPr>
-        <p:txBody>
-          <a:bodyPr xmlns:a="http://schemas.openxmlformats.org/drawingml/2006/main" spcFirstLastPara="1" wrap="square" lIns="0" tIns="0" rIns="0" bIns="0" anchor="t">
-            <a:noAutofit/>
-          </a:bodyPr>
-          <a:lstStyle xmlns:a="http://schemas.openxmlformats.org/drawingml/2006/main"/>
-          <a:p xmlns:a="http://schemas.openxmlformats.org/drawingml/2006/main">
-            <a:pPr marL="0" marR="0" lvl="0" indent="0" algn="l">
-              <a:spcBef>
-                <a:spcPts val="0"/>
-              </a:spcBef>
-              <a:spcAft>
-                <a:spcPts val="0"/>
-              </a:spcAft>
-              <a:buNone/>
-            </a:pPr>
-            <a:r>
-              <a:rPr sz="2400" b="1">
-                <a:solidFill>
-                  <a:srgbClr val="F0E8D9"/>
-                </a:solidFill>
-                <a:latin typeface="Manrope"/>
-                <a:ea typeface="Manrope"/>
-                <a:cs typeface="Manrope"/>
-              </a:rPr>
-              <a:t>Keep working behavior intact</a:t>
-            </a:r>
-            <a:endParaRPr sz="2400" b="1">
-              <a:solidFill>
-                <a:srgbClr val="F0E8D9"/>
-              </a:solidFill>
-              <a:latin typeface="Manrope"/>
-              <a:ea typeface="Manrope"/>
-              <a:cs typeface="Manrope"/>
-            </a:endParaRPr>
-          </a:p>
-        </p:txBody>
-      </p:sp>
-      <p:sp>
-        <p:nvSpPr>
-          <p:cNvPr id="86" name="Google Shape;86;p11">
-            <a:extLst xmlns:a="http://schemas.openxmlformats.org/drawingml/2006/main">
-              <a:ext uri="{FF2B5EF4-FFF2-40B4-BE49-F238E27FC236}">
-                <a16:creationId xmlns:a16="http://schemas.microsoft.com/office/drawing/2014/main" id="{46FE0F30-B444-457F-979A-D852074A2895}"/>
-              </a:ext>
-            </a:extLst>
-          </p:cNvPr>
-          <p:cNvSpPr>
-            <a:spLocks xmlns:a="http://schemas.openxmlformats.org/drawingml/2006/main" noGrp="1"/>
-          </p:cNvSpPr>
-          <p:nvPr/>
-        </p:nvSpPr>
-        <p:spPr>
-          <a:xfrm xmlns:a="http://schemas.openxmlformats.org/drawingml/2006/main">
-            <a:off x="1587500" y="3987800"/>
-            <a:ext cx="9994800" cy="762000"/>
-          </a:xfrm>
-          <a:prstGeom xmlns:a="http://schemas.openxmlformats.org/drawingml/2006/main" prst="rect">
-            <a:avLst/>
-          </a:prstGeom>
-          <a:noFill xmlns:a="http://schemas.openxmlformats.org/drawingml/2006/main"/>
-          <a:ln xmlns:a="http://schemas.openxmlformats.org/drawingml/2006/main">
-            <a:noFill/>
-          </a:ln>
-        </p:spPr>
-        <p:txBody>
-          <a:bodyPr xmlns:a="http://schemas.openxmlformats.org/drawingml/2006/main" spcFirstLastPara="1" wrap="square" lIns="0" tIns="0" rIns="0" bIns="0" anchor="t">
-            <a:noAutofit/>
-          </a:bodyPr>
-          <a:lstStyle xmlns:a="http://schemas.openxmlformats.org/drawingml/2006/main">
-            <a:defPPr>
-              <a:defRPr sz="2000">
-                <a:latin typeface="Manrope"/>
-                <a:ea typeface="Manrope"/>
-                <a:cs typeface="Manrope"/>
-              </a:defRPr>
-            </a:defPPr>
-            <a:lvl1pPr>
-              <a:defRPr sz="2000">
-                <a:latin typeface="Manrope"/>
-                <a:ea typeface="Manrope"/>
-                <a:cs typeface="Manrope"/>
-              </a:defRPr>
-            </a:lvl1pPr>
-            <a:lvl2pPr>
-              <a:defRPr sz="2000">
-                <a:latin typeface="Manrope"/>
-                <a:ea typeface="Manrope"/>
-                <a:cs typeface="Manrope"/>
-              </a:defRPr>
-            </a:lvl2pPr>
-            <a:lvl3pPr>
-              <a:defRPr sz="2000">
-                <a:latin typeface="Manrope"/>
-                <a:ea typeface="Manrope"/>
-                <a:cs typeface="Manrope"/>
-              </a:defRPr>
-            </a:lvl3pPr>
-            <a:lvl4pPr>
-              <a:defRPr sz="2000">
-                <a:latin typeface="Manrope"/>
-                <a:ea typeface="Manrope"/>
-                <a:cs typeface="Manrope"/>
-              </a:defRPr>
-            </a:lvl4pPr>
-            <a:lvl5pPr>
-              <a:defRPr sz="2000">
-                <a:latin typeface="Manrope"/>
-                <a:ea typeface="Manrope"/>
-                <a:cs typeface="Manrope"/>
-              </a:defRPr>
-            </a:lvl5pPr>
-            <a:lvl6pPr>
-              <a:defRPr sz="2000">
-                <a:latin typeface="Manrope"/>
-                <a:ea typeface="Manrope"/>
-                <a:cs typeface="Manrope"/>
-              </a:defRPr>
-            </a:lvl6pPr>
-            <a:lvl7pPr>
-              <a:defRPr sz="2000">
-                <a:latin typeface="Manrope"/>
-                <a:ea typeface="Manrope"/>
-                <a:cs typeface="Manrope"/>
-              </a:defRPr>
-            </a:lvl7pPr>
-            <a:lvl8pPr>
-              <a:defRPr sz="2000">
-                <a:latin typeface="Manrope"/>
-                <a:ea typeface="Manrope"/>
-                <a:cs typeface="Manrope"/>
-              </a:defRPr>
-            </a:lvl8pPr>
-            <a:lvl9pPr>
-              <a:defRPr sz="2000">
-                <a:latin typeface="Manrope"/>
-                <a:ea typeface="Manrope"/>
-                <a:cs typeface="Manrope"/>
-              </a:defRPr>
-            </a:lvl9pPr>
-          </a:lstStyle>
-          <a:p xmlns:a="http://schemas.openxmlformats.org/drawingml/2006/main">
-            <a:pPr marL="0" marR="0" lvl="0" indent="0" algn="l">
-              <a:spcBef>
-                <a:spcPts val="0"/>
-              </a:spcBef>
-              <a:spcAft>
-                <a:spcPts val="0"/>
-              </a:spcAft>
-              <a:buNone/>
-              <a:defRPr sz="2000">
-                <a:latin typeface="Manrope"/>
-                <a:ea typeface="Manrope"/>
-                <a:cs typeface="Manrope"/>
-              </a:defRPr>
-            </a:pPr>
-            <a:r>
-              <a:rPr sz="2000">
-                <a:solidFill>
-                  <a:srgbClr val="B8C7AB"/>
-                </a:solidFill>
-                <a:latin typeface="Manrope"/>
-                <a:ea typeface="Manrope"/>
-                <a:cs typeface="Manrope"/>
-              </a:rPr>
-              <a:t>Check direct Python paths, Shell scripts and an input</a:t>
-            </a:r>
-            <a:endParaRPr sz="1900">
-              <a:solidFill>
-                <a:srgbClr val="B8C7AB"/>
-              </a:solidFill>
-              <a:latin typeface="Manrope"/>
-              <a:ea typeface="Manrope"/>
-              <a:cs typeface="Manrope"/>
-            </a:endParaRPr>
-          </a:p>
-          <a:p xmlns:a="http://schemas.openxmlformats.org/drawingml/2006/main">
-            <a:pPr marL="0" marR="0" lvl="0" indent="0" algn="l">
-              <a:spcBef>
-                <a:spcPts val="0"/>
-              </a:spcBef>
-              <a:spcAft>
-                <a:spcPts val="0"/>
-              </a:spcAft>
-              <a:buNone/>
-              <a:defRPr sz="2000">
-                <a:latin typeface="Manrope"/>
-                <a:ea typeface="Manrope"/>
-                <a:cs typeface="Manrope"/>
-              </a:defRPr>
-            </a:pPr>
-            <a:r>
-              <a:rPr sz="2000">
-                <a:solidFill>
-                  <a:srgbClr val="B8C7AB"/>
-                </a:solidFill>
-                <a:latin typeface="Manrope"/>
-                <a:ea typeface="Manrope"/>
-                <a:cs typeface="Manrope"/>
-              </a:rPr>
-              <a:t>with a newline before the shebang.</a:t>
-            </a:r>
-            <a:endParaRPr sz="1900">
-              <a:solidFill>
-                <a:srgbClr val="B8C7AB"/>
-              </a:solidFill>
-              <a:latin typeface="Manrope"/>
-              <a:ea typeface="Manrope"/>
-              <a:cs typeface="Manrope"/>
-            </a:endParaRPr>
-          </a:p>
-        </p:txBody>
-      </p:sp>
-      <p:sp>
-        <p:nvSpPr>
-          <p:cNvPr id="87" name="Google Shape;87;p11">
-            <a:extLst xmlns:a="http://schemas.openxmlformats.org/drawingml/2006/main">
-              <a:ext uri="{FF2B5EF4-FFF2-40B4-BE49-F238E27FC236}">
-                <a16:creationId xmlns:a16="http://schemas.microsoft.com/office/drawing/2014/main" id="{07629426-1091-4373-9A9D-F21C112CF420}"/>
-              </a:ext>
-            </a:extLst>
-          </p:cNvPr>
-          <p:cNvSpPr>
-            <a:spLocks xmlns:a="http://schemas.openxmlformats.org/drawingml/2006/main" noGrp="1"/>
-          </p:cNvSpPr>
-          <p:nvPr/>
-        </p:nvSpPr>
-        <p:spPr>
-          <a:xfrm xmlns:a="http://schemas.openxmlformats.org/drawingml/2006/main">
-            <a:off x="609600" y="4826000"/>
-            <a:ext cx="736500" cy="609600"/>
-          </a:xfrm>
-          <a:prstGeom xmlns:a="http://schemas.openxmlformats.org/drawingml/2006/main" prst="rect">
-            <a:avLst/>
-          </a:prstGeom>
-          <a:noFill xmlns:a="http://schemas.openxmlformats.org/drawingml/2006/main"/>
-          <a:ln xmlns:a="http://schemas.openxmlformats.org/drawingml/2006/main">
-            <a:noFill/>
-          </a:ln>
-        </p:spPr>
-        <p:txBody>
-          <a:bodyPr xmlns:a="http://schemas.openxmlformats.org/drawingml/2006/main" spcFirstLastPara="1" wrap="square" lIns="0" tIns="0" rIns="0" bIns="0" anchor="t">
-            <a:noAutofit/>
-          </a:bodyPr>
-          <a:lstStyle xmlns:a="http://schemas.openxmlformats.org/drawingml/2006/main"/>
-          <a:p xmlns:a="http://schemas.openxmlformats.org/drawingml/2006/main">
-            <a:pPr marL="0" marR="0" lvl="0" indent="0" algn="l">
-              <a:spcBef>
-                <a:spcPts val="0"/>
-              </a:spcBef>
-              <a:spcAft>
-                <a:spcPts val="0"/>
-              </a:spcAft>
-              <a:buNone/>
-            </a:pPr>
-            <a:r>
-              <a:rPr sz="3000" b="1">
-                <a:solidFill>
-                  <a:srgbClr val="D99575"/>
-                </a:solidFill>
-                <a:latin typeface="Roboto Mono"/>
-                <a:ea typeface="Roboto Mono"/>
-                <a:cs typeface="Roboto Mono"/>
-              </a:rPr>
-              <a:t>03</a:t>
-            </a:r>
-            <a:endParaRPr sz="3000" b="1">
-              <a:solidFill>
-                <a:srgbClr val="D99575"/>
-              </a:solidFill>
-              <a:latin typeface="Roboto Mono"/>
-              <a:ea typeface="Roboto Mono"/>
-              <a:cs typeface="Roboto Mono"/>
-            </a:endParaRPr>
-          </a:p>
-        </p:txBody>
-      </p:sp>
-      <p:sp>
-        <p:nvSpPr>
-          <p:cNvPr id="88" name="Google Shape;88;p11">
-            <a:extLst xmlns:a="http://schemas.openxmlformats.org/drawingml/2006/main">
-              <a:ext uri="{FF2B5EF4-FFF2-40B4-BE49-F238E27FC236}">
-                <a16:creationId xmlns:a16="http://schemas.microsoft.com/office/drawing/2014/main" id="{76757074-0547-430B-976E-4EC8F196C9D2}"/>
-              </a:ext>
-            </a:extLst>
-          </p:cNvPr>
-          <p:cNvSpPr>
-            <a:spLocks xmlns:a="http://schemas.openxmlformats.org/drawingml/2006/main" noGrp="1"/>
-          </p:cNvSpPr>
-          <p:nvPr/>
-        </p:nvSpPr>
-        <p:spPr>
-          <a:xfrm xmlns:a="http://schemas.openxmlformats.org/drawingml/2006/main">
-            <a:off x="1587500" y="4826000"/>
-            <a:ext cx="9994800" cy="533400"/>
-          </a:xfrm>
-          <a:prstGeom xmlns:a="http://schemas.openxmlformats.org/drawingml/2006/main" prst="rect">
-            <a:avLst/>
-          </a:prstGeom>
-          <a:noFill xmlns:a="http://schemas.openxmlformats.org/drawingml/2006/main"/>
-          <a:ln xmlns:a="http://schemas.openxmlformats.org/drawingml/2006/main">
-            <a:noFill/>
-          </a:ln>
-        </p:spPr>
-        <p:txBody>
-          <a:bodyPr xmlns:a="http://schemas.openxmlformats.org/drawingml/2006/main" spcFirstLastPara="1" wrap="square" lIns="0" tIns="0" rIns="0" bIns="0" anchor="t">
-            <a:noAutofit/>
-          </a:bodyPr>
-          <a:lstStyle xmlns:a="http://schemas.openxmlformats.org/drawingml/2006/main">
-            <a:defPPr>
-              <a:defRPr sz="2300"/>
-            </a:defPPr>
-            <a:lvl1pPr>
-              <a:defRPr sz="2300"/>
-            </a:lvl1pPr>
-            <a:lvl2pPr>
-              <a:defRPr sz="2300"/>
-            </a:lvl2pPr>
-            <a:lvl3pPr>
-              <a:defRPr sz="2300"/>
-            </a:lvl3pPr>
-            <a:lvl4pPr>
-              <a:defRPr sz="2300"/>
-            </a:lvl4pPr>
-            <a:lvl5pPr>
-              <a:defRPr sz="2300"/>
-            </a:lvl5pPr>
-            <a:lvl6pPr>
-              <a:defRPr sz="2300"/>
-            </a:lvl6pPr>
-            <a:lvl7pPr>
-              <a:defRPr sz="2300"/>
-            </a:lvl7pPr>
-            <a:lvl8pPr>
-              <a:defRPr sz="2300"/>
-            </a:lvl8pPr>
-            <a:lvl9pPr>
-              <a:defRPr sz="2300"/>
-            </a:lvl9pPr>
-          </a:lstStyle>
-          <a:p xmlns:a="http://schemas.openxmlformats.org/drawingml/2006/main">
-            <a:pPr marL="0" marR="0" lvl="0" indent="0" algn="l">
-              <a:spcBef>
-                <a:spcPts val="0"/>
-              </a:spcBef>
-              <a:spcAft>
-                <a:spcPts val="0"/>
-              </a:spcAft>
-              <a:buNone/>
-              <a:defRPr sz="2300"/>
-            </a:pPr>
-            <a:r>
-              <a:rPr sz="2300" b="1">
-                <a:solidFill>
-                  <a:srgbClr val="F0E8D9"/>
-                </a:solidFill>
-                <a:latin typeface="Manrope"/>
-                <a:ea typeface="Manrope"/>
-                <a:cs typeface="Manrope"/>
-              </a:rPr>
-              <a:t>Same 18 focused checks: 7 failures before, 0 after</a:t>
-            </a:r>
-            <a:endParaRPr sz="2400" b="1">
-              <a:solidFill>
-                <a:srgbClr val="F0E8D9"/>
-              </a:solidFill>
-              <a:latin typeface="Manrope"/>
-              <a:ea typeface="Manrope"/>
-              <a:cs typeface="Manrope"/>
-            </a:endParaRPr>
-          </a:p>
-        </p:txBody>
-      </p:sp>
-      <p:sp>
-        <p:nvSpPr>
-          <p:cNvPr id="89" name="Google Shape;89;p11">
-            <a:extLst xmlns:a="http://schemas.openxmlformats.org/drawingml/2006/main">
-              <a:ext uri="{FF2B5EF4-FFF2-40B4-BE49-F238E27FC236}">
-                <a16:creationId xmlns:a16="http://schemas.microsoft.com/office/drawing/2014/main" id="{9AB7F8B2-ECE8-42A6-B5CB-7BF342CD72FB}"/>
-              </a:ext>
-            </a:extLst>
-          </p:cNvPr>
-          <p:cNvSpPr>
-            <a:spLocks xmlns:a="http://schemas.openxmlformats.org/drawingml/2006/main" noGrp="1"/>
-          </p:cNvSpPr>
-          <p:nvPr/>
-        </p:nvSpPr>
-        <p:spPr>
-          <a:xfrm xmlns:a="http://schemas.openxmlformats.org/drawingml/2006/main">
-            <a:off x="1587500" y="5384800"/>
-            <a:ext cx="9994800" cy="762000"/>
-          </a:xfrm>
-          <a:prstGeom xmlns:a="http://schemas.openxmlformats.org/drawingml/2006/main" prst="rect">
-            <a:avLst/>
-          </a:prstGeom>
-          <a:noFill xmlns:a="http://schemas.openxmlformats.org/drawingml/2006/main"/>
-          <a:ln xmlns:a="http://schemas.openxmlformats.org/drawingml/2006/main">
-            <a:noFill/>
-          </a:ln>
-        </p:spPr>
-        <p:txBody>
-          <a:bodyPr xmlns:a="http://schemas.openxmlformats.org/drawingml/2006/main" spcFirstLastPara="1" wrap="square" lIns="0" tIns="0" rIns="0" bIns="0" anchor="t">
-            <a:noAutofit/>
-          </a:bodyPr>
-          <a:lstStyle xmlns:a="http://schemas.openxmlformats.org/drawingml/2006/main">
-            <a:defPPr>
-              <a:defRPr sz="1900">
-                <a:latin typeface="Manrope"/>
-                <a:ea typeface="Manrope"/>
-                <a:cs typeface="Manrope"/>
-              </a:defRPr>
-            </a:defPPr>
-            <a:lvl1pPr>
-              <a:defRPr sz="1900">
-                <a:latin typeface="Manrope"/>
-                <a:ea typeface="Manrope"/>
-                <a:cs typeface="Manrope"/>
-              </a:defRPr>
-            </a:lvl1pPr>
-            <a:lvl2pPr>
-              <a:defRPr sz="1900">
-                <a:latin typeface="Manrope"/>
-                <a:ea typeface="Manrope"/>
-                <a:cs typeface="Manrope"/>
-              </a:defRPr>
-            </a:lvl2pPr>
-            <a:lvl3pPr>
-              <a:defRPr sz="1900">
-                <a:latin typeface="Manrope"/>
-                <a:ea typeface="Manrope"/>
-                <a:cs typeface="Manrope"/>
-              </a:defRPr>
-            </a:lvl3pPr>
-            <a:lvl4pPr>
-              <a:defRPr sz="1900">
-                <a:latin typeface="Manrope"/>
-                <a:ea typeface="Manrope"/>
-                <a:cs typeface="Manrope"/>
-              </a:defRPr>
-            </a:lvl4pPr>
-            <a:lvl5pPr>
-              <a:defRPr sz="1900">
-                <a:latin typeface="Manrope"/>
-                <a:ea typeface="Manrope"/>
-                <a:cs typeface="Manrope"/>
-              </a:defRPr>
-            </a:lvl5pPr>
-            <a:lvl6pPr>
-              <a:defRPr sz="1900">
-                <a:latin typeface="Manrope"/>
-                <a:ea typeface="Manrope"/>
-                <a:cs typeface="Manrope"/>
-              </a:defRPr>
-            </a:lvl6pPr>
-            <a:lvl7pPr>
-              <a:defRPr sz="1900">
-                <a:latin typeface="Manrope"/>
-                <a:ea typeface="Manrope"/>
-                <a:cs typeface="Manrope"/>
-              </a:defRPr>
-            </a:lvl7pPr>
-            <a:lvl8pPr>
-              <a:defRPr sz="1900">
-                <a:latin typeface="Manrope"/>
-                <a:ea typeface="Manrope"/>
-                <a:cs typeface="Manrope"/>
-              </a:defRPr>
-            </a:lvl8pPr>
-            <a:lvl9pPr>
-              <a:defRPr sz="1900">
-                <a:latin typeface="Manrope"/>
-                <a:ea typeface="Manrope"/>
-                <a:cs typeface="Manrope"/>
-              </a:defRPr>
-            </a:lvl9pPr>
-          </a:lstStyle>
-          <a:p xmlns:a="http://schemas.openxmlformats.org/drawingml/2006/main">
-            <a:pPr marL="0" marR="0" lvl="0" indent="0" algn="l">
-              <a:spcBef>
-                <a:spcPts val="0"/>
-              </a:spcBef>
-              <a:spcAft>
-                <a:spcPts val="0"/>
-              </a:spcAft>
-              <a:buNone/>
-              <a:defRPr sz="1900">
-                <a:latin typeface="Manrope"/>
-                <a:ea typeface="Manrope"/>
-                <a:cs typeface="Manrope"/>
-              </a:defRPr>
-            </a:pPr>
-            <a:r>
-              <a:rPr sz="1900">
-                <a:solidFill>
-                  <a:srgbClr val="B8C7AB"/>
-                </a:solidFill>
-                <a:latin typeface="Manrope"/>
-                <a:ea typeface="Manrope"/>
-                <a:cs typeface="Manrope"/>
-              </a:rPr>
-              <a:t>All 18 passed after the fix. These are local results.</a:t>
-            </a:r>
-            <a:endParaRPr sz="1900">
-              <a:solidFill>
-                <a:srgbClr val="B8C7AB"/>
-              </a:solidFill>
-              <a:latin typeface="Manrope"/>
-              <a:ea typeface="Manrope"/>
-              <a:cs typeface="Manrope"/>
-            </a:endParaRPr>
-          </a:p>
-          <a:p xmlns:a="http://schemas.openxmlformats.org/drawingml/2006/main">
-            <a:pPr marL="0" marR="0" lvl="0" indent="0" algn="l">
-              <a:spcBef>
-                <a:spcPts val="0"/>
-              </a:spcBef>
-              <a:spcAft>
-                <a:spcPts val="0"/>
-              </a:spcAft>
-              <a:buNone/>
-              <a:defRPr sz="1900">
-                <a:latin typeface="Manrope"/>
-                <a:ea typeface="Manrope"/>
-                <a:cs typeface="Manrope"/>
-              </a:defRPr>
-            </a:pPr>
-            <a:r>
-              <a:rPr sz="1900">
-                <a:solidFill>
-                  <a:srgbClr val="B8C7AB"/>
-                </a:solidFill>
-                <a:latin typeface="Manrope"/>
-                <a:ea typeface="Manrope"/>
-                <a:cs typeface="Manrope"/>
-              </a:rPr>
-              <a:t>They do not establish remote CI or whole-project validation.</a:t>
-            </a:r>
-            <a:endParaRPr sz="1900">
-              <a:solidFill>
-                <a:srgbClr val="B8C7AB"/>
-              </a:solidFill>
-              <a:latin typeface="Manrope"/>
-              <a:ea typeface="Manrope"/>
-              <a:cs typeface="Manrope"/>
-            </a:endParaRPr>
-          </a:p>
-        </p:txBody>
-      </p:sp>
-    </p:spTree>
-    <p:extLst>
-      <p:ext uri="{BB962C8B-B14F-4D97-AF65-F5344CB8AC3E}">
-        <p14:creationId xmlns:p14="http://schemas.microsoft.com/office/powerpoint/2010/main" val="1042123372"/>
-      </p:ext>
-    </p:extLst>
-  </p:cSld>
-</p:sld>
-</file>
-
-<file path=ppt/slides/slide3.xml><?xml version="1.0" encoding="utf-8"?>
-<p:sld xmlns:p="http://schemas.openxmlformats.org/presentationml/2006/main">
-  <p:cSld>
-    <p:bg>
-      <p:bgPr>
-        <a:solidFill xmlns:a="http://schemas.openxmlformats.org/drawingml/2006/main">
-          <a:srgbClr val="203B34"/>
-        </a:solidFill>
-      </p:bgPr>
-    </p:bg>
-    <p:spTree>
-      <p:nvGrpSpPr>
-        <p:cNvPr id="1" name=""/>
-        <p:cNvGrpSpPr/>
-        <p:nvPr/>
-      </p:nvGrpSpPr>
-      <p:grpSpPr>
-        <a:xfrm xmlns:a="http://schemas.openxmlformats.org/drawingml/2006/main"/>
-      </p:grpSpPr>
-      <p:sp>
-        <p:nvSpPr>
-          <p:cNvPr id="42" name="Google Shape;42;p9">
-            <a:extLst xmlns:a="http://schemas.openxmlformats.org/drawingml/2006/main">
-              <a:ext uri="{FF2B5EF4-FFF2-40B4-BE49-F238E27FC236}">
-                <a16:creationId xmlns:a16="http://schemas.microsoft.com/office/drawing/2014/main" id="{C649A7DE-3EB6-4F20-99F1-6CCEBCD4FFF0}"/>
-              </a:ext>
-            </a:extLst>
-          </p:cNvPr>
-          <p:cNvSpPr>
-            <a:spLocks xmlns:a="http://schemas.openxmlformats.org/drawingml/2006/main" noGrp="1"/>
-          </p:cNvSpPr>
-          <p:nvPr/>
-        </p:nvSpPr>
-        <p:spPr>
-          <a:xfrm xmlns:a="http://schemas.openxmlformats.org/drawingml/2006/main">
-            <a:off x="0" y="3835400"/>
-            <a:ext cx="12192000" cy="3022500"/>
-          </a:xfrm>
-          <a:prstGeom xmlns:a="http://schemas.openxmlformats.org/drawingml/2006/main" prst="rect">
-            <a:avLst/>
-          </a:prstGeom>
-          <a:solidFill xmlns:a="http://schemas.openxmlformats.org/drawingml/2006/main">
-            <a:srgbClr val="F0E8D9"/>
-          </a:solidFill>
-          <a:ln xmlns:a="http://schemas.openxmlformats.org/drawingml/2006/main">
-            <a:noFill/>
-          </a:ln>
-        </p:spPr>
-        <p:txBody>
-          <a:bodyPr xmlns:a="http://schemas.openxmlformats.org/drawingml/2006/main" spcFirstLastPara="1" wrap="square" lIns="91425" tIns="91425" rIns="91425" bIns="91425" anchor="ctr">
-            <a:noAutofit/>
-          </a:bodyPr>
-          <a:lstStyle xmlns:a="http://schemas.openxmlformats.org/drawingml/2006/main"/>
-          <a:p xmlns:a="http://schemas.openxmlformats.org/drawingml/2006/main">
-            <a:pPr marL="0" lvl="0" indent="0" algn="ctr">
-              <a:spcBef>
-                <a:spcPts val="0"/>
-              </a:spcBef>
-              <a:spcAft>
-                <a:spcPts val="0"/>
-              </a:spcAft>
-              <a:buNone/>
-            </a:pPr>
-            <a:r>
-              <a:t/>
-            </a:r>
-            <a:endParaRPr/>
-          </a:p>
-        </p:txBody>
-      </p:sp>
-      <p:sp>
-        <p:nvSpPr>
-          <p:cNvPr id="43" name="Google Shape;43;p9">
-            <a:extLst xmlns:a="http://schemas.openxmlformats.org/drawingml/2006/main">
-              <a:ext uri="{FF2B5EF4-FFF2-40B4-BE49-F238E27FC236}">
-                <a16:creationId xmlns:a16="http://schemas.microsoft.com/office/drawing/2014/main" id="{F563E5C4-AF43-47DB-A4EC-C542AA844741}"/>
-              </a:ext>
-            </a:extLst>
-          </p:cNvPr>
-          <p:cNvSpPr>
-            <a:spLocks xmlns:a="http://schemas.openxmlformats.org/drawingml/2006/main" noGrp="1"/>
-          </p:cNvSpPr>
-          <p:nvPr/>
-        </p:nvSpPr>
-        <p:spPr>
-          <a:xfrm xmlns:a="http://schemas.openxmlformats.org/drawingml/2006/main">
-            <a:off x="609600" y="330200"/>
-            <a:ext cx="9651900" cy="279300"/>
-          </a:xfrm>
-          <a:prstGeom xmlns:a="http://schemas.openxmlformats.org/drawingml/2006/main" prst="rect">
-            <a:avLst/>
-          </a:prstGeom>
-          <a:noFill xmlns:a="http://schemas.openxmlformats.org/drawingml/2006/main"/>
-          <a:ln xmlns:a="http://schemas.openxmlformats.org/drawingml/2006/main">
-            <a:noFill/>
-          </a:ln>
-        </p:spPr>
-        <p:txBody>
-          <a:bodyPr xmlns:a="http://schemas.openxmlformats.org/drawingml/2006/main" spcFirstLastPara="1" wrap="square" lIns="0" tIns="0" rIns="0" bIns="0" anchor="t">
-            <a:noAutofit/>
-          </a:bodyPr>
-          <a:lstStyle xmlns:a="http://schemas.openxmlformats.org/drawingml/2006/main"/>
-          <a:p xmlns:a="http://schemas.openxmlformats.org/drawingml/2006/main">
-            <a:pPr marL="0" marR="0" lvl="0" indent="0" algn="l">
-              <a:spcBef>
-                <a:spcPts val="0"/>
-              </a:spcBef>
-              <a:spcAft>
-                <a:spcPts val="0"/>
-              </a:spcAft>
-              <a:buNone/>
-            </a:pPr>
-            <a:r>
-              <a:rPr sz="1100">
-                <a:solidFill>
-                  <a:srgbClr val="B8C7AB"/>
-                </a:solidFill>
-                <a:latin typeface="Roboto Mono"/>
-                <a:ea typeface="Roboto Mono"/>
-                <a:cs typeface="Roboto Mono"/>
-              </a:rPr>
-              <a:t>TIKA-4408 / LESSONS FROM REVIEW</a:t>
-            </a:r>
-            <a:endParaRPr sz="1100">
-              <a:solidFill>
-                <a:srgbClr val="B8C7AB"/>
-              </a:solidFill>
-              <a:latin typeface="Roboto Mono"/>
-              <a:ea typeface="Roboto Mono"/>
-              <a:cs typeface="Roboto Mono"/>
-            </a:endParaRPr>
-          </a:p>
-        </p:txBody>
-      </p:sp>
-      <p:sp>
-        <p:nvSpPr>
-          <p:cNvPr id="44" name="Google Shape;44;p9">
-            <a:extLst xmlns:a="http://schemas.openxmlformats.org/drawingml/2006/main">
-              <a:ext uri="{FF2B5EF4-FFF2-40B4-BE49-F238E27FC236}">
-                <a16:creationId xmlns:a16="http://schemas.microsoft.com/office/drawing/2014/main" id="{980F5A0C-EB58-44AD-BE53-98BAFE1A5342}"/>
-              </a:ext>
-            </a:extLst>
-          </p:cNvPr>
-          <p:cNvSpPr>
-            <a:spLocks xmlns:a="http://schemas.openxmlformats.org/drawingml/2006/main" noGrp="1"/>
-          </p:cNvSpPr>
-          <p:nvPr/>
-        </p:nvSpPr>
-        <p:spPr>
-          <a:xfrm xmlns:a="http://schemas.openxmlformats.org/drawingml/2006/main">
-            <a:off x="10871200" y="330200"/>
-            <a:ext cx="711300" cy="279300"/>
-          </a:xfrm>
-          <a:prstGeom xmlns:a="http://schemas.openxmlformats.org/drawingml/2006/main" prst="rect">
-            <a:avLst/>
-          </a:prstGeom>
-          <a:noFill xmlns:a="http://schemas.openxmlformats.org/drawingml/2006/main"/>
-          <a:ln xmlns:a="http://schemas.openxmlformats.org/drawingml/2006/main">
-            <a:noFill/>
-          </a:ln>
-        </p:spPr>
-        <p:txBody>
-          <a:bodyPr xmlns:a="http://schemas.openxmlformats.org/drawingml/2006/main" spcFirstLastPara="1" wrap="square" lIns="0" tIns="0" rIns="0" bIns="0" anchor="t">
-            <a:noAutofit/>
-          </a:bodyPr>
-          <a:lstStyle xmlns:a="http://schemas.openxmlformats.org/drawingml/2006/main"/>
-          <a:p xmlns:a="http://schemas.openxmlformats.org/drawingml/2006/main">
-            <a:pPr marL="0" marR="0" lvl="0" indent="0" algn="r">
-              <a:spcBef>
-                <a:spcPts val="0"/>
-              </a:spcBef>
-              <a:spcAft>
-                <a:spcPts val="0"/>
-              </a:spcAft>
-              <a:buNone/>
-            </a:pPr>
-            <a:r>
-              <a:rPr sz="1100">
-                <a:solidFill>
-                  <a:srgbClr val="B8C7AB"/>
-                </a:solidFill>
-                <a:latin typeface="Roboto Mono"/>
-                <a:ea typeface="Roboto Mono"/>
-                <a:cs typeface="Roboto Mono"/>
-              </a:rPr>
-              <a:t>03</a:t>
-            </a:r>
-            <a:endParaRPr sz="1100">
-              <a:solidFill>
-                <a:srgbClr val="B8C7AB"/>
-              </a:solidFill>
-              <a:latin typeface="Roboto Mono"/>
-              <a:ea typeface="Roboto Mono"/>
-              <a:cs typeface="Roboto Mono"/>
-            </a:endParaRPr>
-          </a:p>
-        </p:txBody>
-      </p:sp>
-      <p:sp>
-        <p:nvSpPr>
-          <p:cNvPr id="45" name="Google Shape;45;p9">
-            <a:extLst xmlns:a="http://schemas.openxmlformats.org/drawingml/2006/main">
-              <a:ext uri="{FF2B5EF4-FFF2-40B4-BE49-F238E27FC236}">
-                <a16:creationId xmlns:a16="http://schemas.microsoft.com/office/drawing/2014/main" id="{33D82BA1-51F6-46A3-A292-B6322244794D}"/>
-              </a:ext>
-            </a:extLst>
-          </p:cNvPr>
-          <p:cNvSpPr>
-            <a:spLocks xmlns:a="http://schemas.openxmlformats.org/drawingml/2006/main" noGrp="1"/>
-          </p:cNvSpPr>
-          <p:nvPr>
-            <p:ph type="title" idx="0"/>
-          </p:nvPr>
-        </p:nvSpPr>
-        <p:spPr>
-          <a:xfrm xmlns:a="http://schemas.openxmlformats.org/drawingml/2006/main">
-            <a:off x="609600" y="952500"/>
-            <a:ext cx="10972800" cy="965100"/>
-          </a:xfrm>
-          <a:prstGeom xmlns:a="http://schemas.openxmlformats.org/drawingml/2006/main" prst="rect">
-            <a:avLst/>
-          </a:prstGeom>
-          <a:noFill xmlns:a="http://schemas.openxmlformats.org/drawingml/2006/main"/>
-          <a:ln xmlns:a="http://schemas.openxmlformats.org/drawingml/2006/main">
-            <a:noFill/>
-          </a:ln>
-        </p:spPr>
-        <p:txBody>
-          <a:bodyPr xmlns:a="http://schemas.openxmlformats.org/drawingml/2006/main" spcFirstLastPara="1" wrap="square" lIns="0" tIns="0" rIns="0" bIns="0" anchor="t">
-            <a:noAutofit/>
-          </a:bodyPr>
-          <a:lstStyle xmlns:a="http://schemas.openxmlformats.org/drawingml/2006/main">
-            <a:defPPr>
-              <a:defRPr sz="3300"/>
-            </a:defPPr>
-            <a:lvl1pPr>
-              <a:defRPr sz="3300"/>
-            </a:lvl1pPr>
-            <a:lvl2pPr>
-              <a:defRPr sz="3300"/>
-            </a:lvl2pPr>
-            <a:lvl3pPr>
-              <a:defRPr sz="3300"/>
-            </a:lvl3pPr>
-            <a:lvl4pPr>
-              <a:defRPr sz="3300"/>
-            </a:lvl4pPr>
-            <a:lvl5pPr>
-              <a:defRPr sz="3300"/>
-            </a:lvl5pPr>
-            <a:lvl6pPr>
-              <a:defRPr sz="3300"/>
-            </a:lvl6pPr>
-            <a:lvl7pPr>
-              <a:defRPr sz="3300"/>
-            </a:lvl7pPr>
-            <a:lvl8pPr>
-              <a:defRPr sz="3300"/>
-            </a:lvl8pPr>
-            <a:lvl9pPr>
-              <a:defRPr sz="3300"/>
-            </a:lvl9pPr>
-          </a:lstStyle>
-          <a:p xmlns:a="http://schemas.openxmlformats.org/drawingml/2006/main">
-            <a:pPr marL="0" marR="0" lvl="0" indent="0" algn="l">
-              <a:spcBef>
-                <a:spcPts val="0"/>
-              </a:spcBef>
-              <a:spcAft>
-                <a:spcPts val="0"/>
-              </a:spcAft>
-              <a:buNone/>
-              <a:defRPr sz="3300"/>
-            </a:pPr>
-            <a:r>
-              <a:rPr sz="3300" b="1">
-                <a:solidFill>
-                  <a:srgbClr val="F0E8D9"/>
-                </a:solidFill>
-                <a:latin typeface="Manrope"/>
-                <a:ea typeface="Manrope"/>
-                <a:cs typeface="Manrope"/>
-              </a:rPr>
-              <a:t>Negative tests catch false positives</a:t>
-            </a:r>
-            <a:endParaRPr sz="3500" b="1">
-              <a:solidFill>
-                <a:srgbClr val="F0E8D9"/>
-              </a:solidFill>
-              <a:latin typeface="Manrope"/>
-              <a:ea typeface="Manrope"/>
-              <a:cs typeface="Manrope"/>
-            </a:endParaRPr>
-          </a:p>
-        </p:txBody>
-      </p:sp>
-      <p:sp>
-        <p:nvSpPr>
-          <p:cNvPr id="46" name="Google Shape;46;p9">
-            <a:extLst xmlns:a="http://schemas.openxmlformats.org/drawingml/2006/main">
-              <a:ext uri="{FF2B5EF4-FFF2-40B4-BE49-F238E27FC236}">
-                <a16:creationId xmlns:a16="http://schemas.microsoft.com/office/drawing/2014/main" id="{35D0A4BF-CD5A-4522-B7C2-CCF382DD9AEF}"/>
-              </a:ext>
-            </a:extLst>
-          </p:cNvPr>
-          <p:cNvSpPr>
-            <a:spLocks xmlns:a="http://schemas.openxmlformats.org/drawingml/2006/main" noGrp="1"/>
-          </p:cNvSpPr>
-          <p:nvPr/>
-        </p:nvSpPr>
-        <p:spPr>
-          <a:xfrm xmlns:a="http://schemas.openxmlformats.org/drawingml/2006/main">
-            <a:off x="7620000" y="6578600"/>
-            <a:ext cx="3962400" cy="203100"/>
-          </a:xfrm>
-          <a:prstGeom xmlns:a="http://schemas.openxmlformats.org/drawingml/2006/main" prst="rect">
-            <a:avLst/>
-          </a:prstGeom>
-          <a:noFill xmlns:a="http://schemas.openxmlformats.org/drawingml/2006/main"/>
-          <a:ln xmlns:a="http://schemas.openxmlformats.org/drawingml/2006/main">
-            <a:noFill/>
-          </a:ln>
-        </p:spPr>
-        <p:txBody>
-          <a:bodyPr xmlns:a="http://schemas.openxmlformats.org/drawingml/2006/main" spcFirstLastPara="1" wrap="square" lIns="0" tIns="0" rIns="0" bIns="0" anchor="t">
-            <a:noAutofit/>
-          </a:bodyPr>
-          <a:lstStyle xmlns:a="http://schemas.openxmlformats.org/drawingml/2006/main"/>
-          <a:p xmlns:a="http://schemas.openxmlformats.org/drawingml/2006/main">
-            <a:pPr marL="0" marR="0" lvl="0" indent="0" algn="r">
-              <a:spcBef>
-                <a:spcPts val="0"/>
-              </a:spcBef>
-              <a:spcAft>
-                <a:spcPts val="0"/>
-              </a:spcAft>
-              <a:buNone/>
-            </a:pPr>
-            <a:r>
-              <a:rPr sz="900">
-                <a:solidFill>
-                  <a:srgbClr val="203B34"/>
-                </a:solidFill>
-                <a:latin typeface="Manrope"/>
-                <a:ea typeface="Manrope"/>
-                <a:cs typeface="Manrope"/>
-              </a:rPr>
-              <a:t>Jiajun Li / TIKA-4408</a:t>
-            </a:r>
-            <a:endParaRPr sz="900">
-              <a:solidFill>
-                <a:srgbClr val="203B34"/>
-              </a:solidFill>
-              <a:latin typeface="Manrope"/>
-              <a:ea typeface="Manrope"/>
-              <a:cs typeface="Manrope"/>
-            </a:endParaRPr>
-          </a:p>
-        </p:txBody>
-      </p:sp>
-      <p:sp>
-        <p:nvSpPr>
-          <p:cNvPr id="47" name="Google Shape;47;p9">
-            <a:extLst xmlns:a="http://schemas.openxmlformats.org/drawingml/2006/main">
-              <a:ext uri="{FF2B5EF4-FFF2-40B4-BE49-F238E27FC236}">
-                <a16:creationId xmlns:a16="http://schemas.microsoft.com/office/drawing/2014/main" id="{9CA6DB4B-926F-4A17-9A79-E05731261294}"/>
-              </a:ext>
-            </a:extLst>
-          </p:cNvPr>
-          <p:cNvSpPr>
-            <a:spLocks xmlns:a="http://schemas.openxmlformats.org/drawingml/2006/main" noGrp="1"/>
-          </p:cNvSpPr>
-          <p:nvPr/>
-        </p:nvSpPr>
-        <p:spPr>
-          <a:xfrm xmlns:a="http://schemas.openxmlformats.org/drawingml/2006/main">
-            <a:off x="609600" y="4152900"/>
-            <a:ext cx="5079900" cy="330300"/>
-          </a:xfrm>
-          <a:prstGeom xmlns:a="http://schemas.openxmlformats.org/drawingml/2006/main" prst="rect">
-            <a:avLst/>
-          </a:prstGeom>
-          <a:noFill xmlns:a="http://schemas.openxmlformats.org/drawingml/2006/main"/>
-          <a:ln xmlns:a="http://schemas.openxmlformats.org/drawingml/2006/main">
-            <a:noFill/>
-          </a:ln>
-        </p:spPr>
-        <p:txBody>
-          <a:bodyPr xmlns:a="http://schemas.openxmlformats.org/drawingml/2006/main" spcFirstLastPara="1" wrap="square" lIns="0" tIns="0" rIns="0" bIns="0" anchor="t">
-            <a:noAutofit/>
-          </a:bodyPr>
-          <a:lstStyle xmlns:a="http://schemas.openxmlformats.org/drawingml/2006/main">
-            <a:defPPr>
-              <a:defRPr sz="1300"/>
-            </a:defPPr>
-            <a:lvl1pPr>
-              <a:defRPr sz="1300"/>
-            </a:lvl1pPr>
-            <a:lvl2pPr>
-              <a:defRPr sz="1300"/>
-            </a:lvl2pPr>
-            <a:lvl3pPr>
-              <a:defRPr sz="1300"/>
-            </a:lvl3pPr>
-            <a:lvl4pPr>
-              <a:defRPr sz="1300"/>
-            </a:lvl4pPr>
-            <a:lvl5pPr>
-              <a:defRPr sz="1300"/>
-            </a:lvl5pPr>
-            <a:lvl6pPr>
-              <a:defRPr sz="1300"/>
-            </a:lvl6pPr>
-            <a:lvl7pPr>
-              <a:defRPr sz="1300"/>
-            </a:lvl7pPr>
-            <a:lvl8pPr>
-              <a:defRPr sz="1300"/>
-            </a:lvl8pPr>
-            <a:lvl9pPr>
-              <a:defRPr sz="1300"/>
-            </a:lvl9pPr>
-          </a:lstStyle>
-          <a:p xmlns:a="http://schemas.openxmlformats.org/drawingml/2006/main">
-            <a:pPr marL="0" marR="0" lvl="0" indent="0" algn="l">
-              <a:spcBef>
-                <a:spcPts val="0"/>
-              </a:spcBef>
-              <a:spcAft>
-                <a:spcPts val="0"/>
-              </a:spcAft>
-              <a:buNone/>
-              <a:defRPr sz="1300"/>
-            </a:pPr>
-            <a:r>
-              <a:rPr sz="1300" b="1">
-                <a:solidFill>
-                  <a:srgbClr val="A14F37"/>
-                </a:solidFill>
-                <a:latin typeface="Manrope"/>
-                <a:ea typeface="Manrope"/>
-                <a:cs typeface="Manrope"/>
-              </a:rPr>
-              <a:t>OLD RULE: ACCIDENTAL MATCH</a:t>
-            </a:r>
-            <a:endParaRPr sz="1200" b="1">
-              <a:solidFill>
-                <a:srgbClr val="A14F37"/>
-              </a:solidFill>
-              <a:latin typeface="Manrope"/>
-              <a:ea typeface="Manrope"/>
-              <a:cs typeface="Manrope"/>
-            </a:endParaRPr>
-          </a:p>
-        </p:txBody>
-      </p:sp>
-      <p:sp>
-        <p:nvSpPr>
-          <p:cNvPr id="48" name="Google Shape;48;p9">
-            <a:extLst xmlns:a="http://schemas.openxmlformats.org/drawingml/2006/main">
-              <a:ext uri="{FF2B5EF4-FFF2-40B4-BE49-F238E27FC236}">
-                <a16:creationId xmlns:a16="http://schemas.microsoft.com/office/drawing/2014/main" id="{1F616BD8-03FF-4592-AFB6-3DAFFA80CB77}"/>
-              </a:ext>
-            </a:extLst>
-          </p:cNvPr>
-          <p:cNvSpPr>
-            <a:spLocks xmlns:a="http://schemas.openxmlformats.org/drawingml/2006/main" noGrp="1"/>
-          </p:cNvSpPr>
-          <p:nvPr/>
-        </p:nvSpPr>
-        <p:spPr>
-          <a:xfrm xmlns:a="http://schemas.openxmlformats.org/drawingml/2006/main">
-            <a:off x="6604000" y="4152900"/>
-            <a:ext cx="4978500" cy="330300"/>
-          </a:xfrm>
-          <a:prstGeom xmlns:a="http://schemas.openxmlformats.org/drawingml/2006/main" prst="rect">
-            <a:avLst/>
-          </a:prstGeom>
-          <a:noFill xmlns:a="http://schemas.openxmlformats.org/drawingml/2006/main"/>
-          <a:ln xmlns:a="http://schemas.openxmlformats.org/drawingml/2006/main">
-            <a:noFill/>
-          </a:ln>
-        </p:spPr>
-        <p:txBody>
-          <a:bodyPr xmlns:a="http://schemas.openxmlformats.org/drawingml/2006/main" spcFirstLastPara="1" wrap="square" lIns="0" tIns="0" rIns="0" bIns="0" anchor="t">
-            <a:noAutofit/>
-          </a:bodyPr>
-          <a:lstStyle xmlns:a="http://schemas.openxmlformats.org/drawingml/2006/main">
-            <a:defPPr>
-              <a:defRPr sz="1300"/>
-            </a:defPPr>
-            <a:lvl1pPr>
-              <a:defRPr sz="1300"/>
-            </a:lvl1pPr>
-            <a:lvl2pPr>
-              <a:defRPr sz="1300"/>
-            </a:lvl2pPr>
-            <a:lvl3pPr>
-              <a:defRPr sz="1300"/>
-            </a:lvl3pPr>
-            <a:lvl4pPr>
-              <a:defRPr sz="1300"/>
-            </a:lvl4pPr>
-            <a:lvl5pPr>
-              <a:defRPr sz="1300"/>
-            </a:lvl5pPr>
-            <a:lvl6pPr>
-              <a:defRPr sz="1300"/>
-            </a:lvl6pPr>
-            <a:lvl7pPr>
-              <a:defRPr sz="1300"/>
-            </a:lvl7pPr>
-            <a:lvl8pPr>
-              <a:defRPr sz="1300"/>
-            </a:lvl8pPr>
-            <a:lvl9pPr>
-              <a:defRPr sz="1300"/>
-            </a:lvl9pPr>
-          </a:lstStyle>
-          <a:p xmlns:a="http://schemas.openxmlformats.org/drawingml/2006/main">
-            <a:pPr marL="0" marR="0" lvl="0" indent="0" algn="l">
-              <a:spcBef>
-                <a:spcPts val="0"/>
-              </a:spcBef>
-              <a:spcAft>
-                <a:spcPts val="0"/>
-              </a:spcAft>
-              <a:buNone/>
-              <a:defRPr sz="1300"/>
-            </a:pPr>
-            <a:r>
-              <a:rPr sz="1300" b="1">
-                <a:solidFill>
-                  <a:srgbClr val="203B34"/>
-                </a:solidFill>
-                <a:latin typeface="Manrope"/>
-                <a:ea typeface="Manrope"/>
-                <a:cs typeface="Manrope"/>
-              </a:rPr>
-              <a:t>EARLIER FIX: FILE-START CHECK</a:t>
-            </a:r>
-            <a:endParaRPr sz="1200" b="1">
-              <a:solidFill>
-                <a:srgbClr val="203B34"/>
-              </a:solidFill>
-              <a:latin typeface="Manrope"/>
-              <a:ea typeface="Manrope"/>
-              <a:cs typeface="Manrope"/>
-            </a:endParaRPr>
-          </a:p>
-        </p:txBody>
-      </p:sp>
-      <p:sp>
-        <p:nvSpPr>
-          <p:cNvPr id="49" name="Google Shape;49;p9">
-            <a:extLst xmlns:a="http://schemas.openxmlformats.org/drawingml/2006/main">
-              <a:ext uri="{FF2B5EF4-FFF2-40B4-BE49-F238E27FC236}">
-                <a16:creationId xmlns:a16="http://schemas.microsoft.com/office/drawing/2014/main" id="{18971D54-D8AE-49CB-9CEC-FA517F7E60AA}"/>
-              </a:ext>
-            </a:extLst>
-          </p:cNvPr>
-          <p:cNvSpPr>
-            <a:spLocks xmlns:a="http://schemas.openxmlformats.org/drawingml/2006/main" noGrp="1"/>
-          </p:cNvSpPr>
-          <p:nvPr/>
-        </p:nvSpPr>
-        <p:spPr>
-          <a:xfrm xmlns:a="http://schemas.openxmlformats.org/drawingml/2006/main">
-            <a:off x="609600" y="2257425"/>
-            <a:ext cx="10972800" cy="876300"/>
-          </a:xfrm>
-          <a:prstGeom xmlns:a="http://schemas.openxmlformats.org/drawingml/2006/main" prst="rect">
-            <a:avLst/>
-          </a:prstGeom>
-          <a:noFill xmlns:a="http://schemas.openxmlformats.org/drawingml/2006/main"/>
-          <a:ln xmlns:a="http://schemas.openxmlformats.org/drawingml/2006/main">
-            <a:noFill/>
-          </a:ln>
-        </p:spPr>
-        <p:txBody>
-          <a:bodyPr xmlns:a="http://schemas.openxmlformats.org/drawingml/2006/main" spcFirstLastPara="1" wrap="square" lIns="0" tIns="0" rIns="0" bIns="0" anchor="t">
-            <a:noAutofit/>
-          </a:bodyPr>
-          <a:lstStyle xmlns:a="http://schemas.openxmlformats.org/drawingml/2006/main">
-            <a:defPPr>
-              <a:defRPr sz="4800">
-                <a:solidFill>
-                  <a:srgbClr val="F0E8D9"/>
-                </a:solidFill>
-                <a:latin typeface="Roboto Mono"/>
-                <a:ea typeface="Roboto Mono"/>
-                <a:cs typeface="Roboto Mono"/>
-              </a:defRPr>
-            </a:defPPr>
-            <a:lvl1pPr>
-              <a:defRPr sz="4800">
-                <a:solidFill>
-                  <a:srgbClr val="F0E8D9"/>
-                </a:solidFill>
-                <a:latin typeface="Roboto Mono"/>
-                <a:ea typeface="Roboto Mono"/>
-                <a:cs typeface="Roboto Mono"/>
-              </a:defRPr>
-            </a:lvl1pPr>
-            <a:lvl2pPr>
-              <a:defRPr sz="4800">
-                <a:solidFill>
-                  <a:srgbClr val="F0E8D9"/>
-                </a:solidFill>
-                <a:latin typeface="Roboto Mono"/>
-                <a:ea typeface="Roboto Mono"/>
-                <a:cs typeface="Roboto Mono"/>
-              </a:defRPr>
-            </a:lvl2pPr>
-            <a:lvl3pPr>
-              <a:defRPr sz="4800">
-                <a:solidFill>
-                  <a:srgbClr val="F0E8D9"/>
-                </a:solidFill>
-                <a:latin typeface="Roboto Mono"/>
-                <a:ea typeface="Roboto Mono"/>
-                <a:cs typeface="Roboto Mono"/>
-              </a:defRPr>
-            </a:lvl3pPr>
-            <a:lvl4pPr>
-              <a:defRPr sz="4800">
-                <a:solidFill>
-                  <a:srgbClr val="F0E8D9"/>
-                </a:solidFill>
-                <a:latin typeface="Roboto Mono"/>
-                <a:ea typeface="Roboto Mono"/>
-                <a:cs typeface="Roboto Mono"/>
-              </a:defRPr>
-            </a:lvl4pPr>
-            <a:lvl5pPr>
-              <a:defRPr sz="4800">
-                <a:solidFill>
-                  <a:srgbClr val="F0E8D9"/>
-                </a:solidFill>
-                <a:latin typeface="Roboto Mono"/>
-                <a:ea typeface="Roboto Mono"/>
-                <a:cs typeface="Roboto Mono"/>
-              </a:defRPr>
-            </a:lvl5pPr>
-            <a:lvl6pPr>
-              <a:defRPr sz="4800">
-                <a:solidFill>
-                  <a:srgbClr val="F0E8D9"/>
-                </a:solidFill>
-                <a:latin typeface="Roboto Mono"/>
-                <a:ea typeface="Roboto Mono"/>
-                <a:cs typeface="Roboto Mono"/>
-              </a:defRPr>
-            </a:lvl6pPr>
-            <a:lvl7pPr>
-              <a:defRPr sz="4800">
-                <a:solidFill>
-                  <a:srgbClr val="F0E8D9"/>
-                </a:solidFill>
-                <a:latin typeface="Roboto Mono"/>
-                <a:ea typeface="Roboto Mono"/>
-                <a:cs typeface="Roboto Mono"/>
-              </a:defRPr>
-            </a:lvl7pPr>
-            <a:lvl8pPr>
-              <a:defRPr sz="4800">
-                <a:solidFill>
-                  <a:srgbClr val="F0E8D9"/>
-                </a:solidFill>
-                <a:latin typeface="Roboto Mono"/>
-                <a:ea typeface="Roboto Mono"/>
-                <a:cs typeface="Roboto Mono"/>
-              </a:defRPr>
-            </a:lvl8pPr>
-            <a:lvl9pPr>
-              <a:defRPr sz="4800">
-                <a:solidFill>
-                  <a:srgbClr val="F0E8D9"/>
-                </a:solidFill>
-                <a:latin typeface="Roboto Mono"/>
-                <a:ea typeface="Roboto Mono"/>
-                <a:cs typeface="Roboto Mono"/>
-              </a:defRPr>
-            </a:lvl9pPr>
-          </a:lstStyle>
-          <a:p xmlns:a="http://schemas.openxmlformats.org/drawingml/2006/main">
-            <a:pPr marL="0" marR="0" lvl="0" indent="0" algn="l">
-              <a:spcBef>
-                <a:spcPts val="0"/>
-              </a:spcBef>
-              <a:spcAft>
-                <a:spcPts val="0"/>
-              </a:spcAft>
-              <a:buNone/>
-              <a:defRPr sz="4800">
-                <a:solidFill>
-                  <a:srgbClr val="F0E8D9"/>
-                </a:solidFill>
-                <a:latin typeface="Roboto Mono"/>
-                <a:ea typeface="Roboto Mono"/>
-                <a:cs typeface="Roboto Mono"/>
-              </a:defRPr>
-            </a:pPr>
-            <a:r>
-              <a:rPr sz="4800">
-                <a:solidFill>
-                  <a:srgbClr val="D99575"/>
-                </a:solidFill>
-                <a:latin typeface="Roboto Mono"/>
-                <a:ea typeface="Roboto Mono"/>
-                <a:cs typeface="Roboto Mono"/>
-              </a:rPr>
-              <a:t>x</a:t>
-            </a:r>
-            <a:r>
-              <a:rPr sz="4800">
-                <a:solidFill>
-                  <a:srgbClr val="F0E8D9"/>
-                </a:solidFill>
-                <a:latin typeface="Roboto Mono"/>
-                <a:ea typeface="Roboto Mono"/>
-                <a:cs typeface="Roboto Mono"/>
-              </a:rPr>
-              <a:t>/bin/env python</a:t>
-            </a:r>
-            <a:endParaRPr sz="4800">
-              <a:solidFill>
-                <a:srgbClr val="F0E8D9"/>
-              </a:solidFill>
-              <a:latin typeface="Roboto Mono"/>
-              <a:ea typeface="Roboto Mono"/>
-              <a:cs typeface="Roboto Mono"/>
-            </a:endParaRPr>
-          </a:p>
-        </p:txBody>
-      </p:sp>
-      <p:sp>
-        <p:nvSpPr>
-          <p:cNvPr id="50" name="Google Shape;50;p9">
-            <a:extLst xmlns:a="http://schemas.openxmlformats.org/drawingml/2006/main">
-              <a:ext uri="{FF2B5EF4-FFF2-40B4-BE49-F238E27FC236}">
-                <a16:creationId xmlns:a16="http://schemas.microsoft.com/office/drawing/2014/main" id="{11EF46E8-D964-43AC-9470-80C28F10DA9E}"/>
-              </a:ext>
-            </a:extLst>
-          </p:cNvPr>
-          <p:cNvSpPr>
-            <a:spLocks xmlns:a="http://schemas.openxmlformats.org/drawingml/2006/main" noGrp="1"/>
-          </p:cNvSpPr>
-          <p:nvPr/>
-        </p:nvSpPr>
-        <p:spPr>
-          <a:xfrm xmlns:a="http://schemas.openxmlformats.org/drawingml/2006/main">
-            <a:off x="609600" y="4673600"/>
-            <a:ext cx="5334000" cy="838200"/>
-          </a:xfrm>
-          <a:prstGeom xmlns:a="http://schemas.openxmlformats.org/drawingml/2006/main" prst="rect">
-            <a:avLst/>
-          </a:prstGeom>
-          <a:noFill xmlns:a="http://schemas.openxmlformats.org/drawingml/2006/main"/>
-          <a:ln xmlns:a="http://schemas.openxmlformats.org/drawingml/2006/main">
-            <a:noFill/>
-          </a:ln>
-        </p:spPr>
-        <p:txBody>
-          <a:bodyPr xmlns:a="http://schemas.openxmlformats.org/drawingml/2006/main" spcFirstLastPara="1" wrap="square" lIns="0" tIns="0" rIns="0" bIns="0" anchor="t">
-            <a:noAutofit/>
-          </a:bodyPr>
-          <a:lstStyle xmlns:a="http://schemas.openxmlformats.org/drawingml/2006/main">
-            <a:defPPr>
-              <a:defRPr sz="1900">
-                <a:latin typeface="Manrope"/>
-                <a:ea typeface="Manrope"/>
-                <a:cs typeface="Manrope"/>
-              </a:defRPr>
-            </a:defPPr>
-            <a:lvl1pPr>
-              <a:defRPr sz="1900">
-                <a:latin typeface="Manrope"/>
-                <a:ea typeface="Manrope"/>
-                <a:cs typeface="Manrope"/>
-              </a:defRPr>
-            </a:lvl1pPr>
-            <a:lvl2pPr>
-              <a:defRPr sz="1900">
-                <a:latin typeface="Manrope"/>
-                <a:ea typeface="Manrope"/>
-                <a:cs typeface="Manrope"/>
-              </a:defRPr>
-            </a:lvl2pPr>
-            <a:lvl3pPr>
-              <a:defRPr sz="1900">
-                <a:latin typeface="Manrope"/>
-                <a:ea typeface="Manrope"/>
-                <a:cs typeface="Manrope"/>
-              </a:defRPr>
-            </a:lvl3pPr>
-            <a:lvl4pPr>
-              <a:defRPr sz="1900">
-                <a:latin typeface="Manrope"/>
-                <a:ea typeface="Manrope"/>
-                <a:cs typeface="Manrope"/>
-              </a:defRPr>
-            </a:lvl4pPr>
-            <a:lvl5pPr>
-              <a:defRPr sz="1900">
-                <a:latin typeface="Manrope"/>
-                <a:ea typeface="Manrope"/>
-                <a:cs typeface="Manrope"/>
-              </a:defRPr>
-            </a:lvl5pPr>
-            <a:lvl6pPr>
-              <a:defRPr sz="1900">
-                <a:latin typeface="Manrope"/>
-                <a:ea typeface="Manrope"/>
-                <a:cs typeface="Manrope"/>
-              </a:defRPr>
-            </a:lvl6pPr>
-            <a:lvl7pPr>
-              <a:defRPr sz="1900">
-                <a:latin typeface="Manrope"/>
-                <a:ea typeface="Manrope"/>
-                <a:cs typeface="Manrope"/>
-              </a:defRPr>
-            </a:lvl7pPr>
-            <a:lvl8pPr>
-              <a:defRPr sz="1900">
-                <a:latin typeface="Manrope"/>
-                <a:ea typeface="Manrope"/>
-                <a:cs typeface="Manrope"/>
-              </a:defRPr>
-            </a:lvl8pPr>
-            <a:lvl9pPr>
-              <a:defRPr sz="1900">
-                <a:latin typeface="Manrope"/>
-                <a:ea typeface="Manrope"/>
-                <a:cs typeface="Manrope"/>
-              </a:defRPr>
-            </a:lvl9pPr>
-          </a:lstStyle>
-          <a:p xmlns:a="http://schemas.openxmlformats.org/drawingml/2006/main">
-            <a:pPr marL="0" marR="0" lvl="0" indent="0" algn="l">
-              <a:spcBef>
-                <a:spcPts val="0"/>
-              </a:spcBef>
-              <a:spcAft>
-                <a:spcPts val="0"/>
-              </a:spcAft>
-              <a:buNone/>
-              <a:defRPr sz="1900">
-                <a:latin typeface="Manrope"/>
-                <a:ea typeface="Manrope"/>
-                <a:cs typeface="Manrope"/>
-              </a:defRPr>
-            </a:pPr>
-            <a:r>
-              <a:rPr sz="1900">
-                <a:solidFill>
-                  <a:srgbClr val="203B34"/>
-                </a:solidFill>
-                <a:latin typeface="Manrope"/>
-                <a:ea typeface="Manrope"/>
-                <a:cs typeface="Manrope"/>
-              </a:rPr>
-              <a:t>Matches the text after x</a:t>
-            </a:r>
-            <a:endParaRPr sz="1900">
-              <a:solidFill>
-                <a:srgbClr val="203B34"/>
-              </a:solidFill>
-              <a:latin typeface="Roboto Mono"/>
-              <a:ea typeface="Roboto Mono"/>
-              <a:cs typeface="Roboto Mono"/>
-            </a:endParaRPr>
-          </a:p>
-          <a:p xmlns:a="http://schemas.openxmlformats.org/drawingml/2006/main">
-            <a:pPr marL="0" marR="0" lvl="0" indent="0" algn="l">
-              <a:spcBef>
-                <a:spcPts val="0"/>
-              </a:spcBef>
-              <a:spcAft>
-                <a:spcPts val="0"/>
-              </a:spcAft>
-              <a:buNone/>
-              <a:defRPr sz="1900">
-                <a:latin typeface="Manrope"/>
-                <a:ea typeface="Manrope"/>
-                <a:cs typeface="Manrope"/>
-              </a:defRPr>
-            </a:pPr>
-            <a:r>
-              <a:rPr sz="1900">
-                <a:solidFill>
-                  <a:srgbClr val="203B34"/>
-                </a:solidFill>
-                <a:latin typeface="Manrope"/>
-                <a:ea typeface="Manrope"/>
-                <a:cs typeface="Manrope"/>
-              </a:rPr>
-              <a:t>Mistakes ordinary text for Python</a:t>
-            </a:r>
-            <a:endParaRPr sz="1900">
-              <a:solidFill>
-                <a:srgbClr val="203B34"/>
-              </a:solidFill>
-              <a:latin typeface="Roboto Mono"/>
-              <a:ea typeface="Roboto Mono"/>
-              <a:cs typeface="Roboto Mono"/>
-            </a:endParaRPr>
-          </a:p>
-        </p:txBody>
-      </p:sp>
-      <p:sp>
-        <p:nvSpPr>
-          <p:cNvPr id="51" name="Google Shape;51;p9">
-            <a:extLst xmlns:a="http://schemas.openxmlformats.org/drawingml/2006/main">
-              <a:ext uri="{FF2B5EF4-FFF2-40B4-BE49-F238E27FC236}">
-                <a16:creationId xmlns:a16="http://schemas.microsoft.com/office/drawing/2014/main" id="{5D9793FC-D20C-4A75-99E4-D049FB147C61}"/>
-              </a:ext>
-            </a:extLst>
-          </p:cNvPr>
-          <p:cNvSpPr>
-            <a:spLocks xmlns:a="http://schemas.openxmlformats.org/drawingml/2006/main" noGrp="1"/>
-          </p:cNvSpPr>
-          <p:nvPr/>
-        </p:nvSpPr>
-        <p:spPr>
-          <a:xfrm xmlns:a="http://schemas.openxmlformats.org/drawingml/2006/main">
-            <a:off x="6604000" y="4673600"/>
-            <a:ext cx="4978500" cy="838200"/>
-          </a:xfrm>
-          <a:prstGeom xmlns:a="http://schemas.openxmlformats.org/drawingml/2006/main" prst="rect">
-            <a:avLst/>
-          </a:prstGeom>
-          <a:noFill xmlns:a="http://schemas.openxmlformats.org/drawingml/2006/main"/>
-          <a:ln xmlns:a="http://schemas.openxmlformats.org/drawingml/2006/main">
-            <a:noFill/>
-          </a:ln>
-        </p:spPr>
-        <p:txBody>
-          <a:bodyPr xmlns:a="http://schemas.openxmlformats.org/drawingml/2006/main" spcFirstLastPara="1" wrap="square" lIns="0" tIns="0" rIns="0" bIns="0" anchor="t">
-            <a:noAutofit/>
-          </a:bodyPr>
-          <a:lstStyle xmlns:a="http://schemas.openxmlformats.org/drawingml/2006/main">
-            <a:defPPr>
-              <a:defRPr sz="1900">
-                <a:latin typeface="Manrope"/>
-                <a:ea typeface="Manrope"/>
-                <a:cs typeface="Manrope"/>
-              </a:defRPr>
-            </a:defPPr>
-            <a:lvl1pPr>
-              <a:defRPr sz="1900">
-                <a:latin typeface="Manrope"/>
-                <a:ea typeface="Manrope"/>
-                <a:cs typeface="Manrope"/>
-              </a:defRPr>
-            </a:lvl1pPr>
-            <a:lvl2pPr>
-              <a:defRPr sz="1900">
-                <a:latin typeface="Manrope"/>
-                <a:ea typeface="Manrope"/>
-                <a:cs typeface="Manrope"/>
-              </a:defRPr>
-            </a:lvl2pPr>
-            <a:lvl3pPr>
-              <a:defRPr sz="1900">
-                <a:latin typeface="Manrope"/>
-                <a:ea typeface="Manrope"/>
-                <a:cs typeface="Manrope"/>
-              </a:defRPr>
-            </a:lvl3pPr>
-            <a:lvl4pPr>
-              <a:defRPr sz="1900">
-                <a:latin typeface="Manrope"/>
-                <a:ea typeface="Manrope"/>
-                <a:cs typeface="Manrope"/>
-              </a:defRPr>
-            </a:lvl4pPr>
-            <a:lvl5pPr>
-              <a:defRPr sz="1900">
-                <a:latin typeface="Manrope"/>
-                <a:ea typeface="Manrope"/>
-                <a:cs typeface="Manrope"/>
-              </a:defRPr>
-            </a:lvl5pPr>
-            <a:lvl6pPr>
-              <a:defRPr sz="1900">
-                <a:latin typeface="Manrope"/>
-                <a:ea typeface="Manrope"/>
-                <a:cs typeface="Manrope"/>
-              </a:defRPr>
-            </a:lvl6pPr>
-            <a:lvl7pPr>
-              <a:defRPr sz="1900">
-                <a:latin typeface="Manrope"/>
-                <a:ea typeface="Manrope"/>
-                <a:cs typeface="Manrope"/>
-              </a:defRPr>
-            </a:lvl7pPr>
-            <a:lvl8pPr>
-              <a:defRPr sz="1900">
-                <a:latin typeface="Manrope"/>
-                <a:ea typeface="Manrope"/>
-                <a:cs typeface="Manrope"/>
-              </a:defRPr>
-            </a:lvl8pPr>
-            <a:lvl9pPr>
-              <a:defRPr sz="1900">
-                <a:latin typeface="Manrope"/>
-                <a:ea typeface="Manrope"/>
-                <a:cs typeface="Manrope"/>
-              </a:defRPr>
-            </a:lvl9pPr>
-          </a:lstStyle>
-          <a:p xmlns:a="http://schemas.openxmlformats.org/drawingml/2006/main">
-            <a:pPr marL="0" marR="0" lvl="0" indent="0" algn="l">
-              <a:spcBef>
-                <a:spcPts val="0"/>
-              </a:spcBef>
-              <a:spcAft>
-                <a:spcPts val="0"/>
-              </a:spcAft>
-              <a:buNone/>
-              <a:defRPr sz="1900">
-                <a:latin typeface="Manrope"/>
-                <a:ea typeface="Manrope"/>
-                <a:cs typeface="Manrope"/>
-              </a:defRPr>
-            </a:pPr>
-            <a:r>
-              <a:rPr sz="1900">
-                <a:solidFill>
-                  <a:srgbClr val="203B34"/>
-                </a:solidFill>
-                <a:latin typeface="Manrope"/>
-                <a:ea typeface="Manrope"/>
-                <a:cs typeface="Manrope"/>
-              </a:rPr>
-              <a:t>No #! prefix at the start</a:t>
-            </a:r>
-            <a:endParaRPr sz="2200">
-              <a:solidFill>
-                <a:srgbClr val="203B34"/>
-              </a:solidFill>
-              <a:latin typeface="Roboto Mono"/>
-              <a:ea typeface="Roboto Mono"/>
-              <a:cs typeface="Roboto Mono"/>
-            </a:endParaRPr>
-          </a:p>
-          <a:p xmlns:a="http://schemas.openxmlformats.org/drawingml/2006/main">
-            <a:pPr marL="0" marR="0" lvl="0" indent="0" algn="l">
-              <a:spcBef>
-                <a:spcPts val="0"/>
-              </a:spcBef>
-              <a:spcAft>
-                <a:spcPts val="0"/>
-              </a:spcAft>
-              <a:buNone/>
-              <a:defRPr sz="1900">
-                <a:latin typeface="Manrope"/>
-                <a:ea typeface="Manrope"/>
-                <a:cs typeface="Manrope"/>
-              </a:defRPr>
-            </a:pPr>
-            <a:r>
-              <a:rPr sz="1900">
-                <a:solidFill>
-                  <a:srgbClr val="203B34"/>
-                </a:solidFill>
-                <a:latin typeface="Manrope"/>
-                <a:ea typeface="Manrope"/>
-                <a:cs typeface="Manrope"/>
-              </a:rPr>
-              <a:t>The Python rule does not match</a:t>
-            </a:r>
-            <a:endParaRPr sz="2200">
-              <a:solidFill>
-                <a:srgbClr val="203B34"/>
-              </a:solidFill>
-              <a:latin typeface="Roboto Mono"/>
-              <a:ea typeface="Roboto Mono"/>
-              <a:cs typeface="Roboto Mono"/>
-            </a:endParaRPr>
-          </a:p>
-        </p:txBody>
-      </p:sp>
-      <p:sp>
-        <p:nvSpPr>
-          <p:cNvPr id="52" name="Google Shape;52;p9">
-            <a:extLst xmlns:a="http://schemas.openxmlformats.org/drawingml/2006/main">
-              <a:ext uri="{FF2B5EF4-FFF2-40B4-BE49-F238E27FC236}">
-                <a16:creationId xmlns:a16="http://schemas.microsoft.com/office/drawing/2014/main" id="{144C3DDD-C040-4974-89DF-3E832254EF11}"/>
-              </a:ext>
-            </a:extLst>
-          </p:cNvPr>
-          <p:cNvSpPr>
-            <a:spLocks xmlns:a="http://schemas.openxmlformats.org/drawingml/2006/main" noGrp="1"/>
-          </p:cNvSpPr>
-          <p:nvPr/>
-        </p:nvSpPr>
-        <p:spPr>
-          <a:xfrm xmlns:a="http://schemas.openxmlformats.org/drawingml/2006/main">
-            <a:off x="6604000" y="5562600"/>
-            <a:ext cx="4978500" cy="558900"/>
-          </a:xfrm>
-          <a:prstGeom xmlns:a="http://schemas.openxmlformats.org/drawingml/2006/main" prst="rect">
-            <a:avLst/>
-          </a:prstGeom>
-          <a:noFill xmlns:a="http://schemas.openxmlformats.org/drawingml/2006/main"/>
-          <a:ln xmlns:a="http://schemas.openxmlformats.org/drawingml/2006/main">
-            <a:noFill/>
-          </a:ln>
-        </p:spPr>
-        <p:txBody>
-          <a:bodyPr xmlns:a="http://schemas.openxmlformats.org/drawingml/2006/main" spcFirstLastPara="1" wrap="square" lIns="0" tIns="0" rIns="0" bIns="0" anchor="t">
-            <a:noAutofit/>
-          </a:bodyPr>
-          <a:lstStyle xmlns:a="http://schemas.openxmlformats.org/drawingml/2006/main">
-            <a:defPPr>
-              <a:defRPr sz="2400" b="1">
-                <a:latin typeface="Roboto Mono"/>
-                <a:ea typeface="Roboto Mono"/>
-                <a:cs typeface="Roboto Mono"/>
-              </a:defRPr>
-            </a:defPPr>
-            <a:lvl1pPr>
-              <a:defRPr sz="2400" b="1">
-                <a:latin typeface="Roboto Mono"/>
-                <a:ea typeface="Roboto Mono"/>
-                <a:cs typeface="Roboto Mono"/>
-              </a:defRPr>
-            </a:lvl1pPr>
-            <a:lvl2pPr>
-              <a:defRPr sz="2400" b="1">
-                <a:latin typeface="Roboto Mono"/>
-                <a:ea typeface="Roboto Mono"/>
-                <a:cs typeface="Roboto Mono"/>
-              </a:defRPr>
-            </a:lvl2pPr>
-            <a:lvl3pPr>
-              <a:defRPr sz="2400" b="1">
-                <a:latin typeface="Roboto Mono"/>
-                <a:ea typeface="Roboto Mono"/>
-                <a:cs typeface="Roboto Mono"/>
-              </a:defRPr>
-            </a:lvl3pPr>
-            <a:lvl4pPr>
-              <a:defRPr sz="2400" b="1">
-                <a:latin typeface="Roboto Mono"/>
-                <a:ea typeface="Roboto Mono"/>
-                <a:cs typeface="Roboto Mono"/>
-              </a:defRPr>
-            </a:lvl4pPr>
-            <a:lvl5pPr>
-              <a:defRPr sz="2400" b="1">
-                <a:latin typeface="Roboto Mono"/>
-                <a:ea typeface="Roboto Mono"/>
-                <a:cs typeface="Roboto Mono"/>
-              </a:defRPr>
-            </a:lvl5pPr>
-            <a:lvl6pPr>
-              <a:defRPr sz="2400" b="1">
-                <a:latin typeface="Roboto Mono"/>
-                <a:ea typeface="Roboto Mono"/>
-                <a:cs typeface="Roboto Mono"/>
-              </a:defRPr>
-            </a:lvl6pPr>
-            <a:lvl7pPr>
-              <a:defRPr sz="2400" b="1">
-                <a:latin typeface="Roboto Mono"/>
-                <a:ea typeface="Roboto Mono"/>
-                <a:cs typeface="Roboto Mono"/>
-              </a:defRPr>
-            </a:lvl7pPr>
-            <a:lvl8pPr>
-              <a:defRPr sz="2400" b="1">
-                <a:latin typeface="Roboto Mono"/>
-                <a:ea typeface="Roboto Mono"/>
-                <a:cs typeface="Roboto Mono"/>
-              </a:defRPr>
-            </a:lvl8pPr>
-            <a:lvl9pPr>
-              <a:defRPr sz="2400" b="1">
-                <a:latin typeface="Roboto Mono"/>
-                <a:ea typeface="Roboto Mono"/>
-                <a:cs typeface="Roboto Mono"/>
-              </a:defRPr>
-            </a:lvl9pPr>
-          </a:lstStyle>
-          <a:p xmlns:a="http://schemas.openxmlformats.org/drawingml/2006/main">
-            <a:pPr marL="0" marR="0" lvl="0" indent="0" algn="l">
-              <a:spcBef>
-                <a:spcPts val="0"/>
-              </a:spcBef>
-              <a:spcAft>
-                <a:spcPts val="0"/>
-              </a:spcAft>
-              <a:buNone/>
-              <a:defRPr sz="2400" b="1">
-                <a:latin typeface="Roboto Mono"/>
-                <a:ea typeface="Roboto Mono"/>
-                <a:cs typeface="Roboto Mono"/>
-              </a:defRPr>
-            </a:pPr>
-            <a:r>
-              <a:rPr sz="2400" b="1">
-                <a:solidFill>
-                  <a:srgbClr val="203B34"/>
-                </a:solidFill>
-                <a:latin typeface="Roboto Mono"/>
-                <a:ea typeface="Roboto Mono"/>
-                <a:cs typeface="Roboto Mono"/>
-              </a:rPr>
-              <a:t>text/plain</a:t>
-            </a:r>
-            <a:endParaRPr sz="2600" b="1">
-              <a:solidFill>
-                <a:srgbClr val="203B34"/>
-              </a:solidFill>
-              <a:latin typeface="Roboto Mono"/>
-              <a:ea typeface="Roboto Mono"/>
-              <a:cs typeface="Roboto Mono"/>
-            </a:endParaRPr>
-          </a:p>
-        </p:txBody>
-      </p:sp>
-      <p:sp>
-        <p:nvSpPr>
-          <p:cNvPr id="53" name="Google Shape;53;p9">
-            <a:extLst xmlns:a="http://schemas.openxmlformats.org/drawingml/2006/main">
-              <a:ext uri="{FF2B5EF4-FFF2-40B4-BE49-F238E27FC236}">
-                <a16:creationId xmlns:a16="http://schemas.microsoft.com/office/drawing/2014/main" id="{891A0147-F0A1-4ABB-A43C-E67884E61197}"/>
-              </a:ext>
-            </a:extLst>
-          </p:cNvPr>
-          <p:cNvSpPr>
-            <a:spLocks xmlns:a="http://schemas.openxmlformats.org/drawingml/2006/main" noGrp="1"/>
-          </p:cNvSpPr>
-          <p:nvPr/>
-        </p:nvSpPr>
-        <p:spPr>
-          <a:xfrm xmlns:a="http://schemas.openxmlformats.org/drawingml/2006/main">
-            <a:off x="609600" y="5562600"/>
-            <a:ext cx="5334000" cy="558900"/>
-          </a:xfrm>
-          <a:prstGeom xmlns:a="http://schemas.openxmlformats.org/drawingml/2006/main" prst="rect">
-            <a:avLst/>
-          </a:prstGeom>
-          <a:noFill xmlns:a="http://schemas.openxmlformats.org/drawingml/2006/main"/>
-          <a:ln xmlns:a="http://schemas.openxmlformats.org/drawingml/2006/main">
-            <a:noFill/>
-          </a:ln>
-        </p:spPr>
-        <p:txBody>
-          <a:bodyPr xmlns:a="http://schemas.openxmlformats.org/drawingml/2006/main" spcFirstLastPara="1" wrap="square" lIns="0" tIns="0" rIns="0" bIns="0" anchor="t">
-            <a:noAutofit/>
-          </a:bodyPr>
-          <a:lstStyle xmlns:a="http://schemas.openxmlformats.org/drawingml/2006/main">
-            <a:defPPr>
-              <a:defRPr sz="2400" b="1">
-                <a:latin typeface="Roboto Mono"/>
-                <a:ea typeface="Roboto Mono"/>
-                <a:cs typeface="Roboto Mono"/>
-              </a:defRPr>
-            </a:defPPr>
-            <a:lvl1pPr>
-              <a:defRPr sz="2400" b="1">
-                <a:latin typeface="Roboto Mono"/>
-                <a:ea typeface="Roboto Mono"/>
-                <a:cs typeface="Roboto Mono"/>
-              </a:defRPr>
-            </a:lvl1pPr>
-            <a:lvl2pPr>
-              <a:defRPr sz="2400" b="1">
-                <a:latin typeface="Roboto Mono"/>
-                <a:ea typeface="Roboto Mono"/>
-                <a:cs typeface="Roboto Mono"/>
-              </a:defRPr>
-            </a:lvl2pPr>
-            <a:lvl3pPr>
-              <a:defRPr sz="2400" b="1">
-                <a:latin typeface="Roboto Mono"/>
-                <a:ea typeface="Roboto Mono"/>
-                <a:cs typeface="Roboto Mono"/>
-              </a:defRPr>
-            </a:lvl3pPr>
-            <a:lvl4pPr>
-              <a:defRPr sz="2400" b="1">
-                <a:latin typeface="Roboto Mono"/>
-                <a:ea typeface="Roboto Mono"/>
-                <a:cs typeface="Roboto Mono"/>
-              </a:defRPr>
-            </a:lvl4pPr>
-            <a:lvl5pPr>
-              <a:defRPr sz="2400" b="1">
-                <a:latin typeface="Roboto Mono"/>
-                <a:ea typeface="Roboto Mono"/>
-                <a:cs typeface="Roboto Mono"/>
-              </a:defRPr>
-            </a:lvl5pPr>
-            <a:lvl6pPr>
-              <a:defRPr sz="2400" b="1">
-                <a:latin typeface="Roboto Mono"/>
-                <a:ea typeface="Roboto Mono"/>
-                <a:cs typeface="Roboto Mono"/>
-              </a:defRPr>
-            </a:lvl6pPr>
-            <a:lvl7pPr>
-              <a:defRPr sz="2400" b="1">
-                <a:latin typeface="Roboto Mono"/>
-                <a:ea typeface="Roboto Mono"/>
-                <a:cs typeface="Roboto Mono"/>
-              </a:defRPr>
-            </a:lvl7pPr>
-            <a:lvl8pPr>
-              <a:defRPr sz="2400" b="1">
-                <a:latin typeface="Roboto Mono"/>
-                <a:ea typeface="Roboto Mono"/>
-                <a:cs typeface="Roboto Mono"/>
-              </a:defRPr>
-            </a:lvl8pPr>
-            <a:lvl9pPr>
-              <a:defRPr sz="2400" b="1">
-                <a:latin typeface="Roboto Mono"/>
-                <a:ea typeface="Roboto Mono"/>
-                <a:cs typeface="Roboto Mono"/>
-              </a:defRPr>
-            </a:lvl9pPr>
-          </a:lstStyle>
-          <a:p xmlns:a="http://schemas.openxmlformats.org/drawingml/2006/main">
-            <a:pPr marL="0" marR="0" lvl="0" indent="0" algn="l">
-              <a:spcBef>
-                <a:spcPts val="0"/>
-              </a:spcBef>
-              <a:spcAft>
-                <a:spcPts val="0"/>
-              </a:spcAft>
-              <a:buNone/>
-              <a:defRPr sz="2400" b="1">
-                <a:latin typeface="Roboto Mono"/>
-                <a:ea typeface="Roboto Mono"/>
-                <a:cs typeface="Roboto Mono"/>
-              </a:defRPr>
-            </a:pPr>
-            <a:r>
-              <a:rPr sz="2400" b="1">
-                <a:solidFill>
-                  <a:srgbClr val="A14F37"/>
-                </a:solidFill>
-                <a:latin typeface="Roboto Mono"/>
-                <a:ea typeface="Roboto Mono"/>
-                <a:cs typeface="Roboto Mono"/>
-              </a:rPr>
-              <a:t>text/x-python</a:t>
-            </a:r>
-            <a:endParaRPr sz="2600" b="1">
-              <a:solidFill>
-                <a:srgbClr val="A14F37"/>
-              </a:solidFill>
-              <a:latin typeface="Roboto Mono"/>
-              <a:ea typeface="Roboto Mono"/>
-              <a:cs typeface="Roboto Mono"/>
-            </a:endParaRPr>
-          </a:p>
-        </p:txBody>
-      </p:sp>
-      <p:sp>
-        <p:nvSpPr>
-          <p:cNvPr id="54" name="Google Shape;54;p9">
-            <a:extLst xmlns:a="http://schemas.openxmlformats.org/drawingml/2006/main">
-              <a:ext uri="{FF2B5EF4-FFF2-40B4-BE49-F238E27FC236}">
-                <a16:creationId xmlns:a16="http://schemas.microsoft.com/office/drawing/2014/main" id="{2C6D2F51-FA40-42D0-B0E3-CE24DABECCF3}"/>
-              </a:ext>
-            </a:extLst>
-          </p:cNvPr>
-          <p:cNvSpPr>
-            <a:spLocks xmlns:a="http://schemas.openxmlformats.org/drawingml/2006/main" noGrp="1"/>
-          </p:cNvSpPr>
-          <p:nvPr/>
-        </p:nvSpPr>
-        <p:spPr>
-          <a:xfrm xmlns:a="http://schemas.openxmlformats.org/drawingml/2006/main">
-            <a:off x="609600" y="3267075"/>
-            <a:ext cx="10972800" cy="419100"/>
-          </a:xfrm>
-          <a:prstGeom xmlns:a="http://schemas.openxmlformats.org/drawingml/2006/main" prst="rect">
-            <a:avLst/>
-          </a:prstGeom>
-          <a:noFill xmlns:a="http://schemas.openxmlformats.org/drawingml/2006/main"/>
-          <a:ln xmlns:a="http://schemas.openxmlformats.org/drawingml/2006/main">
-            <a:noFill/>
-          </a:ln>
-        </p:spPr>
-        <p:txBody>
-          <a:bodyPr xmlns:a="http://schemas.openxmlformats.org/drawingml/2006/main" spcFirstLastPara="1" wrap="square" lIns="0" tIns="0" rIns="0" bIns="0" anchor="t">
-            <a:noAutofit/>
-          </a:bodyPr>
-          <a:lstStyle xmlns:a="http://schemas.openxmlformats.org/drawingml/2006/main">
-            <a:defPPr>
-              <a:defRPr sz="1900">
-                <a:solidFill>
-                  <a:srgbClr val="B8C7AB"/>
-                </a:solidFill>
-                <a:latin typeface="Manrope"/>
-                <a:ea typeface="Manrope"/>
-                <a:cs typeface="Manrope"/>
-              </a:defRPr>
-            </a:defPPr>
-            <a:lvl1pPr>
-              <a:defRPr sz="1900">
-                <a:solidFill>
-                  <a:srgbClr val="B8C7AB"/>
-                </a:solidFill>
-                <a:latin typeface="Manrope"/>
-                <a:ea typeface="Manrope"/>
-                <a:cs typeface="Manrope"/>
-              </a:defRPr>
-            </a:lvl1pPr>
-            <a:lvl2pPr>
-              <a:defRPr sz="1900">
-                <a:solidFill>
-                  <a:srgbClr val="B8C7AB"/>
-                </a:solidFill>
-                <a:latin typeface="Manrope"/>
-                <a:ea typeface="Manrope"/>
-                <a:cs typeface="Manrope"/>
-              </a:defRPr>
-            </a:lvl2pPr>
-            <a:lvl3pPr>
-              <a:defRPr sz="1900">
-                <a:solidFill>
-                  <a:srgbClr val="B8C7AB"/>
-                </a:solidFill>
-                <a:latin typeface="Manrope"/>
-                <a:ea typeface="Manrope"/>
-                <a:cs typeface="Manrope"/>
-              </a:defRPr>
-            </a:lvl3pPr>
-            <a:lvl4pPr>
-              <a:defRPr sz="1900">
-                <a:solidFill>
-                  <a:srgbClr val="B8C7AB"/>
-                </a:solidFill>
-                <a:latin typeface="Manrope"/>
-                <a:ea typeface="Manrope"/>
-                <a:cs typeface="Manrope"/>
-              </a:defRPr>
-            </a:lvl4pPr>
-            <a:lvl5pPr>
-              <a:defRPr sz="1900">
-                <a:solidFill>
-                  <a:srgbClr val="B8C7AB"/>
-                </a:solidFill>
-                <a:latin typeface="Manrope"/>
-                <a:ea typeface="Manrope"/>
-                <a:cs typeface="Manrope"/>
-              </a:defRPr>
-            </a:lvl5pPr>
-            <a:lvl6pPr>
-              <a:defRPr sz="1900">
-                <a:solidFill>
-                  <a:srgbClr val="B8C7AB"/>
-                </a:solidFill>
-                <a:latin typeface="Manrope"/>
-                <a:ea typeface="Manrope"/>
-                <a:cs typeface="Manrope"/>
-              </a:defRPr>
-            </a:lvl6pPr>
-            <a:lvl7pPr>
-              <a:defRPr sz="1900">
-                <a:solidFill>
-                  <a:srgbClr val="B8C7AB"/>
-                </a:solidFill>
-                <a:latin typeface="Manrope"/>
-                <a:ea typeface="Manrope"/>
-                <a:cs typeface="Manrope"/>
-              </a:defRPr>
-            </a:lvl7pPr>
-            <a:lvl8pPr>
-              <a:defRPr sz="1900">
-                <a:solidFill>
-                  <a:srgbClr val="B8C7AB"/>
-                </a:solidFill>
-                <a:latin typeface="Manrope"/>
-                <a:ea typeface="Manrope"/>
-                <a:cs typeface="Manrope"/>
-              </a:defRPr>
-            </a:lvl8pPr>
-            <a:lvl9pPr>
-              <a:defRPr sz="1900">
-                <a:solidFill>
-                  <a:srgbClr val="B8C7AB"/>
-                </a:solidFill>
-                <a:latin typeface="Manrope"/>
-                <a:ea typeface="Manrope"/>
-                <a:cs typeface="Manrope"/>
-              </a:defRPr>
-            </a:lvl9pPr>
-          </a:lstStyle>
-          <a:p xmlns:a="http://schemas.openxmlformats.org/drawingml/2006/main">
-            <a:pPr marL="0" marR="0" lvl="0" indent="0" algn="l">
-              <a:spcBef>
-                <a:spcPts val="0"/>
-              </a:spcBef>
-              <a:spcAft>
-                <a:spcPts val="0"/>
-              </a:spcAft>
-              <a:buNone/>
-              <a:defRPr sz="1900">
-                <a:solidFill>
-                  <a:srgbClr val="B8C7AB"/>
-                </a:solidFill>
-                <a:latin typeface="Manrope"/>
-                <a:ea typeface="Manrope"/>
-                <a:cs typeface="Manrope"/>
-              </a:defRPr>
-            </a:pPr>
-            <a:r>
-              <a:rPr sz="1900">
-                <a:solidFill>
-                  <a:srgbClr val="B8C7AB"/>
-                </a:solidFill>
-                <a:latin typeface="Manrope"/>
-                <a:ea typeface="Manrope"/>
-                <a:cs typeface="Manrope"/>
-              </a:rPr>
-              <a:t>x is at offset 0. /bin/env python begins at offset 1.</a:t>
-            </a:r>
-            <a:endParaRPr sz="1250">
-              <a:solidFill>
-                <a:srgbClr val="203B34"/>
-              </a:solidFill>
-              <a:latin typeface="Manrope"/>
-              <a:ea typeface="Manrope"/>
-              <a:cs typeface="Manrope"/>
-            </a:endParaRPr>
-          </a:p>
-        </p:txBody>
-      </p:sp>
-      <p:sp>
-        <p:nvSpPr>
-          <p:cNvPr id="55" name="review-limit">
-            <a:extLst xmlns:a="http://schemas.openxmlformats.org/drawingml/2006/main">
-              <a:ext uri="{FF2B5EF4-FFF2-40B4-BE49-F238E27FC236}">
-                <a16:creationId xmlns:a16="http://schemas.microsoft.com/office/drawing/2014/main" id="{CB801659-53C3-4D16-A259-30A0DA7CA219}"/>
-              </a:ext>
-            </a:extLst>
-          </p:cNvPr>
-          <p:cNvSpPr>
-            <a:spLocks xmlns:a="http://schemas.openxmlformats.org/drawingml/2006/main" noGrp="1"/>
-          </p:cNvSpPr>
-          <p:nvPr/>
-        </p:nvSpPr>
-        <p:spPr>
-          <a:xfrm xmlns:a="http://schemas.openxmlformats.org/drawingml/2006/main">
-            <a:off x="609600" y="6200775"/>
-            <a:ext cx="10972800" cy="333375"/>
-          </a:xfrm>
-          <a:prstGeom xmlns:a="http://schemas.openxmlformats.org/drawingml/2006/main" prst="rect">
-            <a:avLst/>
-          </a:prstGeom>
-          <a:noFill xmlns:a="http://schemas.openxmlformats.org/drawingml/2006/main"/>
-          <a:ln xmlns:a="http://schemas.openxmlformats.org/drawingml/2006/main" w="0">
-            <a:noFill/>
-          </a:ln>
-        </p:spPr>
-        <p:txBody>
-          <a:bodyPr xmlns:a="http://schemas.openxmlformats.org/drawingml/2006/main" lIns="0" tIns="0" rIns="0" bIns="0" anchor="t">
-            <a:noAutofit/>
-          </a:bodyPr>
-          <a:lstStyle xmlns:a="http://schemas.openxmlformats.org/drawingml/2006/main">
-            <a:defPPr>
-              <a:defRPr sz="1550">
-                <a:solidFill>
-                  <a:srgbClr val="203B34"/>
-                </a:solidFill>
-                <a:latin typeface="Manrope"/>
-                <a:ea typeface="Manrope"/>
-                <a:cs typeface="Manrope"/>
-              </a:defRPr>
-            </a:defPPr>
-            <a:lvl1pPr>
-              <a:defRPr sz="1550">
-                <a:solidFill>
-                  <a:srgbClr val="203B34"/>
-                </a:solidFill>
-                <a:latin typeface="Manrope"/>
-                <a:ea typeface="Manrope"/>
-                <a:cs typeface="Manrope"/>
-              </a:defRPr>
-            </a:lvl1pPr>
-            <a:lvl2pPr>
-              <a:defRPr sz="1550">
-                <a:solidFill>
-                  <a:srgbClr val="203B34"/>
-                </a:solidFill>
-                <a:latin typeface="Manrope"/>
-                <a:ea typeface="Manrope"/>
-                <a:cs typeface="Manrope"/>
-              </a:defRPr>
-            </a:lvl2pPr>
-            <a:lvl3pPr>
-              <a:defRPr sz="1550">
-                <a:solidFill>
-                  <a:srgbClr val="203B34"/>
-                </a:solidFill>
-                <a:latin typeface="Manrope"/>
-                <a:ea typeface="Manrope"/>
-                <a:cs typeface="Manrope"/>
-              </a:defRPr>
-            </a:lvl3pPr>
-            <a:lvl4pPr>
-              <a:defRPr sz="1550">
-                <a:solidFill>
-                  <a:srgbClr val="203B34"/>
-                </a:solidFill>
-                <a:latin typeface="Manrope"/>
-                <a:ea typeface="Manrope"/>
-                <a:cs typeface="Manrope"/>
-              </a:defRPr>
-            </a:lvl4pPr>
-            <a:lvl5pPr>
-              <a:defRPr sz="1550">
-                <a:solidFill>
-                  <a:srgbClr val="203B34"/>
-                </a:solidFill>
-                <a:latin typeface="Manrope"/>
-                <a:ea typeface="Manrope"/>
-                <a:cs typeface="Manrope"/>
-              </a:defRPr>
-            </a:lvl5pPr>
-            <a:lvl6pPr>
-              <a:defRPr sz="1550">
-                <a:solidFill>
-                  <a:srgbClr val="203B34"/>
-                </a:solidFill>
-                <a:latin typeface="Manrope"/>
-                <a:ea typeface="Manrope"/>
-                <a:cs typeface="Manrope"/>
-              </a:defRPr>
-            </a:lvl6pPr>
-            <a:lvl7pPr>
-              <a:defRPr sz="1550">
-                <a:solidFill>
-                  <a:srgbClr val="203B34"/>
-                </a:solidFill>
-                <a:latin typeface="Manrope"/>
-                <a:ea typeface="Manrope"/>
-                <a:cs typeface="Manrope"/>
-              </a:defRPr>
-            </a:lvl7pPr>
-            <a:lvl8pPr>
-              <a:defRPr sz="1550">
-                <a:solidFill>
-                  <a:srgbClr val="203B34"/>
-                </a:solidFill>
-                <a:latin typeface="Manrope"/>
-                <a:ea typeface="Manrope"/>
-                <a:cs typeface="Manrope"/>
-              </a:defRPr>
-            </a:lvl8pPr>
-            <a:lvl9pPr>
-              <a:defRPr sz="1550">
-                <a:solidFill>
-                  <a:srgbClr val="203B34"/>
-                </a:solidFill>
-                <a:latin typeface="Manrope"/>
-                <a:ea typeface="Manrope"/>
-                <a:cs typeface="Manrope"/>
-              </a:defRPr>
-            </a:lvl9pPr>
-          </a:lstStyle>
-          <a:p xmlns:a="http://schemas.openxmlformats.org/drawingml/2006/main">
-            <a:pPr>
-              <a:defRPr sz="1550">
-                <a:solidFill>
-                  <a:srgbClr val="203B34"/>
-                </a:solidFill>
-                <a:latin typeface="Manrope"/>
-                <a:ea typeface="Manrope"/>
-                <a:cs typeface="Manrope"/>
-              </a:defRPr>
-            </a:pPr>
-            <a:r>
-              <a:rPr sz="1550">
-                <a:solidFill>
-                  <a:srgbClr val="203B34"/>
-                </a:solidFill>
-                <a:latin typeface="Manrope"/>
-                <a:ea typeface="Manrope"/>
-                <a:cs typeface="Manrope"/>
-              </a:rPr>
-              <a:t>Kyubin checked the earlier fix separately. A permanent regression test is deferred.</a:t>
-            </a:r>
-          </a:p>
-        </p:txBody>
-      </p:sp>
-    </p:spTree>
-    <p:extLst>
-      <p:ext uri="{BB962C8B-B14F-4D97-AF65-F5344CB8AC3E}">
-        <p14:creationId xmlns:p14="http://schemas.microsoft.com/office/powerpoint/2010/main" val="1007464614"/>
-      </p:ext>
-    </p:extLst>
-  </p:cSld>
-</p:sld>
-</file>
-
-<file path=ppt/slides/slide4.xml><?xml version="1.0" encoding="utf-8"?>
-<p:sld xmlns:p="http://schemas.openxmlformats.org/presentationml/2006/main">
-  <p:cSld>
-    <p:bg>
-      <p:bgPr>
-        <a:solidFill xmlns:a="http://schemas.openxmlformats.org/drawingml/2006/main">
-          <a:srgbClr val="F0E8D9"/>
-        </a:solidFill>
-      </p:bgPr>
-    </p:bg>
-    <p:spTree>
-      <p:nvGrpSpPr>
-        <p:cNvPr id="1" name=""/>
-        <p:cNvGrpSpPr/>
-        <p:nvPr/>
-      </p:nvGrpSpPr>
-      <p:grpSpPr>
-        <a:xfrm xmlns:a="http://schemas.openxmlformats.org/drawingml/2006/main"/>
-      </p:grpSpPr>
-      <p:sp>
-        <p:nvSpPr>
-          <p:cNvPr id="60" name="Google Shape;60;p10">
-            <a:extLst xmlns:a="http://schemas.openxmlformats.org/drawingml/2006/main">
-              <a:ext uri="{FF2B5EF4-FFF2-40B4-BE49-F238E27FC236}">
-                <a16:creationId xmlns:a16="http://schemas.microsoft.com/office/drawing/2014/main" id="{EA26F8E9-B2B4-4F71-B282-16387F35F775}"/>
-              </a:ext>
-            </a:extLst>
-          </p:cNvPr>
-          <p:cNvSpPr>
-            <a:spLocks xmlns:a="http://schemas.openxmlformats.org/drawingml/2006/main" noGrp="1"/>
-          </p:cNvSpPr>
-          <p:nvPr/>
-        </p:nvSpPr>
-        <p:spPr>
-          <a:xfrm xmlns:a="http://schemas.openxmlformats.org/drawingml/2006/main">
-            <a:off x="609600" y="390525"/>
-            <a:ext cx="9048750" cy="190500"/>
-          </a:xfrm>
-          <a:prstGeom xmlns:a="http://schemas.openxmlformats.org/drawingml/2006/main" prst="rect">
-            <a:avLst/>
-          </a:prstGeom>
-          <a:noFill xmlns:a="http://schemas.openxmlformats.org/drawingml/2006/main"/>
-          <a:ln xmlns:a="http://schemas.openxmlformats.org/drawingml/2006/main">
-            <a:noFill/>
-          </a:ln>
-        </p:spPr>
-        <p:txBody>
-          <a:bodyPr xmlns:a="http://schemas.openxmlformats.org/drawingml/2006/main" spcFirstLastPara="1" wrap="square" lIns="0" tIns="0" rIns="0" bIns="0" anchor="t">
-            <a:noAutofit/>
-          </a:bodyPr>
-          <a:lstStyle xmlns:a="http://schemas.openxmlformats.org/drawingml/2006/main"/>
-          <a:p xmlns:a="http://schemas.openxmlformats.org/drawingml/2006/main">
-            <a:pPr marL="0" marR="0" lvl="0" indent="0" algn="l">
-              <a:spcBef>
-                <a:spcPts val="0"/>
-              </a:spcBef>
-              <a:spcAft>
-                <a:spcPts val="0"/>
-              </a:spcAft>
-              <a:buNone/>
-            </a:pPr>
-            <a:r>
-              <a:rPr sz="1050" b="1">
-                <a:solidFill>
-                  <a:srgbClr val="203B34"/>
-                </a:solidFill>
-                <a:latin typeface="Manrope"/>
-                <a:ea typeface="Manrope"/>
-                <a:cs typeface="Manrope"/>
-              </a:rPr>
-              <a:t>TIKA-4408 / LESSONS AND NEXT TIME</a:t>
-            </a:r>
-            <a:endParaRPr sz="1050" b="1">
-              <a:solidFill>
-                <a:srgbClr val="203B34"/>
-              </a:solidFill>
-              <a:latin typeface="Manrope"/>
-              <a:ea typeface="Manrope"/>
-              <a:cs typeface="Manrope"/>
-            </a:endParaRPr>
-          </a:p>
-        </p:txBody>
-      </p:sp>
-      <p:sp>
-        <p:nvSpPr>
-          <p:cNvPr id="61" name="Google Shape;61;p10">
-            <a:extLst xmlns:a="http://schemas.openxmlformats.org/drawingml/2006/main">
-              <a:ext uri="{FF2B5EF4-FFF2-40B4-BE49-F238E27FC236}">
-                <a16:creationId xmlns:a16="http://schemas.microsoft.com/office/drawing/2014/main" id="{477ACC48-F0F9-4C9C-8C1D-2C43549D9CDF}"/>
-              </a:ext>
-            </a:extLst>
-          </p:cNvPr>
-          <p:cNvSpPr>
-            <a:spLocks xmlns:a="http://schemas.openxmlformats.org/drawingml/2006/main" noGrp="1"/>
-          </p:cNvSpPr>
-          <p:nvPr/>
-        </p:nvSpPr>
-        <p:spPr>
-          <a:xfrm xmlns:a="http://schemas.openxmlformats.org/drawingml/2006/main">
-            <a:off x="10953750" y="390525"/>
-            <a:ext cx="628650" cy="190500"/>
-          </a:xfrm>
-          <a:prstGeom xmlns:a="http://schemas.openxmlformats.org/drawingml/2006/main" prst="rect">
-            <a:avLst/>
-          </a:prstGeom>
-          <a:noFill xmlns:a="http://schemas.openxmlformats.org/drawingml/2006/main"/>
-          <a:ln xmlns:a="http://schemas.openxmlformats.org/drawingml/2006/main">
-            <a:noFill/>
-          </a:ln>
-        </p:spPr>
-        <p:txBody>
-          <a:bodyPr xmlns:a="http://schemas.openxmlformats.org/drawingml/2006/main" spcFirstLastPara="1" wrap="square" lIns="0" tIns="0" rIns="0" bIns="0" anchor="t">
-            <a:noAutofit/>
-          </a:bodyPr>
-          <a:lstStyle xmlns:a="http://schemas.openxmlformats.org/drawingml/2006/main"/>
-          <a:p xmlns:a="http://schemas.openxmlformats.org/drawingml/2006/main">
-            <a:pPr marL="0" marR="0" lvl="0" indent="0" algn="r">
-              <a:spcBef>
-                <a:spcPts val="0"/>
-              </a:spcBef>
-              <a:spcAft>
-                <a:spcPts val="0"/>
-              </a:spcAft>
-              <a:buNone/>
-            </a:pPr>
-            <a:r>
-              <a:rPr sz="1000">
-                <a:solidFill>
-                  <a:srgbClr val="52665B"/>
-                </a:solidFill>
-                <a:latin typeface="Manrope"/>
-                <a:ea typeface="Manrope"/>
-                <a:cs typeface="Manrope"/>
-              </a:rPr>
-              <a:t>04</a:t>
-            </a:r>
-            <a:endParaRPr sz="1000">
-              <a:solidFill>
-                <a:srgbClr val="52665B"/>
-              </a:solidFill>
-              <a:latin typeface="Manrope"/>
-              <a:ea typeface="Manrope"/>
-              <a:cs typeface="Manrope"/>
-            </a:endParaRPr>
-          </a:p>
-        </p:txBody>
-      </p:sp>
-      <p:sp>
-        <p:nvSpPr>
-          <p:cNvPr id="62" name="Google Shape;62;p10">
-            <a:extLst xmlns:a="http://schemas.openxmlformats.org/drawingml/2006/main">
-              <a:ext uri="{FF2B5EF4-FFF2-40B4-BE49-F238E27FC236}">
-                <a16:creationId xmlns:a16="http://schemas.microsoft.com/office/drawing/2014/main" id="{EE63C3A9-2F82-4443-B657-8A3980D42F4F}"/>
-              </a:ext>
-            </a:extLst>
-          </p:cNvPr>
-          <p:cNvSpPr>
-            <a:spLocks xmlns:a="http://schemas.openxmlformats.org/drawingml/2006/main" noGrp="1"/>
-          </p:cNvSpPr>
-          <p:nvPr>
-            <p:ph type="title" idx="0"/>
-          </p:nvPr>
-        </p:nvSpPr>
-        <p:spPr>
-          <a:xfrm xmlns:a="http://schemas.openxmlformats.org/drawingml/2006/main">
-            <a:off x="609600" y="825500"/>
-            <a:ext cx="10972800" cy="1016100"/>
-          </a:xfrm>
-          <a:prstGeom xmlns:a="http://schemas.openxmlformats.org/drawingml/2006/main" prst="rect">
-            <a:avLst/>
-          </a:prstGeom>
-          <a:noFill xmlns:a="http://schemas.openxmlformats.org/drawingml/2006/main"/>
-          <a:ln xmlns:a="http://schemas.openxmlformats.org/drawingml/2006/main">
-            <a:noFill/>
-          </a:ln>
-        </p:spPr>
-        <p:txBody>
-          <a:bodyPr xmlns:a="http://schemas.openxmlformats.org/drawingml/2006/main" spcFirstLastPara="1" wrap="square" lIns="0" tIns="0" rIns="0" bIns="0" anchor="t">
-            <a:noAutofit/>
-          </a:bodyPr>
-          <a:lstStyle xmlns:a="http://schemas.openxmlformats.org/drawingml/2006/main">
-            <a:defPPr>
-              <a:defRPr sz="3300"/>
-            </a:defPPr>
-            <a:lvl1pPr>
-              <a:defRPr sz="3300"/>
-            </a:lvl1pPr>
-            <a:lvl2pPr>
-              <a:defRPr sz="3300"/>
-            </a:lvl2pPr>
-            <a:lvl3pPr>
-              <a:defRPr sz="3300"/>
-            </a:lvl3pPr>
-            <a:lvl4pPr>
-              <a:defRPr sz="3300"/>
-            </a:lvl4pPr>
-            <a:lvl5pPr>
-              <a:defRPr sz="3300"/>
-            </a:lvl5pPr>
-            <a:lvl6pPr>
-              <a:defRPr sz="3300"/>
-            </a:lvl6pPr>
-            <a:lvl7pPr>
-              <a:defRPr sz="3300"/>
-            </a:lvl7pPr>
-            <a:lvl8pPr>
-              <a:defRPr sz="3300"/>
-            </a:lvl8pPr>
-            <a:lvl9pPr>
-              <a:defRPr sz="3300"/>
-            </a:lvl9pPr>
-          </a:lstStyle>
-          <a:p xmlns:a="http://schemas.openxmlformats.org/drawingml/2006/main">
-            <a:pPr marL="0" marR="0" lvl="0" indent="0" algn="l">
-              <a:spcBef>
-                <a:spcPts val="0"/>
-              </a:spcBef>
-              <a:spcAft>
-                <a:spcPts val="0"/>
-              </a:spcAft>
-              <a:buNone/>
-              <a:defRPr sz="3300"/>
-            </a:pPr>
-            <a:r>
-              <a:rPr sz="3300" b="1">
-                <a:solidFill>
-                  <a:srgbClr val="203B34"/>
-                </a:solidFill>
-                <a:latin typeface="Manrope"/>
-                <a:ea typeface="Manrope"/>
-                <a:cs typeface="Manrope"/>
-              </a:rPr>
-              <a:t>What I learned and would change</a:t>
-            </a:r>
-            <a:endParaRPr sz="3200" b="1">
-              <a:solidFill>
-                <a:srgbClr val="203B34"/>
-              </a:solidFill>
-              <a:latin typeface="Manrope"/>
-              <a:ea typeface="Manrope"/>
-              <a:cs typeface="Manrope"/>
-            </a:endParaRPr>
-          </a:p>
-        </p:txBody>
-      </p:sp>
-      <p:sp>
-        <p:nvSpPr>
-          <p:cNvPr id="63" name="Google Shape;63;p10">
-            <a:extLst xmlns:a="http://schemas.openxmlformats.org/drawingml/2006/main">
-              <a:ext uri="{FF2B5EF4-FFF2-40B4-BE49-F238E27FC236}">
-                <a16:creationId xmlns:a16="http://schemas.microsoft.com/office/drawing/2014/main" id="{750A9B0D-3985-4205-BE33-CDFBB9743C58}"/>
-              </a:ext>
-            </a:extLst>
-          </p:cNvPr>
-          <p:cNvSpPr>
-            <a:spLocks xmlns:a="http://schemas.openxmlformats.org/drawingml/2006/main" noGrp="1"/>
-          </p:cNvSpPr>
-          <p:nvPr/>
-        </p:nvSpPr>
-        <p:spPr>
-          <a:xfrm xmlns:a="http://schemas.openxmlformats.org/drawingml/2006/main">
-            <a:off x="5238750" y="6486525"/>
-            <a:ext cx="6343650" cy="171450"/>
-          </a:xfrm>
-          <a:prstGeom xmlns:a="http://schemas.openxmlformats.org/drawingml/2006/main" prst="rect">
-            <a:avLst/>
-          </a:prstGeom>
-          <a:noFill xmlns:a="http://schemas.openxmlformats.org/drawingml/2006/main"/>
-          <a:ln xmlns:a="http://schemas.openxmlformats.org/drawingml/2006/main">
-            <a:noFill/>
-          </a:ln>
-        </p:spPr>
-        <p:txBody>
-          <a:bodyPr xmlns:a="http://schemas.openxmlformats.org/drawingml/2006/main" spcFirstLastPara="1" wrap="square" lIns="0" tIns="0" rIns="0" bIns="0" anchor="t">
-            <a:noAutofit/>
-          </a:bodyPr>
-          <a:lstStyle xmlns:a="http://schemas.openxmlformats.org/drawingml/2006/main"/>
-          <a:p xmlns:a="http://schemas.openxmlformats.org/drawingml/2006/main">
-            <a:pPr marL="0" marR="0" lvl="0" indent="0" algn="r">
-              <a:spcBef>
-                <a:spcPts val="0"/>
-              </a:spcBef>
-              <a:spcAft>
-                <a:spcPts val="0"/>
-              </a:spcAft>
-              <a:buNone/>
-            </a:pPr>
-            <a:r>
-              <a:rPr sz="1000">
-                <a:solidFill>
                   <a:srgbClr val="52665B"/>
                 </a:solidFill>
                 <a:latin typeface="Manrope"/>
@@ -10530,7 +6935,7 @@
           <p:cNvPr id="64" name="Google Shape;64;p10">
             <a:extLst xmlns:a="http://schemas.openxmlformats.org/drawingml/2006/main">
               <a:ext uri="{FF2B5EF4-FFF2-40B4-BE49-F238E27FC236}">
-                <a16:creationId xmlns:a16="http://schemas.microsoft.com/office/drawing/2014/main" id="{5ACE5F7A-0897-4BBE-8A51-582A131F91FD}"/>
+                <a16:creationId xmlns:a16="http://schemas.microsoft.com/office/drawing/2014/main" id="{B2D625AF-1597-47FA-B0FC-D0E422172F6C}"/>
               </a:ext>
             </a:extLst>
           </p:cNvPr>
@@ -10652,7 +7057,7 @@
                 <a:ea typeface="Manrope"/>
                 <a:cs typeface="Manrope"/>
               </a:rPr>
-              <a:t>Understand rule interactions</a:t>
+              <a:t>Test both detection modes</a:t>
             </a:r>
             <a:endParaRPr sz="1600" b="1">
               <a:solidFill>
@@ -10670,7 +7075,7 @@
           <p:cNvPr id="65" name="Google Shape;65;p10">
             <a:extLst xmlns:a="http://schemas.openxmlformats.org/drawingml/2006/main">
               <a:ext uri="{FF2B5EF4-FFF2-40B4-BE49-F238E27FC236}">
-                <a16:creationId xmlns:a16="http://schemas.microsoft.com/office/drawing/2014/main" id="{5BBC0063-C1C6-4DB9-A57E-7B608277AED8}"/>
+                <a16:creationId xmlns:a16="http://schemas.microsoft.com/office/drawing/2014/main" id="{DAB066CC-3F74-4813-81E7-456C0D6B0E5E}"/>
               </a:ext>
             </a:extLst>
           </p:cNvPr>
@@ -10792,7 +7197,7 @@
                 <a:ea typeface="Manrope"/>
                 <a:cs typeface="Manrope"/>
               </a:rPr>
-              <a:t>Trace competing rules and write the expected</a:t>
+              <a:t>Check content alone, then add a filename.</a:t>
             </a:r>
             <a:endParaRPr sz="2000">
               <a:solidFill>
@@ -10827,7 +7232,7 @@
                 <a:ea typeface="Manrope"/>
                 <a:cs typeface="Manrope"/>
               </a:rPr>
-              <a:t>behavior before changing the implementation.</a:t>
+              <a:t>A filename can hide a missing content rule.</a:t>
             </a:r>
             <a:endParaRPr sz="2000">
               <a:solidFill>
@@ -10845,7 +7250,7 @@
           <p:cNvPr id="66" name="Google Shape;66;p10">
             <a:extLst xmlns:a="http://schemas.openxmlformats.org/drawingml/2006/main">
               <a:ext uri="{FF2B5EF4-FFF2-40B4-BE49-F238E27FC236}">
-                <a16:creationId xmlns:a16="http://schemas.microsoft.com/office/drawing/2014/main" id="{A4295220-7EB5-4C0C-8827-955D83C60DF6}"/>
+                <a16:creationId xmlns:a16="http://schemas.microsoft.com/office/drawing/2014/main" id="{893B9EAE-C892-45AD-BE36-AD94C2D47E47}"/>
               </a:ext>
             </a:extLst>
           </p:cNvPr>
@@ -10967,7 +7372,7 @@
                 <a:ea typeface="Manrope"/>
                 <a:cs typeface="Manrope"/>
               </a:rPr>
-              <a:t>Plan broader coverage earlier</a:t>
+              <a:t>Test different inputs</a:t>
             </a:r>
             <a:endParaRPr sz="1600" b="1">
               <a:solidFill>
@@ -10985,7 +7390,7 @@
           <p:cNvPr id="67" name="Google Shape;67;p10">
             <a:extLst xmlns:a="http://schemas.openxmlformats.org/drawingml/2006/main">
               <a:ext uri="{FF2B5EF4-FFF2-40B4-BE49-F238E27FC236}">
-                <a16:creationId xmlns:a16="http://schemas.microsoft.com/office/drawing/2014/main" id="{204183BF-EBF4-45A3-903A-53FBCCCC9D5C}"/>
+                <a16:creationId xmlns:a16="http://schemas.microsoft.com/office/drawing/2014/main" id="{F06698BE-6329-4662-84A7-AF4BE1D9F30F}"/>
               </a:ext>
             </a:extLst>
           </p:cNvPr>
@@ -11107,7 +7512,7 @@
                 <a:ea typeface="Manrope"/>
                 <a:cs typeface="Manrope"/>
               </a:rPr>
-              <a:t>Build an initial test matrix for Python, Shell,</a:t>
+              <a:t>Check Python, Shell and boundary cases.</a:t>
             </a:r>
             <a:endParaRPr sz="2000">
               <a:solidFill>
@@ -11142,7 +7547,7 @@
                 <a:ea typeface="Manrope"/>
                 <a:cs typeface="Manrope"/>
               </a:rPr>
-              <a:t>filename hints and boundary cases.</a:t>
+              <a:t>Review suggestions can reveal gaps.</a:t>
             </a:r>
             <a:endParaRPr sz="2000">
               <a:solidFill>
@@ -11160,7 +7565,7 @@
           <p:cNvPr id="68" name="Google Shape;68;p10">
             <a:extLst xmlns:a="http://schemas.openxmlformats.org/drawingml/2006/main">
               <a:ext uri="{FF2B5EF4-FFF2-40B4-BE49-F238E27FC236}">
-                <a16:creationId xmlns:a16="http://schemas.microsoft.com/office/drawing/2014/main" id="{2BB066E7-47F7-4D71-9954-4EFE8EB7E355}"/>
+                <a16:creationId xmlns:a16="http://schemas.microsoft.com/office/drawing/2014/main" id="{241AC74B-8112-4BF2-AF4F-F57BAFD32070}"/>
               </a:ext>
             </a:extLst>
           </p:cNvPr>
@@ -11282,7 +7687,7 @@
                 <a:ea typeface="Manrope"/>
                 <a:cs typeface="Manrope"/>
               </a:rPr>
-              <a:t>Preserve useful review checks</a:t>
+              <a:t>Follow existing conventions</a:t>
             </a:r>
             <a:endParaRPr sz="1600" b="1">
               <a:solidFill>
@@ -11300,7 +7705,7 @@
           <p:cNvPr id="69" name="Google Shape;69;p10">
             <a:extLst xmlns:a="http://schemas.openxmlformats.org/drawingml/2006/main">
               <a:ext uri="{FF2B5EF4-FFF2-40B4-BE49-F238E27FC236}">
-                <a16:creationId xmlns:a16="http://schemas.microsoft.com/office/drawing/2014/main" id="{A3792373-862B-4D1D-B6FC-3A9A99C58C74}"/>
+                <a16:creationId xmlns:a16="http://schemas.microsoft.com/office/drawing/2014/main" id="{226CF650-43DE-4613-8D98-2A616B9664C3}"/>
               </a:ext>
             </a:extLst>
           </p:cNvPr>
@@ -11422,7 +7827,7 @@
                 <a:ea typeface="Manrope"/>
                 <a:cs typeface="Manrope"/>
               </a:rPr>
-              <a:t>Turn probes such as x/bin/env python into</a:t>
+              <a:t>Use the existing pattern of two literal rules:</a:t>
             </a:r>
             <a:endParaRPr sz="2000">
               <a:solidFill>
@@ -11457,7 +7862,7 @@
                 <a:ea typeface="Manrope"/>
                 <a:cs typeface="Manrope"/>
               </a:rPr>
-              <a:t>permanent automated regression tests.</a:t>
+              <a:t>no space and exactly one space after #!.</a:t>
             </a:r>
             <a:endParaRPr sz="2000">
               <a:solidFill>
@@ -11475,7 +7880,7 @@
           <p:cNvPr id="70" name="Google Shape;70;p10">
             <a:extLst xmlns:a="http://schemas.openxmlformats.org/drawingml/2006/main">
               <a:ext uri="{FF2B5EF4-FFF2-40B4-BE49-F238E27FC236}">
-                <a16:creationId xmlns:a16="http://schemas.microsoft.com/office/drawing/2014/main" id="{A805EEED-0476-4E8A-8D52-AAAF0A5E4AB2}"/>
+                <a16:creationId xmlns:a16="http://schemas.microsoft.com/office/drawing/2014/main" id="{5373534B-C000-4FD3-B40D-9A29DF976AAF}"/>
               </a:ext>
             </a:extLst>
           </p:cNvPr>
@@ -11597,7 +8002,7 @@
                 <a:ea typeface="Manrope"/>
                 <a:cs typeface="Manrope"/>
               </a:rPr>
-              <a:t>Keep the useful workflow</a:t>
+              <a:t>Keep fixes focused</a:t>
             </a:r>
             <a:endParaRPr sz="1600" b="1">
               <a:solidFill>
@@ -11615,7 +8020,7 @@
           <p:cNvPr id="71" name="Google Shape;71;p10">
             <a:extLst xmlns:a="http://schemas.openxmlformats.org/drawingml/2006/main">
               <a:ext uri="{FF2B5EF4-FFF2-40B4-BE49-F238E27FC236}">
-                <a16:creationId xmlns:a16="http://schemas.microsoft.com/office/drawing/2014/main" id="{AD409504-FF7E-451E-AAEF-D674B707033A}"/>
+                <a16:creationId xmlns:a16="http://schemas.microsoft.com/office/drawing/2014/main" id="{3FDA41D3-5D6C-49DB-8E93-E6A80582452A}"/>
               </a:ext>
             </a:extLst>
           </p:cNvPr>
@@ -11737,7 +8142,7 @@
                 <a:ea typeface="Manrope"/>
                 <a:cs typeface="Manrope"/>
               </a:rPr>
-              <a:t>Continue reproducing first and comparing the</a:t>
+              <a:t>Reproduce first, then compare the same tests.</a:t>
             </a:r>
             <a:endParaRPr sz="2000">
               <a:solidFill>
@@ -11772,7 +8177,7 @@
                 <a:ea typeface="Manrope"/>
                 <a:cs typeface="Manrope"/>
               </a:rPr>
-              <a:t>same checks before and after a focused fix.</a:t>
+              <a:t>Change the relevant rules and their tests.</a:t>
             </a:r>
             <a:endParaRPr sz="2000">
               <a:solidFill>
@@ -11788,7 +8193,7 @@
     </p:spTree>
     <p:extLst>
       <p:ext uri="{BB962C8B-B14F-4D97-AF65-F5344CB8AC3E}">
-        <p14:creationId xmlns:p14="http://schemas.microsoft.com/office/powerpoint/2010/main" val="875521473"/>
+        <p14:creationId xmlns:p14="http://schemas.microsoft.com/office/powerpoint/2010/main" val="1746114630"/>
       </p:ext>
     </p:extLst>
   </p:cSld>

</xml_diff>